<commit_message>
Fix presentation blank space: chapter-style dividers, filled text cards, hero title
Rendered the deck to PDF (LibreOffice) and found 3 layouts wasting space:
- the 4 section dividers were ~90% blank (small top-left title only)
- text-only slides floated bullets mid-slide
- the title slide was plain white

build_pptx.py now renders:
- TITLE: full-bleed navy hero with accent rule, white title, accent subtitle, author
- SECTION DIVIDERS: navy chapter slides — "SECTION n / 4" kicker, large centered
  title, accent underline, subtitle (no more empty slides)
- TEXT-ONLY slides: a light filled card with a left accent bar and large bullets,
  so definitional slides read as intentional, not empty
Figure slides and the ▶ live-demo video placeholder are unchanged.

Verified by rendering all 26 slides to images (PyMuPDF) and inspecting a contact
sheet. Also commits the flat lab3_presentation.pdf render.

Co-Authored-By: Claude Opus 4.8 (1M context) <noreply@anthropic.com>
</commit_message>
<xml_diff>
--- a/lab3/outputs/slides/lab3_presentation.pptx
+++ b/lab3/outputs/slides/lab3_presentation.pptx
@@ -5285,14 +5285,102 @@
       <p:grpSpPr/>
       <p:sp>
         <p:nvSpPr>
-          <p:cNvPr id="2" name="TextBox 1"/>
+          <p:cNvPr id="2" name="Rectangle 1"/>
+          <p:cNvSpPr/>
+          <p:nvPr/>
+        </p:nvSpPr>
+        <p:spPr>
+          <a:xfrm>
+            <a:off x="0" y="0"/>
+            <a:ext cx="12191695" cy="6858000"/>
+          </a:xfrm>
+          <a:prstGeom prst="rect">
+            <a:avLst/>
+          </a:prstGeom>
+          <a:solidFill>
+            <a:srgbClr val="1F2D3D"/>
+          </a:solidFill>
+          <a:ln>
+            <a:noFill/>
+          </a:ln>
+          <a:effectLst/>
+        </p:spPr>
+        <p:style>
+          <a:lnRef idx="1">
+            <a:schemeClr val="accent1"/>
+          </a:lnRef>
+          <a:fillRef idx="3">
+            <a:schemeClr val="accent1"/>
+          </a:fillRef>
+          <a:effectRef idx="2">
+            <a:schemeClr val="accent1"/>
+          </a:effectRef>
+          <a:fontRef idx="minor">
+            <a:schemeClr val="lt1"/>
+          </a:fontRef>
+        </p:style>
+        <p:txBody>
+          <a:bodyPr rtlCol="0" anchor="ctr"/>
+          <a:lstStyle/>
+          <a:p>
+            <a:pPr algn="ctr"/>
+          </a:p>
+        </p:txBody>
+      </p:sp>
+      <p:sp>
+        <p:nvSpPr>
+          <p:cNvPr id="3" name="Rectangle 2"/>
+          <p:cNvSpPr/>
+          <p:nvPr/>
+        </p:nvSpPr>
+        <p:spPr>
+          <a:xfrm>
+            <a:off x="4727448" y="2148840"/>
+            <a:ext cx="2743200" cy="63500"/>
+          </a:xfrm>
+          <a:prstGeom prst="rect">
+            <a:avLst/>
+          </a:prstGeom>
+          <a:solidFill>
+            <a:srgbClr val="6FB7F0"/>
+          </a:solidFill>
+          <a:ln>
+            <a:noFill/>
+          </a:ln>
+          <a:effectLst/>
+        </p:spPr>
+        <p:style>
+          <a:lnRef idx="1">
+            <a:schemeClr val="accent1"/>
+          </a:lnRef>
+          <a:fillRef idx="3">
+            <a:schemeClr val="accent1"/>
+          </a:fillRef>
+          <a:effectRef idx="2">
+            <a:schemeClr val="accent1"/>
+          </a:effectRef>
+          <a:fontRef idx="minor">
+            <a:schemeClr val="lt1"/>
+          </a:fontRef>
+        </p:style>
+        <p:txBody>
+          <a:bodyPr rtlCol="0" anchor="ctr"/>
+          <a:lstStyle/>
+          <a:p>
+            <a:pPr algn="ctr"/>
+          </a:p>
+        </p:txBody>
+      </p:sp>
+      <p:sp>
+        <p:nvSpPr>
+          <p:cNvPr id="4" name="TextBox 3"/>
           <p:cNvSpPr txBox="1"/>
           <p:nvPr/>
         </p:nvSpPr>
         <p:spPr>
           <a:xfrm>
-            <a:off x="914400" y="2377440"/>
-            <a:ext cx="10360152" cy="1463040"/>
+            <a:off x="731520" y="2468880"/>
+            <a:ext cx="10725912" cy="2011680"/>
           </a:xfrm>
           <a:prstGeom prst="rect">
             <a:avLst/>
@@ -5309,7 +5397,7 @@
             <a:r>
               <a:rPr sz="4000" b="1">
                 <a:solidFill>
-                  <a:srgbClr val="1F2D3D"/>
+                  <a:srgbClr val="FFFFFF"/>
                 </a:solidFill>
               </a:rPr>
               <a:t>From a 1.57 m KNN baseline to a 0.75 m honest cascade</a:t>
@@ -5319,14 +5407,14 @@
       </p:sp>
       <p:sp>
         <p:nvSpPr>
-          <p:cNvPr id="3" name="TextBox 2"/>
+          <p:cNvPr id="5" name="TextBox 4"/>
           <p:cNvSpPr txBox="1"/>
           <p:nvPr/>
         </p:nvSpPr>
         <p:spPr>
           <a:xfrm>
-            <a:off x="914400" y="3931920"/>
-            <a:ext cx="10360152" cy="914400"/>
+            <a:off x="914400" y="4572000"/>
+            <a:ext cx="10360152" cy="1097280"/>
           </a:xfrm>
           <a:prstGeom prst="rect">
             <a:avLst/>
@@ -5343,10 +5431,44 @@
             <a:r>
               <a:rPr sz="2000">
                 <a:solidFill>
-                  <a:srgbClr val="555555"/>
+                  <a:srgbClr val="6FB7F0"/>
                 </a:solidFill>
               </a:rPr>
               <a:t>Standard protocol 0.75 m, strict nested-CV 0.95 m — and we caught our own overfitting</a:t>
+            </a:r>
+          </a:p>
+        </p:txBody>
+      </p:sp>
+      <p:sp>
+        <p:nvSpPr>
+          <p:cNvPr id="6" name="TextBox 5"/>
+          <p:cNvSpPr txBox="1"/>
+          <p:nvPr/>
+        </p:nvSpPr>
+        <p:spPr>
+          <a:xfrm>
+            <a:off x="914400" y="6035040"/>
+            <a:ext cx="10360152" cy="548640"/>
+          </a:xfrm>
+          <a:prstGeom prst="rect">
+            <a:avLst/>
+          </a:prstGeom>
+          <a:noFill/>
+        </p:spPr>
+        <p:txBody>
+          <a:bodyPr wrap="none">
+            <a:spAutoFit/>
+          </a:bodyPr>
+          <a:lstStyle/>
+          <a:p>
+            <a:pPr algn="ctr"/>
+            <a:r>
+              <a:rPr sz="1400">
+                <a:solidFill>
+                  <a:srgbClr val="AAB6C4"/>
+                </a:solidFill>
+              </a:rPr>
+              <a:t>NYCU CV2X Lab 3</a:t>
             </a:r>
           </a:p>
         </p:txBody>
@@ -5371,14 +5493,58 @@
       <p:grpSpPr/>
       <p:sp>
         <p:nvSpPr>
-          <p:cNvPr id="2" name="TextBox 1"/>
+          <p:cNvPr id="2" name="Rectangle 1"/>
+          <p:cNvSpPr/>
+          <p:nvPr/>
+        </p:nvSpPr>
+        <p:spPr>
+          <a:xfrm>
+            <a:off x="0" y="0"/>
+            <a:ext cx="12191695" cy="6858000"/>
+          </a:xfrm>
+          <a:prstGeom prst="rect">
+            <a:avLst/>
+          </a:prstGeom>
+          <a:solidFill>
+            <a:srgbClr val="1F2D3D"/>
+          </a:solidFill>
+          <a:ln>
+            <a:noFill/>
+          </a:ln>
+          <a:effectLst/>
+        </p:spPr>
+        <p:style>
+          <a:lnRef idx="1">
+            <a:schemeClr val="accent1"/>
+          </a:lnRef>
+          <a:fillRef idx="3">
+            <a:schemeClr val="accent1"/>
+          </a:fillRef>
+          <a:effectRef idx="2">
+            <a:schemeClr val="accent1"/>
+          </a:effectRef>
+          <a:fontRef idx="minor">
+            <a:schemeClr val="lt1"/>
+          </a:fontRef>
+        </p:style>
+        <p:txBody>
+          <a:bodyPr rtlCol="0" anchor="ctr"/>
+          <a:lstStyle/>
+          <a:p>
+            <a:pPr algn="ctr"/>
+          </a:p>
+        </p:txBody>
+      </p:sp>
+      <p:sp>
+        <p:nvSpPr>
+          <p:cNvPr id="3" name="TextBox 2"/>
           <p:cNvSpPr txBox="1"/>
           <p:nvPr/>
         </p:nvSpPr>
         <p:spPr>
           <a:xfrm>
-            <a:off x="457200" y="320040"/>
-            <a:ext cx="11274552" cy="868680"/>
+            <a:off x="822960" y="2331720"/>
+            <a:ext cx="10515600" cy="548640"/>
           </a:xfrm>
           <a:prstGeom prst="rect">
             <a:avLst/>
@@ -5386,32 +5552,33 @@
           <a:noFill/>
         </p:spPr>
         <p:txBody>
-          <a:bodyPr wrap="square">
+          <a:bodyPr wrap="none">
             <a:spAutoFit/>
           </a:bodyPr>
           <a:lstStyle/>
           <a:p>
-            <a:r>
-              <a:rPr sz="2700" b="1">
-                <a:solidFill>
-                  <a:srgbClr val="1F2D3D"/>
-                </a:solidFill>
-              </a:rPr>
-              <a:t>做法 / Method</a:t>
-            </a:r>
-          </a:p>
-        </p:txBody>
-      </p:sp>
-      <p:sp>
-        <p:nvSpPr>
-          <p:cNvPr id="3" name="TextBox 2"/>
+            <a:pPr algn="ctr"/>
+            <a:r>
+              <a:rPr sz="1800" b="1">
+                <a:solidFill>
+                  <a:srgbClr val="6FB7F0"/>
+                </a:solidFill>
+              </a:rPr>
+              <a:t>SECTION 3 / 4</a:t>
+            </a:r>
+          </a:p>
+        </p:txBody>
+      </p:sp>
+      <p:sp>
+        <p:nvSpPr>
+          <p:cNvPr id="4" name="TextBox 3"/>
           <p:cNvSpPr txBox="1"/>
           <p:nvPr/>
         </p:nvSpPr>
         <p:spPr>
           <a:xfrm>
-            <a:off x="1371600" y="1463040"/>
-            <a:ext cx="9418320" cy="4937760"/>
+            <a:off x="731520" y="2788920"/>
+            <a:ext cx="10725912" cy="1371600"/>
           </a:xfrm>
           <a:prstGeom prst="rect">
             <a:avLst/>
@@ -5419,11 +5586,99 @@
           <a:noFill/>
         </p:spPr>
         <p:txBody>
-          <a:bodyPr wrap="square" anchor="ctr">
+          <a:bodyPr wrap="square">
             <a:spAutoFit/>
           </a:bodyPr>
           <a:lstStyle/>
-          <a:p/>
+          <a:p>
+            <a:pPr algn="ctr"/>
+            <a:r>
+              <a:rPr sz="4000" b="1">
+                <a:solidFill>
+                  <a:srgbClr val="FFFFFF"/>
+                </a:solidFill>
+              </a:rPr>
+              <a:t>做法 / Method</a:t>
+            </a:r>
+          </a:p>
+        </p:txBody>
+      </p:sp>
+      <p:sp>
+        <p:nvSpPr>
+          <p:cNvPr id="5" name="Rectangle 4"/>
+          <p:cNvSpPr/>
+          <p:nvPr/>
+        </p:nvSpPr>
+        <p:spPr>
+          <a:xfrm>
+            <a:off x="5184648" y="4160520"/>
+            <a:ext cx="1828800" cy="50800"/>
+          </a:xfrm>
+          <a:prstGeom prst="rect">
+            <a:avLst/>
+          </a:prstGeom>
+          <a:solidFill>
+            <a:srgbClr val="6FB7F0"/>
+          </a:solidFill>
+          <a:ln>
+            <a:noFill/>
+          </a:ln>
+          <a:effectLst/>
+        </p:spPr>
+        <p:style>
+          <a:lnRef idx="1">
+            <a:schemeClr val="accent1"/>
+          </a:lnRef>
+          <a:fillRef idx="3">
+            <a:schemeClr val="accent1"/>
+          </a:fillRef>
+          <a:effectRef idx="2">
+            <a:schemeClr val="accent1"/>
+          </a:effectRef>
+          <a:fontRef idx="minor">
+            <a:schemeClr val="lt1"/>
+          </a:fontRef>
+        </p:style>
+        <p:txBody>
+          <a:bodyPr rtlCol="0" anchor="ctr"/>
+          <a:lstStyle/>
+          <a:p>
+            <a:pPr algn="ctr"/>
+          </a:p>
+        </p:txBody>
+      </p:sp>
+      <p:sp>
+        <p:nvSpPr>
+          <p:cNvPr id="6" name="TextBox 5"/>
+          <p:cNvSpPr txBox="1"/>
+          <p:nvPr/>
+        </p:nvSpPr>
+        <p:spPr>
+          <a:xfrm>
+            <a:off x="1371600" y="4389120"/>
+            <a:ext cx="9445752" cy="914400"/>
+          </a:xfrm>
+          <a:prstGeom prst="rect">
+            <a:avLst/>
+          </a:prstGeom>
+          <a:noFill/>
+        </p:spPr>
+        <p:txBody>
+          <a:bodyPr wrap="square">
+            <a:spAutoFit/>
+          </a:bodyPr>
+          <a:lstStyle/>
+          <a:p>
+            <a:pPr algn="ctr"/>
+            <a:r>
+              <a:rPr sz="1800">
+                <a:solidFill>
+                  <a:srgbClr val="C8D2DE"/>
+                </a:solidFill>
+              </a:rPr>
+              <a:t>The climb: each method change fixes one named problem</a:t>
+            </a:r>
+          </a:p>
         </p:txBody>
       </p:sp>
     </p:spTree>
@@ -6776,14 +7031,58 @@
       <p:grpSpPr/>
       <p:sp>
         <p:nvSpPr>
-          <p:cNvPr id="2" name="TextBox 1"/>
+          <p:cNvPr id="2" name="Rectangle 1"/>
+          <p:cNvSpPr/>
+          <p:nvPr/>
+        </p:nvSpPr>
+        <p:spPr>
+          <a:xfrm>
+            <a:off x="0" y="0"/>
+            <a:ext cx="12191695" cy="6858000"/>
+          </a:xfrm>
+          <a:prstGeom prst="rect">
+            <a:avLst/>
+          </a:prstGeom>
+          <a:solidFill>
+            <a:srgbClr val="1F2D3D"/>
+          </a:solidFill>
+          <a:ln>
+            <a:noFill/>
+          </a:ln>
+          <a:effectLst/>
+        </p:spPr>
+        <p:style>
+          <a:lnRef idx="1">
+            <a:schemeClr val="accent1"/>
+          </a:lnRef>
+          <a:fillRef idx="3">
+            <a:schemeClr val="accent1"/>
+          </a:fillRef>
+          <a:effectRef idx="2">
+            <a:schemeClr val="accent1"/>
+          </a:effectRef>
+          <a:fontRef idx="minor">
+            <a:schemeClr val="lt1"/>
+          </a:fontRef>
+        </p:style>
+        <p:txBody>
+          <a:bodyPr rtlCol="0" anchor="ctr"/>
+          <a:lstStyle/>
+          <a:p>
+            <a:pPr algn="ctr"/>
+          </a:p>
+        </p:txBody>
+      </p:sp>
+      <p:sp>
+        <p:nvSpPr>
+          <p:cNvPr id="3" name="TextBox 2"/>
           <p:cNvSpPr txBox="1"/>
           <p:nvPr/>
         </p:nvSpPr>
         <p:spPr>
           <a:xfrm>
-            <a:off x="457200" y="320040"/>
-            <a:ext cx="11274552" cy="868680"/>
+            <a:off x="822960" y="2331720"/>
+            <a:ext cx="10515600" cy="548640"/>
           </a:xfrm>
           <a:prstGeom prst="rect">
             <a:avLst/>
@@ -6791,32 +7090,33 @@
           <a:noFill/>
         </p:spPr>
         <p:txBody>
-          <a:bodyPr wrap="square">
+          <a:bodyPr wrap="none">
             <a:spAutoFit/>
           </a:bodyPr>
           <a:lstStyle/>
           <a:p>
-            <a:r>
-              <a:rPr sz="2700" b="1">
-                <a:solidFill>
-                  <a:srgbClr val="1F2D3D"/>
-                </a:solidFill>
-              </a:rPr>
-              <a:t>實驗結果 / Experimental Results</a:t>
-            </a:r>
-          </a:p>
-        </p:txBody>
-      </p:sp>
-      <p:sp>
-        <p:nvSpPr>
-          <p:cNvPr id="3" name="TextBox 2"/>
+            <a:pPr algn="ctr"/>
+            <a:r>
+              <a:rPr sz="1800" b="1">
+                <a:solidFill>
+                  <a:srgbClr val="6FB7F0"/>
+                </a:solidFill>
+              </a:rPr>
+              <a:t>SECTION 4 / 4</a:t>
+            </a:r>
+          </a:p>
+        </p:txBody>
+      </p:sp>
+      <p:sp>
+        <p:nvSpPr>
+          <p:cNvPr id="4" name="TextBox 3"/>
           <p:cNvSpPr txBox="1"/>
           <p:nvPr/>
         </p:nvSpPr>
         <p:spPr>
           <a:xfrm>
-            <a:off x="1371600" y="1463040"/>
-            <a:ext cx="9418320" cy="4937760"/>
+            <a:off x="731520" y="2788920"/>
+            <a:ext cx="10725912" cy="1371600"/>
           </a:xfrm>
           <a:prstGeom prst="rect">
             <a:avLst/>
@@ -6824,11 +7124,99 @@
           <a:noFill/>
         </p:spPr>
         <p:txBody>
-          <a:bodyPr wrap="square" anchor="ctr">
+          <a:bodyPr wrap="square">
             <a:spAutoFit/>
           </a:bodyPr>
           <a:lstStyle/>
-          <a:p/>
+          <a:p>
+            <a:pPr algn="ctr"/>
+            <a:r>
+              <a:rPr sz="4000" b="1">
+                <a:solidFill>
+                  <a:srgbClr val="FFFFFF"/>
+                </a:solidFill>
+              </a:rPr>
+              <a:t>實驗結果 / Experimental Results</a:t>
+            </a:r>
+          </a:p>
+        </p:txBody>
+      </p:sp>
+      <p:sp>
+        <p:nvSpPr>
+          <p:cNvPr id="5" name="Rectangle 4"/>
+          <p:cNvSpPr/>
+          <p:nvPr/>
+        </p:nvSpPr>
+        <p:spPr>
+          <a:xfrm>
+            <a:off x="5184648" y="4160520"/>
+            <a:ext cx="1828800" cy="50800"/>
+          </a:xfrm>
+          <a:prstGeom prst="rect">
+            <a:avLst/>
+          </a:prstGeom>
+          <a:solidFill>
+            <a:srgbClr val="6FB7F0"/>
+          </a:solidFill>
+          <a:ln>
+            <a:noFill/>
+          </a:ln>
+          <a:effectLst/>
+        </p:spPr>
+        <p:style>
+          <a:lnRef idx="1">
+            <a:schemeClr val="accent1"/>
+          </a:lnRef>
+          <a:fillRef idx="3">
+            <a:schemeClr val="accent1"/>
+          </a:fillRef>
+          <a:effectRef idx="2">
+            <a:schemeClr val="accent1"/>
+          </a:effectRef>
+          <a:fontRef idx="minor">
+            <a:schemeClr val="lt1"/>
+          </a:fontRef>
+        </p:style>
+        <p:txBody>
+          <a:bodyPr rtlCol="0" anchor="ctr"/>
+          <a:lstStyle/>
+          <a:p>
+            <a:pPr algn="ctr"/>
+          </a:p>
+        </p:txBody>
+      </p:sp>
+      <p:sp>
+        <p:nvSpPr>
+          <p:cNvPr id="6" name="TextBox 5"/>
+          <p:cNvSpPr txBox="1"/>
+          <p:nvPr/>
+        </p:nvSpPr>
+        <p:spPr>
+          <a:xfrm>
+            <a:off x="1371600" y="4389120"/>
+            <a:ext cx="9445752" cy="914400"/>
+          </a:xfrm>
+          <a:prstGeom prst="rect">
+            <a:avLst/>
+          </a:prstGeom>
+          <a:noFill/>
+        </p:spPr>
+        <p:txBody>
+          <a:bodyPr wrap="square">
+            <a:spAutoFit/>
+          </a:bodyPr>
+          <a:lstStyle/>
+          <a:p>
+            <a:pPr algn="ctr"/>
+            <a:r>
+              <a:rPr sz="1800">
+                <a:solidFill>
+                  <a:srgbClr val="C8D2DE"/>
+                </a:solidFill>
+              </a:rPr>
+              <a:t>The full climb, the honesty audit, the failures, and the live demo</a:t>
+            </a:r>
+          </a:p>
         </p:txBody>
       </p:sp>
     </p:spTree>
@@ -8683,14 +9071,58 @@
       <p:grpSpPr/>
       <p:sp>
         <p:nvSpPr>
-          <p:cNvPr id="2" name="TextBox 1"/>
+          <p:cNvPr id="2" name="Rectangle 1"/>
+          <p:cNvSpPr/>
+          <p:nvPr/>
+        </p:nvSpPr>
+        <p:spPr>
+          <a:xfrm>
+            <a:off x="0" y="0"/>
+            <a:ext cx="12191695" cy="6858000"/>
+          </a:xfrm>
+          <a:prstGeom prst="rect">
+            <a:avLst/>
+          </a:prstGeom>
+          <a:solidFill>
+            <a:srgbClr val="1F2D3D"/>
+          </a:solidFill>
+          <a:ln>
+            <a:noFill/>
+          </a:ln>
+          <a:effectLst/>
+        </p:spPr>
+        <p:style>
+          <a:lnRef idx="1">
+            <a:schemeClr val="accent1"/>
+          </a:lnRef>
+          <a:fillRef idx="3">
+            <a:schemeClr val="accent1"/>
+          </a:fillRef>
+          <a:effectRef idx="2">
+            <a:schemeClr val="accent1"/>
+          </a:effectRef>
+          <a:fontRef idx="minor">
+            <a:schemeClr val="lt1"/>
+          </a:fontRef>
+        </p:style>
+        <p:txBody>
+          <a:bodyPr rtlCol="0" anchor="ctr"/>
+          <a:lstStyle/>
+          <a:p>
+            <a:pPr algn="ctr"/>
+          </a:p>
+        </p:txBody>
+      </p:sp>
+      <p:sp>
+        <p:nvSpPr>
+          <p:cNvPr id="3" name="TextBox 2"/>
           <p:cNvSpPr txBox="1"/>
           <p:nvPr/>
         </p:nvSpPr>
         <p:spPr>
           <a:xfrm>
-            <a:off x="457200" y="320040"/>
-            <a:ext cx="11274552" cy="868680"/>
+            <a:off x="822960" y="2331720"/>
+            <a:ext cx="10515600" cy="548640"/>
           </a:xfrm>
           <a:prstGeom prst="rect">
             <a:avLst/>
@@ -8698,32 +9130,33 @@
           <a:noFill/>
         </p:spPr>
         <p:txBody>
-          <a:bodyPr wrap="square">
+          <a:bodyPr wrap="none">
             <a:spAutoFit/>
           </a:bodyPr>
           <a:lstStyle/>
           <a:p>
-            <a:r>
-              <a:rPr sz="2700" b="1">
-                <a:solidFill>
-                  <a:srgbClr val="1F2D3D"/>
-                </a:solidFill>
-              </a:rPr>
-              <a:t>題目定義 / Problem Definition</a:t>
-            </a:r>
-          </a:p>
-        </p:txBody>
-      </p:sp>
-      <p:sp>
-        <p:nvSpPr>
-          <p:cNvPr id="3" name="TextBox 2"/>
+            <a:pPr algn="ctr"/>
+            <a:r>
+              <a:rPr sz="1800" b="1">
+                <a:solidFill>
+                  <a:srgbClr val="6FB7F0"/>
+                </a:solidFill>
+              </a:rPr>
+              <a:t>SECTION 1 / 4</a:t>
+            </a:r>
+          </a:p>
+        </p:txBody>
+      </p:sp>
+      <p:sp>
+        <p:nvSpPr>
+          <p:cNvPr id="4" name="TextBox 3"/>
           <p:cNvSpPr txBox="1"/>
           <p:nvPr/>
         </p:nvSpPr>
         <p:spPr>
           <a:xfrm>
-            <a:off x="1371600" y="1463040"/>
-            <a:ext cx="9418320" cy="4937760"/>
+            <a:off x="731520" y="2788920"/>
+            <a:ext cx="10725912" cy="1371600"/>
           </a:xfrm>
           <a:prstGeom prst="rect">
             <a:avLst/>
@@ -8731,11 +9164,99 @@
           <a:noFill/>
         </p:spPr>
         <p:txBody>
-          <a:bodyPr wrap="square" anchor="ctr">
+          <a:bodyPr wrap="square">
             <a:spAutoFit/>
           </a:bodyPr>
           <a:lstStyle/>
-          <a:p/>
+          <a:p>
+            <a:pPr algn="ctr"/>
+            <a:r>
+              <a:rPr sz="4000" b="1">
+                <a:solidFill>
+                  <a:srgbClr val="FFFFFF"/>
+                </a:solidFill>
+              </a:rPr>
+              <a:t>題目定義 / Problem Definition</a:t>
+            </a:r>
+          </a:p>
+        </p:txBody>
+      </p:sp>
+      <p:sp>
+        <p:nvSpPr>
+          <p:cNvPr id="5" name="Rectangle 4"/>
+          <p:cNvSpPr/>
+          <p:nvPr/>
+        </p:nvSpPr>
+        <p:spPr>
+          <a:xfrm>
+            <a:off x="5184648" y="4160520"/>
+            <a:ext cx="1828800" cy="50800"/>
+          </a:xfrm>
+          <a:prstGeom prst="rect">
+            <a:avLst/>
+          </a:prstGeom>
+          <a:solidFill>
+            <a:srgbClr val="6FB7F0"/>
+          </a:solidFill>
+          <a:ln>
+            <a:noFill/>
+          </a:ln>
+          <a:effectLst/>
+        </p:spPr>
+        <p:style>
+          <a:lnRef idx="1">
+            <a:schemeClr val="accent1"/>
+          </a:lnRef>
+          <a:fillRef idx="3">
+            <a:schemeClr val="accent1"/>
+          </a:fillRef>
+          <a:effectRef idx="2">
+            <a:schemeClr val="accent1"/>
+          </a:effectRef>
+          <a:fontRef idx="minor">
+            <a:schemeClr val="lt1"/>
+          </a:fontRef>
+        </p:style>
+        <p:txBody>
+          <a:bodyPr rtlCol="0" anchor="ctr"/>
+          <a:lstStyle/>
+          <a:p>
+            <a:pPr algn="ctr"/>
+          </a:p>
+        </p:txBody>
+      </p:sp>
+      <p:sp>
+        <p:nvSpPr>
+          <p:cNvPr id="6" name="TextBox 5"/>
+          <p:cNvSpPr txBox="1"/>
+          <p:nvPr/>
+        </p:nvSpPr>
+        <p:spPr>
+          <a:xfrm>
+            <a:off x="1371600" y="4389120"/>
+            <a:ext cx="9445752" cy="914400"/>
+          </a:xfrm>
+          <a:prstGeom prst="rect">
+            <a:avLst/>
+          </a:prstGeom>
+          <a:noFill/>
+        </p:spPr>
+        <p:txBody>
+          <a:bodyPr wrap="square">
+            <a:spAutoFit/>
+          </a:bodyPr>
+          <a:lstStyle/>
+          <a:p>
+            <a:pPr algn="ctr"/>
+            <a:r>
+              <a:rPr sz="1800">
+                <a:solidFill>
+                  <a:srgbClr val="C8D2DE"/>
+                </a:solidFill>
+              </a:rPr>
+              <a:t>What exactly are we predicting, and why is it hard?</a:t>
+            </a:r>
+          </a:p>
         </p:txBody>
       </p:sp>
     </p:spTree>
@@ -8797,8 +9318,8 @@
         </p:nvSpPr>
         <p:spPr>
           <a:xfrm>
-            <a:off x="1371600" y="1463040"/>
-            <a:ext cx="9418320" cy="4937760"/>
+            <a:off x="548640" y="1170432"/>
+            <a:ext cx="11064240" cy="457200"/>
           </a:xfrm>
           <a:prstGeom prst="rect">
             <a:avLst/>
@@ -8806,6 +9327,127 @@
           <a:noFill/>
         </p:spPr>
         <p:txBody>
+          <a:bodyPr wrap="none">
+            <a:spAutoFit/>
+          </a:bodyPr>
+          <a:lstStyle/>
+          <a:p>
+            <a:r>
+              <a:rPr sz="1600" i="1">
+                <a:solidFill>
+                  <a:srgbClr val="1B6EC2"/>
+                </a:solidFill>
+              </a:rPr>
+              <a:t>Input = a set of (BSSID, RSSI); output = (x, y) in metres</a:t>
+            </a:r>
+          </a:p>
+        </p:txBody>
+      </p:sp>
+      <p:sp>
+        <p:nvSpPr>
+          <p:cNvPr id="4" name="Rectangle 3"/>
+          <p:cNvSpPr/>
+          <p:nvPr/>
+        </p:nvSpPr>
+        <p:spPr>
+          <a:xfrm>
+            <a:off x="640080" y="1691640"/>
+            <a:ext cx="10908792" cy="4846320"/>
+          </a:xfrm>
+          <a:prstGeom prst="rect">
+            <a:avLst/>
+          </a:prstGeom>
+          <a:solidFill>
+            <a:srgbClr val="F2F4F7"/>
+          </a:solidFill>
+          <a:ln>
+            <a:noFill/>
+          </a:ln>
+          <a:effectLst/>
+        </p:spPr>
+        <p:style>
+          <a:lnRef idx="1">
+            <a:schemeClr val="accent1"/>
+          </a:lnRef>
+          <a:fillRef idx="3">
+            <a:schemeClr val="accent1"/>
+          </a:fillRef>
+          <a:effectRef idx="2">
+            <a:schemeClr val="accent1"/>
+          </a:effectRef>
+          <a:fontRef idx="minor">
+            <a:schemeClr val="lt1"/>
+          </a:fontRef>
+        </p:style>
+        <p:txBody>
+          <a:bodyPr rtlCol="0" anchor="ctr"/>
+          <a:lstStyle/>
+          <a:p>
+            <a:pPr algn="ctr"/>
+          </a:p>
+        </p:txBody>
+      </p:sp>
+      <p:sp>
+        <p:nvSpPr>
+          <p:cNvPr id="5" name="Rectangle 4"/>
+          <p:cNvSpPr/>
+          <p:nvPr/>
+        </p:nvSpPr>
+        <p:spPr>
+          <a:xfrm>
+            <a:off x="640080" y="1691640"/>
+            <a:ext cx="88900" cy="4846320"/>
+          </a:xfrm>
+          <a:prstGeom prst="rect">
+            <a:avLst/>
+          </a:prstGeom>
+          <a:solidFill>
+            <a:srgbClr val="1B6EC2"/>
+          </a:solidFill>
+          <a:ln>
+            <a:noFill/>
+          </a:ln>
+          <a:effectLst/>
+        </p:spPr>
+        <p:style>
+          <a:lnRef idx="1">
+            <a:schemeClr val="accent1"/>
+          </a:lnRef>
+          <a:fillRef idx="3">
+            <a:schemeClr val="accent1"/>
+          </a:fillRef>
+          <a:effectRef idx="2">
+            <a:schemeClr val="accent1"/>
+          </a:effectRef>
+          <a:fontRef idx="minor">
+            <a:schemeClr val="lt1"/>
+          </a:fontRef>
+        </p:style>
+        <p:txBody>
+          <a:bodyPr rtlCol="0" anchor="ctr"/>
+          <a:lstStyle/>
+          <a:p>
+            <a:pPr algn="ctr"/>
+          </a:p>
+        </p:txBody>
+      </p:sp>
+      <p:sp>
+        <p:nvSpPr>
+          <p:cNvPr id="6" name="TextBox 5"/>
+          <p:cNvSpPr txBox="1"/>
+          <p:nvPr/>
+        </p:nvSpPr>
+        <p:spPr>
+          <a:xfrm>
+            <a:off x="1051560" y="2011680"/>
+            <a:ext cx="10149840" cy="4206240"/>
+          </a:xfrm>
+          <a:prstGeom prst="rect">
+            <a:avLst/>
+          </a:prstGeom>
+          <a:noFill/>
+        </p:spPr>
+        <p:txBody>
           <a:bodyPr wrap="square" anchor="ctr">
             <a:spAutoFit/>
           </a:bodyPr>
@@ -8813,19 +9455,19 @@
           <a:p>
             <a:pPr>
               <a:spcAft>
-                <a:spcPts val="1000"/>
+                <a:spcPts val="1600"/>
               </a:spcAft>
             </a:pPr>
             <a:r>
-              <a:rPr sz="2200" b="1">
+              <a:rPr sz="2600" b="1">
                 <a:solidFill>
                   <a:srgbClr val="1B6EC2"/>
                 </a:solidFill>
               </a:rPr>
-              <a:t>•  </a:t>
-            </a:r>
-            <a:r>
-              <a:rPr sz="2200">
+              <a:t>▪  </a:t>
+            </a:r>
+            <a:r>
+              <a:rPr sz="2600">
                 <a:solidFill>
                   <a:srgbClr val="1F2D3D"/>
                 </a:solidFill>
@@ -8836,19 +9478,19 @@
           <a:p>
             <a:pPr>
               <a:spcAft>
-                <a:spcPts val="1000"/>
+                <a:spcPts val="1600"/>
               </a:spcAft>
             </a:pPr>
             <a:r>
-              <a:rPr sz="2200" b="1">
+              <a:rPr sz="2600" b="1">
                 <a:solidFill>
                   <a:srgbClr val="1B6EC2"/>
                 </a:solidFill>
               </a:rPr>
-              <a:t>•  </a:t>
-            </a:r>
-            <a:r>
-              <a:rPr sz="2200">
+              <a:t>▪  </a:t>
+            </a:r>
+            <a:r>
+              <a:rPr sz="2600">
                 <a:solidFill>
                   <a:srgbClr val="1F2D3D"/>
                 </a:solidFill>
@@ -8859,19 +9501,19 @@
           <a:p>
             <a:pPr>
               <a:spcAft>
-                <a:spcPts val="1000"/>
+                <a:spcPts val="1600"/>
               </a:spcAft>
             </a:pPr>
             <a:r>
-              <a:rPr sz="2200" b="1">
+              <a:rPr sz="2600" b="1">
                 <a:solidFill>
                   <a:srgbClr val="1B6EC2"/>
                 </a:solidFill>
               </a:rPr>
-              <a:t>•  </a:t>
-            </a:r>
-            <a:r>
-              <a:rPr sz="2200">
+              <a:t>▪  </a:t>
+            </a:r>
+            <a:r>
+              <a:rPr sz="2600">
                 <a:solidFill>
                   <a:srgbClr val="1F2D3D"/>
                 </a:solidFill>
@@ -8882,19 +9524,19 @@
           <a:p>
             <a:pPr>
               <a:spcAft>
-                <a:spcPts val="1000"/>
+                <a:spcPts val="1600"/>
               </a:spcAft>
             </a:pPr>
             <a:r>
-              <a:rPr sz="2200" b="1">
+              <a:rPr sz="2600" b="1">
                 <a:solidFill>
                   <a:srgbClr val="1B6EC2"/>
                 </a:solidFill>
               </a:rPr>
-              <a:t>•  </a:t>
-            </a:r>
-            <a:r>
-              <a:rPr sz="2200">
+              <a:t>▪  </a:t>
+            </a:r>
+            <a:r>
+              <a:rPr sz="2600">
                 <a:solidFill>
                   <a:srgbClr val="1F2D3D"/>
                 </a:solidFill>
@@ -8924,14 +9566,58 @@
       <p:grpSpPr/>
       <p:sp>
         <p:nvSpPr>
-          <p:cNvPr id="2" name="TextBox 1"/>
+          <p:cNvPr id="2" name="Rectangle 1"/>
+          <p:cNvSpPr/>
+          <p:nvPr/>
+        </p:nvSpPr>
+        <p:spPr>
+          <a:xfrm>
+            <a:off x="0" y="0"/>
+            <a:ext cx="12191695" cy="6858000"/>
+          </a:xfrm>
+          <a:prstGeom prst="rect">
+            <a:avLst/>
+          </a:prstGeom>
+          <a:solidFill>
+            <a:srgbClr val="1F2D3D"/>
+          </a:solidFill>
+          <a:ln>
+            <a:noFill/>
+          </a:ln>
+          <a:effectLst/>
+        </p:spPr>
+        <p:style>
+          <a:lnRef idx="1">
+            <a:schemeClr val="accent1"/>
+          </a:lnRef>
+          <a:fillRef idx="3">
+            <a:schemeClr val="accent1"/>
+          </a:fillRef>
+          <a:effectRef idx="2">
+            <a:schemeClr val="accent1"/>
+          </a:effectRef>
+          <a:fontRef idx="minor">
+            <a:schemeClr val="lt1"/>
+          </a:fontRef>
+        </p:style>
+        <p:txBody>
+          <a:bodyPr rtlCol="0" anchor="ctr"/>
+          <a:lstStyle/>
+          <a:p>
+            <a:pPr algn="ctr"/>
+          </a:p>
+        </p:txBody>
+      </p:sp>
+      <p:sp>
+        <p:nvSpPr>
+          <p:cNvPr id="3" name="TextBox 2"/>
           <p:cNvSpPr txBox="1"/>
           <p:nvPr/>
         </p:nvSpPr>
         <p:spPr>
           <a:xfrm>
-            <a:off x="457200" y="320040"/>
-            <a:ext cx="11274552" cy="868680"/>
+            <a:off x="822960" y="2331720"/>
+            <a:ext cx="10515600" cy="548640"/>
           </a:xfrm>
           <a:prstGeom prst="rect">
             <a:avLst/>
@@ -8939,32 +9625,33 @@
           <a:noFill/>
         </p:spPr>
         <p:txBody>
-          <a:bodyPr wrap="square">
+          <a:bodyPr wrap="none">
             <a:spAutoFit/>
           </a:bodyPr>
           <a:lstStyle/>
           <a:p>
-            <a:r>
-              <a:rPr sz="2700" b="1">
-                <a:solidFill>
-                  <a:srgbClr val="1F2D3D"/>
-                </a:solidFill>
-              </a:rPr>
-              <a:t>資料集切分 / Dataset &amp; Splits</a:t>
-            </a:r>
-          </a:p>
-        </p:txBody>
-      </p:sp>
-      <p:sp>
-        <p:nvSpPr>
-          <p:cNvPr id="3" name="TextBox 2"/>
+            <a:pPr algn="ctr"/>
+            <a:r>
+              <a:rPr sz="1800" b="1">
+                <a:solidFill>
+                  <a:srgbClr val="6FB7F0"/>
+                </a:solidFill>
+              </a:rPr>
+              <a:t>SECTION 2 / 4</a:t>
+            </a:r>
+          </a:p>
+        </p:txBody>
+      </p:sp>
+      <p:sp>
+        <p:nvSpPr>
+          <p:cNvPr id="4" name="TextBox 3"/>
           <p:cNvSpPr txBox="1"/>
           <p:nvPr/>
         </p:nvSpPr>
         <p:spPr>
           <a:xfrm>
-            <a:off x="1371600" y="1463040"/>
-            <a:ext cx="9418320" cy="4937760"/>
+            <a:off x="731520" y="2788920"/>
+            <a:ext cx="10725912" cy="1371600"/>
           </a:xfrm>
           <a:prstGeom prst="rect">
             <a:avLst/>
@@ -8972,11 +9659,99 @@
           <a:noFill/>
         </p:spPr>
         <p:txBody>
-          <a:bodyPr wrap="square" anchor="ctr">
+          <a:bodyPr wrap="square">
             <a:spAutoFit/>
           </a:bodyPr>
           <a:lstStyle/>
-          <a:p/>
+          <a:p>
+            <a:pPr algn="ctr"/>
+            <a:r>
+              <a:rPr sz="4000" b="1">
+                <a:solidFill>
+                  <a:srgbClr val="FFFFFF"/>
+                </a:solidFill>
+              </a:rPr>
+              <a:t>資料集切分 / Dataset &amp; Splits</a:t>
+            </a:r>
+          </a:p>
+        </p:txBody>
+      </p:sp>
+      <p:sp>
+        <p:nvSpPr>
+          <p:cNvPr id="5" name="Rectangle 4"/>
+          <p:cNvSpPr/>
+          <p:nvPr/>
+        </p:nvSpPr>
+        <p:spPr>
+          <a:xfrm>
+            <a:off x="5184648" y="4160520"/>
+            <a:ext cx="1828800" cy="50800"/>
+          </a:xfrm>
+          <a:prstGeom prst="rect">
+            <a:avLst/>
+          </a:prstGeom>
+          <a:solidFill>
+            <a:srgbClr val="6FB7F0"/>
+          </a:solidFill>
+          <a:ln>
+            <a:noFill/>
+          </a:ln>
+          <a:effectLst/>
+        </p:spPr>
+        <p:style>
+          <a:lnRef idx="1">
+            <a:schemeClr val="accent1"/>
+          </a:lnRef>
+          <a:fillRef idx="3">
+            <a:schemeClr val="accent1"/>
+          </a:fillRef>
+          <a:effectRef idx="2">
+            <a:schemeClr val="accent1"/>
+          </a:effectRef>
+          <a:fontRef idx="minor">
+            <a:schemeClr val="lt1"/>
+          </a:fontRef>
+        </p:style>
+        <p:txBody>
+          <a:bodyPr rtlCol="0" anchor="ctr"/>
+          <a:lstStyle/>
+          <a:p>
+            <a:pPr algn="ctr"/>
+          </a:p>
+        </p:txBody>
+      </p:sp>
+      <p:sp>
+        <p:nvSpPr>
+          <p:cNvPr id="6" name="TextBox 5"/>
+          <p:cNvSpPr txBox="1"/>
+          <p:nvPr/>
+        </p:nvSpPr>
+        <p:spPr>
+          <a:xfrm>
+            <a:off x="1371600" y="4389120"/>
+            <a:ext cx="9445752" cy="914400"/>
+          </a:xfrm>
+          <a:prstGeom prst="rect">
+            <a:avLst/>
+          </a:prstGeom>
+          <a:noFill/>
+        </p:spPr>
+        <p:txBody>
+          <a:bodyPr wrap="square">
+            <a:spAutoFit/>
+          </a:bodyPr>
+          <a:lstStyle/>
+          <a:p>
+            <a:pPr algn="ctr"/>
+            <a:r>
+              <a:rPr sz="1800">
+                <a:solidFill>
+                  <a:srgbClr val="C8D2DE"/>
+                </a:solidFill>
+              </a:rPr>
+              <a:t>1,812 real scans, a coverage hole, and four generalisation stress-tests</a:t>
+            </a:r>
+          </a:p>
         </p:txBody>
       </p:sp>
     </p:spTree>

</xml_diff>

<commit_message>
Update lab3_presentation.pptx with edits made in PowerPoint
Commits the user's saved version of the deck as-is (+277 KB over the generated
build — e.g. live-demo video inserted). Not regenerated from deck_v3.json so the
in-PowerPoint edits are preserved. Also gitignore MS Office ~$ owner-lock files.

Co-Authored-By: Claude Opus 4.8 (1M context) <noreply@anthropic.com>
</commit_message>
<xml_diff>
--- a/lab3/outputs/slides/lab3_presentation.pptx
+++ b/lab3/outputs/slides/lab3_presentation.pptx
@@ -4,42 +4,45 @@
   <p:sldMasterIdLst>
     <p:sldMasterId id="2147483648" r:id="rId1"/>
   </p:sldMasterIdLst>
+  <p:notesMasterIdLst>
+    <p:notesMasterId r:id="rId35"/>
+  </p:notesMasterIdLst>
   <p:sldIdLst>
-    <p:sldId id="256" r:id="rId7"/>
-    <p:sldId id="257" r:id="rId9"/>
-    <p:sldId id="258" r:id="rId10"/>
-    <p:sldId id="259" r:id="rId11"/>
-    <p:sldId id="260" r:id="rId12"/>
-    <p:sldId id="261" r:id="rId13"/>
-    <p:sldId id="262" r:id="rId14"/>
-    <p:sldId id="263" r:id="rId15"/>
-    <p:sldId id="264" r:id="rId16"/>
-    <p:sldId id="265" r:id="rId17"/>
-    <p:sldId id="266" r:id="rId18"/>
-    <p:sldId id="267" r:id="rId19"/>
-    <p:sldId id="268" r:id="rId20"/>
-    <p:sldId id="269" r:id="rId21"/>
-    <p:sldId id="270" r:id="rId22"/>
-    <p:sldId id="271" r:id="rId23"/>
-    <p:sldId id="272" r:id="rId24"/>
-    <p:sldId id="273" r:id="rId25"/>
-    <p:sldId id="274" r:id="rId26"/>
-    <p:sldId id="275" r:id="rId27"/>
-    <p:sldId id="276" r:id="rId28"/>
-    <p:sldId id="277" r:id="rId29"/>
-    <p:sldId id="278" r:id="rId30"/>
-    <p:sldId id="279" r:id="rId31"/>
-    <p:sldId id="280" r:id="rId32"/>
-    <p:sldId id="281" r:id="rId33"/>
-    <p:sldId id="282" r:id="rId34"/>
-    <p:sldId id="283" r:id="rId35"/>
-    <p:sldId id="284" r:id="rId36"/>
-    <p:sldId id="285" r:id="rId37"/>
-    <p:sldId id="286" r:id="rId38"/>
-    <p:sldId id="287" r:id="rId39"/>
-    <p:sldId id="288" r:id="rId40"/>
+    <p:sldId id="256" r:id="rId2"/>
+    <p:sldId id="257" r:id="rId3"/>
+    <p:sldId id="258" r:id="rId4"/>
+    <p:sldId id="259" r:id="rId5"/>
+    <p:sldId id="260" r:id="rId6"/>
+    <p:sldId id="261" r:id="rId7"/>
+    <p:sldId id="262" r:id="rId8"/>
+    <p:sldId id="263" r:id="rId9"/>
+    <p:sldId id="264" r:id="rId10"/>
+    <p:sldId id="265" r:id="rId11"/>
+    <p:sldId id="266" r:id="rId12"/>
+    <p:sldId id="267" r:id="rId13"/>
+    <p:sldId id="268" r:id="rId14"/>
+    <p:sldId id="269" r:id="rId15"/>
+    <p:sldId id="270" r:id="rId16"/>
+    <p:sldId id="271" r:id="rId17"/>
+    <p:sldId id="272" r:id="rId18"/>
+    <p:sldId id="273" r:id="rId19"/>
+    <p:sldId id="274" r:id="rId20"/>
+    <p:sldId id="275" r:id="rId21"/>
+    <p:sldId id="276" r:id="rId22"/>
+    <p:sldId id="277" r:id="rId23"/>
+    <p:sldId id="278" r:id="rId24"/>
+    <p:sldId id="279" r:id="rId25"/>
+    <p:sldId id="280" r:id="rId26"/>
+    <p:sldId id="281" r:id="rId27"/>
+    <p:sldId id="282" r:id="rId28"/>
+    <p:sldId id="283" r:id="rId29"/>
+    <p:sldId id="284" r:id="rId30"/>
+    <p:sldId id="285" r:id="rId31"/>
+    <p:sldId id="286" r:id="rId32"/>
+    <p:sldId id="287" r:id="rId33"/>
+    <p:sldId id="288" r:id="rId34"/>
   </p:sldIdLst>
-  <p:sldSz cx="12191695" cy="6858000" type="screen4x3"/>
+  <p:sldSz cx="12192000" cy="6858000"/>
   <p:notesSz cx="6858000" cy="9144000"/>
   <p:defaultTextStyle>
     <a:defPPr>
@@ -136,11 +139,27 @@
       </a:defRPr>
     </a:lvl9pPr>
   </p:defaultTextStyle>
+  <p:extLst>
+    <p:ext uri="{EFAFB233-063F-42B5-8137-9DF3F51BA10A}">
+      <p15:sldGuideLst xmlns:p15="http://schemas.microsoft.com/office/powerpoint/2012/main">
+        <p15:guide id="1" orient="horz" pos="2160">
+          <p15:clr>
+            <a:srgbClr val="A4A3A4"/>
+          </p15:clr>
+        </p15:guide>
+        <p15:guide id="2" pos="2880">
+          <p15:clr>
+            <a:srgbClr val="A4A3A4"/>
+          </p15:clr>
+        </p15:guide>
+      </p15:sldGuideLst>
+    </p:ext>
+  </p:extLst>
 </p:presentation>
 </file>
 
 <file path=ppt/notesMasters/notesMaster1.xml><?xml version="1.0" encoding="utf-8"?>
-<p:notesMaster xmlns:a="http://schemas.openxmlformats.org/drawingml/2006/main" xmlns:p="http://schemas.openxmlformats.org/presentationml/2006/main" xmlns:r="http://schemas.openxmlformats.org/officeDocument/2006/relationships">
+<p:notesMaster xmlns:a="http://schemas.openxmlformats.org/drawingml/2006/main" xmlns:r="http://schemas.openxmlformats.org/officeDocument/2006/relationships" xmlns:p="http://schemas.openxmlformats.org/presentationml/2006/main">
   <p:cSld>
     <p:bg>
       <p:bgRef idx="1001">
@@ -161,241 +180,16 @@
           <a:chExt cx="0" cy="0"/>
         </a:xfrm>
       </p:grpSpPr>
-      <p:sp>
-        <p:nvSpPr>
-          <p:cNvPr id="2" name="Header Placeholder 1"/>
-          <p:cNvSpPr>
-            <a:spLocks noGrp="1"/>
-          </p:cNvSpPr>
-          <p:nvPr>
-            <p:ph type="hdr" sz="quarter"/>
-          </p:nvPr>
-        </p:nvSpPr>
-        <p:spPr>
-          <a:xfrm>
-            <a:off x="0" y="0"/>
-            <a:ext cx="2971800" cy="457200"/>
-          </a:xfrm>
-          <a:prstGeom prst="rect">
-            <a:avLst/>
-          </a:prstGeom>
-        </p:spPr>
-        <p:txBody>
-          <a:bodyPr vert="horz" lIns="91440" tIns="45720" rIns="91440" bIns="45720" rtlCol="0"/>
-          <a:lstStyle>
-            <a:lvl1pPr algn="l">
-              <a:defRPr sz="1200"/>
-            </a:lvl1pPr>
-          </a:lstStyle>
-          <a:p>
-            <a:endParaRPr lang="en-US"/>
-          </a:p>
-        </p:txBody>
-      </p:sp>
-      <p:sp>
-        <p:nvSpPr>
-          <p:cNvPr id="3" name="Date Placeholder 2"/>
-          <p:cNvSpPr>
-            <a:spLocks noGrp="1"/>
-          </p:cNvSpPr>
-          <p:nvPr>
-            <p:ph type="dt" idx="1"/>
-          </p:nvPr>
-        </p:nvSpPr>
-        <p:spPr>
-          <a:xfrm>
-            <a:off x="3884613" y="0"/>
-            <a:ext cx="2971800" cy="457200"/>
-          </a:xfrm>
-          <a:prstGeom prst="rect">
-            <a:avLst/>
-          </a:prstGeom>
-        </p:spPr>
-        <p:txBody>
-          <a:bodyPr vert="horz" lIns="91440" tIns="45720" rIns="91440" bIns="45720" rtlCol="0"/>
-          <a:lstStyle>
-            <a:lvl1pPr algn="r">
-              <a:defRPr sz="1200"/>
-            </a:lvl1pPr>
-          </a:lstStyle>
-          <a:p>
-            <a:fld id="{0F89C1C7-3DCD-1040-A9CF-14679D8B5DDD}" type="datetimeFigureOut">
-              <a:rPr lang="en-US" smtClean="0"/>
-              <a:t>10/17/16</a:t>
-            </a:fld>
-            <a:endParaRPr lang="en-US"/>
-          </a:p>
-        </p:txBody>
-      </p:sp>
-      <p:sp>
-        <p:nvSpPr>
-          <p:cNvPr id="4" name="Slide Image Placeholder 3"/>
-          <p:cNvSpPr>
-            <a:spLocks noGrp="1" noRot="1" noChangeAspect="1"/>
-          </p:cNvSpPr>
-          <p:nvPr>
-            <p:ph type="sldImg" idx="2"/>
-          </p:nvPr>
-        </p:nvSpPr>
-        <p:spPr>
-          <a:xfrm>
-            <a:off x="1143000" y="685800"/>
-            <a:ext cx="4572000" cy="3429000"/>
-          </a:xfrm>
-          <a:prstGeom prst="rect">
-            <a:avLst/>
-          </a:prstGeom>
-          <a:noFill/>
-          <a:ln w="12700">
-            <a:solidFill>
-              <a:prstClr val="black"/>
-            </a:solidFill>
-          </a:ln>
-        </p:spPr>
-        <p:txBody>
-          <a:bodyPr vert="horz" lIns="91440" tIns="45720" rIns="91440" bIns="45720" rtlCol="0" anchor="ctr"/>
-          <a:lstStyle/>
-          <a:p>
-            <a:endParaRPr lang="en-US"/>
-          </a:p>
-        </p:txBody>
-      </p:sp>
-      <p:sp>
-        <p:nvSpPr>
-          <p:cNvPr id="5" name="Notes Placeholder 4"/>
-          <p:cNvSpPr>
-            <a:spLocks noGrp="1"/>
-          </p:cNvSpPr>
-          <p:nvPr>
-            <p:ph type="body" sz="quarter" idx="3"/>
-          </p:nvPr>
-        </p:nvSpPr>
-        <p:spPr>
-          <a:xfrm>
-            <a:off x="685800" y="4343400"/>
-            <a:ext cx="5486400" cy="4114800"/>
-          </a:xfrm>
-          <a:prstGeom prst="rect">
-            <a:avLst/>
-          </a:prstGeom>
-        </p:spPr>
-        <p:txBody>
-          <a:bodyPr vert="horz" lIns="91440" tIns="45720" rIns="91440" bIns="45720" rtlCol="0"/>
-          <a:lstStyle/>
-          <a:p>
-            <a:pPr lvl="0"/>
-            <a:r>
-              <a:rPr lang="en-US" smtClean="0"/>
-              <a:t>Click to edit Master text styles</a:t>
-            </a:r>
-          </a:p>
-          <a:p>
-            <a:pPr lvl="1"/>
-            <a:r>
-              <a:rPr lang="en-US" smtClean="0"/>
-              <a:t>Second level</a:t>
-            </a:r>
-          </a:p>
-          <a:p>
-            <a:pPr lvl="2"/>
-            <a:r>
-              <a:rPr lang="en-US" smtClean="0"/>
-              <a:t>Third level</a:t>
-            </a:r>
-          </a:p>
-          <a:p>
-            <a:pPr lvl="3"/>
-            <a:r>
-              <a:rPr lang="en-US" smtClean="0"/>
-              <a:t>Fourth level</a:t>
-            </a:r>
-          </a:p>
-          <a:p>
-            <a:pPr lvl="4"/>
-            <a:r>
-              <a:rPr lang="en-US" smtClean="0"/>
-              <a:t>Fifth level</a:t>
-            </a:r>
-            <a:endParaRPr lang="en-US"/>
-          </a:p>
-        </p:txBody>
-      </p:sp>
-      <p:sp>
-        <p:nvSpPr>
-          <p:cNvPr id="6" name="Footer Placeholder 5"/>
-          <p:cNvSpPr>
-            <a:spLocks noGrp="1"/>
-          </p:cNvSpPr>
-          <p:nvPr>
-            <p:ph type="ftr" sz="quarter" idx="4"/>
-          </p:nvPr>
-        </p:nvSpPr>
-        <p:spPr>
-          <a:xfrm>
-            <a:off x="0" y="8685213"/>
-            <a:ext cx="2971800" cy="457200"/>
-          </a:xfrm>
-          <a:prstGeom prst="rect">
-            <a:avLst/>
-          </a:prstGeom>
-        </p:spPr>
-        <p:txBody>
-          <a:bodyPr vert="horz" lIns="91440" tIns="45720" rIns="91440" bIns="45720" rtlCol="0" anchor="b"/>
-          <a:lstStyle>
-            <a:lvl1pPr algn="l">
-              <a:defRPr sz="1200"/>
-            </a:lvl1pPr>
-          </a:lstStyle>
-          <a:p>
-            <a:endParaRPr lang="en-US"/>
-          </a:p>
-        </p:txBody>
-      </p:sp>
-      <p:sp>
-        <p:nvSpPr>
-          <p:cNvPr id="7" name="Slide Number Placeholder 6"/>
-          <p:cNvSpPr>
-            <a:spLocks noGrp="1"/>
-          </p:cNvSpPr>
-          <p:nvPr>
-            <p:ph type="sldNum" sz="quarter" idx="5"/>
-          </p:nvPr>
-        </p:nvSpPr>
-        <p:spPr>
-          <a:xfrm>
-            <a:off x="3884613" y="8685213"/>
-            <a:ext cx="2971800" cy="457200"/>
-          </a:xfrm>
-          <a:prstGeom prst="rect">
-            <a:avLst/>
-          </a:prstGeom>
-        </p:spPr>
-        <p:txBody>
-          <a:bodyPr vert="horz" lIns="91440" tIns="45720" rIns="91440" bIns="45720" rtlCol="0" anchor="b"/>
-          <a:lstStyle>
-            <a:lvl1pPr algn="r">
-              <a:defRPr sz="1200"/>
-            </a:lvl1pPr>
-          </a:lstStyle>
-          <a:p>
-            <a:fld id="{BB5E49A5-4136-284D-997B-48E1D791AD67}" type="slidenum">
-              <a:rPr lang="en-US" smtClean="0"/>
-              <a:t>‹#›</a:t>
-            </a:fld>
-            <a:endParaRPr lang="en-US"/>
-          </a:p>
-        </p:txBody>
-      </p:sp>
     </p:spTree>
     <p:extLst>
       <p:ext uri="{BB962C8B-B14F-4D97-AF65-F5344CB8AC3E}">
-        <p14:creationId xmlns:p14="http://schemas.microsoft.com/office/powerpoint/2010/main" val="2623252185"/>
+        <p14:creationId xmlns:p14="http://schemas.microsoft.com/office/powerpoint/2010/main" val="396566436"/>
       </p:ext>
     </p:extLst>
   </p:cSld>
   <p:clrMap bg1="lt1" tx1="dk1" bg2="lt2" tx2="dk2" accent1="accent1" accent2="accent2" accent3="accent3" accent4="accent4" accent5="accent5" accent6="accent6" hlink="hlink" folHlink="folHlink"/>
   <p:notesStyle>
-    <a:lvl1pPr marL="0" algn="l" defTabSz="457200" rtl="0" eaLnBrk="1" latinLnBrk="0" hangingPunct="1">
+    <a:lvl1pPr marL="0" algn="l" defTabSz="914400" rtl="0" eaLnBrk="1" latinLnBrk="0" hangingPunct="1">
       <a:defRPr sz="1200" kern="1200">
         <a:solidFill>
           <a:schemeClr val="tx1"/>
@@ -405,7 +199,7 @@
         <a:cs typeface="+mn-cs"/>
       </a:defRPr>
     </a:lvl1pPr>
-    <a:lvl2pPr marL="457200" algn="l" defTabSz="457200" rtl="0" eaLnBrk="1" latinLnBrk="0" hangingPunct="1">
+    <a:lvl2pPr marL="457200" algn="l" defTabSz="914400" rtl="0" eaLnBrk="1" latinLnBrk="0" hangingPunct="1">
       <a:defRPr sz="1200" kern="1200">
         <a:solidFill>
           <a:schemeClr val="tx1"/>
@@ -415,7 +209,7 @@
         <a:cs typeface="+mn-cs"/>
       </a:defRPr>
     </a:lvl2pPr>
-    <a:lvl3pPr marL="914400" algn="l" defTabSz="457200" rtl="0" eaLnBrk="1" latinLnBrk="0" hangingPunct="1">
+    <a:lvl3pPr marL="914400" algn="l" defTabSz="914400" rtl="0" eaLnBrk="1" latinLnBrk="0" hangingPunct="1">
       <a:defRPr sz="1200" kern="1200">
         <a:solidFill>
           <a:schemeClr val="tx1"/>
@@ -425,7 +219,7 @@
         <a:cs typeface="+mn-cs"/>
       </a:defRPr>
     </a:lvl3pPr>
-    <a:lvl4pPr marL="1371600" algn="l" defTabSz="457200" rtl="0" eaLnBrk="1" latinLnBrk="0" hangingPunct="1">
+    <a:lvl4pPr marL="1371600" algn="l" defTabSz="914400" rtl="0" eaLnBrk="1" latinLnBrk="0" hangingPunct="1">
       <a:defRPr sz="1200" kern="1200">
         <a:solidFill>
           <a:schemeClr val="tx1"/>
@@ -435,7 +229,7 @@
         <a:cs typeface="+mn-cs"/>
       </a:defRPr>
     </a:lvl4pPr>
-    <a:lvl5pPr marL="1828800" algn="l" defTabSz="457200" rtl="0" eaLnBrk="1" latinLnBrk="0" hangingPunct="1">
+    <a:lvl5pPr marL="1828800" algn="l" defTabSz="914400" rtl="0" eaLnBrk="1" latinLnBrk="0" hangingPunct="1">
       <a:defRPr sz="1200" kern="1200">
         <a:solidFill>
           <a:schemeClr val="tx1"/>
@@ -445,7 +239,7 @@
         <a:cs typeface="+mn-cs"/>
       </a:defRPr>
     </a:lvl5pPr>
-    <a:lvl6pPr marL="2286000" algn="l" defTabSz="457200" rtl="0" eaLnBrk="1" latinLnBrk="0" hangingPunct="1">
+    <a:lvl6pPr marL="2286000" algn="l" defTabSz="914400" rtl="0" eaLnBrk="1" latinLnBrk="0" hangingPunct="1">
       <a:defRPr sz="1200" kern="1200">
         <a:solidFill>
           <a:schemeClr val="tx1"/>
@@ -455,7 +249,7 @@
         <a:cs typeface="+mn-cs"/>
       </a:defRPr>
     </a:lvl6pPr>
-    <a:lvl7pPr marL="2743200" algn="l" defTabSz="457200" rtl="0" eaLnBrk="1" latinLnBrk="0" hangingPunct="1">
+    <a:lvl7pPr marL="2743200" algn="l" defTabSz="914400" rtl="0" eaLnBrk="1" latinLnBrk="0" hangingPunct="1">
       <a:defRPr sz="1200" kern="1200">
         <a:solidFill>
           <a:schemeClr val="tx1"/>
@@ -465,7 +259,7 @@
         <a:cs typeface="+mn-cs"/>
       </a:defRPr>
     </a:lvl7pPr>
-    <a:lvl8pPr marL="3200400" algn="l" defTabSz="457200" rtl="0" eaLnBrk="1" latinLnBrk="0" hangingPunct="1">
+    <a:lvl8pPr marL="3200400" algn="l" defTabSz="914400" rtl="0" eaLnBrk="1" latinLnBrk="0" hangingPunct="1">
       <a:defRPr sz="1200" kern="1200">
         <a:solidFill>
           <a:schemeClr val="tx1"/>
@@ -475,7 +269,7 @@
         <a:cs typeface="+mn-cs"/>
       </a:defRPr>
     </a:lvl8pPr>
-    <a:lvl9pPr marL="3657600" algn="l" defTabSz="457200" rtl="0" eaLnBrk="1" latinLnBrk="0" hangingPunct="1">
+    <a:lvl9pPr marL="3657600" algn="l" defTabSz="914400" rtl="0" eaLnBrk="1" latinLnBrk="0" hangingPunct="1">
       <a:defRPr sz="1200" kern="1200">
         <a:solidFill>
           <a:schemeClr val="tx1"/>
@@ -490,7 +284,7 @@
 </file>
 
 <file path=ppt/notesSlides/notesSlide1.xml><?xml version="1.0" encoding="utf-8"?>
-<p:notes xmlns:a="http://schemas.openxmlformats.org/drawingml/2006/main" xmlns:p="http://schemas.openxmlformats.org/presentationml/2006/main" xmlns:r="http://schemas.openxmlformats.org/officeDocument/2006/relationships">
+<p:notes xmlns:a="http://schemas.openxmlformats.org/drawingml/2006/main" xmlns:r="http://schemas.openxmlformats.org/officeDocument/2006/relationships" xmlns:p="http://schemas.openxmlformats.org/presentationml/2006/main">
   <p:cSld>
     <p:spTree>
       <p:nvGrpSpPr>
@@ -510,7 +304,7 @@
         <p:nvSpPr>
           <p:cNvPr id="2" name="Slide Image Placeholder 1"/>
           <p:cNvSpPr>
-            <a:spLocks noGrp="1"/>
+            <a:spLocks noGrp="1" noRot="1" noChangeAspect="1"/>
           </p:cNvSpPr>
           <p:nvPr>
             <p:ph type="sldImg" idx="2"/>
@@ -525,7 +319,7 @@
             <a:spLocks noGrp="1"/>
           </p:cNvSpPr>
           <p:nvPr>
-            <p:ph type="body" idx="3" sz="quarter"/>
+            <p:ph type="body" sz="quarter" idx="3"/>
           </p:nvPr>
         </p:nvSpPr>
         <p:spPr/>
@@ -546,7 +340,7 @@
             <a:spLocks noGrp="1"/>
           </p:cNvSpPr>
           <p:nvPr>
-            <p:ph type="sldNum" idx="5" sz="quarter"/>
+            <p:ph type="sldNum" sz="quarter" idx="5"/>
           </p:nvPr>
         </p:nvSpPr>
         <p:spPr/>
@@ -560,7 +354,7 @@
 </file>
 
 <file path=ppt/notesSlides/notesSlide10.xml><?xml version="1.0" encoding="utf-8"?>
-<p:notes xmlns:a="http://schemas.openxmlformats.org/drawingml/2006/main" xmlns:p="http://schemas.openxmlformats.org/presentationml/2006/main" xmlns:r="http://schemas.openxmlformats.org/officeDocument/2006/relationships">
+<p:notes xmlns:a="http://schemas.openxmlformats.org/drawingml/2006/main" xmlns:r="http://schemas.openxmlformats.org/officeDocument/2006/relationships" xmlns:p="http://schemas.openxmlformats.org/presentationml/2006/main">
   <p:cSld>
     <p:spTree>
       <p:nvGrpSpPr>
@@ -580,7 +374,7 @@
         <p:nvSpPr>
           <p:cNvPr id="2" name="Slide Image Placeholder 1"/>
           <p:cNvSpPr>
-            <a:spLocks noGrp="1"/>
+            <a:spLocks noGrp="1" noRot="1" noChangeAspect="1"/>
           </p:cNvSpPr>
           <p:nvPr>
             <p:ph type="sldImg" idx="2"/>
@@ -595,7 +389,7 @@
             <a:spLocks noGrp="1"/>
           </p:cNvSpPr>
           <p:nvPr>
-            <p:ph type="body" idx="3" sz="quarter"/>
+            <p:ph type="body" sz="quarter" idx="3"/>
           </p:nvPr>
         </p:nvSpPr>
         <p:spPr/>
@@ -616,7 +410,7 @@
             <a:spLocks noGrp="1"/>
           </p:cNvSpPr>
           <p:nvPr>
-            <p:ph type="sldNum" idx="5" sz="quarter"/>
+            <p:ph type="sldNum" sz="quarter" idx="5"/>
           </p:nvPr>
         </p:nvSpPr>
         <p:spPr/>
@@ -630,7 +424,7 @@
 </file>
 
 <file path=ppt/notesSlides/notesSlide11.xml><?xml version="1.0" encoding="utf-8"?>
-<p:notes xmlns:a="http://schemas.openxmlformats.org/drawingml/2006/main" xmlns:p="http://schemas.openxmlformats.org/presentationml/2006/main" xmlns:r="http://schemas.openxmlformats.org/officeDocument/2006/relationships">
+<p:notes xmlns:a="http://schemas.openxmlformats.org/drawingml/2006/main" xmlns:r="http://schemas.openxmlformats.org/officeDocument/2006/relationships" xmlns:p="http://schemas.openxmlformats.org/presentationml/2006/main">
   <p:cSld>
     <p:spTree>
       <p:nvGrpSpPr>
@@ -650,7 +444,7 @@
         <p:nvSpPr>
           <p:cNvPr id="2" name="Slide Image Placeholder 1"/>
           <p:cNvSpPr>
-            <a:spLocks noGrp="1"/>
+            <a:spLocks noGrp="1" noRot="1" noChangeAspect="1"/>
           </p:cNvSpPr>
           <p:nvPr>
             <p:ph type="sldImg" idx="2"/>
@@ -665,7 +459,7 @@
             <a:spLocks noGrp="1"/>
           </p:cNvSpPr>
           <p:nvPr>
-            <p:ph type="body" idx="3" sz="quarter"/>
+            <p:ph type="body" sz="quarter" idx="3"/>
           </p:nvPr>
         </p:nvSpPr>
         <p:spPr/>
@@ -686,7 +480,7 @@
             <a:spLocks noGrp="1"/>
           </p:cNvSpPr>
           <p:nvPr>
-            <p:ph type="sldNum" idx="5" sz="quarter"/>
+            <p:ph type="sldNum" sz="quarter" idx="5"/>
           </p:nvPr>
         </p:nvSpPr>
         <p:spPr/>
@@ -700,7 +494,7 @@
 </file>
 
 <file path=ppt/notesSlides/notesSlide12.xml><?xml version="1.0" encoding="utf-8"?>
-<p:notes xmlns:a="http://schemas.openxmlformats.org/drawingml/2006/main" xmlns:p="http://schemas.openxmlformats.org/presentationml/2006/main" xmlns:r="http://schemas.openxmlformats.org/officeDocument/2006/relationships">
+<p:notes xmlns:a="http://schemas.openxmlformats.org/drawingml/2006/main" xmlns:r="http://schemas.openxmlformats.org/officeDocument/2006/relationships" xmlns:p="http://schemas.openxmlformats.org/presentationml/2006/main">
   <p:cSld>
     <p:spTree>
       <p:nvGrpSpPr>
@@ -720,7 +514,7 @@
         <p:nvSpPr>
           <p:cNvPr id="2" name="Slide Image Placeholder 1"/>
           <p:cNvSpPr>
-            <a:spLocks noGrp="1"/>
+            <a:spLocks noGrp="1" noRot="1" noChangeAspect="1"/>
           </p:cNvSpPr>
           <p:nvPr>
             <p:ph type="sldImg" idx="2"/>
@@ -735,7 +529,7 @@
             <a:spLocks noGrp="1"/>
           </p:cNvSpPr>
           <p:nvPr>
-            <p:ph type="body" idx="3" sz="quarter"/>
+            <p:ph type="body" sz="quarter" idx="3"/>
           </p:nvPr>
         </p:nvSpPr>
         <p:spPr/>
@@ -756,7 +550,7 @@
             <a:spLocks noGrp="1"/>
           </p:cNvSpPr>
           <p:nvPr>
-            <p:ph type="sldNum" idx="5" sz="quarter"/>
+            <p:ph type="sldNum" sz="quarter" idx="5"/>
           </p:nvPr>
         </p:nvSpPr>
         <p:spPr/>
@@ -770,7 +564,7 @@
 </file>
 
 <file path=ppt/notesSlides/notesSlide13.xml><?xml version="1.0" encoding="utf-8"?>
-<p:notes xmlns:a="http://schemas.openxmlformats.org/drawingml/2006/main" xmlns:p="http://schemas.openxmlformats.org/presentationml/2006/main" xmlns:r="http://schemas.openxmlformats.org/officeDocument/2006/relationships">
+<p:notes xmlns:a="http://schemas.openxmlformats.org/drawingml/2006/main" xmlns:r="http://schemas.openxmlformats.org/officeDocument/2006/relationships" xmlns:p="http://schemas.openxmlformats.org/presentationml/2006/main">
   <p:cSld>
     <p:spTree>
       <p:nvGrpSpPr>
@@ -790,7 +584,7 @@
         <p:nvSpPr>
           <p:cNvPr id="2" name="Slide Image Placeholder 1"/>
           <p:cNvSpPr>
-            <a:spLocks noGrp="1"/>
+            <a:spLocks noGrp="1" noRot="1" noChangeAspect="1"/>
           </p:cNvSpPr>
           <p:nvPr>
             <p:ph type="sldImg" idx="2"/>
@@ -805,7 +599,7 @@
             <a:spLocks noGrp="1"/>
           </p:cNvSpPr>
           <p:nvPr>
-            <p:ph type="body" idx="3" sz="quarter"/>
+            <p:ph type="body" sz="quarter" idx="3"/>
           </p:nvPr>
         </p:nvSpPr>
         <p:spPr/>
@@ -826,7 +620,7 @@
             <a:spLocks noGrp="1"/>
           </p:cNvSpPr>
           <p:nvPr>
-            <p:ph type="sldNum" idx="5" sz="quarter"/>
+            <p:ph type="sldNum" sz="quarter" idx="5"/>
           </p:nvPr>
         </p:nvSpPr>
         <p:spPr/>
@@ -840,7 +634,7 @@
 </file>
 
 <file path=ppt/notesSlides/notesSlide14.xml><?xml version="1.0" encoding="utf-8"?>
-<p:notes xmlns:a="http://schemas.openxmlformats.org/drawingml/2006/main" xmlns:p="http://schemas.openxmlformats.org/presentationml/2006/main" xmlns:r="http://schemas.openxmlformats.org/officeDocument/2006/relationships">
+<p:notes xmlns:a="http://schemas.openxmlformats.org/drawingml/2006/main" xmlns:r="http://schemas.openxmlformats.org/officeDocument/2006/relationships" xmlns:p="http://schemas.openxmlformats.org/presentationml/2006/main">
   <p:cSld>
     <p:spTree>
       <p:nvGrpSpPr>
@@ -860,7 +654,7 @@
         <p:nvSpPr>
           <p:cNvPr id="2" name="Slide Image Placeholder 1"/>
           <p:cNvSpPr>
-            <a:spLocks noGrp="1"/>
+            <a:spLocks noGrp="1" noRot="1" noChangeAspect="1"/>
           </p:cNvSpPr>
           <p:nvPr>
             <p:ph type="sldImg" idx="2"/>
@@ -875,7 +669,7 @@
             <a:spLocks noGrp="1"/>
           </p:cNvSpPr>
           <p:nvPr>
-            <p:ph type="body" idx="3" sz="quarter"/>
+            <p:ph type="body" sz="quarter" idx="3"/>
           </p:nvPr>
         </p:nvSpPr>
         <p:spPr/>
@@ -896,7 +690,7 @@
             <a:spLocks noGrp="1"/>
           </p:cNvSpPr>
           <p:nvPr>
-            <p:ph type="sldNum" idx="5" sz="quarter"/>
+            <p:ph type="sldNum" sz="quarter" idx="5"/>
           </p:nvPr>
         </p:nvSpPr>
         <p:spPr/>
@@ -910,7 +704,7 @@
 </file>
 
 <file path=ppt/notesSlides/notesSlide15.xml><?xml version="1.0" encoding="utf-8"?>
-<p:notes xmlns:a="http://schemas.openxmlformats.org/drawingml/2006/main" xmlns:p="http://schemas.openxmlformats.org/presentationml/2006/main" xmlns:r="http://schemas.openxmlformats.org/officeDocument/2006/relationships">
+<p:notes xmlns:a="http://schemas.openxmlformats.org/drawingml/2006/main" xmlns:r="http://schemas.openxmlformats.org/officeDocument/2006/relationships" xmlns:p="http://schemas.openxmlformats.org/presentationml/2006/main">
   <p:cSld>
     <p:spTree>
       <p:nvGrpSpPr>
@@ -930,7 +724,7 @@
         <p:nvSpPr>
           <p:cNvPr id="2" name="Slide Image Placeholder 1"/>
           <p:cNvSpPr>
-            <a:spLocks noGrp="1"/>
+            <a:spLocks noGrp="1" noRot="1" noChangeAspect="1"/>
           </p:cNvSpPr>
           <p:nvPr>
             <p:ph type="sldImg" idx="2"/>
@@ -945,7 +739,7 @@
             <a:spLocks noGrp="1"/>
           </p:cNvSpPr>
           <p:nvPr>
-            <p:ph type="body" idx="3" sz="quarter"/>
+            <p:ph type="body" sz="quarter" idx="3"/>
           </p:nvPr>
         </p:nvSpPr>
         <p:spPr/>
@@ -966,7 +760,7 @@
             <a:spLocks noGrp="1"/>
           </p:cNvSpPr>
           <p:nvPr>
-            <p:ph type="sldNum" idx="5" sz="quarter"/>
+            <p:ph type="sldNum" sz="quarter" idx="5"/>
           </p:nvPr>
         </p:nvSpPr>
         <p:spPr/>
@@ -980,7 +774,7 @@
 </file>
 
 <file path=ppt/notesSlides/notesSlide16.xml><?xml version="1.0" encoding="utf-8"?>
-<p:notes xmlns:a="http://schemas.openxmlformats.org/drawingml/2006/main" xmlns:p="http://schemas.openxmlformats.org/presentationml/2006/main" xmlns:r="http://schemas.openxmlformats.org/officeDocument/2006/relationships">
+<p:notes xmlns:a="http://schemas.openxmlformats.org/drawingml/2006/main" xmlns:r="http://schemas.openxmlformats.org/officeDocument/2006/relationships" xmlns:p="http://schemas.openxmlformats.org/presentationml/2006/main">
   <p:cSld>
     <p:spTree>
       <p:nvGrpSpPr>
@@ -1000,7 +794,7 @@
         <p:nvSpPr>
           <p:cNvPr id="2" name="Slide Image Placeholder 1"/>
           <p:cNvSpPr>
-            <a:spLocks noGrp="1"/>
+            <a:spLocks noGrp="1" noRot="1" noChangeAspect="1"/>
           </p:cNvSpPr>
           <p:nvPr>
             <p:ph type="sldImg" idx="2"/>
@@ -1015,7 +809,7 @@
             <a:spLocks noGrp="1"/>
           </p:cNvSpPr>
           <p:nvPr>
-            <p:ph type="body" idx="3" sz="quarter"/>
+            <p:ph type="body" sz="quarter" idx="3"/>
           </p:nvPr>
         </p:nvSpPr>
         <p:spPr/>
@@ -1036,7 +830,7 @@
             <a:spLocks noGrp="1"/>
           </p:cNvSpPr>
           <p:nvPr>
-            <p:ph type="sldNum" idx="5" sz="quarter"/>
+            <p:ph type="sldNum" sz="quarter" idx="5"/>
           </p:nvPr>
         </p:nvSpPr>
         <p:spPr/>
@@ -1050,7 +844,7 @@
 </file>
 
 <file path=ppt/notesSlides/notesSlide17.xml><?xml version="1.0" encoding="utf-8"?>
-<p:notes xmlns:a="http://schemas.openxmlformats.org/drawingml/2006/main" xmlns:p="http://schemas.openxmlformats.org/presentationml/2006/main" xmlns:r="http://schemas.openxmlformats.org/officeDocument/2006/relationships">
+<p:notes xmlns:a="http://schemas.openxmlformats.org/drawingml/2006/main" xmlns:r="http://schemas.openxmlformats.org/officeDocument/2006/relationships" xmlns:p="http://schemas.openxmlformats.org/presentationml/2006/main">
   <p:cSld>
     <p:spTree>
       <p:nvGrpSpPr>
@@ -1070,7 +864,7 @@
         <p:nvSpPr>
           <p:cNvPr id="2" name="Slide Image Placeholder 1"/>
           <p:cNvSpPr>
-            <a:spLocks noGrp="1"/>
+            <a:spLocks noGrp="1" noRot="1" noChangeAspect="1"/>
           </p:cNvSpPr>
           <p:nvPr>
             <p:ph type="sldImg" idx="2"/>
@@ -1085,7 +879,7 @@
             <a:spLocks noGrp="1"/>
           </p:cNvSpPr>
           <p:nvPr>
-            <p:ph type="body" idx="3" sz="quarter"/>
+            <p:ph type="body" sz="quarter" idx="3"/>
           </p:nvPr>
         </p:nvSpPr>
         <p:spPr/>
@@ -1106,7 +900,7 @@
             <a:spLocks noGrp="1"/>
           </p:cNvSpPr>
           <p:nvPr>
-            <p:ph type="sldNum" idx="5" sz="quarter"/>
+            <p:ph type="sldNum" sz="quarter" idx="5"/>
           </p:nvPr>
         </p:nvSpPr>
         <p:spPr/>
@@ -1120,7 +914,7 @@
 </file>
 
 <file path=ppt/notesSlides/notesSlide18.xml><?xml version="1.0" encoding="utf-8"?>
-<p:notes xmlns:a="http://schemas.openxmlformats.org/drawingml/2006/main" xmlns:p="http://schemas.openxmlformats.org/presentationml/2006/main" xmlns:r="http://schemas.openxmlformats.org/officeDocument/2006/relationships">
+<p:notes xmlns:a="http://schemas.openxmlformats.org/drawingml/2006/main" xmlns:r="http://schemas.openxmlformats.org/officeDocument/2006/relationships" xmlns:p="http://schemas.openxmlformats.org/presentationml/2006/main">
   <p:cSld>
     <p:spTree>
       <p:nvGrpSpPr>
@@ -1140,7 +934,7 @@
         <p:nvSpPr>
           <p:cNvPr id="2" name="Slide Image Placeholder 1"/>
           <p:cNvSpPr>
-            <a:spLocks noGrp="1"/>
+            <a:spLocks noGrp="1" noRot="1" noChangeAspect="1"/>
           </p:cNvSpPr>
           <p:nvPr>
             <p:ph type="sldImg" idx="2"/>
@@ -1155,7 +949,7 @@
             <a:spLocks noGrp="1"/>
           </p:cNvSpPr>
           <p:nvPr>
-            <p:ph type="body" idx="3" sz="quarter"/>
+            <p:ph type="body" sz="quarter" idx="3"/>
           </p:nvPr>
         </p:nvSpPr>
         <p:spPr/>
@@ -1176,7 +970,7 @@
             <a:spLocks noGrp="1"/>
           </p:cNvSpPr>
           <p:nvPr>
-            <p:ph type="sldNum" idx="5" sz="quarter"/>
+            <p:ph type="sldNum" sz="quarter" idx="5"/>
           </p:nvPr>
         </p:nvSpPr>
         <p:spPr/>
@@ -1190,7 +984,7 @@
 </file>
 
 <file path=ppt/notesSlides/notesSlide19.xml><?xml version="1.0" encoding="utf-8"?>
-<p:notes xmlns:a="http://schemas.openxmlformats.org/drawingml/2006/main" xmlns:p="http://schemas.openxmlformats.org/presentationml/2006/main" xmlns:r="http://schemas.openxmlformats.org/officeDocument/2006/relationships">
+<p:notes xmlns:a="http://schemas.openxmlformats.org/drawingml/2006/main" xmlns:r="http://schemas.openxmlformats.org/officeDocument/2006/relationships" xmlns:p="http://schemas.openxmlformats.org/presentationml/2006/main">
   <p:cSld>
     <p:spTree>
       <p:nvGrpSpPr>
@@ -1210,7 +1004,7 @@
         <p:nvSpPr>
           <p:cNvPr id="2" name="Slide Image Placeholder 1"/>
           <p:cNvSpPr>
-            <a:spLocks noGrp="1"/>
+            <a:spLocks noGrp="1" noRot="1" noChangeAspect="1"/>
           </p:cNvSpPr>
           <p:nvPr>
             <p:ph type="sldImg" idx="2"/>
@@ -1225,7 +1019,7 @@
             <a:spLocks noGrp="1"/>
           </p:cNvSpPr>
           <p:nvPr>
-            <p:ph type="body" idx="3" sz="quarter"/>
+            <p:ph type="body" sz="quarter" idx="3"/>
           </p:nvPr>
         </p:nvSpPr>
         <p:spPr/>
@@ -1246,7 +1040,7 @@
             <a:spLocks noGrp="1"/>
           </p:cNvSpPr>
           <p:nvPr>
-            <p:ph type="sldNum" idx="5" sz="quarter"/>
+            <p:ph type="sldNum" sz="quarter" idx="5"/>
           </p:nvPr>
         </p:nvSpPr>
         <p:spPr/>
@@ -1260,7 +1054,7 @@
 </file>
 
 <file path=ppt/notesSlides/notesSlide2.xml><?xml version="1.0" encoding="utf-8"?>
-<p:notes xmlns:a="http://schemas.openxmlformats.org/drawingml/2006/main" xmlns:p="http://schemas.openxmlformats.org/presentationml/2006/main" xmlns:r="http://schemas.openxmlformats.org/officeDocument/2006/relationships">
+<p:notes xmlns:a="http://schemas.openxmlformats.org/drawingml/2006/main" xmlns:r="http://schemas.openxmlformats.org/officeDocument/2006/relationships" xmlns:p="http://schemas.openxmlformats.org/presentationml/2006/main">
   <p:cSld>
     <p:spTree>
       <p:nvGrpSpPr>
@@ -1280,7 +1074,7 @@
         <p:nvSpPr>
           <p:cNvPr id="2" name="Slide Image Placeholder 1"/>
           <p:cNvSpPr>
-            <a:spLocks noGrp="1"/>
+            <a:spLocks noGrp="1" noRot="1" noChangeAspect="1"/>
           </p:cNvSpPr>
           <p:nvPr>
             <p:ph type="sldImg" idx="2"/>
@@ -1295,7 +1089,7 @@
             <a:spLocks noGrp="1"/>
           </p:cNvSpPr>
           <p:nvPr>
-            <p:ph type="body" idx="3" sz="quarter"/>
+            <p:ph type="body" sz="quarter" idx="3"/>
           </p:nvPr>
         </p:nvSpPr>
         <p:spPr/>
@@ -1316,7 +1110,7 @@
             <a:spLocks noGrp="1"/>
           </p:cNvSpPr>
           <p:nvPr>
-            <p:ph type="sldNum" idx="5" sz="quarter"/>
+            <p:ph type="sldNum" sz="quarter" idx="5"/>
           </p:nvPr>
         </p:nvSpPr>
         <p:spPr/>
@@ -1330,7 +1124,7 @@
 </file>
 
 <file path=ppt/notesSlides/notesSlide20.xml><?xml version="1.0" encoding="utf-8"?>
-<p:notes xmlns:a="http://schemas.openxmlformats.org/drawingml/2006/main" xmlns:p="http://schemas.openxmlformats.org/presentationml/2006/main" xmlns:r="http://schemas.openxmlformats.org/officeDocument/2006/relationships">
+<p:notes xmlns:a="http://schemas.openxmlformats.org/drawingml/2006/main" xmlns:r="http://schemas.openxmlformats.org/officeDocument/2006/relationships" xmlns:p="http://schemas.openxmlformats.org/presentationml/2006/main">
   <p:cSld>
     <p:spTree>
       <p:nvGrpSpPr>
@@ -1350,7 +1144,7 @@
         <p:nvSpPr>
           <p:cNvPr id="2" name="Slide Image Placeholder 1"/>
           <p:cNvSpPr>
-            <a:spLocks noGrp="1"/>
+            <a:spLocks noGrp="1" noRot="1" noChangeAspect="1"/>
           </p:cNvSpPr>
           <p:nvPr>
             <p:ph type="sldImg" idx="2"/>
@@ -1365,7 +1159,7 @@
             <a:spLocks noGrp="1"/>
           </p:cNvSpPr>
           <p:nvPr>
-            <p:ph type="body" idx="3" sz="quarter"/>
+            <p:ph type="body" sz="quarter" idx="3"/>
           </p:nvPr>
         </p:nvSpPr>
         <p:spPr/>
@@ -1386,7 +1180,7 @@
             <a:spLocks noGrp="1"/>
           </p:cNvSpPr>
           <p:nvPr>
-            <p:ph type="sldNum" idx="5" sz="quarter"/>
+            <p:ph type="sldNum" sz="quarter" idx="5"/>
           </p:nvPr>
         </p:nvSpPr>
         <p:spPr/>
@@ -1400,7 +1194,7 @@
 </file>
 
 <file path=ppt/notesSlides/notesSlide21.xml><?xml version="1.0" encoding="utf-8"?>
-<p:notes xmlns:a="http://schemas.openxmlformats.org/drawingml/2006/main" xmlns:p="http://schemas.openxmlformats.org/presentationml/2006/main" xmlns:r="http://schemas.openxmlformats.org/officeDocument/2006/relationships">
+<p:notes xmlns:a="http://schemas.openxmlformats.org/drawingml/2006/main" xmlns:r="http://schemas.openxmlformats.org/officeDocument/2006/relationships" xmlns:p="http://schemas.openxmlformats.org/presentationml/2006/main">
   <p:cSld>
     <p:spTree>
       <p:nvGrpSpPr>
@@ -1420,7 +1214,7 @@
         <p:nvSpPr>
           <p:cNvPr id="2" name="Slide Image Placeholder 1"/>
           <p:cNvSpPr>
-            <a:spLocks noGrp="1"/>
+            <a:spLocks noGrp="1" noRot="1" noChangeAspect="1"/>
           </p:cNvSpPr>
           <p:nvPr>
             <p:ph type="sldImg" idx="2"/>
@@ -1435,7 +1229,7 @@
             <a:spLocks noGrp="1"/>
           </p:cNvSpPr>
           <p:nvPr>
-            <p:ph type="body" idx="3" sz="quarter"/>
+            <p:ph type="body" sz="quarter" idx="3"/>
           </p:nvPr>
         </p:nvSpPr>
         <p:spPr/>
@@ -1456,7 +1250,7 @@
             <a:spLocks noGrp="1"/>
           </p:cNvSpPr>
           <p:nvPr>
-            <p:ph type="sldNum" idx="5" sz="quarter"/>
+            <p:ph type="sldNum" sz="quarter" idx="5"/>
           </p:nvPr>
         </p:nvSpPr>
         <p:spPr/>
@@ -1470,7 +1264,7 @@
 </file>
 
 <file path=ppt/notesSlides/notesSlide22.xml><?xml version="1.0" encoding="utf-8"?>
-<p:notes xmlns:a="http://schemas.openxmlformats.org/drawingml/2006/main" xmlns:p="http://schemas.openxmlformats.org/presentationml/2006/main" xmlns:r="http://schemas.openxmlformats.org/officeDocument/2006/relationships">
+<p:notes xmlns:a="http://schemas.openxmlformats.org/drawingml/2006/main" xmlns:r="http://schemas.openxmlformats.org/officeDocument/2006/relationships" xmlns:p="http://schemas.openxmlformats.org/presentationml/2006/main">
   <p:cSld>
     <p:spTree>
       <p:nvGrpSpPr>
@@ -1490,7 +1284,7 @@
         <p:nvSpPr>
           <p:cNvPr id="2" name="Slide Image Placeholder 1"/>
           <p:cNvSpPr>
-            <a:spLocks noGrp="1"/>
+            <a:spLocks noGrp="1" noRot="1" noChangeAspect="1"/>
           </p:cNvSpPr>
           <p:nvPr>
             <p:ph type="sldImg" idx="2"/>
@@ -1505,7 +1299,7 @@
             <a:spLocks noGrp="1"/>
           </p:cNvSpPr>
           <p:nvPr>
-            <p:ph type="body" idx="3" sz="quarter"/>
+            <p:ph type="body" sz="quarter" idx="3"/>
           </p:nvPr>
         </p:nvSpPr>
         <p:spPr/>
@@ -1526,7 +1320,7 @@
             <a:spLocks noGrp="1"/>
           </p:cNvSpPr>
           <p:nvPr>
-            <p:ph type="sldNum" idx="5" sz="quarter"/>
+            <p:ph type="sldNum" sz="quarter" idx="5"/>
           </p:nvPr>
         </p:nvSpPr>
         <p:spPr/>
@@ -1540,7 +1334,7 @@
 </file>
 
 <file path=ppt/notesSlides/notesSlide23.xml><?xml version="1.0" encoding="utf-8"?>
-<p:notes xmlns:a="http://schemas.openxmlformats.org/drawingml/2006/main" xmlns:p="http://schemas.openxmlformats.org/presentationml/2006/main" xmlns:r="http://schemas.openxmlformats.org/officeDocument/2006/relationships">
+<p:notes xmlns:a="http://schemas.openxmlformats.org/drawingml/2006/main" xmlns:r="http://schemas.openxmlformats.org/officeDocument/2006/relationships" xmlns:p="http://schemas.openxmlformats.org/presentationml/2006/main">
   <p:cSld>
     <p:spTree>
       <p:nvGrpSpPr>
@@ -1560,7 +1354,7 @@
         <p:nvSpPr>
           <p:cNvPr id="2" name="Slide Image Placeholder 1"/>
           <p:cNvSpPr>
-            <a:spLocks noGrp="1"/>
+            <a:spLocks noGrp="1" noRot="1" noChangeAspect="1"/>
           </p:cNvSpPr>
           <p:nvPr>
             <p:ph type="sldImg" idx="2"/>
@@ -1575,7 +1369,7 @@
             <a:spLocks noGrp="1"/>
           </p:cNvSpPr>
           <p:nvPr>
-            <p:ph type="body" idx="3" sz="quarter"/>
+            <p:ph type="body" sz="quarter" idx="3"/>
           </p:nvPr>
         </p:nvSpPr>
         <p:spPr/>
@@ -1596,7 +1390,7 @@
             <a:spLocks noGrp="1"/>
           </p:cNvSpPr>
           <p:nvPr>
-            <p:ph type="sldNum" idx="5" sz="quarter"/>
+            <p:ph type="sldNum" sz="quarter" idx="5"/>
           </p:nvPr>
         </p:nvSpPr>
         <p:spPr/>
@@ -1610,7 +1404,7 @@
 </file>
 
 <file path=ppt/notesSlides/notesSlide24.xml><?xml version="1.0" encoding="utf-8"?>
-<p:notes xmlns:a="http://schemas.openxmlformats.org/drawingml/2006/main" xmlns:p="http://schemas.openxmlformats.org/presentationml/2006/main" xmlns:r="http://schemas.openxmlformats.org/officeDocument/2006/relationships">
+<p:notes xmlns:a="http://schemas.openxmlformats.org/drawingml/2006/main" xmlns:r="http://schemas.openxmlformats.org/officeDocument/2006/relationships" xmlns:p="http://schemas.openxmlformats.org/presentationml/2006/main">
   <p:cSld>
     <p:spTree>
       <p:nvGrpSpPr>
@@ -1630,7 +1424,7 @@
         <p:nvSpPr>
           <p:cNvPr id="2" name="Slide Image Placeholder 1"/>
           <p:cNvSpPr>
-            <a:spLocks noGrp="1"/>
+            <a:spLocks noGrp="1" noRot="1" noChangeAspect="1"/>
           </p:cNvSpPr>
           <p:nvPr>
             <p:ph type="sldImg" idx="2"/>
@@ -1645,7 +1439,7 @@
             <a:spLocks noGrp="1"/>
           </p:cNvSpPr>
           <p:nvPr>
-            <p:ph type="body" idx="3" sz="quarter"/>
+            <p:ph type="body" sz="quarter" idx="3"/>
           </p:nvPr>
         </p:nvSpPr>
         <p:spPr/>
@@ -1666,7 +1460,7 @@
             <a:spLocks noGrp="1"/>
           </p:cNvSpPr>
           <p:nvPr>
-            <p:ph type="sldNum" idx="5" sz="quarter"/>
+            <p:ph type="sldNum" sz="quarter" idx="5"/>
           </p:nvPr>
         </p:nvSpPr>
         <p:spPr/>
@@ -1680,7 +1474,7 @@
 </file>
 
 <file path=ppt/notesSlides/notesSlide25.xml><?xml version="1.0" encoding="utf-8"?>
-<p:notes xmlns:a="http://schemas.openxmlformats.org/drawingml/2006/main" xmlns:p="http://schemas.openxmlformats.org/presentationml/2006/main" xmlns:r="http://schemas.openxmlformats.org/officeDocument/2006/relationships">
+<p:notes xmlns:a="http://schemas.openxmlformats.org/drawingml/2006/main" xmlns:r="http://schemas.openxmlformats.org/officeDocument/2006/relationships" xmlns:p="http://schemas.openxmlformats.org/presentationml/2006/main">
   <p:cSld>
     <p:spTree>
       <p:nvGrpSpPr>
@@ -1700,7 +1494,7 @@
         <p:nvSpPr>
           <p:cNvPr id="2" name="Slide Image Placeholder 1"/>
           <p:cNvSpPr>
-            <a:spLocks noGrp="1"/>
+            <a:spLocks noGrp="1" noRot="1" noChangeAspect="1"/>
           </p:cNvSpPr>
           <p:nvPr>
             <p:ph type="sldImg" idx="2"/>
@@ -1715,7 +1509,7 @@
             <a:spLocks noGrp="1"/>
           </p:cNvSpPr>
           <p:nvPr>
-            <p:ph type="body" idx="3" sz="quarter"/>
+            <p:ph type="body" sz="quarter" idx="3"/>
           </p:nvPr>
         </p:nvSpPr>
         <p:spPr/>
@@ -1736,7 +1530,7 @@
             <a:spLocks noGrp="1"/>
           </p:cNvSpPr>
           <p:nvPr>
-            <p:ph type="sldNum" idx="5" sz="quarter"/>
+            <p:ph type="sldNum" sz="quarter" idx="5"/>
           </p:nvPr>
         </p:nvSpPr>
         <p:spPr/>
@@ -1750,7 +1544,7 @@
 </file>
 
 <file path=ppt/notesSlides/notesSlide26.xml><?xml version="1.0" encoding="utf-8"?>
-<p:notes xmlns:a="http://schemas.openxmlformats.org/drawingml/2006/main" xmlns:p="http://schemas.openxmlformats.org/presentationml/2006/main" xmlns:r="http://schemas.openxmlformats.org/officeDocument/2006/relationships">
+<p:notes xmlns:a="http://schemas.openxmlformats.org/drawingml/2006/main" xmlns:r="http://schemas.openxmlformats.org/officeDocument/2006/relationships" xmlns:p="http://schemas.openxmlformats.org/presentationml/2006/main">
   <p:cSld>
     <p:spTree>
       <p:nvGrpSpPr>
@@ -1770,7 +1564,7 @@
         <p:nvSpPr>
           <p:cNvPr id="2" name="Slide Image Placeholder 1"/>
           <p:cNvSpPr>
-            <a:spLocks noGrp="1"/>
+            <a:spLocks noGrp="1" noRot="1" noChangeAspect="1"/>
           </p:cNvSpPr>
           <p:nvPr>
             <p:ph type="sldImg" idx="2"/>
@@ -1785,7 +1579,7 @@
             <a:spLocks noGrp="1"/>
           </p:cNvSpPr>
           <p:nvPr>
-            <p:ph type="body" idx="3" sz="quarter"/>
+            <p:ph type="body" sz="quarter" idx="3"/>
           </p:nvPr>
         </p:nvSpPr>
         <p:spPr/>
@@ -1806,7 +1600,7 @@
             <a:spLocks noGrp="1"/>
           </p:cNvSpPr>
           <p:nvPr>
-            <p:ph type="sldNum" idx="5" sz="quarter"/>
+            <p:ph type="sldNum" sz="quarter" idx="5"/>
           </p:nvPr>
         </p:nvSpPr>
         <p:spPr/>
@@ -1820,7 +1614,7 @@
 </file>
 
 <file path=ppt/notesSlides/notesSlide27.xml><?xml version="1.0" encoding="utf-8"?>
-<p:notes xmlns:a="http://schemas.openxmlformats.org/drawingml/2006/main" xmlns:p="http://schemas.openxmlformats.org/presentationml/2006/main" xmlns:r="http://schemas.openxmlformats.org/officeDocument/2006/relationships">
+<p:notes xmlns:a="http://schemas.openxmlformats.org/drawingml/2006/main" xmlns:r="http://schemas.openxmlformats.org/officeDocument/2006/relationships" xmlns:p="http://schemas.openxmlformats.org/presentationml/2006/main">
   <p:cSld>
     <p:spTree>
       <p:nvGrpSpPr>
@@ -1840,7 +1634,7 @@
         <p:nvSpPr>
           <p:cNvPr id="2" name="Slide Image Placeholder 1"/>
           <p:cNvSpPr>
-            <a:spLocks noGrp="1"/>
+            <a:spLocks noGrp="1" noRot="1" noChangeAspect="1"/>
           </p:cNvSpPr>
           <p:nvPr>
             <p:ph type="sldImg" idx="2"/>
@@ -1855,7 +1649,7 @@
             <a:spLocks noGrp="1"/>
           </p:cNvSpPr>
           <p:nvPr>
-            <p:ph type="body" idx="3" sz="quarter"/>
+            <p:ph type="body" sz="quarter" idx="3"/>
           </p:nvPr>
         </p:nvSpPr>
         <p:spPr/>
@@ -1876,7 +1670,7 @@
             <a:spLocks noGrp="1"/>
           </p:cNvSpPr>
           <p:nvPr>
-            <p:ph type="sldNum" idx="5" sz="quarter"/>
+            <p:ph type="sldNum" sz="quarter" idx="5"/>
           </p:nvPr>
         </p:nvSpPr>
         <p:spPr/>
@@ -1890,7 +1684,7 @@
 </file>
 
 <file path=ppt/notesSlides/notesSlide28.xml><?xml version="1.0" encoding="utf-8"?>
-<p:notes xmlns:a="http://schemas.openxmlformats.org/drawingml/2006/main" xmlns:p="http://schemas.openxmlformats.org/presentationml/2006/main" xmlns:r="http://schemas.openxmlformats.org/officeDocument/2006/relationships">
+<p:notes xmlns:a="http://schemas.openxmlformats.org/drawingml/2006/main" xmlns:r="http://schemas.openxmlformats.org/officeDocument/2006/relationships" xmlns:p="http://schemas.openxmlformats.org/presentationml/2006/main">
   <p:cSld>
     <p:spTree>
       <p:nvGrpSpPr>
@@ -1910,7 +1704,7 @@
         <p:nvSpPr>
           <p:cNvPr id="2" name="Slide Image Placeholder 1"/>
           <p:cNvSpPr>
-            <a:spLocks noGrp="1"/>
+            <a:spLocks noGrp="1" noRot="1" noChangeAspect="1"/>
           </p:cNvSpPr>
           <p:nvPr>
             <p:ph type="sldImg" idx="2"/>
@@ -1925,7 +1719,7 @@
             <a:spLocks noGrp="1"/>
           </p:cNvSpPr>
           <p:nvPr>
-            <p:ph type="body" idx="3" sz="quarter"/>
+            <p:ph type="body" sz="quarter" idx="3"/>
           </p:nvPr>
         </p:nvSpPr>
         <p:spPr/>
@@ -1946,7 +1740,7 @@
             <a:spLocks noGrp="1"/>
           </p:cNvSpPr>
           <p:nvPr>
-            <p:ph type="sldNum" idx="5" sz="quarter"/>
+            <p:ph type="sldNum" sz="quarter" idx="5"/>
           </p:nvPr>
         </p:nvSpPr>
         <p:spPr/>
@@ -1960,7 +1754,7 @@
 </file>
 
 <file path=ppt/notesSlides/notesSlide29.xml><?xml version="1.0" encoding="utf-8"?>
-<p:notes xmlns:a="http://schemas.openxmlformats.org/drawingml/2006/main" xmlns:p="http://schemas.openxmlformats.org/presentationml/2006/main" xmlns:r="http://schemas.openxmlformats.org/officeDocument/2006/relationships">
+<p:notes xmlns:a="http://schemas.openxmlformats.org/drawingml/2006/main" xmlns:r="http://schemas.openxmlformats.org/officeDocument/2006/relationships" xmlns:p="http://schemas.openxmlformats.org/presentationml/2006/main">
   <p:cSld>
     <p:spTree>
       <p:nvGrpSpPr>
@@ -1980,7 +1774,7 @@
         <p:nvSpPr>
           <p:cNvPr id="2" name="Slide Image Placeholder 1"/>
           <p:cNvSpPr>
-            <a:spLocks noGrp="1"/>
+            <a:spLocks noGrp="1" noRot="1" noChangeAspect="1"/>
           </p:cNvSpPr>
           <p:nvPr>
             <p:ph type="sldImg" idx="2"/>
@@ -1995,7 +1789,7 @@
             <a:spLocks noGrp="1"/>
           </p:cNvSpPr>
           <p:nvPr>
-            <p:ph type="body" idx="3" sz="quarter"/>
+            <p:ph type="body" sz="quarter" idx="3"/>
           </p:nvPr>
         </p:nvSpPr>
         <p:spPr/>
@@ -2016,7 +1810,7 @@
             <a:spLocks noGrp="1"/>
           </p:cNvSpPr>
           <p:nvPr>
-            <p:ph type="sldNum" idx="5" sz="quarter"/>
+            <p:ph type="sldNum" sz="quarter" idx="5"/>
           </p:nvPr>
         </p:nvSpPr>
         <p:spPr/>
@@ -2030,7 +1824,7 @@
 </file>
 
 <file path=ppt/notesSlides/notesSlide3.xml><?xml version="1.0" encoding="utf-8"?>
-<p:notes xmlns:a="http://schemas.openxmlformats.org/drawingml/2006/main" xmlns:p="http://schemas.openxmlformats.org/presentationml/2006/main" xmlns:r="http://schemas.openxmlformats.org/officeDocument/2006/relationships">
+<p:notes xmlns:a="http://schemas.openxmlformats.org/drawingml/2006/main" xmlns:r="http://schemas.openxmlformats.org/officeDocument/2006/relationships" xmlns:p="http://schemas.openxmlformats.org/presentationml/2006/main">
   <p:cSld>
     <p:spTree>
       <p:nvGrpSpPr>
@@ -2050,7 +1844,7 @@
         <p:nvSpPr>
           <p:cNvPr id="2" name="Slide Image Placeholder 1"/>
           <p:cNvSpPr>
-            <a:spLocks noGrp="1"/>
+            <a:spLocks noGrp="1" noRot="1" noChangeAspect="1"/>
           </p:cNvSpPr>
           <p:nvPr>
             <p:ph type="sldImg" idx="2"/>
@@ -2065,7 +1859,7 @@
             <a:spLocks noGrp="1"/>
           </p:cNvSpPr>
           <p:nvPr>
-            <p:ph type="body" idx="3" sz="quarter"/>
+            <p:ph type="body" sz="quarter" idx="3"/>
           </p:nvPr>
         </p:nvSpPr>
         <p:spPr/>
@@ -2086,7 +1880,7 @@
             <a:spLocks noGrp="1"/>
           </p:cNvSpPr>
           <p:nvPr>
-            <p:ph type="sldNum" idx="5" sz="quarter"/>
+            <p:ph type="sldNum" sz="quarter" idx="5"/>
           </p:nvPr>
         </p:nvSpPr>
         <p:spPr/>
@@ -2100,7 +1894,7 @@
 </file>
 
 <file path=ppt/notesSlides/notesSlide30.xml><?xml version="1.0" encoding="utf-8"?>
-<p:notes xmlns:a="http://schemas.openxmlformats.org/drawingml/2006/main" xmlns:p="http://schemas.openxmlformats.org/presentationml/2006/main" xmlns:r="http://schemas.openxmlformats.org/officeDocument/2006/relationships">
+<p:notes xmlns:a="http://schemas.openxmlformats.org/drawingml/2006/main" xmlns:r="http://schemas.openxmlformats.org/officeDocument/2006/relationships" xmlns:p="http://schemas.openxmlformats.org/presentationml/2006/main">
   <p:cSld>
     <p:spTree>
       <p:nvGrpSpPr>
@@ -2120,7 +1914,7 @@
         <p:nvSpPr>
           <p:cNvPr id="2" name="Slide Image Placeholder 1"/>
           <p:cNvSpPr>
-            <a:spLocks noGrp="1"/>
+            <a:spLocks noGrp="1" noRot="1" noChangeAspect="1"/>
           </p:cNvSpPr>
           <p:nvPr>
             <p:ph type="sldImg" idx="2"/>
@@ -2135,7 +1929,7 @@
             <a:spLocks noGrp="1"/>
           </p:cNvSpPr>
           <p:nvPr>
-            <p:ph type="body" idx="3" sz="quarter"/>
+            <p:ph type="body" sz="quarter" idx="3"/>
           </p:nvPr>
         </p:nvSpPr>
         <p:spPr/>
@@ -2156,7 +1950,7 @@
             <a:spLocks noGrp="1"/>
           </p:cNvSpPr>
           <p:nvPr>
-            <p:ph type="sldNum" idx="5" sz="quarter"/>
+            <p:ph type="sldNum" sz="quarter" idx="5"/>
           </p:nvPr>
         </p:nvSpPr>
         <p:spPr/>
@@ -2170,7 +1964,7 @@
 </file>
 
 <file path=ppt/notesSlides/notesSlide31.xml><?xml version="1.0" encoding="utf-8"?>
-<p:notes xmlns:a="http://schemas.openxmlformats.org/drawingml/2006/main" xmlns:p="http://schemas.openxmlformats.org/presentationml/2006/main" xmlns:r="http://schemas.openxmlformats.org/officeDocument/2006/relationships">
+<p:notes xmlns:a="http://schemas.openxmlformats.org/drawingml/2006/main" xmlns:r="http://schemas.openxmlformats.org/officeDocument/2006/relationships" xmlns:p="http://schemas.openxmlformats.org/presentationml/2006/main">
   <p:cSld>
     <p:spTree>
       <p:nvGrpSpPr>
@@ -2190,7 +1984,7 @@
         <p:nvSpPr>
           <p:cNvPr id="2" name="Slide Image Placeholder 1"/>
           <p:cNvSpPr>
-            <a:spLocks noGrp="1"/>
+            <a:spLocks noGrp="1" noRot="1" noChangeAspect="1"/>
           </p:cNvSpPr>
           <p:nvPr>
             <p:ph type="sldImg" idx="2"/>
@@ -2205,7 +1999,7 @@
             <a:spLocks noGrp="1"/>
           </p:cNvSpPr>
           <p:nvPr>
-            <p:ph type="body" idx="3" sz="quarter"/>
+            <p:ph type="body" sz="quarter" idx="3"/>
           </p:nvPr>
         </p:nvSpPr>
         <p:spPr/>
@@ -2226,7 +2020,7 @@
             <a:spLocks noGrp="1"/>
           </p:cNvSpPr>
           <p:nvPr>
-            <p:ph type="sldNum" idx="5" sz="quarter"/>
+            <p:ph type="sldNum" sz="quarter" idx="5"/>
           </p:nvPr>
         </p:nvSpPr>
         <p:spPr/>
@@ -2240,7 +2034,7 @@
 </file>
 
 <file path=ppt/notesSlides/notesSlide32.xml><?xml version="1.0" encoding="utf-8"?>
-<p:notes xmlns:a="http://schemas.openxmlformats.org/drawingml/2006/main" xmlns:p="http://schemas.openxmlformats.org/presentationml/2006/main" xmlns:r="http://schemas.openxmlformats.org/officeDocument/2006/relationships">
+<p:notes xmlns:a="http://schemas.openxmlformats.org/drawingml/2006/main" xmlns:r="http://schemas.openxmlformats.org/officeDocument/2006/relationships" xmlns:p="http://schemas.openxmlformats.org/presentationml/2006/main">
   <p:cSld>
     <p:spTree>
       <p:nvGrpSpPr>
@@ -2260,7 +2054,7 @@
         <p:nvSpPr>
           <p:cNvPr id="2" name="Slide Image Placeholder 1"/>
           <p:cNvSpPr>
-            <a:spLocks noGrp="1"/>
+            <a:spLocks noGrp="1" noRot="1" noChangeAspect="1"/>
           </p:cNvSpPr>
           <p:nvPr>
             <p:ph type="sldImg" idx="2"/>
@@ -2275,7 +2069,7 @@
             <a:spLocks noGrp="1"/>
           </p:cNvSpPr>
           <p:nvPr>
-            <p:ph type="body" idx="3" sz="quarter"/>
+            <p:ph type="body" sz="quarter" idx="3"/>
           </p:nvPr>
         </p:nvSpPr>
         <p:spPr/>
@@ -2296,7 +2090,7 @@
             <a:spLocks noGrp="1"/>
           </p:cNvSpPr>
           <p:nvPr>
-            <p:ph type="sldNum" idx="5" sz="quarter"/>
+            <p:ph type="sldNum" sz="quarter" idx="5"/>
           </p:nvPr>
         </p:nvSpPr>
         <p:spPr/>
@@ -2310,7 +2104,7 @@
 </file>
 
 <file path=ppt/notesSlides/notesSlide33.xml><?xml version="1.0" encoding="utf-8"?>
-<p:notes xmlns:a="http://schemas.openxmlformats.org/drawingml/2006/main" xmlns:p="http://schemas.openxmlformats.org/presentationml/2006/main" xmlns:r="http://schemas.openxmlformats.org/officeDocument/2006/relationships">
+<p:notes xmlns:a="http://schemas.openxmlformats.org/drawingml/2006/main" xmlns:r="http://schemas.openxmlformats.org/officeDocument/2006/relationships" xmlns:p="http://schemas.openxmlformats.org/presentationml/2006/main">
   <p:cSld>
     <p:spTree>
       <p:nvGrpSpPr>
@@ -2330,7 +2124,7 @@
         <p:nvSpPr>
           <p:cNvPr id="2" name="Slide Image Placeholder 1"/>
           <p:cNvSpPr>
-            <a:spLocks noGrp="1"/>
+            <a:spLocks noGrp="1" noRot="1" noChangeAspect="1"/>
           </p:cNvSpPr>
           <p:nvPr>
             <p:ph type="sldImg" idx="2"/>
@@ -2345,7 +2139,7 @@
             <a:spLocks noGrp="1"/>
           </p:cNvSpPr>
           <p:nvPr>
-            <p:ph type="body" idx="3" sz="quarter"/>
+            <p:ph type="body" sz="quarter" idx="3"/>
           </p:nvPr>
         </p:nvSpPr>
         <p:spPr/>
@@ -2366,7 +2160,7 @@
             <a:spLocks noGrp="1"/>
           </p:cNvSpPr>
           <p:nvPr>
-            <p:ph type="sldNum" idx="5" sz="quarter"/>
+            <p:ph type="sldNum" sz="quarter" idx="5"/>
           </p:nvPr>
         </p:nvSpPr>
         <p:spPr/>
@@ -2380,7 +2174,7 @@
 </file>
 
 <file path=ppt/notesSlides/notesSlide4.xml><?xml version="1.0" encoding="utf-8"?>
-<p:notes xmlns:a="http://schemas.openxmlformats.org/drawingml/2006/main" xmlns:p="http://schemas.openxmlformats.org/presentationml/2006/main" xmlns:r="http://schemas.openxmlformats.org/officeDocument/2006/relationships">
+<p:notes xmlns:a="http://schemas.openxmlformats.org/drawingml/2006/main" xmlns:r="http://schemas.openxmlformats.org/officeDocument/2006/relationships" xmlns:p="http://schemas.openxmlformats.org/presentationml/2006/main">
   <p:cSld>
     <p:spTree>
       <p:nvGrpSpPr>
@@ -2400,7 +2194,7 @@
         <p:nvSpPr>
           <p:cNvPr id="2" name="Slide Image Placeholder 1"/>
           <p:cNvSpPr>
-            <a:spLocks noGrp="1"/>
+            <a:spLocks noGrp="1" noRot="1" noChangeAspect="1"/>
           </p:cNvSpPr>
           <p:nvPr>
             <p:ph type="sldImg" idx="2"/>
@@ -2415,7 +2209,7 @@
             <a:spLocks noGrp="1"/>
           </p:cNvSpPr>
           <p:nvPr>
-            <p:ph type="body" idx="3" sz="quarter"/>
+            <p:ph type="body" sz="quarter" idx="3"/>
           </p:nvPr>
         </p:nvSpPr>
         <p:spPr/>
@@ -2427,7 +2221,9 @@
               <a:t>把題目定清楚。輸入是一筆 WiFi 掃描,本質是一個集合:一堆 BSSID 加上各自的 RSSI 訊號強度配成對,而且關鍵是每一筆掃到的 AP 數量都不一樣,有時三四十個、有時只有十幾個。輸出是機器人在這個 189.5 平方公尺實驗室地圖上的座標,單位是公尺。先說評估口徑,後面所有數字都用同一把尺:誤差指的是預測座標到 AMCL 地面真值的歐氏距離、單位公尺,我報的都是中位數。為什麼用 WiFi?因為室內收不到 GPS,而 WiFi 訊號到處都有、現成免裝,指紋定位就是業界最經典的室內備案。</a:t>
             </a:r>
           </a:p>
-          <a:p/>
+          <a:p>
+            <a:endParaRPr/>
+          </a:p>
           <a:p>
             <a:r>
               <a:t>重點是這題為什麼難,而且是四個難點同時並存、互相疊加,後面每一步我都會回來指其中一個。第一,輸入是變動長度的無序集合,不是固定向量,這是之後改用 Set Transformer 的理由。第二,RSSI 多峰又會混淆——房間裡兩個不同地點的訊號組合可能幾乎一模一樣,也就是 ambiguous RSSI,一個輸入對到兩個合理答案,這是後面把回歸改成網格分類的理由。第三,覆蓋稀疏,資料沿著機器人走過的路徑收、不是均勻鋪滿,上半部幾乎沒走到,這是後面用高斯過程補洞的理由。第四,地面真值是 ROS AMCL 給的,本身就帶約 0.3 公尺定位噪聲,這是準度的物理天花板,意思是再強的模型也不可能系統性地比標籤本身還準。預期會被問:既然 GPS 不行,為什麼不用藍牙信標或 UWB?那些都要額外佈建硬體跟成本,而 WiFi 是環境裡免費既有的訊號,這份工作的價值正是只靠現成 WiFi 加對的模型,就把誤差壓到接近標籤精度。</a:t>
@@ -2442,7 +2238,7 @@
             <a:spLocks noGrp="1"/>
           </p:cNvSpPr>
           <p:nvPr>
-            <p:ph type="sldNum" idx="5" sz="quarter"/>
+            <p:ph type="sldNum" sz="quarter" idx="5"/>
           </p:nvPr>
         </p:nvSpPr>
         <p:spPr/>
@@ -2456,7 +2252,7 @@
 </file>
 
 <file path=ppt/notesSlides/notesSlide5.xml><?xml version="1.0" encoding="utf-8"?>
-<p:notes xmlns:a="http://schemas.openxmlformats.org/drawingml/2006/main" xmlns:p="http://schemas.openxmlformats.org/presentationml/2006/main" xmlns:r="http://schemas.openxmlformats.org/officeDocument/2006/relationships">
+<p:notes xmlns:a="http://schemas.openxmlformats.org/drawingml/2006/main" xmlns:r="http://schemas.openxmlformats.org/officeDocument/2006/relationships" xmlns:p="http://schemas.openxmlformats.org/presentationml/2006/main">
   <p:cSld>
     <p:spTree>
       <p:nvGrpSpPr>
@@ -2476,7 +2272,7 @@
         <p:nvSpPr>
           <p:cNvPr id="2" name="Slide Image Placeholder 1"/>
           <p:cNvSpPr>
-            <a:spLocks noGrp="1"/>
+            <a:spLocks noGrp="1" noRot="1" noChangeAspect="1"/>
           </p:cNvSpPr>
           <p:nvPr>
             <p:ph type="sldImg" idx="2"/>
@@ -2491,7 +2287,7 @@
             <a:spLocks noGrp="1"/>
           </p:cNvSpPr>
           <p:nvPr>
-            <p:ph type="body" idx="3" sz="quarter"/>
+            <p:ph type="body" sz="quarter" idx="3"/>
           </p:nvPr>
         </p:nvSpPr>
         <p:spPr/>
@@ -2503,7 +2299,9 @@
               <a:t>(這張是深入剖析、屬於可快可慢的彈性投影片:若時間緊,口頭講兩句『一筆掃描就是一袋無序又變長的配對,硬塞成固定向量會塞進一堆假欄位』就推進;若有時間或被問到再展開。)後面整條技術路線的第一個轉折完全建立在一筆掃描長什麼樣這件事上,值得攤開。一筆原始掃描就是一袋無序的配對,像 ap_3f 強度 -52、ap_1a 強度 -67、ap_b2 強度 -78 這樣列下去,單位 dBm,越接近零代表訊號越強、離 AP 越近,大概落在 -40 到 -90 之間。注意兩個字:無序、變長。無序是這一袋裡誰先誰後完全沒意義;變長是不同掃描裝的 AP 數量不一樣,少則十幾個、多則三四十個。</a:t>
             </a:r>
           </a:p>
-          <a:p/>
+          <a:p>
+            <a:endParaRPr/>
+          </a:p>
           <a:p>
             <a:r>
               <a:t>更麻煩的是同一個位置連續掃兩次,列出的 AP 清單都不見得一樣——有的 AP 這次剛好掃到、下次因為通道忙或訊號瞬間掉到底噪就沒列進來。所以同一地點的兩筆掃描可能長度不同、成員也略有出入,卻該對到同一個座標。核心矛盾就在這:資料天生是無序、變長、成員會抖動的集合,可是傳統 MLP 只吃固定維度、有固定欄位順序的向量。硬塞會怎樣?KNN 跟第一版 MLP 就是先固定一張 80 個 AP 的詞彙表,把掃描攤成 80 維,某 AP 沒掃到就在那一格填 -100。問題是一筆典型掃描平均只點亮 27.7 個 AP,等於約三分之二的維度都是 -100 填充,模型有三分之二的輸入是假的、在學著忽略不存在的東西,白白浪費容量。結論一句、也承先啟後:資料本來就是集合,就該用對集合的模型去處理它——這直接預告下一段把每個 AP 當 token、用 Set Transformer 的轉折。預期追問:那把 RSSI 正規化成 0 到 1、缺席填 0 不就好?那只是換個數值,集合無序跟變長兩個本質問題還在,治標不治本。</a:t>
@@ -2518,7 +2316,7 @@
             <a:spLocks noGrp="1"/>
           </p:cNvSpPr>
           <p:nvPr>
-            <p:ph type="sldNum" idx="5" sz="quarter"/>
+            <p:ph type="sldNum" sz="quarter" idx="5"/>
           </p:nvPr>
         </p:nvSpPr>
         <p:spPr/>
@@ -2532,7 +2330,7 @@
 </file>
 
 <file path=ppt/notesSlides/notesSlide6.xml><?xml version="1.0" encoding="utf-8"?>
-<p:notes xmlns:a="http://schemas.openxmlformats.org/drawingml/2006/main" xmlns:p="http://schemas.openxmlformats.org/presentationml/2006/main" xmlns:r="http://schemas.openxmlformats.org/officeDocument/2006/relationships">
+<p:notes xmlns:a="http://schemas.openxmlformats.org/drawingml/2006/main" xmlns:r="http://schemas.openxmlformats.org/officeDocument/2006/relationships" xmlns:p="http://schemas.openxmlformats.org/presentationml/2006/main">
   <p:cSld>
     <p:spTree>
       <p:nvGrpSpPr>
@@ -2552,7 +2350,7 @@
         <p:nvSpPr>
           <p:cNvPr id="2" name="Slide Image Placeholder 1"/>
           <p:cNvSpPr>
-            <a:spLocks noGrp="1"/>
+            <a:spLocks noGrp="1" noRot="1" noChangeAspect="1"/>
           </p:cNvSpPr>
           <p:nvPr>
             <p:ph type="sldImg" idx="2"/>
@@ -2567,7 +2365,7 @@
             <a:spLocks noGrp="1"/>
           </p:cNvSpPr>
           <p:nvPr>
-            <p:ph type="body" idx="3" sz="quarter"/>
+            <p:ph type="body" sz="quarter" idx="3"/>
           </p:nvPr>
         </p:nvSpPr>
         <p:spPr/>
@@ -2588,7 +2386,7 @@
             <a:spLocks noGrp="1"/>
           </p:cNvSpPr>
           <p:nvPr>
-            <p:ph type="sldNum" idx="5" sz="quarter"/>
+            <p:ph type="sldNum" sz="quarter" idx="5"/>
           </p:nvPr>
         </p:nvSpPr>
         <p:spPr/>
@@ -2602,7 +2400,7 @@
 </file>
 
 <file path=ppt/notesSlides/notesSlide7.xml><?xml version="1.0" encoding="utf-8"?>
-<p:notes xmlns:a="http://schemas.openxmlformats.org/drawingml/2006/main" xmlns:p="http://schemas.openxmlformats.org/presentationml/2006/main" xmlns:r="http://schemas.openxmlformats.org/officeDocument/2006/relationships">
+<p:notes xmlns:a="http://schemas.openxmlformats.org/drawingml/2006/main" xmlns:r="http://schemas.openxmlformats.org/officeDocument/2006/relationships" xmlns:p="http://schemas.openxmlformats.org/presentationml/2006/main">
   <p:cSld>
     <p:spTree>
       <p:nvGrpSpPr>
@@ -2622,7 +2420,7 @@
         <p:nvSpPr>
           <p:cNvPr id="2" name="Slide Image Placeholder 1"/>
           <p:cNvSpPr>
-            <a:spLocks noGrp="1"/>
+            <a:spLocks noGrp="1" noRot="1" noChangeAspect="1"/>
           </p:cNvSpPr>
           <p:nvPr>
             <p:ph type="sldImg" idx="2"/>
@@ -2637,7 +2435,7 @@
             <a:spLocks noGrp="1"/>
           </p:cNvSpPr>
           <p:nvPr>
-            <p:ph type="body" idx="3" sz="quarter"/>
+            <p:ph type="body" sz="quarter" idx="3"/>
           </p:nvPr>
         </p:nvSpPr>
         <p:spPr/>
@@ -2658,7 +2456,7 @@
             <a:spLocks noGrp="1"/>
           </p:cNvSpPr>
           <p:nvPr>
-            <p:ph type="sldNum" idx="5" sz="quarter"/>
+            <p:ph type="sldNum" sz="quarter" idx="5"/>
           </p:nvPr>
         </p:nvSpPr>
         <p:spPr/>
@@ -2672,7 +2470,7 @@
 </file>
 
 <file path=ppt/notesSlides/notesSlide8.xml><?xml version="1.0" encoding="utf-8"?>
-<p:notes xmlns:a="http://schemas.openxmlformats.org/drawingml/2006/main" xmlns:p="http://schemas.openxmlformats.org/presentationml/2006/main" xmlns:r="http://schemas.openxmlformats.org/officeDocument/2006/relationships">
+<p:notes xmlns:a="http://schemas.openxmlformats.org/drawingml/2006/main" xmlns:r="http://schemas.openxmlformats.org/officeDocument/2006/relationships" xmlns:p="http://schemas.openxmlformats.org/presentationml/2006/main">
   <p:cSld>
     <p:spTree>
       <p:nvGrpSpPr>
@@ -2692,7 +2490,7 @@
         <p:nvSpPr>
           <p:cNvPr id="2" name="Slide Image Placeholder 1"/>
           <p:cNvSpPr>
-            <a:spLocks noGrp="1"/>
+            <a:spLocks noGrp="1" noRot="1" noChangeAspect="1"/>
           </p:cNvSpPr>
           <p:nvPr>
             <p:ph type="sldImg" idx="2"/>
@@ -2707,7 +2505,7 @@
             <a:spLocks noGrp="1"/>
           </p:cNvSpPr>
           <p:nvPr>
-            <p:ph type="body" idx="3" sz="quarter"/>
+            <p:ph type="body" sz="quarter" idx="3"/>
           </p:nvPr>
         </p:nvSpPr>
         <p:spPr/>
@@ -2728,7 +2526,7 @@
             <a:spLocks noGrp="1"/>
           </p:cNvSpPr>
           <p:nvPr>
-            <p:ph type="sldNum" idx="5" sz="quarter"/>
+            <p:ph type="sldNum" sz="quarter" idx="5"/>
           </p:nvPr>
         </p:nvSpPr>
         <p:spPr/>
@@ -2742,7 +2540,7 @@
 </file>
 
 <file path=ppt/notesSlides/notesSlide9.xml><?xml version="1.0" encoding="utf-8"?>
-<p:notes xmlns:a="http://schemas.openxmlformats.org/drawingml/2006/main" xmlns:p="http://schemas.openxmlformats.org/presentationml/2006/main" xmlns:r="http://schemas.openxmlformats.org/officeDocument/2006/relationships">
+<p:notes xmlns:a="http://schemas.openxmlformats.org/drawingml/2006/main" xmlns:r="http://schemas.openxmlformats.org/officeDocument/2006/relationships" xmlns:p="http://schemas.openxmlformats.org/presentationml/2006/main">
   <p:cSld>
     <p:spTree>
       <p:nvGrpSpPr>
@@ -2762,7 +2560,7 @@
         <p:nvSpPr>
           <p:cNvPr id="2" name="Slide Image Placeholder 1"/>
           <p:cNvSpPr>
-            <a:spLocks noGrp="1"/>
+            <a:spLocks noGrp="1" noRot="1" noChangeAspect="1"/>
           </p:cNvSpPr>
           <p:nvPr>
             <p:ph type="sldImg" idx="2"/>
@@ -2777,7 +2575,7 @@
             <a:spLocks noGrp="1"/>
           </p:cNvSpPr>
           <p:nvPr>
-            <p:ph type="body" idx="3" sz="quarter"/>
+            <p:ph type="body" sz="quarter" idx="3"/>
           </p:nvPr>
         </p:nvSpPr>
         <p:spPr/>
@@ -2798,7 +2596,7 @@
             <a:spLocks noGrp="1"/>
           </p:cNvSpPr>
           <p:nvPr>
-            <p:ph type="sldNum" idx="5" sz="quarter"/>
+            <p:ph type="sldNum" sz="quarter" idx="5"/>
           </p:nvPr>
         </p:nvSpPr>
         <p:spPr/>
@@ -2849,10 +2647,9 @@
           <a:lstStyle/>
           <a:p>
             <a:r>
-              <a:rPr lang="en-US" smtClean="0"/>
+              <a:rPr lang="en-US"/>
               <a:t>Click to edit Master title style</a:t>
             </a:r>
-            <a:endParaRPr lang="en-US"/>
           </a:p>
         </p:txBody>
       </p:sp>
@@ -2968,10 +2765,9 @@
           </a:lstStyle>
           <a:p>
             <a:r>
-              <a:rPr lang="en-US" smtClean="0"/>
+              <a:rPr lang="en-US"/>
               <a:t>Click to edit Master subtitle style</a:t>
             </a:r>
-            <a:endParaRPr lang="en-US"/>
           </a:p>
         </p:txBody>
       </p:sp>
@@ -2992,7 +2788,7 @@
           <a:p>
             <a:fld id="{5BCAD085-E8A6-8845-BD4E-CB4CCA059FC4}" type="datetimeFigureOut">
               <a:rPr lang="en-US" smtClean="0"/>
-              <a:t>1/27/13</a:t>
+              <a:t>6/7/2026</a:t>
             </a:fld>
             <a:endParaRPr lang="en-US"/>
           </a:p>
@@ -3086,10 +2882,9 @@
           <a:lstStyle/>
           <a:p>
             <a:r>
-              <a:rPr lang="en-US" smtClean="0"/>
+              <a:rPr lang="en-US"/>
               <a:t>Click to edit Master title style</a:t>
             </a:r>
-            <a:endParaRPr lang="en-US"/>
           </a:p>
         </p:txBody>
       </p:sp>
@@ -3110,38 +2905,37 @@
           <a:p>
             <a:pPr lvl="0"/>
             <a:r>
-              <a:rPr lang="en-US" smtClean="0"/>
+              <a:rPr lang="en-US"/>
               <a:t>Click to edit Master text styles</a:t>
             </a:r>
           </a:p>
           <a:p>
             <a:pPr lvl="1"/>
             <a:r>
-              <a:rPr lang="en-US" smtClean="0"/>
+              <a:rPr lang="en-US"/>
               <a:t>Second level</a:t>
             </a:r>
           </a:p>
           <a:p>
             <a:pPr lvl="2"/>
             <a:r>
-              <a:rPr lang="en-US" smtClean="0"/>
+              <a:rPr lang="en-US"/>
               <a:t>Third level</a:t>
             </a:r>
           </a:p>
           <a:p>
             <a:pPr lvl="3"/>
             <a:r>
-              <a:rPr lang="en-US" smtClean="0"/>
+              <a:rPr lang="en-US"/>
               <a:t>Fourth level</a:t>
             </a:r>
           </a:p>
           <a:p>
             <a:pPr lvl="4"/>
             <a:r>
-              <a:rPr lang="en-US" smtClean="0"/>
+              <a:rPr lang="en-US"/>
               <a:t>Fifth level</a:t>
             </a:r>
-            <a:endParaRPr lang="en-US"/>
           </a:p>
         </p:txBody>
       </p:sp>
@@ -3162,7 +2956,7 @@
           <a:p>
             <a:fld id="{5BCAD085-E8A6-8845-BD4E-CB4CCA059FC4}" type="datetimeFigureOut">
               <a:rPr lang="en-US" smtClean="0"/>
-              <a:t>1/27/13</a:t>
+              <a:t>6/7/2026</a:t>
             </a:fld>
             <a:endParaRPr lang="en-US"/>
           </a:p>
@@ -3261,10 +3055,9 @@
           <a:lstStyle/>
           <a:p>
             <a:r>
-              <a:rPr lang="en-US" smtClean="0"/>
+              <a:rPr lang="en-US"/>
               <a:t>Click to edit Master title style</a:t>
             </a:r>
-            <a:endParaRPr lang="en-US"/>
           </a:p>
         </p:txBody>
       </p:sp>
@@ -3290,38 +3083,37 @@
           <a:p>
             <a:pPr lvl="0"/>
             <a:r>
-              <a:rPr lang="en-US" smtClean="0"/>
+              <a:rPr lang="en-US"/>
               <a:t>Click to edit Master text styles</a:t>
             </a:r>
           </a:p>
           <a:p>
             <a:pPr lvl="1"/>
             <a:r>
-              <a:rPr lang="en-US" smtClean="0"/>
+              <a:rPr lang="en-US"/>
               <a:t>Second level</a:t>
             </a:r>
           </a:p>
           <a:p>
             <a:pPr lvl="2"/>
             <a:r>
-              <a:rPr lang="en-US" smtClean="0"/>
+              <a:rPr lang="en-US"/>
               <a:t>Third level</a:t>
             </a:r>
           </a:p>
           <a:p>
             <a:pPr lvl="3"/>
             <a:r>
-              <a:rPr lang="en-US" smtClean="0"/>
+              <a:rPr lang="en-US"/>
               <a:t>Fourth level</a:t>
             </a:r>
           </a:p>
           <a:p>
             <a:pPr lvl="4"/>
             <a:r>
-              <a:rPr lang="en-US" smtClean="0"/>
+              <a:rPr lang="en-US"/>
               <a:t>Fifth level</a:t>
             </a:r>
-            <a:endParaRPr lang="en-US"/>
           </a:p>
         </p:txBody>
       </p:sp>
@@ -3342,7 +3134,7 @@
           <a:p>
             <a:fld id="{5BCAD085-E8A6-8845-BD4E-CB4CCA059FC4}" type="datetimeFigureOut">
               <a:rPr lang="en-US" smtClean="0"/>
-              <a:t>1/27/13</a:t>
+              <a:t>6/7/2026</a:t>
             </a:fld>
             <a:endParaRPr lang="en-US"/>
           </a:p>
@@ -3436,10 +3228,9 @@
           <a:lstStyle/>
           <a:p>
             <a:r>
-              <a:rPr lang="en-US" smtClean="0"/>
+              <a:rPr lang="en-US"/>
               <a:t>Click to edit Master title style</a:t>
             </a:r>
-            <a:endParaRPr lang="en-US"/>
           </a:p>
         </p:txBody>
       </p:sp>
@@ -3460,38 +3251,37 @@
           <a:p>
             <a:pPr lvl="0"/>
             <a:r>
-              <a:rPr lang="en-US" smtClean="0"/>
+              <a:rPr lang="en-US"/>
               <a:t>Click to edit Master text styles</a:t>
             </a:r>
           </a:p>
           <a:p>
             <a:pPr lvl="1"/>
             <a:r>
-              <a:rPr lang="en-US" smtClean="0"/>
+              <a:rPr lang="en-US"/>
               <a:t>Second level</a:t>
             </a:r>
           </a:p>
           <a:p>
             <a:pPr lvl="2"/>
             <a:r>
-              <a:rPr lang="en-US" smtClean="0"/>
+              <a:rPr lang="en-US"/>
               <a:t>Third level</a:t>
             </a:r>
           </a:p>
           <a:p>
             <a:pPr lvl="3"/>
             <a:r>
-              <a:rPr lang="en-US" smtClean="0"/>
+              <a:rPr lang="en-US"/>
               <a:t>Fourth level</a:t>
             </a:r>
           </a:p>
           <a:p>
             <a:pPr lvl="4"/>
             <a:r>
-              <a:rPr lang="en-US" smtClean="0"/>
+              <a:rPr lang="en-US"/>
               <a:t>Fifth level</a:t>
             </a:r>
-            <a:endParaRPr lang="en-US"/>
           </a:p>
         </p:txBody>
       </p:sp>
@@ -3512,7 +3302,7 @@
           <a:p>
             <a:fld id="{5BCAD085-E8A6-8845-BD4E-CB4CCA059FC4}" type="datetimeFigureOut">
               <a:rPr lang="en-US" smtClean="0"/>
-              <a:t>1/27/13</a:t>
+              <a:t>6/7/2026</a:t>
             </a:fld>
             <a:endParaRPr lang="en-US"/>
           </a:p>
@@ -3615,10 +3405,9 @@
           </a:lstStyle>
           <a:p>
             <a:r>
-              <a:rPr lang="en-US" smtClean="0"/>
+              <a:rPr lang="en-US"/>
               <a:t>Click to edit Master title style</a:t>
             </a:r>
-            <a:endParaRPr lang="en-US"/>
           </a:p>
         </p:txBody>
       </p:sp>
@@ -3735,7 +3524,7 @@
           <a:p>
             <a:pPr lvl="0"/>
             <a:r>
-              <a:rPr lang="en-US" smtClean="0"/>
+              <a:rPr lang="en-US"/>
               <a:t>Click to edit Master text styles</a:t>
             </a:r>
           </a:p>
@@ -3758,7 +3547,7 @@
           <a:p>
             <a:fld id="{5BCAD085-E8A6-8845-BD4E-CB4CCA059FC4}" type="datetimeFigureOut">
               <a:rPr lang="en-US" smtClean="0"/>
-              <a:t>1/27/13</a:t>
+              <a:t>6/7/2026</a:t>
             </a:fld>
             <a:endParaRPr lang="en-US"/>
           </a:p>
@@ -3852,10 +3641,9 @@
           <a:lstStyle/>
           <a:p>
             <a:r>
-              <a:rPr lang="en-US" smtClean="0"/>
+              <a:rPr lang="en-US"/>
               <a:t>Click to edit Master title style</a:t>
             </a:r>
-            <a:endParaRPr lang="en-US"/>
           </a:p>
         </p:txBody>
       </p:sp>
@@ -3909,38 +3697,37 @@
           <a:p>
             <a:pPr lvl="0"/>
             <a:r>
-              <a:rPr lang="en-US" smtClean="0"/>
+              <a:rPr lang="en-US"/>
               <a:t>Click to edit Master text styles</a:t>
             </a:r>
           </a:p>
           <a:p>
             <a:pPr lvl="1"/>
             <a:r>
-              <a:rPr lang="en-US" smtClean="0"/>
+              <a:rPr lang="en-US"/>
               <a:t>Second level</a:t>
             </a:r>
           </a:p>
           <a:p>
             <a:pPr lvl="2"/>
             <a:r>
-              <a:rPr lang="en-US" smtClean="0"/>
+              <a:rPr lang="en-US"/>
               <a:t>Third level</a:t>
             </a:r>
           </a:p>
           <a:p>
             <a:pPr lvl="3"/>
             <a:r>
-              <a:rPr lang="en-US" smtClean="0"/>
+              <a:rPr lang="en-US"/>
               <a:t>Fourth level</a:t>
             </a:r>
           </a:p>
           <a:p>
             <a:pPr lvl="4"/>
             <a:r>
-              <a:rPr lang="en-US" smtClean="0"/>
+              <a:rPr lang="en-US"/>
               <a:t>Fifth level</a:t>
             </a:r>
-            <a:endParaRPr lang="en-US"/>
           </a:p>
         </p:txBody>
       </p:sp>
@@ -3994,38 +3781,37 @@
           <a:p>
             <a:pPr lvl="0"/>
             <a:r>
-              <a:rPr lang="en-US" smtClean="0"/>
+              <a:rPr lang="en-US"/>
               <a:t>Click to edit Master text styles</a:t>
             </a:r>
           </a:p>
           <a:p>
             <a:pPr lvl="1"/>
             <a:r>
-              <a:rPr lang="en-US" smtClean="0"/>
+              <a:rPr lang="en-US"/>
               <a:t>Second level</a:t>
             </a:r>
           </a:p>
           <a:p>
             <a:pPr lvl="2"/>
             <a:r>
-              <a:rPr lang="en-US" smtClean="0"/>
+              <a:rPr lang="en-US"/>
               <a:t>Third level</a:t>
             </a:r>
           </a:p>
           <a:p>
             <a:pPr lvl="3"/>
             <a:r>
-              <a:rPr lang="en-US" smtClean="0"/>
+              <a:rPr lang="en-US"/>
               <a:t>Fourth level</a:t>
             </a:r>
           </a:p>
           <a:p>
             <a:pPr lvl="4"/>
             <a:r>
-              <a:rPr lang="en-US" smtClean="0"/>
+              <a:rPr lang="en-US"/>
               <a:t>Fifth level</a:t>
             </a:r>
-            <a:endParaRPr lang="en-US"/>
           </a:p>
         </p:txBody>
       </p:sp>
@@ -4046,7 +3832,7 @@
           <a:p>
             <a:fld id="{5BCAD085-E8A6-8845-BD4E-CB4CCA059FC4}" type="datetimeFigureOut">
               <a:rPr lang="en-US" smtClean="0"/>
-              <a:t>1/27/13</a:t>
+              <a:t>6/7/2026</a:t>
             </a:fld>
             <a:endParaRPr lang="en-US"/>
           </a:p>
@@ -4144,10 +3930,9 @@
           </a:lstStyle>
           <a:p>
             <a:r>
-              <a:rPr lang="en-US" smtClean="0"/>
+              <a:rPr lang="en-US"/>
               <a:t>Click to edit Master title style</a:t>
             </a:r>
-            <a:endParaRPr lang="en-US"/>
           </a:p>
         </p:txBody>
       </p:sp>
@@ -4210,7 +3995,7 @@
           <a:p>
             <a:pPr lvl="0"/>
             <a:r>
-              <a:rPr lang="en-US" smtClean="0"/>
+              <a:rPr lang="en-US"/>
               <a:t>Click to edit Master text styles</a:t>
             </a:r>
           </a:p>
@@ -4266,38 +4051,37 @@
           <a:p>
             <a:pPr lvl="0"/>
             <a:r>
-              <a:rPr lang="en-US" smtClean="0"/>
+              <a:rPr lang="en-US"/>
               <a:t>Click to edit Master text styles</a:t>
             </a:r>
           </a:p>
           <a:p>
             <a:pPr lvl="1"/>
             <a:r>
-              <a:rPr lang="en-US" smtClean="0"/>
+              <a:rPr lang="en-US"/>
               <a:t>Second level</a:t>
             </a:r>
           </a:p>
           <a:p>
             <a:pPr lvl="2"/>
             <a:r>
-              <a:rPr lang="en-US" smtClean="0"/>
+              <a:rPr lang="en-US"/>
               <a:t>Third level</a:t>
             </a:r>
           </a:p>
           <a:p>
             <a:pPr lvl="3"/>
             <a:r>
-              <a:rPr lang="en-US" smtClean="0"/>
+              <a:rPr lang="en-US"/>
               <a:t>Fourth level</a:t>
             </a:r>
           </a:p>
           <a:p>
             <a:pPr lvl="4"/>
             <a:r>
-              <a:rPr lang="en-US" smtClean="0"/>
+              <a:rPr lang="en-US"/>
               <a:t>Fifth level</a:t>
             </a:r>
-            <a:endParaRPr lang="en-US"/>
           </a:p>
         </p:txBody>
       </p:sp>
@@ -4360,7 +4144,7 @@
           <a:p>
             <a:pPr lvl="0"/>
             <a:r>
-              <a:rPr lang="en-US" smtClean="0"/>
+              <a:rPr lang="en-US"/>
               <a:t>Click to edit Master text styles</a:t>
             </a:r>
           </a:p>
@@ -4416,38 +4200,37 @@
           <a:p>
             <a:pPr lvl="0"/>
             <a:r>
-              <a:rPr lang="en-US" smtClean="0"/>
+              <a:rPr lang="en-US"/>
               <a:t>Click to edit Master text styles</a:t>
             </a:r>
           </a:p>
           <a:p>
             <a:pPr lvl="1"/>
             <a:r>
-              <a:rPr lang="en-US" smtClean="0"/>
+              <a:rPr lang="en-US"/>
               <a:t>Second level</a:t>
             </a:r>
           </a:p>
           <a:p>
             <a:pPr lvl="2"/>
             <a:r>
-              <a:rPr lang="en-US" smtClean="0"/>
+              <a:rPr lang="en-US"/>
               <a:t>Third level</a:t>
             </a:r>
           </a:p>
           <a:p>
             <a:pPr lvl="3"/>
             <a:r>
-              <a:rPr lang="en-US" smtClean="0"/>
+              <a:rPr lang="en-US"/>
               <a:t>Fourth level</a:t>
             </a:r>
           </a:p>
           <a:p>
             <a:pPr lvl="4"/>
             <a:r>
-              <a:rPr lang="en-US" smtClean="0"/>
+              <a:rPr lang="en-US"/>
               <a:t>Fifth level</a:t>
             </a:r>
-            <a:endParaRPr lang="en-US"/>
           </a:p>
         </p:txBody>
       </p:sp>
@@ -4468,7 +4251,7 @@
           <a:p>
             <a:fld id="{5BCAD085-E8A6-8845-BD4E-CB4CCA059FC4}" type="datetimeFigureOut">
               <a:rPr lang="en-US" smtClean="0"/>
-              <a:t>1/27/13</a:t>
+              <a:t>6/7/2026</a:t>
             </a:fld>
             <a:endParaRPr lang="en-US"/>
           </a:p>
@@ -4562,10 +4345,9 @@
           <a:lstStyle/>
           <a:p>
             <a:r>
-              <a:rPr lang="en-US" smtClean="0"/>
+              <a:rPr lang="en-US"/>
               <a:t>Click to edit Master title style</a:t>
             </a:r>
-            <a:endParaRPr lang="en-US"/>
           </a:p>
         </p:txBody>
       </p:sp>
@@ -4586,7 +4368,7 @@
           <a:p>
             <a:fld id="{5BCAD085-E8A6-8845-BD4E-CB4CCA059FC4}" type="datetimeFigureOut">
               <a:rPr lang="en-US" smtClean="0"/>
-              <a:t>1/27/13</a:t>
+              <a:t>6/7/2026</a:t>
             </a:fld>
             <a:endParaRPr lang="en-US"/>
           </a:p>
@@ -4681,7 +4463,7 @@
           <a:p>
             <a:fld id="{5BCAD085-E8A6-8845-BD4E-CB4CCA059FC4}" type="datetimeFigureOut">
               <a:rPr lang="en-US" smtClean="0"/>
-              <a:t>1/27/13</a:t>
+              <a:t>6/7/2026</a:t>
             </a:fld>
             <a:endParaRPr lang="en-US"/>
           </a:p>
@@ -4784,10 +4566,9 @@
           </a:lstStyle>
           <a:p>
             <a:r>
-              <a:rPr lang="en-US" smtClean="0"/>
+              <a:rPr lang="en-US"/>
               <a:t>Click to edit Master title style</a:t>
             </a:r>
-            <a:endParaRPr lang="en-US"/>
           </a:p>
         </p:txBody>
       </p:sp>
@@ -4841,38 +4622,37 @@
           <a:p>
             <a:pPr lvl="0"/>
             <a:r>
-              <a:rPr lang="en-US" smtClean="0"/>
+              <a:rPr lang="en-US"/>
               <a:t>Click to edit Master text styles</a:t>
             </a:r>
           </a:p>
           <a:p>
             <a:pPr lvl="1"/>
             <a:r>
-              <a:rPr lang="en-US" smtClean="0"/>
+              <a:rPr lang="en-US"/>
               <a:t>Second level</a:t>
             </a:r>
           </a:p>
           <a:p>
             <a:pPr lvl="2"/>
             <a:r>
-              <a:rPr lang="en-US" smtClean="0"/>
+              <a:rPr lang="en-US"/>
               <a:t>Third level</a:t>
             </a:r>
           </a:p>
           <a:p>
             <a:pPr lvl="3"/>
             <a:r>
-              <a:rPr lang="en-US" smtClean="0"/>
+              <a:rPr lang="en-US"/>
               <a:t>Fourth level</a:t>
             </a:r>
           </a:p>
           <a:p>
             <a:pPr lvl="4"/>
             <a:r>
-              <a:rPr lang="en-US" smtClean="0"/>
+              <a:rPr lang="en-US"/>
               <a:t>Fifth level</a:t>
             </a:r>
-            <a:endParaRPr lang="en-US"/>
           </a:p>
         </p:txBody>
       </p:sp>
@@ -4935,7 +4715,7 @@
           <a:p>
             <a:pPr lvl="0"/>
             <a:r>
-              <a:rPr lang="en-US" smtClean="0"/>
+              <a:rPr lang="en-US"/>
               <a:t>Click to edit Master text styles</a:t>
             </a:r>
           </a:p>
@@ -4958,7 +4738,7 @@
           <a:p>
             <a:fld id="{5BCAD085-E8A6-8845-BD4E-CB4CCA059FC4}" type="datetimeFigureOut">
               <a:rPr lang="en-US" smtClean="0"/>
-              <a:t>1/27/13</a:t>
+              <a:t>6/7/2026</a:t>
             </a:fld>
             <a:endParaRPr lang="en-US"/>
           </a:p>
@@ -5061,10 +4841,9 @@
           </a:lstStyle>
           <a:p>
             <a:r>
-              <a:rPr lang="en-US" smtClean="0"/>
+              <a:rPr lang="en-US"/>
               <a:t>Click to edit Master title style</a:t>
             </a:r>
-            <a:endParaRPr lang="en-US"/>
           </a:p>
         </p:txBody>
       </p:sp>
@@ -5188,7 +4967,7 @@
           <a:p>
             <a:pPr lvl="0"/>
             <a:r>
-              <a:rPr lang="en-US" smtClean="0"/>
+              <a:rPr lang="en-US"/>
               <a:t>Click to edit Master text styles</a:t>
             </a:r>
           </a:p>
@@ -5211,7 +4990,7 @@
           <a:p>
             <a:fld id="{5BCAD085-E8A6-8845-BD4E-CB4CCA059FC4}" type="datetimeFigureOut">
               <a:rPr lang="en-US" smtClean="0"/>
-              <a:t>1/27/13</a:t>
+              <a:t>6/7/2026</a:t>
             </a:fld>
             <a:endParaRPr lang="en-US"/>
           </a:p>
@@ -5320,10 +5099,9 @@
           <a:lstStyle/>
           <a:p>
             <a:r>
-              <a:rPr lang="en-US" smtClean="0"/>
+              <a:rPr lang="en-US"/>
               <a:t>Click to edit Master title style</a:t>
             </a:r>
-            <a:endParaRPr lang="en-US"/>
           </a:p>
         </p:txBody>
       </p:sp>
@@ -5354,38 +5132,37 @@
           <a:p>
             <a:pPr lvl="0"/>
             <a:r>
-              <a:rPr lang="en-US" smtClean="0"/>
+              <a:rPr lang="en-US"/>
               <a:t>Click to edit Master text styles</a:t>
             </a:r>
           </a:p>
           <a:p>
             <a:pPr lvl="1"/>
             <a:r>
-              <a:rPr lang="en-US" smtClean="0"/>
+              <a:rPr lang="en-US"/>
               <a:t>Second level</a:t>
             </a:r>
           </a:p>
           <a:p>
             <a:pPr lvl="2"/>
             <a:r>
-              <a:rPr lang="en-US" smtClean="0"/>
+              <a:rPr lang="en-US"/>
               <a:t>Third level</a:t>
             </a:r>
           </a:p>
           <a:p>
             <a:pPr lvl="3"/>
             <a:r>
-              <a:rPr lang="en-US" smtClean="0"/>
+              <a:rPr lang="en-US"/>
               <a:t>Fourth level</a:t>
             </a:r>
           </a:p>
           <a:p>
             <a:pPr lvl="4"/>
             <a:r>
-              <a:rPr lang="en-US" smtClean="0"/>
+              <a:rPr lang="en-US"/>
               <a:t>Fifth level</a:t>
             </a:r>
-            <a:endParaRPr lang="en-US"/>
           </a:p>
         </p:txBody>
       </p:sp>
@@ -5424,7 +5201,7 @@
           <a:p>
             <a:fld id="{5BCAD085-E8A6-8845-BD4E-CB4CCA059FC4}" type="datetimeFigureOut">
               <a:rPr lang="en-US" smtClean="0"/>
-              <a:t>1/27/13</a:t>
+              <a:t>6/7/2026</a:t>
             </a:fld>
             <a:endParaRPr lang="en-US"/>
           </a:p>
@@ -5783,7 +5560,7 @@
 </file>
 
 <file path=ppt/slides/slide1.xml><?xml version="1.0" encoding="utf-8"?>
-<p:sld xmlns:a="http://schemas.openxmlformats.org/drawingml/2006/main" xmlns:p="http://schemas.openxmlformats.org/presentationml/2006/main" xmlns:r="http://schemas.openxmlformats.org/officeDocument/2006/relationships">
+<p:sld xmlns:a="http://schemas.openxmlformats.org/drawingml/2006/main" xmlns:r="http://schemas.openxmlformats.org/officeDocument/2006/relationships" xmlns:p="http://schemas.openxmlformats.org/presentationml/2006/main">
   <p:cSld>
     <p:spTree>
       <p:nvGrpSpPr>
@@ -5791,7 +5568,14 @@
         <p:cNvGrpSpPr/>
         <p:nvPr/>
       </p:nvGrpSpPr>
-      <p:grpSpPr/>
+      <p:grpSpPr>
+        <a:xfrm>
+          <a:off x="0" y="0"/>
+          <a:ext cx="0" cy="0"/>
+          <a:chOff x="0" y="0"/>
+          <a:chExt cx="0" cy="0"/>
+        </a:xfrm>
+      </p:grpSpPr>
       <p:sp>
         <p:nvSpPr>
           <p:cNvPr id="2" name="Rectangle 1"/>
@@ -5833,6 +5617,7 @@
           <a:lstStyle/>
           <a:p>
             <a:pPr algn="ctr"/>
+            <a:endParaRPr/>
           </a:p>
         </p:txBody>
       </p:sp>
@@ -5877,6 +5662,7 @@
           <a:lstStyle/>
           <a:p>
             <a:pPr algn="ctr"/>
+            <a:endParaRPr/>
           </a:p>
         </p:txBody>
       </p:sp>
@@ -5889,7 +5675,7 @@
         <p:spPr>
           <a:xfrm>
             <a:off x="731520" y="2468880"/>
-            <a:ext cx="10725912" cy="2011680"/>
+            <a:ext cx="10725912" cy="1323439"/>
           </a:xfrm>
           <a:prstGeom prst="rect">
             <a:avLst/>
@@ -5904,13 +5690,29 @@
           <a:p>
             <a:pPr algn="ctr"/>
             <a:r>
-              <a:rPr sz="4000" b="1">
+              <a:rPr lang="en-US" altLang="zh-TW" sz="4000" b="1" dirty="0">
                 <a:solidFill>
                   <a:srgbClr val="FFFFFF"/>
                 </a:solidFill>
               </a:rPr>
-              <a:t>From a 1.57 m KNN baseline to a 0.75 m honest cascade</a:t>
-            </a:r>
+              <a:t>cv2x-wifi-fingerprint</a:t>
+            </a:r>
+          </a:p>
+          <a:p>
+            <a:pPr algn="ctr"/>
+            <a:r>
+              <a:rPr lang="en-US" altLang="zh-TW" sz="4000" b="1" dirty="0">
+                <a:solidFill>
+                  <a:srgbClr val="FFFFFF"/>
+                </a:solidFill>
+              </a:rPr>
+              <a:t>Indoor location</a:t>
+            </a:r>
+            <a:endParaRPr sz="4000" b="1" dirty="0">
+              <a:solidFill>
+                <a:srgbClr val="FFFFFF"/>
+              </a:solidFill>
+            </a:endParaRPr>
           </a:p>
         </p:txBody>
       </p:sp>
@@ -5923,7 +5725,7 @@
         <p:spPr>
           <a:xfrm>
             <a:off x="914400" y="4572000"/>
-            <a:ext cx="10360152" cy="1097280"/>
+            <a:ext cx="10360152" cy="707886"/>
           </a:xfrm>
           <a:prstGeom prst="rect">
             <a:avLst/>
@@ -5938,13 +5740,50 @@
           <a:p>
             <a:pPr algn="ctr"/>
             <a:r>
-              <a:rPr sz="2000">
+              <a:rPr lang="en-US" sz="2000" dirty="0">
                 <a:solidFill>
                   <a:srgbClr val="6FB7F0"/>
                 </a:solidFill>
               </a:rPr>
-              <a:t>Standard protocol 0.75 m, strict nested-CV 0.94 m — and we caught our own overfitting</a:t>
-            </a:r>
+              <a:t>314831017 </a:t>
+            </a:r>
+            <a:r>
+              <a:rPr lang="zh-TW" altLang="en-US" sz="2000" dirty="0">
+                <a:solidFill>
+                  <a:srgbClr val="6FB7F0"/>
+                </a:solidFill>
+              </a:rPr>
+              <a:t>王瑋琛</a:t>
+            </a:r>
+            <a:endParaRPr lang="en-US" altLang="zh-TW" sz="2000" dirty="0">
+              <a:solidFill>
+                <a:srgbClr val="6FB7F0"/>
+              </a:solidFill>
+            </a:endParaRPr>
+          </a:p>
+          <a:p>
+            <a:pPr algn="ctr"/>
+            <a:r>
+              <a:rPr lang="en-US" altLang="zh-TW" sz="2000" dirty="0">
+                <a:solidFill>
+                  <a:srgbClr val="6FB7F0"/>
+                </a:solidFill>
+              </a:rPr>
+              <a:t>314831024</a:t>
+            </a:r>
+            <a:r>
+              <a:rPr lang="zh-TW" altLang="en-US" sz="2000" dirty="0">
+                <a:solidFill>
+                  <a:srgbClr val="6FB7F0"/>
+                </a:solidFill>
+              </a:rPr>
+              <a:t> 李朋逸</a:t>
+            </a:r>
+            <a:endParaRPr sz="2000" dirty="0">
+              <a:solidFill>
+                <a:srgbClr val="6FB7F0"/>
+              </a:solidFill>
+            </a:endParaRPr>
           </a:p>
         </p:txBody>
       </p:sp>
@@ -5991,7 +5830,7 @@
 </file>
 
 <file path=ppt/slides/slide10.xml><?xml version="1.0" encoding="utf-8"?>
-<p:sld xmlns:a="http://schemas.openxmlformats.org/drawingml/2006/main" xmlns:p="http://schemas.openxmlformats.org/presentationml/2006/main" xmlns:r="http://schemas.openxmlformats.org/officeDocument/2006/relationships">
+<p:sld xmlns:a="http://schemas.openxmlformats.org/drawingml/2006/main" xmlns:r="http://schemas.openxmlformats.org/officeDocument/2006/relationships" xmlns:p="http://schemas.openxmlformats.org/presentationml/2006/main">
   <p:cSld>
     <p:spTree>
       <p:nvGrpSpPr>
@@ -5999,7 +5838,14 @@
         <p:cNvGrpSpPr/>
         <p:nvPr/>
       </p:nvGrpSpPr>
-      <p:grpSpPr/>
+      <p:grpSpPr>
+        <a:xfrm>
+          <a:off x="0" y="0"/>
+          <a:ext cx="0" cy="0"/>
+          <a:chOff x="0" y="0"/>
+          <a:chExt cx="0" cy="0"/>
+        </a:xfrm>
+      </p:grpSpPr>
       <p:sp>
         <p:nvSpPr>
           <p:cNvPr id="2" name="TextBox 1"/>
@@ -6157,7 +6003,7 @@
           <p:nvPr/>
         </p:nvPicPr>
         <p:blipFill>
-          <a:blip r:embed="rId2"/>
+          <a:blip r:embed="rId3"/>
           <a:stretch>
             <a:fillRect/>
           </a:stretch>
@@ -6213,6 +6059,7 @@
           <a:lstStyle/>
           <a:p>
             <a:pPr algn="ctr"/>
+            <a:endParaRPr/>
           </a:p>
         </p:txBody>
       </p:sp>
@@ -6327,7 +6174,7 @@
 </file>
 
 <file path=ppt/slides/slide11.xml><?xml version="1.0" encoding="utf-8"?>
-<p:sld xmlns:a="http://schemas.openxmlformats.org/drawingml/2006/main" xmlns:p="http://schemas.openxmlformats.org/presentationml/2006/main" xmlns:r="http://schemas.openxmlformats.org/officeDocument/2006/relationships">
+<p:sld xmlns:a="http://schemas.openxmlformats.org/drawingml/2006/main" xmlns:r="http://schemas.openxmlformats.org/officeDocument/2006/relationships" xmlns:p="http://schemas.openxmlformats.org/presentationml/2006/main">
   <p:cSld>
     <p:spTree>
       <p:nvGrpSpPr>
@@ -6335,7 +6182,14 @@
         <p:cNvGrpSpPr/>
         <p:nvPr/>
       </p:nvGrpSpPr>
-      <p:grpSpPr/>
+      <p:grpSpPr>
+        <a:xfrm>
+          <a:off x="0" y="0"/>
+          <a:ext cx="0" cy="0"/>
+          <a:chOff x="0" y="0"/>
+          <a:chExt cx="0" cy="0"/>
+        </a:xfrm>
+      </p:grpSpPr>
       <p:sp>
         <p:nvSpPr>
           <p:cNvPr id="2" name="Rectangle 1"/>
@@ -6377,6 +6231,7 @@
           <a:lstStyle/>
           <a:p>
             <a:pPr algn="ctr"/>
+            <a:endParaRPr/>
           </a:p>
         </p:txBody>
       </p:sp>
@@ -6489,6 +6344,7 @@
           <a:lstStyle/>
           <a:p>
             <a:pPr algn="ctr"/>
+            <a:endParaRPr/>
           </a:p>
         </p:txBody>
       </p:sp>
@@ -6535,7 +6391,7 @@
 </file>
 
 <file path=ppt/slides/slide12.xml><?xml version="1.0" encoding="utf-8"?>
-<p:sld xmlns:a="http://schemas.openxmlformats.org/drawingml/2006/main" xmlns:p="http://schemas.openxmlformats.org/presentationml/2006/main" xmlns:r="http://schemas.openxmlformats.org/officeDocument/2006/relationships">
+<p:sld xmlns:a="http://schemas.openxmlformats.org/drawingml/2006/main" xmlns:r="http://schemas.openxmlformats.org/officeDocument/2006/relationships" xmlns:p="http://schemas.openxmlformats.org/presentationml/2006/main">
   <p:cSld>
     <p:spTree>
       <p:nvGrpSpPr>
@@ -6543,7 +6399,14 @@
         <p:cNvGrpSpPr/>
         <p:nvPr/>
       </p:nvGrpSpPr>
-      <p:grpSpPr/>
+      <p:grpSpPr>
+        <a:xfrm>
+          <a:off x="0" y="0"/>
+          <a:ext cx="0" cy="0"/>
+          <a:chOff x="0" y="0"/>
+          <a:chExt cx="0" cy="0"/>
+        </a:xfrm>
+      </p:grpSpPr>
       <p:sp>
         <p:nvSpPr>
           <p:cNvPr id="2" name="TextBox 1"/>
@@ -6701,7 +6564,7 @@
           <p:nvPr/>
         </p:nvPicPr>
         <p:blipFill>
-          <a:blip r:embed="rId2"/>
+          <a:blip r:embed="rId3"/>
           <a:stretch>
             <a:fillRect/>
           </a:stretch>
@@ -6757,6 +6620,7 @@
           <a:lstStyle/>
           <a:p>
             <a:pPr algn="ctr"/>
+            <a:endParaRPr/>
           </a:p>
         </p:txBody>
       </p:sp>
@@ -6871,7 +6735,7 @@
 </file>
 
 <file path=ppt/slides/slide13.xml><?xml version="1.0" encoding="utf-8"?>
-<p:sld xmlns:a="http://schemas.openxmlformats.org/drawingml/2006/main" xmlns:p="http://schemas.openxmlformats.org/presentationml/2006/main" xmlns:r="http://schemas.openxmlformats.org/officeDocument/2006/relationships">
+<p:sld xmlns:a="http://schemas.openxmlformats.org/drawingml/2006/main" xmlns:r="http://schemas.openxmlformats.org/officeDocument/2006/relationships" xmlns:p="http://schemas.openxmlformats.org/presentationml/2006/main">
   <p:cSld>
     <p:spTree>
       <p:nvGrpSpPr>
@@ -6879,7 +6743,14 @@
         <p:cNvGrpSpPr/>
         <p:nvPr/>
       </p:nvGrpSpPr>
-      <p:grpSpPr/>
+      <p:grpSpPr>
+        <a:xfrm>
+          <a:off x="0" y="0"/>
+          <a:ext cx="0" cy="0"/>
+          <a:chOff x="0" y="0"/>
+          <a:chExt cx="0" cy="0"/>
+        </a:xfrm>
+      </p:grpSpPr>
       <p:sp>
         <p:nvSpPr>
           <p:cNvPr id="2" name="TextBox 1"/>
@@ -7037,7 +6908,7 @@
           <p:nvPr/>
         </p:nvPicPr>
         <p:blipFill>
-          <a:blip r:embed="rId2"/>
+          <a:blip r:embed="rId3"/>
           <a:stretch>
             <a:fillRect/>
           </a:stretch>
@@ -7093,6 +6964,7 @@
           <a:lstStyle/>
           <a:p>
             <a:pPr algn="ctr"/>
+            <a:endParaRPr/>
           </a:p>
         </p:txBody>
       </p:sp>
@@ -7207,7 +7079,7 @@
 </file>
 
 <file path=ppt/slides/slide14.xml><?xml version="1.0" encoding="utf-8"?>
-<p:sld xmlns:a="http://schemas.openxmlformats.org/drawingml/2006/main" xmlns:p="http://schemas.openxmlformats.org/presentationml/2006/main" xmlns:r="http://schemas.openxmlformats.org/officeDocument/2006/relationships">
+<p:sld xmlns:a="http://schemas.openxmlformats.org/drawingml/2006/main" xmlns:r="http://schemas.openxmlformats.org/officeDocument/2006/relationships" xmlns:p="http://schemas.openxmlformats.org/presentationml/2006/main">
   <p:cSld>
     <p:spTree>
       <p:nvGrpSpPr>
@@ -7215,7 +7087,14 @@
         <p:cNvGrpSpPr/>
         <p:nvPr/>
       </p:nvGrpSpPr>
-      <p:grpSpPr/>
+      <p:grpSpPr>
+        <a:xfrm>
+          <a:off x="0" y="0"/>
+          <a:ext cx="0" cy="0"/>
+          <a:chOff x="0" y="0"/>
+          <a:chExt cx="0" cy="0"/>
+        </a:xfrm>
+      </p:grpSpPr>
       <p:sp>
         <p:nvSpPr>
           <p:cNvPr id="2" name="TextBox 1"/>
@@ -7323,6 +7202,7 @@
           <a:lstStyle/>
           <a:p>
             <a:pPr algn="ctr"/>
+            <a:endParaRPr/>
           </a:p>
         </p:txBody>
       </p:sp>
@@ -7367,6 +7247,7 @@
           <a:lstStyle/>
           <a:p>
             <a:pPr algn="ctr"/>
+            <a:endParaRPr/>
           </a:p>
         </p:txBody>
       </p:sp>
@@ -7526,6 +7407,7 @@
           <a:lstStyle/>
           <a:p>
             <a:pPr algn="ctr"/>
+            <a:endParaRPr/>
           </a:p>
         </p:txBody>
       </p:sp>
@@ -7640,7 +7522,7 @@
 </file>
 
 <file path=ppt/slides/slide15.xml><?xml version="1.0" encoding="utf-8"?>
-<p:sld xmlns:a="http://schemas.openxmlformats.org/drawingml/2006/main" xmlns:p="http://schemas.openxmlformats.org/presentationml/2006/main" xmlns:r="http://schemas.openxmlformats.org/officeDocument/2006/relationships">
+<p:sld xmlns:a="http://schemas.openxmlformats.org/drawingml/2006/main" xmlns:r="http://schemas.openxmlformats.org/officeDocument/2006/relationships" xmlns:p="http://schemas.openxmlformats.org/presentationml/2006/main">
   <p:cSld>
     <p:spTree>
       <p:nvGrpSpPr>
@@ -7648,7 +7530,14 @@
         <p:cNvGrpSpPr/>
         <p:nvPr/>
       </p:nvGrpSpPr>
-      <p:grpSpPr/>
+      <p:grpSpPr>
+        <a:xfrm>
+          <a:off x="0" y="0"/>
+          <a:ext cx="0" cy="0"/>
+          <a:chOff x="0" y="0"/>
+          <a:chExt cx="0" cy="0"/>
+        </a:xfrm>
+      </p:grpSpPr>
       <p:sp>
         <p:nvSpPr>
           <p:cNvPr id="2" name="TextBox 1"/>
@@ -7806,7 +7695,7 @@
           <p:nvPr/>
         </p:nvPicPr>
         <p:blipFill>
-          <a:blip r:embed="rId2"/>
+          <a:blip r:embed="rId3"/>
           <a:stretch>
             <a:fillRect/>
           </a:stretch>
@@ -7862,6 +7751,7 @@
           <a:lstStyle/>
           <a:p>
             <a:pPr algn="ctr"/>
+            <a:endParaRPr/>
           </a:p>
         </p:txBody>
       </p:sp>
@@ -7976,7 +7866,7 @@
 </file>
 
 <file path=ppt/slides/slide16.xml><?xml version="1.0" encoding="utf-8"?>
-<p:sld xmlns:a="http://schemas.openxmlformats.org/drawingml/2006/main" xmlns:p="http://schemas.openxmlformats.org/presentationml/2006/main" xmlns:r="http://schemas.openxmlformats.org/officeDocument/2006/relationships">
+<p:sld xmlns:a="http://schemas.openxmlformats.org/drawingml/2006/main" xmlns:r="http://schemas.openxmlformats.org/officeDocument/2006/relationships" xmlns:p="http://schemas.openxmlformats.org/presentationml/2006/main">
   <p:cSld>
     <p:spTree>
       <p:nvGrpSpPr>
@@ -7984,7 +7874,14 @@
         <p:cNvGrpSpPr/>
         <p:nvPr/>
       </p:nvGrpSpPr>
-      <p:grpSpPr/>
+      <p:grpSpPr>
+        <a:xfrm>
+          <a:off x="0" y="0"/>
+          <a:ext cx="0" cy="0"/>
+          <a:chOff x="0" y="0"/>
+          <a:chExt cx="0" cy="0"/>
+        </a:xfrm>
+      </p:grpSpPr>
       <p:sp>
         <p:nvSpPr>
           <p:cNvPr id="2" name="TextBox 1"/>
@@ -8142,7 +8039,7 @@
           <p:nvPr/>
         </p:nvPicPr>
         <p:blipFill>
-          <a:blip r:embed="rId2"/>
+          <a:blip r:embed="rId3"/>
           <a:stretch>
             <a:fillRect/>
           </a:stretch>
@@ -8198,6 +8095,7 @@
           <a:lstStyle/>
           <a:p>
             <a:pPr algn="ctr"/>
+            <a:endParaRPr/>
           </a:p>
         </p:txBody>
       </p:sp>
@@ -8312,7 +8210,7 @@
 </file>
 
 <file path=ppt/slides/slide17.xml><?xml version="1.0" encoding="utf-8"?>
-<p:sld xmlns:a="http://schemas.openxmlformats.org/drawingml/2006/main" xmlns:p="http://schemas.openxmlformats.org/presentationml/2006/main" xmlns:r="http://schemas.openxmlformats.org/officeDocument/2006/relationships">
+<p:sld xmlns:a="http://schemas.openxmlformats.org/drawingml/2006/main" xmlns:r="http://schemas.openxmlformats.org/officeDocument/2006/relationships" xmlns:p="http://schemas.openxmlformats.org/presentationml/2006/main">
   <p:cSld>
     <p:spTree>
       <p:nvGrpSpPr>
@@ -8320,7 +8218,14 @@
         <p:cNvGrpSpPr/>
         <p:nvPr/>
       </p:nvGrpSpPr>
-      <p:grpSpPr/>
+      <p:grpSpPr>
+        <a:xfrm>
+          <a:off x="0" y="0"/>
+          <a:ext cx="0" cy="0"/>
+          <a:chOff x="0" y="0"/>
+          <a:chExt cx="0" cy="0"/>
+        </a:xfrm>
+      </p:grpSpPr>
       <p:sp>
         <p:nvSpPr>
           <p:cNvPr id="2" name="TextBox 1"/>
@@ -8478,7 +8383,7 @@
           <p:nvPr/>
         </p:nvPicPr>
         <p:blipFill>
-          <a:blip r:embed="rId2"/>
+          <a:blip r:embed="rId3"/>
           <a:stretch>
             <a:fillRect/>
           </a:stretch>
@@ -8534,6 +8439,7 @@
           <a:lstStyle/>
           <a:p>
             <a:pPr algn="ctr"/>
+            <a:endParaRPr/>
           </a:p>
         </p:txBody>
       </p:sp>
@@ -8648,7 +8554,7 @@
 </file>
 
 <file path=ppt/slides/slide18.xml><?xml version="1.0" encoding="utf-8"?>
-<p:sld xmlns:a="http://schemas.openxmlformats.org/drawingml/2006/main" xmlns:p="http://schemas.openxmlformats.org/presentationml/2006/main" xmlns:r="http://schemas.openxmlformats.org/officeDocument/2006/relationships">
+<p:sld xmlns:a="http://schemas.openxmlformats.org/drawingml/2006/main" xmlns:r="http://schemas.openxmlformats.org/officeDocument/2006/relationships" xmlns:p="http://schemas.openxmlformats.org/presentationml/2006/main">
   <p:cSld>
     <p:spTree>
       <p:nvGrpSpPr>
@@ -8656,7 +8562,14 @@
         <p:cNvGrpSpPr/>
         <p:nvPr/>
       </p:nvGrpSpPr>
-      <p:grpSpPr/>
+      <p:grpSpPr>
+        <a:xfrm>
+          <a:off x="0" y="0"/>
+          <a:ext cx="0" cy="0"/>
+          <a:chOff x="0" y="0"/>
+          <a:chExt cx="0" cy="0"/>
+        </a:xfrm>
+      </p:grpSpPr>
       <p:sp>
         <p:nvSpPr>
           <p:cNvPr id="2" name="TextBox 1"/>
@@ -8814,7 +8727,7 @@
           <p:nvPr/>
         </p:nvPicPr>
         <p:blipFill>
-          <a:blip r:embed="rId2"/>
+          <a:blip r:embed="rId3"/>
           <a:stretch>
             <a:fillRect/>
           </a:stretch>
@@ -8870,6 +8783,7 @@
           <a:lstStyle/>
           <a:p>
             <a:pPr algn="ctr"/>
+            <a:endParaRPr/>
           </a:p>
         </p:txBody>
       </p:sp>
@@ -8984,7 +8898,7 @@
 </file>
 
 <file path=ppt/slides/slide19.xml><?xml version="1.0" encoding="utf-8"?>
-<p:sld xmlns:a="http://schemas.openxmlformats.org/drawingml/2006/main" xmlns:p="http://schemas.openxmlformats.org/presentationml/2006/main" xmlns:r="http://schemas.openxmlformats.org/officeDocument/2006/relationships">
+<p:sld xmlns:a="http://schemas.openxmlformats.org/drawingml/2006/main" xmlns:r="http://schemas.openxmlformats.org/officeDocument/2006/relationships" xmlns:p="http://schemas.openxmlformats.org/presentationml/2006/main">
   <p:cSld>
     <p:spTree>
       <p:nvGrpSpPr>
@@ -8992,7 +8906,14 @@
         <p:cNvGrpSpPr/>
         <p:nvPr/>
       </p:nvGrpSpPr>
-      <p:grpSpPr/>
+      <p:grpSpPr>
+        <a:xfrm>
+          <a:off x="0" y="0"/>
+          <a:ext cx="0" cy="0"/>
+          <a:chOff x="0" y="0"/>
+          <a:chExt cx="0" cy="0"/>
+        </a:xfrm>
+      </p:grpSpPr>
       <p:sp>
         <p:nvSpPr>
           <p:cNvPr id="2" name="TextBox 1"/>
@@ -9150,7 +9071,7 @@
           <p:nvPr/>
         </p:nvPicPr>
         <p:blipFill>
-          <a:blip r:embed="rId2"/>
+          <a:blip r:embed="rId3"/>
           <a:stretch>
             <a:fillRect/>
           </a:stretch>
@@ -9206,6 +9127,7 @@
           <a:lstStyle/>
           <a:p>
             <a:pPr algn="ctr"/>
+            <a:endParaRPr/>
           </a:p>
         </p:txBody>
       </p:sp>
@@ -9320,7 +9242,7 @@
 </file>
 
 <file path=ppt/slides/slide2.xml><?xml version="1.0" encoding="utf-8"?>
-<p:sld xmlns:a="http://schemas.openxmlformats.org/drawingml/2006/main" xmlns:p="http://schemas.openxmlformats.org/presentationml/2006/main" xmlns:r="http://schemas.openxmlformats.org/officeDocument/2006/relationships">
+<p:sld xmlns:a="http://schemas.openxmlformats.org/drawingml/2006/main" xmlns:r="http://schemas.openxmlformats.org/officeDocument/2006/relationships" xmlns:p="http://schemas.openxmlformats.org/presentationml/2006/main">
   <p:cSld>
     <p:spTree>
       <p:nvGrpSpPr>
@@ -9328,7 +9250,14 @@
         <p:cNvGrpSpPr/>
         <p:nvPr/>
       </p:nvGrpSpPr>
-      <p:grpSpPr/>
+      <p:grpSpPr>
+        <a:xfrm>
+          <a:off x="0" y="0"/>
+          <a:ext cx="0" cy="0"/>
+          <a:chOff x="0" y="0"/>
+          <a:chExt cx="0" cy="0"/>
+        </a:xfrm>
+      </p:grpSpPr>
       <p:sp>
         <p:nvSpPr>
           <p:cNvPr id="2" name="TextBox 1"/>
@@ -9371,7 +9300,7 @@
         <p:spPr>
           <a:xfrm>
             <a:off x="548640" y="1170432"/>
-            <a:ext cx="11064240" cy="457200"/>
+            <a:ext cx="3728328" cy="338554"/>
           </a:xfrm>
           <a:prstGeom prst="rect">
             <a:avLst/>
@@ -9385,12 +9314,12 @@
           <a:lstStyle/>
           <a:p>
             <a:r>
-              <a:rPr sz="1600" i="1">
+              <a:rPr sz="1600" i="1" dirty="0">
                 <a:solidFill>
                   <a:srgbClr val="1B6EC2"/>
                 </a:solidFill>
               </a:rPr>
-              <a:t>Problem, Method, Dataset &amp; splits, Results — framed by an honesty audit</a:t>
+              <a:t>Problem, Method, Dataset &amp; splits, Results</a:t>
             </a:r>
           </a:p>
         </p:txBody>
@@ -9436,6 +9365,7 @@
           <a:lstStyle/>
           <a:p>
             <a:pPr algn="ctr"/>
+            <a:endParaRPr/>
           </a:p>
         </p:txBody>
       </p:sp>
@@ -9480,6 +9410,7 @@
           <a:lstStyle/>
           <a:p>
             <a:pPr algn="ctr"/>
+            <a:endParaRPr/>
           </a:p>
         </p:txBody>
       </p:sp>
@@ -9491,8 +9422,8 @@
         </p:nvSpPr>
         <p:spPr>
           <a:xfrm>
-            <a:off x="1051560" y="1965960"/>
-            <a:ext cx="10149840" cy="4069080"/>
+            <a:off x="1051560" y="2446228"/>
+            <a:ext cx="10149840" cy="3108543"/>
           </a:xfrm>
           <a:prstGeom prst="rect">
             <a:avLst/>
@@ -9511,7 +9442,7 @@
               </a:spcAft>
             </a:pPr>
             <a:r>
-              <a:rPr sz="2600" b="1">
+              <a:rPr sz="2600" b="1" dirty="0">
                 <a:solidFill>
                   <a:srgbClr val="1B6EC2"/>
                 </a:solidFill>
@@ -9519,12 +9450,36 @@
               <a:t>▪  </a:t>
             </a:r>
             <a:r>
-              <a:rPr sz="2600">
+              <a:rPr sz="2600" dirty="0" err="1">
                 <a:solidFill>
                   <a:srgbClr val="1F2D3D"/>
                 </a:solidFill>
               </a:rPr>
-              <a:t>題目定義 / Problem: one variable-length scan to (x, y) in metres, no GPS</a:t>
+              <a:t>題目定義</a:t>
+            </a:r>
+            <a:r>
+              <a:rPr sz="2600" dirty="0">
+                <a:solidFill>
+                  <a:srgbClr val="1F2D3D"/>
+                </a:solidFill>
+              </a:rPr>
+              <a:t> / Problem: one variable-length scan to (x, y) in </a:t>
+            </a:r>
+            <a:r>
+              <a:rPr sz="2600" dirty="0" err="1">
+                <a:solidFill>
+                  <a:srgbClr val="1F2D3D"/>
+                </a:solidFill>
+              </a:rPr>
+              <a:t>metres</a:t>
+            </a:r>
+            <a:r>
+              <a:rPr sz="2600" dirty="0">
+                <a:solidFill>
+                  <a:srgbClr val="1F2D3D"/>
+                </a:solidFill>
+              </a:rPr>
+              <a:t>, no GPS</a:t>
             </a:r>
           </a:p>
           <a:p>
@@ -9534,7 +9489,7 @@
               </a:spcAft>
             </a:pPr>
             <a:r>
-              <a:rPr sz="2600" b="1">
+              <a:rPr sz="2600" b="1" dirty="0">
                 <a:solidFill>
                   <a:srgbClr val="1B6EC2"/>
                 </a:solidFill>
@@ -9542,12 +9497,20 @@
               <a:t>▪  </a:t>
             </a:r>
             <a:r>
-              <a:rPr sz="2600">
+              <a:rPr sz="2600" dirty="0" err="1">
                 <a:solidFill>
                   <a:srgbClr val="1F2D3D"/>
                 </a:solidFill>
               </a:rPr>
-              <a:t>做法 / Method: Set Transformer to grid classification to coarse-gated cascade</a:t>
+              <a:t>做法</a:t>
+            </a:r>
+            <a:r>
+              <a:rPr sz="2600" dirty="0">
+                <a:solidFill>
+                  <a:srgbClr val="1F2D3D"/>
+                </a:solidFill>
+              </a:rPr>
+              <a:t> / Method: Set Transformer to grid classification to coarse-gated cascade</a:t>
             </a:r>
           </a:p>
           <a:p>
@@ -9557,7 +9520,7 @@
               </a:spcAft>
             </a:pPr>
             <a:r>
-              <a:rPr sz="2600" b="1">
+              <a:rPr sz="2600" b="1" dirty="0">
                 <a:solidFill>
                   <a:srgbClr val="1B6EC2"/>
                 </a:solidFill>
@@ -9565,12 +9528,20 @@
               <a:t>▪  </a:t>
             </a:r>
             <a:r>
-              <a:rPr sz="2600">
+              <a:rPr sz="2600" dirty="0" err="1">
                 <a:solidFill>
                   <a:srgbClr val="1F2D3D"/>
                 </a:solidFill>
               </a:rPr>
-              <a:t>資料集切分 / Dataset: 1,812 scans, 4 splits (A main, C cross-time hardest)</a:t>
+              <a:t>資料集切分</a:t>
+            </a:r>
+            <a:r>
+              <a:rPr sz="2600" dirty="0">
+                <a:solidFill>
+                  <a:srgbClr val="1F2D3D"/>
+                </a:solidFill>
+              </a:rPr>
+              <a:t> / Dataset: 1,812 scans, 4 splits (A main, C cross-time hardest)</a:t>
             </a:r>
           </a:p>
           <a:p>
@@ -9580,7 +9551,7 @@
               </a:spcAft>
             </a:pPr>
             <a:r>
-              <a:rPr sz="2600" b="1">
+              <a:rPr sz="2600" b="1" dirty="0">
                 <a:solidFill>
                   <a:srgbClr val="1B6EC2"/>
                 </a:solidFill>
@@ -9588,12 +9559,36 @@
               <a:t>▪  </a:t>
             </a:r>
             <a:r>
-              <a:rPr sz="2600">
+              <a:rPr sz="2600" dirty="0" err="1">
                 <a:solidFill>
                   <a:srgbClr val="1F2D3D"/>
                 </a:solidFill>
               </a:rPr>
-              <a:t>實驗結果 / Results: 1.57 to honest 0.75 m, with a self-caught 0.65 m mirage</a:t>
+              <a:t>實驗結果</a:t>
+            </a:r>
+            <a:r>
+              <a:rPr sz="2600" dirty="0">
+                <a:solidFill>
+                  <a:srgbClr val="1F2D3D"/>
+                </a:solidFill>
+              </a:rPr>
+              <a:t> / Results: 1.57 to 0.75</a:t>
+            </a:r>
+            <a:r>
+              <a:rPr lang="en-US" altLang="zh-TW" sz="2600" dirty="0">
+                <a:solidFill>
+                  <a:srgbClr val="1F2D3D"/>
+                </a:solidFill>
+              </a:rPr>
+              <a:t>2</a:t>
+            </a:r>
+            <a:r>
+              <a:rPr sz="2600" dirty="0">
+                <a:solidFill>
+                  <a:srgbClr val="1F2D3D"/>
+                </a:solidFill>
+              </a:rPr>
+              <a:t> m</a:t>
             </a:r>
           </a:p>
         </p:txBody>
@@ -9639,6 +9634,7 @@
           <a:lstStyle/>
           <a:p>
             <a:pPr algn="ctr"/>
+            <a:endParaRPr/>
           </a:p>
         </p:txBody>
       </p:sp>
@@ -9719,7 +9715,7 @@
 </file>
 
 <file path=ppt/slides/slide20.xml><?xml version="1.0" encoding="utf-8"?>
-<p:sld xmlns:a="http://schemas.openxmlformats.org/drawingml/2006/main" xmlns:p="http://schemas.openxmlformats.org/presentationml/2006/main" xmlns:r="http://schemas.openxmlformats.org/officeDocument/2006/relationships">
+<p:sld xmlns:a="http://schemas.openxmlformats.org/drawingml/2006/main" xmlns:r="http://schemas.openxmlformats.org/officeDocument/2006/relationships" xmlns:p="http://schemas.openxmlformats.org/presentationml/2006/main">
   <p:cSld>
     <p:spTree>
       <p:nvGrpSpPr>
@@ -9727,7 +9723,14 @@
         <p:cNvGrpSpPr/>
         <p:nvPr/>
       </p:nvGrpSpPr>
-      <p:grpSpPr/>
+      <p:grpSpPr>
+        <a:xfrm>
+          <a:off x="0" y="0"/>
+          <a:ext cx="0" cy="0"/>
+          <a:chOff x="0" y="0"/>
+          <a:chExt cx="0" cy="0"/>
+        </a:xfrm>
+      </p:grpSpPr>
       <p:sp>
         <p:nvSpPr>
           <p:cNvPr id="2" name="TextBox 1"/>
@@ -9885,7 +9888,7 @@
           <p:nvPr/>
         </p:nvPicPr>
         <p:blipFill>
-          <a:blip r:embed="rId2"/>
+          <a:blip r:embed="rId3"/>
           <a:stretch>
             <a:fillRect/>
           </a:stretch>
@@ -9941,6 +9944,7 @@
           <a:lstStyle/>
           <a:p>
             <a:pPr algn="ctr"/>
+            <a:endParaRPr/>
           </a:p>
         </p:txBody>
       </p:sp>
@@ -10055,7 +10059,7 @@
 </file>
 
 <file path=ppt/slides/slide21.xml><?xml version="1.0" encoding="utf-8"?>
-<p:sld xmlns:a="http://schemas.openxmlformats.org/drawingml/2006/main" xmlns:p="http://schemas.openxmlformats.org/presentationml/2006/main" xmlns:r="http://schemas.openxmlformats.org/officeDocument/2006/relationships">
+<p:sld xmlns:a="http://schemas.openxmlformats.org/drawingml/2006/main" xmlns:r="http://schemas.openxmlformats.org/officeDocument/2006/relationships" xmlns:p="http://schemas.openxmlformats.org/presentationml/2006/main">
   <p:cSld>
     <p:spTree>
       <p:nvGrpSpPr>
@@ -10063,7 +10067,14 @@
         <p:cNvGrpSpPr/>
         <p:nvPr/>
       </p:nvGrpSpPr>
-      <p:grpSpPr/>
+      <p:grpSpPr>
+        <a:xfrm>
+          <a:off x="0" y="0"/>
+          <a:ext cx="0" cy="0"/>
+          <a:chOff x="0" y="0"/>
+          <a:chExt cx="0" cy="0"/>
+        </a:xfrm>
+      </p:grpSpPr>
       <p:sp>
         <p:nvSpPr>
           <p:cNvPr id="2" name="TextBox 1"/>
@@ -10221,7 +10232,7 @@
           <p:nvPr/>
         </p:nvPicPr>
         <p:blipFill>
-          <a:blip r:embed="rId2"/>
+          <a:blip r:embed="rId3"/>
           <a:stretch>
             <a:fillRect/>
           </a:stretch>
@@ -10277,6 +10288,7 @@
           <a:lstStyle/>
           <a:p>
             <a:pPr algn="ctr"/>
+            <a:endParaRPr/>
           </a:p>
         </p:txBody>
       </p:sp>
@@ -10391,7 +10403,7 @@
 </file>
 
 <file path=ppt/slides/slide22.xml><?xml version="1.0" encoding="utf-8"?>
-<p:sld xmlns:a="http://schemas.openxmlformats.org/drawingml/2006/main" xmlns:p="http://schemas.openxmlformats.org/presentationml/2006/main" xmlns:r="http://schemas.openxmlformats.org/officeDocument/2006/relationships">
+<p:sld xmlns:a="http://schemas.openxmlformats.org/drawingml/2006/main" xmlns:r="http://schemas.openxmlformats.org/officeDocument/2006/relationships" xmlns:p="http://schemas.openxmlformats.org/presentationml/2006/main">
   <p:cSld>
     <p:spTree>
       <p:nvGrpSpPr>
@@ -10399,7 +10411,14 @@
         <p:cNvGrpSpPr/>
         <p:nvPr/>
       </p:nvGrpSpPr>
-      <p:grpSpPr/>
+      <p:grpSpPr>
+        <a:xfrm>
+          <a:off x="0" y="0"/>
+          <a:ext cx="0" cy="0"/>
+          <a:chOff x="0" y="0"/>
+          <a:chExt cx="0" cy="0"/>
+        </a:xfrm>
+      </p:grpSpPr>
       <p:sp>
         <p:nvSpPr>
           <p:cNvPr id="2" name="TextBox 1"/>
@@ -10557,7 +10576,7 @@
           <p:nvPr/>
         </p:nvPicPr>
         <p:blipFill>
-          <a:blip r:embed="rId2"/>
+          <a:blip r:embed="rId3"/>
           <a:stretch>
             <a:fillRect/>
           </a:stretch>
@@ -10613,6 +10632,7 @@
           <a:lstStyle/>
           <a:p>
             <a:pPr algn="ctr"/>
+            <a:endParaRPr/>
           </a:p>
         </p:txBody>
       </p:sp>
@@ -10727,7 +10747,7 @@
 </file>
 
 <file path=ppt/slides/slide23.xml><?xml version="1.0" encoding="utf-8"?>
-<p:sld xmlns:a="http://schemas.openxmlformats.org/drawingml/2006/main" xmlns:p="http://schemas.openxmlformats.org/presentationml/2006/main" xmlns:r="http://schemas.openxmlformats.org/officeDocument/2006/relationships">
+<p:sld xmlns:a="http://schemas.openxmlformats.org/drawingml/2006/main" xmlns:r="http://schemas.openxmlformats.org/officeDocument/2006/relationships" xmlns:p="http://schemas.openxmlformats.org/presentationml/2006/main">
   <p:cSld>
     <p:spTree>
       <p:nvGrpSpPr>
@@ -10735,7 +10755,14 @@
         <p:cNvGrpSpPr/>
         <p:nvPr/>
       </p:nvGrpSpPr>
-      <p:grpSpPr/>
+      <p:grpSpPr>
+        <a:xfrm>
+          <a:off x="0" y="0"/>
+          <a:ext cx="0" cy="0"/>
+          <a:chOff x="0" y="0"/>
+          <a:chExt cx="0" cy="0"/>
+        </a:xfrm>
+      </p:grpSpPr>
       <p:sp>
         <p:nvSpPr>
           <p:cNvPr id="2" name="Rectangle 1"/>
@@ -10777,6 +10804,7 @@
           <a:lstStyle/>
           <a:p>
             <a:pPr algn="ctr"/>
+            <a:endParaRPr/>
           </a:p>
         </p:txBody>
       </p:sp>
@@ -10889,6 +10917,7 @@
           <a:lstStyle/>
           <a:p>
             <a:pPr algn="ctr"/>
+            <a:endParaRPr/>
           </a:p>
         </p:txBody>
       </p:sp>
@@ -10935,7 +10964,7 @@
 </file>
 
 <file path=ppt/slides/slide24.xml><?xml version="1.0" encoding="utf-8"?>
-<p:sld xmlns:a="http://schemas.openxmlformats.org/drawingml/2006/main" xmlns:p="http://schemas.openxmlformats.org/presentationml/2006/main" xmlns:r="http://schemas.openxmlformats.org/officeDocument/2006/relationships">
+<p:sld xmlns:a="http://schemas.openxmlformats.org/drawingml/2006/main" xmlns:r="http://schemas.openxmlformats.org/officeDocument/2006/relationships" xmlns:p="http://schemas.openxmlformats.org/presentationml/2006/main">
   <p:cSld>
     <p:spTree>
       <p:nvGrpSpPr>
@@ -10943,7 +10972,14 @@
         <p:cNvGrpSpPr/>
         <p:nvPr/>
       </p:nvGrpSpPr>
-      <p:grpSpPr/>
+      <p:grpSpPr>
+        <a:xfrm>
+          <a:off x="0" y="0"/>
+          <a:ext cx="0" cy="0"/>
+          <a:chOff x="0" y="0"/>
+          <a:chExt cx="0" cy="0"/>
+        </a:xfrm>
+      </p:grpSpPr>
       <p:sp>
         <p:nvSpPr>
           <p:cNvPr id="2" name="TextBox 1"/>
@@ -11101,7 +11137,7 @@
           <p:nvPr/>
         </p:nvPicPr>
         <p:blipFill>
-          <a:blip r:embed="rId2"/>
+          <a:blip r:embed="rId3"/>
           <a:stretch>
             <a:fillRect/>
           </a:stretch>
@@ -11157,6 +11193,7 @@
           <a:lstStyle/>
           <a:p>
             <a:pPr algn="ctr"/>
+            <a:endParaRPr/>
           </a:p>
         </p:txBody>
       </p:sp>
@@ -11271,7 +11308,7 @@
 </file>
 
 <file path=ppt/slides/slide25.xml><?xml version="1.0" encoding="utf-8"?>
-<p:sld xmlns:a="http://schemas.openxmlformats.org/drawingml/2006/main" xmlns:p="http://schemas.openxmlformats.org/presentationml/2006/main" xmlns:r="http://schemas.openxmlformats.org/officeDocument/2006/relationships">
+<p:sld xmlns:a="http://schemas.openxmlformats.org/drawingml/2006/main" xmlns:r="http://schemas.openxmlformats.org/officeDocument/2006/relationships" xmlns:p="http://schemas.openxmlformats.org/presentationml/2006/main">
   <p:cSld>
     <p:spTree>
       <p:nvGrpSpPr>
@@ -11279,7 +11316,14 @@
         <p:cNvGrpSpPr/>
         <p:nvPr/>
       </p:nvGrpSpPr>
-      <p:grpSpPr/>
+      <p:grpSpPr>
+        <a:xfrm>
+          <a:off x="0" y="0"/>
+          <a:ext cx="0" cy="0"/>
+          <a:chOff x="0" y="0"/>
+          <a:chExt cx="0" cy="0"/>
+        </a:xfrm>
+      </p:grpSpPr>
       <p:sp>
         <p:nvSpPr>
           <p:cNvPr id="2" name="TextBox 1"/>
@@ -11437,7 +11481,7 @@
           <p:nvPr/>
         </p:nvPicPr>
         <p:blipFill>
-          <a:blip r:embed="rId2"/>
+          <a:blip r:embed="rId3"/>
           <a:stretch>
             <a:fillRect/>
           </a:stretch>
@@ -11493,6 +11537,7 @@
           <a:lstStyle/>
           <a:p>
             <a:pPr algn="ctr"/>
+            <a:endParaRPr/>
           </a:p>
         </p:txBody>
       </p:sp>
@@ -11607,7 +11652,7 @@
 </file>
 
 <file path=ppt/slides/slide26.xml><?xml version="1.0" encoding="utf-8"?>
-<p:sld xmlns:a="http://schemas.openxmlformats.org/drawingml/2006/main" xmlns:p="http://schemas.openxmlformats.org/presentationml/2006/main" xmlns:r="http://schemas.openxmlformats.org/officeDocument/2006/relationships">
+<p:sld xmlns:a="http://schemas.openxmlformats.org/drawingml/2006/main" xmlns:r="http://schemas.openxmlformats.org/officeDocument/2006/relationships" xmlns:p="http://schemas.openxmlformats.org/presentationml/2006/main">
   <p:cSld>
     <p:spTree>
       <p:nvGrpSpPr>
@@ -11615,7 +11660,14 @@
         <p:cNvGrpSpPr/>
         <p:nvPr/>
       </p:nvGrpSpPr>
-      <p:grpSpPr/>
+      <p:grpSpPr>
+        <a:xfrm>
+          <a:off x="0" y="0"/>
+          <a:ext cx="0" cy="0"/>
+          <a:chOff x="0" y="0"/>
+          <a:chExt cx="0" cy="0"/>
+        </a:xfrm>
+      </p:grpSpPr>
       <p:sp>
         <p:nvSpPr>
           <p:cNvPr id="2" name="TextBox 1"/>
@@ -11773,7 +11825,7 @@
           <p:nvPr/>
         </p:nvPicPr>
         <p:blipFill>
-          <a:blip r:embed="rId2"/>
+          <a:blip r:embed="rId3"/>
           <a:stretch>
             <a:fillRect/>
           </a:stretch>
@@ -11829,6 +11881,7 @@
           <a:lstStyle/>
           <a:p>
             <a:pPr algn="ctr"/>
+            <a:endParaRPr/>
           </a:p>
         </p:txBody>
       </p:sp>
@@ -11943,7 +11996,7 @@
 </file>
 
 <file path=ppt/slides/slide27.xml><?xml version="1.0" encoding="utf-8"?>
-<p:sld xmlns:a="http://schemas.openxmlformats.org/drawingml/2006/main" xmlns:p="http://schemas.openxmlformats.org/presentationml/2006/main" xmlns:r="http://schemas.openxmlformats.org/officeDocument/2006/relationships">
+<p:sld xmlns:a="http://schemas.openxmlformats.org/drawingml/2006/main" xmlns:r="http://schemas.openxmlformats.org/officeDocument/2006/relationships" xmlns:p="http://schemas.openxmlformats.org/presentationml/2006/main">
   <p:cSld>
     <p:spTree>
       <p:nvGrpSpPr>
@@ -11951,7 +12004,14 @@
         <p:cNvGrpSpPr/>
         <p:nvPr/>
       </p:nvGrpSpPr>
-      <p:grpSpPr/>
+      <p:grpSpPr>
+        <a:xfrm>
+          <a:off x="0" y="0"/>
+          <a:ext cx="0" cy="0"/>
+          <a:chOff x="0" y="0"/>
+          <a:chExt cx="0" cy="0"/>
+        </a:xfrm>
+      </p:grpSpPr>
       <p:sp>
         <p:nvSpPr>
           <p:cNvPr id="2" name="TextBox 1"/>
@@ -12109,7 +12169,7 @@
           <p:nvPr/>
         </p:nvPicPr>
         <p:blipFill>
-          <a:blip r:embed="rId2"/>
+          <a:blip r:embed="rId3"/>
           <a:stretch>
             <a:fillRect/>
           </a:stretch>
@@ -12165,6 +12225,7 @@
           <a:lstStyle/>
           <a:p>
             <a:pPr algn="ctr"/>
+            <a:endParaRPr/>
           </a:p>
         </p:txBody>
       </p:sp>
@@ -12279,7 +12340,7 @@
 </file>
 
 <file path=ppt/slides/slide28.xml><?xml version="1.0" encoding="utf-8"?>
-<p:sld xmlns:a="http://schemas.openxmlformats.org/drawingml/2006/main" xmlns:p="http://schemas.openxmlformats.org/presentationml/2006/main" xmlns:r="http://schemas.openxmlformats.org/officeDocument/2006/relationships">
+<p:sld xmlns:a="http://schemas.openxmlformats.org/drawingml/2006/main" xmlns:r="http://schemas.openxmlformats.org/officeDocument/2006/relationships" xmlns:p="http://schemas.openxmlformats.org/presentationml/2006/main">
   <p:cSld>
     <p:spTree>
       <p:nvGrpSpPr>
@@ -12287,7 +12348,14 @@
         <p:cNvGrpSpPr/>
         <p:nvPr/>
       </p:nvGrpSpPr>
-      <p:grpSpPr/>
+      <p:grpSpPr>
+        <a:xfrm>
+          <a:off x="0" y="0"/>
+          <a:ext cx="0" cy="0"/>
+          <a:chOff x="0" y="0"/>
+          <a:chExt cx="0" cy="0"/>
+        </a:xfrm>
+      </p:grpSpPr>
       <p:sp>
         <p:nvSpPr>
           <p:cNvPr id="2" name="TextBox 1"/>
@@ -12445,7 +12513,7 @@
           <p:nvPr/>
         </p:nvPicPr>
         <p:blipFill>
-          <a:blip r:embed="rId2"/>
+          <a:blip r:embed="rId3"/>
           <a:stretch>
             <a:fillRect/>
           </a:stretch>
@@ -12501,6 +12569,7 @@
           <a:lstStyle/>
           <a:p>
             <a:pPr algn="ctr"/>
+            <a:endParaRPr/>
           </a:p>
         </p:txBody>
       </p:sp>
@@ -12615,7 +12684,7 @@
 </file>
 
 <file path=ppt/slides/slide29.xml><?xml version="1.0" encoding="utf-8"?>
-<p:sld xmlns:a="http://schemas.openxmlformats.org/drawingml/2006/main" xmlns:p="http://schemas.openxmlformats.org/presentationml/2006/main" xmlns:r="http://schemas.openxmlformats.org/officeDocument/2006/relationships">
+<p:sld xmlns:a="http://schemas.openxmlformats.org/drawingml/2006/main" xmlns:r="http://schemas.openxmlformats.org/officeDocument/2006/relationships" xmlns:p="http://schemas.openxmlformats.org/presentationml/2006/main">
   <p:cSld>
     <p:spTree>
       <p:nvGrpSpPr>
@@ -12623,7 +12692,14 @@
         <p:cNvGrpSpPr/>
         <p:nvPr/>
       </p:nvGrpSpPr>
-      <p:grpSpPr/>
+      <p:grpSpPr>
+        <a:xfrm>
+          <a:off x="0" y="0"/>
+          <a:ext cx="0" cy="0"/>
+          <a:chOff x="0" y="0"/>
+          <a:chExt cx="0" cy="0"/>
+        </a:xfrm>
+      </p:grpSpPr>
       <p:sp>
         <p:nvSpPr>
           <p:cNvPr id="2" name="TextBox 1"/>
@@ -12781,7 +12857,7 @@
           <p:nvPr/>
         </p:nvPicPr>
         <p:blipFill>
-          <a:blip r:embed="rId2"/>
+          <a:blip r:embed="rId3"/>
           <a:stretch>
             <a:fillRect/>
           </a:stretch>
@@ -12837,6 +12913,7 @@
           <a:lstStyle/>
           <a:p>
             <a:pPr algn="ctr"/>
+            <a:endParaRPr/>
           </a:p>
         </p:txBody>
       </p:sp>
@@ -12951,7 +13028,7 @@
 </file>
 
 <file path=ppt/slides/slide3.xml><?xml version="1.0" encoding="utf-8"?>
-<p:sld xmlns:a="http://schemas.openxmlformats.org/drawingml/2006/main" xmlns:p="http://schemas.openxmlformats.org/presentationml/2006/main" xmlns:r="http://schemas.openxmlformats.org/officeDocument/2006/relationships">
+<p:sld xmlns:a="http://schemas.openxmlformats.org/drawingml/2006/main" xmlns:r="http://schemas.openxmlformats.org/officeDocument/2006/relationships" xmlns:p="http://schemas.openxmlformats.org/presentationml/2006/main">
   <p:cSld>
     <p:spTree>
       <p:nvGrpSpPr>
@@ -12959,7 +13036,14 @@
         <p:cNvGrpSpPr/>
         <p:nvPr/>
       </p:nvGrpSpPr>
-      <p:grpSpPr/>
+      <p:grpSpPr>
+        <a:xfrm>
+          <a:off x="0" y="0"/>
+          <a:ext cx="0" cy="0"/>
+          <a:chOff x="0" y="0"/>
+          <a:chExt cx="0" cy="0"/>
+        </a:xfrm>
+      </p:grpSpPr>
       <p:sp>
         <p:nvSpPr>
           <p:cNvPr id="2" name="Rectangle 1"/>
@@ -13001,6 +13085,7 @@
           <a:lstStyle/>
           <a:p>
             <a:pPr algn="ctr"/>
+            <a:endParaRPr/>
           </a:p>
         </p:txBody>
       </p:sp>
@@ -13113,6 +13198,7 @@
           <a:lstStyle/>
           <a:p>
             <a:pPr algn="ctr"/>
+            <a:endParaRPr/>
           </a:p>
         </p:txBody>
       </p:sp>
@@ -13159,7 +13245,7 @@
 </file>
 
 <file path=ppt/slides/slide30.xml><?xml version="1.0" encoding="utf-8"?>
-<p:sld xmlns:a="http://schemas.openxmlformats.org/drawingml/2006/main" xmlns:p="http://schemas.openxmlformats.org/presentationml/2006/main" xmlns:r="http://schemas.openxmlformats.org/officeDocument/2006/relationships">
+<p:sld xmlns:a="http://schemas.openxmlformats.org/drawingml/2006/main" xmlns:r="http://schemas.openxmlformats.org/officeDocument/2006/relationships" xmlns:p="http://schemas.openxmlformats.org/presentationml/2006/main">
   <p:cSld>
     <p:spTree>
       <p:nvGrpSpPr>
@@ -13167,7 +13253,14 @@
         <p:cNvGrpSpPr/>
         <p:nvPr/>
       </p:nvGrpSpPr>
-      <p:grpSpPr/>
+      <p:grpSpPr>
+        <a:xfrm>
+          <a:off x="0" y="0"/>
+          <a:ext cx="0" cy="0"/>
+          <a:chOff x="0" y="0"/>
+          <a:chExt cx="0" cy="0"/>
+        </a:xfrm>
+      </p:grpSpPr>
       <p:sp>
         <p:nvSpPr>
           <p:cNvPr id="2" name="TextBox 1"/>
@@ -13325,7 +13418,7 @@
           <p:nvPr/>
         </p:nvPicPr>
         <p:blipFill>
-          <a:blip r:embed="rId2"/>
+          <a:blip r:embed="rId3"/>
           <a:stretch>
             <a:fillRect/>
           </a:stretch>
@@ -13381,6 +13474,7 @@
           <a:lstStyle/>
           <a:p>
             <a:pPr algn="ctr"/>
+            <a:endParaRPr/>
           </a:p>
         </p:txBody>
       </p:sp>
@@ -13495,7 +13589,7 @@
 </file>
 
 <file path=ppt/slides/slide31.xml><?xml version="1.0" encoding="utf-8"?>
-<p:sld xmlns:a="http://schemas.openxmlformats.org/drawingml/2006/main" xmlns:p="http://schemas.openxmlformats.org/presentationml/2006/main" xmlns:r="http://schemas.openxmlformats.org/officeDocument/2006/relationships">
+<p:sld xmlns:a="http://schemas.openxmlformats.org/drawingml/2006/main" xmlns:r="http://schemas.openxmlformats.org/officeDocument/2006/relationships" xmlns:p="http://schemas.openxmlformats.org/presentationml/2006/main">
   <p:cSld>
     <p:spTree>
       <p:nvGrpSpPr>
@@ -13503,7 +13597,14 @@
         <p:cNvGrpSpPr/>
         <p:nvPr/>
       </p:nvGrpSpPr>
-      <p:grpSpPr/>
+      <p:grpSpPr>
+        <a:xfrm>
+          <a:off x="0" y="0"/>
+          <a:ext cx="0" cy="0"/>
+          <a:chOff x="0" y="0"/>
+          <a:chExt cx="0" cy="0"/>
+        </a:xfrm>
+      </p:grpSpPr>
       <p:sp>
         <p:nvSpPr>
           <p:cNvPr id="2" name="TextBox 1"/>
@@ -13661,7 +13762,7 @@
           <p:nvPr/>
         </p:nvPicPr>
         <p:blipFill>
-          <a:blip r:embed="rId2"/>
+          <a:blip r:embed="rId3"/>
           <a:stretch>
             <a:fillRect/>
           </a:stretch>
@@ -13717,6 +13818,7 @@
           <a:lstStyle/>
           <a:p>
             <a:pPr algn="ctr"/>
+            <a:endParaRPr/>
           </a:p>
         </p:txBody>
       </p:sp>
@@ -13831,7 +13933,7 @@
 </file>
 
 <file path=ppt/slides/slide32.xml><?xml version="1.0" encoding="utf-8"?>
-<p:sld xmlns:a="http://schemas.openxmlformats.org/drawingml/2006/main" xmlns:p="http://schemas.openxmlformats.org/presentationml/2006/main" xmlns:r="http://schemas.openxmlformats.org/officeDocument/2006/relationships">
+<p:sld xmlns:a="http://schemas.openxmlformats.org/drawingml/2006/main" xmlns:r="http://schemas.openxmlformats.org/officeDocument/2006/relationships" xmlns:p="http://schemas.openxmlformats.org/presentationml/2006/main">
   <p:cSld>
     <p:spTree>
       <p:nvGrpSpPr>
@@ -13839,7 +13941,14 @@
         <p:cNvGrpSpPr/>
         <p:nvPr/>
       </p:nvGrpSpPr>
-      <p:grpSpPr/>
+      <p:grpSpPr>
+        <a:xfrm>
+          <a:off x="0" y="0"/>
+          <a:ext cx="0" cy="0"/>
+          <a:chOff x="0" y="0"/>
+          <a:chExt cx="0" cy="0"/>
+        </a:xfrm>
+      </p:grpSpPr>
       <p:sp>
         <p:nvSpPr>
           <p:cNvPr id="2" name="TextBox 1"/>
@@ -13997,7 +14106,7 @@
           <p:nvPr/>
         </p:nvPicPr>
         <p:blipFill>
-          <a:blip r:embed="rId2"/>
+          <a:blip r:embed="rId3"/>
           <a:stretch>
             <a:fillRect/>
           </a:stretch>
@@ -14054,6 +14163,7 @@
           <a:lstStyle/>
           <a:p>
             <a:pPr algn="ctr"/>
+            <a:endParaRPr/>
           </a:p>
         </p:txBody>
       </p:sp>
@@ -14097,6 +14207,7 @@
           <a:lstStyle/>
           <a:p>
             <a:pPr algn="ctr"/>
+            <a:endParaRPr/>
           </a:p>
         </p:txBody>
       </p:sp>
@@ -14175,6 +14286,7 @@
           <a:lstStyle/>
           <a:p>
             <a:pPr algn="ctr"/>
+            <a:endParaRPr/>
           </a:p>
         </p:txBody>
       </p:sp>
@@ -14289,7 +14401,7 @@
 </file>
 
 <file path=ppt/slides/slide33.xml><?xml version="1.0" encoding="utf-8"?>
-<p:sld xmlns:a="http://schemas.openxmlformats.org/drawingml/2006/main" xmlns:p="http://schemas.openxmlformats.org/presentationml/2006/main" xmlns:r="http://schemas.openxmlformats.org/officeDocument/2006/relationships">
+<p:sld xmlns:a="http://schemas.openxmlformats.org/drawingml/2006/main" xmlns:r="http://schemas.openxmlformats.org/officeDocument/2006/relationships" xmlns:p="http://schemas.openxmlformats.org/presentationml/2006/main">
   <p:cSld>
     <p:spTree>
       <p:nvGrpSpPr>
@@ -14297,7 +14409,14 @@
         <p:cNvGrpSpPr/>
         <p:nvPr/>
       </p:nvGrpSpPr>
-      <p:grpSpPr/>
+      <p:grpSpPr>
+        <a:xfrm>
+          <a:off x="0" y="0"/>
+          <a:ext cx="0" cy="0"/>
+          <a:chOff x="0" y="0"/>
+          <a:chExt cx="0" cy="0"/>
+        </a:xfrm>
+      </p:grpSpPr>
       <p:sp>
         <p:nvSpPr>
           <p:cNvPr id="2" name="TextBox 1"/>
@@ -14455,7 +14574,7 @@
           <p:nvPr/>
         </p:nvPicPr>
         <p:blipFill>
-          <a:blip r:embed="rId2"/>
+          <a:blip r:embed="rId3"/>
           <a:stretch>
             <a:fillRect/>
           </a:stretch>
@@ -14511,6 +14630,7 @@
           <a:lstStyle/>
           <a:p>
             <a:pPr algn="ctr"/>
+            <a:endParaRPr/>
           </a:p>
         </p:txBody>
       </p:sp>
@@ -14625,7 +14745,7 @@
 </file>
 
 <file path=ppt/slides/slide4.xml><?xml version="1.0" encoding="utf-8"?>
-<p:sld xmlns:a="http://schemas.openxmlformats.org/drawingml/2006/main" xmlns:p="http://schemas.openxmlformats.org/presentationml/2006/main" xmlns:r="http://schemas.openxmlformats.org/officeDocument/2006/relationships">
+<p:sld xmlns:a="http://schemas.openxmlformats.org/drawingml/2006/main" xmlns:r="http://schemas.openxmlformats.org/officeDocument/2006/relationships" xmlns:p="http://schemas.openxmlformats.org/presentationml/2006/main">
   <p:cSld>
     <p:spTree>
       <p:nvGrpSpPr>
@@ -14633,7 +14753,14 @@
         <p:cNvGrpSpPr/>
         <p:nvPr/>
       </p:nvGrpSpPr>
-      <p:grpSpPr/>
+      <p:grpSpPr>
+        <a:xfrm>
+          <a:off x="0" y="0"/>
+          <a:ext cx="0" cy="0"/>
+          <a:chOff x="0" y="0"/>
+          <a:chExt cx="0" cy="0"/>
+        </a:xfrm>
+      </p:grpSpPr>
       <p:sp>
         <p:nvSpPr>
           <p:cNvPr id="2" name="TextBox 1"/>
@@ -14741,6 +14868,7 @@
           <a:lstStyle/>
           <a:p>
             <a:pPr algn="ctr"/>
+            <a:endParaRPr/>
           </a:p>
         </p:txBody>
       </p:sp>
@@ -14785,6 +14913,7 @@
           <a:lstStyle/>
           <a:p>
             <a:pPr algn="ctr"/>
+            <a:endParaRPr/>
           </a:p>
         </p:txBody>
       </p:sp>
@@ -14944,6 +15073,7 @@
           <a:lstStyle/>
           <a:p>
             <a:pPr algn="ctr"/>
+            <a:endParaRPr/>
           </a:p>
         </p:txBody>
       </p:sp>
@@ -15058,7 +15188,7 @@
 </file>
 
 <file path=ppt/slides/slide5.xml><?xml version="1.0" encoding="utf-8"?>
-<p:sld xmlns:a="http://schemas.openxmlformats.org/drawingml/2006/main" xmlns:p="http://schemas.openxmlformats.org/presentationml/2006/main" xmlns:r="http://schemas.openxmlformats.org/officeDocument/2006/relationships">
+<p:sld xmlns:a="http://schemas.openxmlformats.org/drawingml/2006/main" xmlns:r="http://schemas.openxmlformats.org/officeDocument/2006/relationships" xmlns:p="http://schemas.openxmlformats.org/presentationml/2006/main">
   <p:cSld>
     <p:spTree>
       <p:nvGrpSpPr>
@@ -15066,7 +15196,14 @@
         <p:cNvGrpSpPr/>
         <p:nvPr/>
       </p:nvGrpSpPr>
-      <p:grpSpPr/>
+      <p:grpSpPr>
+        <a:xfrm>
+          <a:off x="0" y="0"/>
+          <a:ext cx="0" cy="0"/>
+          <a:chOff x="0" y="0"/>
+          <a:chExt cx="0" cy="0"/>
+        </a:xfrm>
+      </p:grpSpPr>
       <p:sp>
         <p:nvSpPr>
           <p:cNvPr id="2" name="TextBox 1"/>
@@ -15174,6 +15311,7 @@
           <a:lstStyle/>
           <a:p>
             <a:pPr algn="ctr"/>
+            <a:endParaRPr/>
           </a:p>
         </p:txBody>
       </p:sp>
@@ -15218,6 +15356,7 @@
           <a:lstStyle/>
           <a:p>
             <a:pPr algn="ctr"/>
+            <a:endParaRPr/>
           </a:p>
         </p:txBody>
       </p:sp>
@@ -15377,6 +15516,7 @@
           <a:lstStyle/>
           <a:p>
             <a:pPr algn="ctr"/>
+            <a:endParaRPr/>
           </a:p>
         </p:txBody>
       </p:sp>
@@ -15491,7 +15631,7 @@
 </file>
 
 <file path=ppt/slides/slide6.xml><?xml version="1.0" encoding="utf-8"?>
-<p:sld xmlns:a="http://schemas.openxmlformats.org/drawingml/2006/main" xmlns:p="http://schemas.openxmlformats.org/presentationml/2006/main" xmlns:r="http://schemas.openxmlformats.org/officeDocument/2006/relationships">
+<p:sld xmlns:a="http://schemas.openxmlformats.org/drawingml/2006/main" xmlns:r="http://schemas.openxmlformats.org/officeDocument/2006/relationships" xmlns:p="http://schemas.openxmlformats.org/presentationml/2006/main">
   <p:cSld>
     <p:spTree>
       <p:nvGrpSpPr>
@@ -15499,7 +15639,14 @@
         <p:cNvGrpSpPr/>
         <p:nvPr/>
       </p:nvGrpSpPr>
-      <p:grpSpPr/>
+      <p:grpSpPr>
+        <a:xfrm>
+          <a:off x="0" y="0"/>
+          <a:ext cx="0" cy="0"/>
+          <a:chOff x="0" y="0"/>
+          <a:chExt cx="0" cy="0"/>
+        </a:xfrm>
+      </p:grpSpPr>
       <p:sp>
         <p:nvSpPr>
           <p:cNvPr id="2" name="Rectangle 1"/>
@@ -15541,6 +15688,7 @@
           <a:lstStyle/>
           <a:p>
             <a:pPr algn="ctr"/>
+            <a:endParaRPr/>
           </a:p>
         </p:txBody>
       </p:sp>
@@ -15653,6 +15801,7 @@
           <a:lstStyle/>
           <a:p>
             <a:pPr algn="ctr"/>
+            <a:endParaRPr/>
           </a:p>
         </p:txBody>
       </p:sp>
@@ -15699,7 +15848,7 @@
 </file>
 
 <file path=ppt/slides/slide7.xml><?xml version="1.0" encoding="utf-8"?>
-<p:sld xmlns:a="http://schemas.openxmlformats.org/drawingml/2006/main" xmlns:p="http://schemas.openxmlformats.org/presentationml/2006/main" xmlns:r="http://schemas.openxmlformats.org/officeDocument/2006/relationships">
+<p:sld xmlns:a="http://schemas.openxmlformats.org/drawingml/2006/main" xmlns:r="http://schemas.openxmlformats.org/officeDocument/2006/relationships" xmlns:p="http://schemas.openxmlformats.org/presentationml/2006/main">
   <p:cSld>
     <p:spTree>
       <p:nvGrpSpPr>
@@ -15707,7 +15856,14 @@
         <p:cNvGrpSpPr/>
         <p:nvPr/>
       </p:nvGrpSpPr>
-      <p:grpSpPr/>
+      <p:grpSpPr>
+        <a:xfrm>
+          <a:off x="0" y="0"/>
+          <a:ext cx="0" cy="0"/>
+          <a:chOff x="0" y="0"/>
+          <a:chExt cx="0" cy="0"/>
+        </a:xfrm>
+      </p:grpSpPr>
       <p:sp>
         <p:nvSpPr>
           <p:cNvPr id="2" name="TextBox 1"/>
@@ -15815,6 +15971,7 @@
           <a:lstStyle/>
           <a:p>
             <a:pPr algn="ctr"/>
+            <a:endParaRPr/>
           </a:p>
         </p:txBody>
       </p:sp>
@@ -15859,6 +16016,7 @@
           <a:lstStyle/>
           <a:p>
             <a:pPr algn="ctr"/>
+            <a:endParaRPr/>
           </a:p>
         </p:txBody>
       </p:sp>
@@ -16018,6 +16176,7 @@
           <a:lstStyle/>
           <a:p>
             <a:pPr algn="ctr"/>
+            <a:endParaRPr/>
           </a:p>
         </p:txBody>
       </p:sp>
@@ -16132,7 +16291,7 @@
 </file>
 
 <file path=ppt/slides/slide8.xml><?xml version="1.0" encoding="utf-8"?>
-<p:sld xmlns:a="http://schemas.openxmlformats.org/drawingml/2006/main" xmlns:p="http://schemas.openxmlformats.org/presentationml/2006/main" xmlns:r="http://schemas.openxmlformats.org/officeDocument/2006/relationships">
+<p:sld xmlns:a="http://schemas.openxmlformats.org/drawingml/2006/main" xmlns:r="http://schemas.openxmlformats.org/officeDocument/2006/relationships" xmlns:p="http://schemas.openxmlformats.org/presentationml/2006/main">
   <p:cSld>
     <p:spTree>
       <p:nvGrpSpPr>
@@ -16140,7 +16299,14 @@
         <p:cNvGrpSpPr/>
         <p:nvPr/>
       </p:nvGrpSpPr>
-      <p:grpSpPr/>
+      <p:grpSpPr>
+        <a:xfrm>
+          <a:off x="0" y="0"/>
+          <a:ext cx="0" cy="0"/>
+          <a:chOff x="0" y="0"/>
+          <a:chExt cx="0" cy="0"/>
+        </a:xfrm>
+      </p:grpSpPr>
       <p:sp>
         <p:nvSpPr>
           <p:cNvPr id="2" name="TextBox 1"/>
@@ -16298,7 +16464,7 @@
           <p:nvPr/>
         </p:nvPicPr>
         <p:blipFill>
-          <a:blip r:embed="rId2"/>
+          <a:blip r:embed="rId3"/>
           <a:stretch>
             <a:fillRect/>
           </a:stretch>
@@ -16354,6 +16520,7 @@
           <a:lstStyle/>
           <a:p>
             <a:pPr algn="ctr"/>
+            <a:endParaRPr/>
           </a:p>
         </p:txBody>
       </p:sp>
@@ -16468,7 +16635,7 @@
 </file>
 
 <file path=ppt/slides/slide9.xml><?xml version="1.0" encoding="utf-8"?>
-<p:sld xmlns:a="http://schemas.openxmlformats.org/drawingml/2006/main" xmlns:p="http://schemas.openxmlformats.org/presentationml/2006/main" xmlns:r="http://schemas.openxmlformats.org/officeDocument/2006/relationships">
+<p:sld xmlns:a="http://schemas.openxmlformats.org/drawingml/2006/main" xmlns:r="http://schemas.openxmlformats.org/officeDocument/2006/relationships" xmlns:p="http://schemas.openxmlformats.org/presentationml/2006/main">
   <p:cSld>
     <p:spTree>
       <p:nvGrpSpPr>
@@ -16476,7 +16643,14 @@
         <p:cNvGrpSpPr/>
         <p:nvPr/>
       </p:nvGrpSpPr>
-      <p:grpSpPr/>
+      <p:grpSpPr>
+        <a:xfrm>
+          <a:off x="0" y="0"/>
+          <a:ext cx="0" cy="0"/>
+          <a:chOff x="0" y="0"/>
+          <a:chExt cx="0" cy="0"/>
+        </a:xfrm>
+      </p:grpSpPr>
       <p:sp>
         <p:nvSpPr>
           <p:cNvPr id="2" name="TextBox 1"/>
@@ -16584,6 +16758,7 @@
           <a:lstStyle/>
           <a:p>
             <a:pPr algn="ctr"/>
+            <a:endParaRPr/>
           </a:p>
         </p:txBody>
       </p:sp>
@@ -16628,6 +16803,7 @@
           <a:lstStyle/>
           <a:p>
             <a:pPr algn="ctr"/>
+            <a:endParaRPr/>
           </a:p>
         </p:txBody>
       </p:sp>
@@ -16787,6 +16963,7 @@
           <a:lstStyle/>
           <a:p>
             <a:pPr algn="ctr"/>
+            <a:endParaRPr/>
           </a:p>
         </p:txBody>
       </p:sp>
@@ -17221,7 +17398,7 @@
 </file>
 
 <file path=ppt/theme/theme2.xml><?xml version="1.0" encoding="utf-8"?>
-<a:theme xmlns:a="http://schemas.openxmlformats.org/drawingml/2006/main" name="Office Theme">
+<a:theme xmlns:a="http://schemas.openxmlformats.org/drawingml/2006/main" name="Office 佈景主題">
   <a:themeElements>
     <a:clrScheme name="Office">
       <a:dk1>
@@ -17231,44 +17408,44 @@
         <a:sysClr val="window" lastClr="FFFFFF"/>
       </a:lt1>
       <a:dk2>
-        <a:srgbClr val="1F497D"/>
+        <a:srgbClr val="0E2841"/>
       </a:dk2>
       <a:lt2>
-        <a:srgbClr val="EEECE1"/>
+        <a:srgbClr val="E8E8E8"/>
       </a:lt2>
       <a:accent1>
-        <a:srgbClr val="4F81BD"/>
+        <a:srgbClr val="156082"/>
       </a:accent1>
       <a:accent2>
-        <a:srgbClr val="C0504D"/>
+        <a:srgbClr val="E97132"/>
       </a:accent2>
       <a:accent3>
-        <a:srgbClr val="9BBB59"/>
+        <a:srgbClr val="196B24"/>
       </a:accent3>
       <a:accent4>
-        <a:srgbClr val="8064A2"/>
+        <a:srgbClr val="0F9ED5"/>
       </a:accent4>
       <a:accent5>
-        <a:srgbClr val="4BACC6"/>
+        <a:srgbClr val="A02B93"/>
       </a:accent5>
       <a:accent6>
-        <a:srgbClr val="F79646"/>
+        <a:srgbClr val="4EA72E"/>
       </a:accent6>
       <a:hlink>
-        <a:srgbClr val="0000FF"/>
+        <a:srgbClr val="467886"/>
       </a:hlink>
       <a:folHlink>
-        <a:srgbClr val="800080"/>
+        <a:srgbClr val="96607D"/>
       </a:folHlink>
     </a:clrScheme>
     <a:fontScheme name="Office">
       <a:majorFont>
-        <a:latin typeface="Calibri"/>
+        <a:latin typeface="Aptos Display" panose="02110004020202020204"/>
         <a:ea typeface=""/>
         <a:cs typeface=""/>
-        <a:font script="Jpan" typeface="ＭＳ Ｐゴシック"/>
+        <a:font script="Jpan" typeface="游ゴシック Light"/>
         <a:font script="Hang" typeface="맑은 고딕"/>
-        <a:font script="Hans" typeface="宋体"/>
+        <a:font script="Hans" typeface="等线 Light"/>
         <a:font script="Hant" typeface="新細明體"/>
         <a:font script="Arab" typeface="Times New Roman"/>
         <a:font script="Hebr" typeface="Times New Roman"/>
@@ -17296,14 +17473,31 @@
         <a:font script="Viet" typeface="Times New Roman"/>
         <a:font script="Uigh" typeface="Microsoft Uighur"/>
         <a:font script="Geor" typeface="Sylfaen"/>
+        <a:font script="Armn" typeface="Arial"/>
+        <a:font script="Bugi" typeface="Leelawadee UI"/>
+        <a:font script="Bopo" typeface="Microsoft JhengHei"/>
+        <a:font script="Java" typeface="Javanese Text"/>
+        <a:font script="Lisu" typeface="Segoe UI"/>
+        <a:font script="Mymr" typeface="Myanmar Text"/>
+        <a:font script="Nkoo" typeface="Ebrima"/>
+        <a:font script="Olck" typeface="Nirmala UI"/>
+        <a:font script="Osma" typeface="Ebrima"/>
+        <a:font script="Phag" typeface="Phagspa"/>
+        <a:font script="Syrn" typeface="Estrangelo Edessa"/>
+        <a:font script="Syrj" typeface="Estrangelo Edessa"/>
+        <a:font script="Syre" typeface="Estrangelo Edessa"/>
+        <a:font script="Sora" typeface="Nirmala UI"/>
+        <a:font script="Tale" typeface="Microsoft Tai Le"/>
+        <a:font script="Talu" typeface="Microsoft New Tai Lue"/>
+        <a:font script="Tfng" typeface="Ebrima"/>
       </a:majorFont>
       <a:minorFont>
-        <a:latin typeface="Calibri"/>
+        <a:latin typeface="Aptos" panose="02110004020202020204"/>
         <a:ea typeface=""/>
         <a:cs typeface=""/>
-        <a:font script="Jpan" typeface="ＭＳ Ｐゴシック"/>
+        <a:font script="Jpan" typeface="游ゴシック"/>
         <a:font script="Hang" typeface="맑은 고딕"/>
-        <a:font script="Hans" typeface="宋体"/>
+        <a:font script="Hans" typeface="等线"/>
         <a:font script="Hant" typeface="新細明體"/>
         <a:font script="Arab" typeface="Arial"/>
         <a:font script="Hebr" typeface="Arial"/>
@@ -17331,6 +17525,23 @@
         <a:font script="Viet" typeface="Arial"/>
         <a:font script="Uigh" typeface="Microsoft Uighur"/>
         <a:font script="Geor" typeface="Sylfaen"/>
+        <a:font script="Armn" typeface="Arial"/>
+        <a:font script="Bugi" typeface="Leelawadee UI"/>
+        <a:font script="Bopo" typeface="Microsoft JhengHei"/>
+        <a:font script="Java" typeface="Javanese Text"/>
+        <a:font script="Lisu" typeface="Segoe UI"/>
+        <a:font script="Mymr" typeface="Myanmar Text"/>
+        <a:font script="Nkoo" typeface="Ebrima"/>
+        <a:font script="Olck" typeface="Nirmala UI"/>
+        <a:font script="Osma" typeface="Ebrima"/>
+        <a:font script="Phag" typeface="Phagspa"/>
+        <a:font script="Syrn" typeface="Estrangelo Edessa"/>
+        <a:font script="Syrj" typeface="Estrangelo Edessa"/>
+        <a:font script="Syre" typeface="Estrangelo Edessa"/>
+        <a:font script="Sora" typeface="Nirmala UI"/>
+        <a:font script="Tale" typeface="Microsoft Tai Le"/>
+        <a:font script="Talu" typeface="Microsoft New Tai Lue"/>
+        <a:font script="Tfng" typeface="Ebrima"/>
       </a:minorFont>
     </a:fontScheme>
     <a:fmtScheme name="Office">
@@ -17342,180 +17553,136 @@
           <a:gsLst>
             <a:gs pos="0">
               <a:schemeClr val="phClr">
-                <a:tint val="50000"/>
-                <a:satMod val="300000"/>
+                <a:lumMod val="110000"/>
+                <a:satMod val="105000"/>
+                <a:tint val="67000"/>
               </a:schemeClr>
             </a:gs>
-            <a:gs pos="35000">
+            <a:gs pos="50000">
               <a:schemeClr val="phClr">
-                <a:tint val="37000"/>
-                <a:satMod val="300000"/>
+                <a:lumMod val="105000"/>
+                <a:satMod val="103000"/>
+                <a:tint val="73000"/>
               </a:schemeClr>
             </a:gs>
             <a:gs pos="100000">
               <a:schemeClr val="phClr">
-                <a:tint val="15000"/>
-                <a:satMod val="350000"/>
+                <a:lumMod val="105000"/>
+                <a:satMod val="109000"/>
+                <a:tint val="81000"/>
               </a:schemeClr>
             </a:gs>
           </a:gsLst>
-          <a:lin ang="16200000" scaled="1"/>
+          <a:lin ang="5400000" scaled="0"/>
         </a:gradFill>
         <a:gradFill rotWithShape="1">
           <a:gsLst>
             <a:gs pos="0">
               <a:schemeClr val="phClr">
-                <a:tint val="100000"/>
+                <a:satMod val="103000"/>
+                <a:lumMod val="102000"/>
+                <a:tint val="94000"/>
+              </a:schemeClr>
+            </a:gs>
+            <a:gs pos="50000">
+              <a:schemeClr val="phClr">
+                <a:satMod val="110000"/>
+                <a:lumMod val="100000"/>
                 <a:shade val="100000"/>
-                <a:satMod val="130000"/>
               </a:schemeClr>
             </a:gs>
             <a:gs pos="100000">
               <a:schemeClr val="phClr">
-                <a:tint val="50000"/>
-                <a:shade val="100000"/>
-                <a:satMod val="350000"/>
+                <a:lumMod val="99000"/>
+                <a:satMod val="120000"/>
+                <a:shade val="78000"/>
               </a:schemeClr>
             </a:gs>
           </a:gsLst>
-          <a:lin ang="16200000" scaled="0"/>
+          <a:lin ang="5400000" scaled="0"/>
         </a:gradFill>
       </a:fillStyleLst>
       <a:lnStyleLst>
-        <a:ln w="9525" cap="flat" cmpd="sng" algn="ctr">
+        <a:ln w="12700" cap="flat" cmpd="sng" algn="ctr">
           <a:solidFill>
-            <a:schemeClr val="phClr">
-              <a:shade val="95000"/>
-              <a:satMod val="105000"/>
-            </a:schemeClr>
+            <a:schemeClr val="phClr"/>
           </a:solidFill>
           <a:prstDash val="solid"/>
+          <a:miter lim="800000"/>
+        </a:ln>
+        <a:ln w="19050" cap="flat" cmpd="sng" algn="ctr">
+          <a:solidFill>
+            <a:schemeClr val="phClr"/>
+          </a:solidFill>
+          <a:prstDash val="solid"/>
+          <a:miter lim="800000"/>
         </a:ln>
         <a:ln w="25400" cap="flat" cmpd="sng" algn="ctr">
           <a:solidFill>
             <a:schemeClr val="phClr"/>
           </a:solidFill>
           <a:prstDash val="solid"/>
-        </a:ln>
-        <a:ln w="38100" cap="flat" cmpd="sng" algn="ctr">
-          <a:solidFill>
-            <a:schemeClr val="phClr"/>
-          </a:solidFill>
-          <a:prstDash val="solid"/>
+          <a:miter lim="800000"/>
         </a:ln>
       </a:lnStyleLst>
       <a:effectStyleLst>
         <a:effectStyle>
+          <a:effectLst/>
+        </a:effectStyle>
+        <a:effectStyle>
+          <a:effectLst/>
+        </a:effectStyle>
+        <a:effectStyle>
           <a:effectLst>
-            <a:outerShdw blurRad="40000" dist="20000" dir="5400000" rotWithShape="0">
+            <a:outerShdw blurRad="57150" dist="19050" dir="5400000" algn="ctr" rotWithShape="0">
               <a:srgbClr val="000000">
-                <a:alpha val="38000"/>
+                <a:alpha val="63000"/>
               </a:srgbClr>
             </a:outerShdw>
           </a:effectLst>
-        </a:effectStyle>
-        <a:effectStyle>
-          <a:effectLst>
-            <a:outerShdw blurRad="40000" dist="23000" dir="5400000" rotWithShape="0">
-              <a:srgbClr val="000000">
-                <a:alpha val="35000"/>
-              </a:srgbClr>
-            </a:outerShdw>
-          </a:effectLst>
-        </a:effectStyle>
-        <a:effectStyle>
-          <a:effectLst>
-            <a:outerShdw blurRad="40000" dist="23000" dir="5400000" rotWithShape="0">
-              <a:srgbClr val="000000">
-                <a:alpha val="35000"/>
-              </a:srgbClr>
-            </a:outerShdw>
-          </a:effectLst>
-          <a:scene3d>
-            <a:camera prst="orthographicFront">
-              <a:rot lat="0" lon="0" rev="0"/>
-            </a:camera>
-            <a:lightRig rig="threePt" dir="t">
-              <a:rot lat="0" lon="0" rev="1200000"/>
-            </a:lightRig>
-          </a:scene3d>
-          <a:sp3d>
-            <a:bevelT w="63500" h="25400"/>
-          </a:sp3d>
         </a:effectStyle>
       </a:effectStyleLst>
       <a:bgFillStyleLst>
         <a:solidFill>
           <a:schemeClr val="phClr"/>
         </a:solidFill>
+        <a:solidFill>
+          <a:schemeClr val="phClr">
+            <a:tint val="95000"/>
+            <a:satMod val="170000"/>
+          </a:schemeClr>
+        </a:solidFill>
         <a:gradFill rotWithShape="1">
           <a:gsLst>
             <a:gs pos="0">
               <a:schemeClr val="phClr">
-                <a:tint val="40000"/>
-                <a:satMod val="350000"/>
+                <a:tint val="93000"/>
+                <a:satMod val="150000"/>
+                <a:shade val="98000"/>
+                <a:lumMod val="102000"/>
               </a:schemeClr>
             </a:gs>
-            <a:gs pos="40000">
+            <a:gs pos="50000">
               <a:schemeClr val="phClr">
-                <a:tint val="45000"/>
-                <a:shade val="99000"/>
-                <a:satMod val="350000"/>
+                <a:tint val="98000"/>
+                <a:satMod val="130000"/>
+                <a:shade val="90000"/>
+                <a:lumMod val="103000"/>
               </a:schemeClr>
             </a:gs>
             <a:gs pos="100000">
               <a:schemeClr val="phClr">
-                <a:shade val="20000"/>
-                <a:satMod val="255000"/>
+                <a:shade val="63000"/>
+                <a:satMod val="120000"/>
               </a:schemeClr>
             </a:gs>
           </a:gsLst>
-          <a:path path="circle">
-            <a:fillToRect l="50000" t="-80000" r="50000" b="180000"/>
-          </a:path>
-        </a:gradFill>
-        <a:gradFill rotWithShape="1">
-          <a:gsLst>
-            <a:gs pos="0">
-              <a:schemeClr val="phClr">
-                <a:tint val="80000"/>
-                <a:satMod val="300000"/>
-              </a:schemeClr>
-            </a:gs>
-            <a:gs pos="100000">
-              <a:schemeClr val="phClr">
-                <a:shade val="30000"/>
-                <a:satMod val="200000"/>
-              </a:schemeClr>
-            </a:gs>
-          </a:gsLst>
-          <a:path path="circle">
-            <a:fillToRect l="50000" t="50000" r="50000" b="50000"/>
-          </a:path>
+          <a:lin ang="5400000" scaled="0"/>
         </a:gradFill>
       </a:bgFillStyleLst>
     </a:fmtScheme>
   </a:themeElements>
   <a:objectDefaults>
-    <a:spDef>
-      <a:spPr/>
-      <a:bodyPr/>
-      <a:lstStyle/>
-      <a:style>
-        <a:lnRef idx="1">
-          <a:schemeClr val="accent1"/>
-        </a:lnRef>
-        <a:fillRef idx="3">
-          <a:schemeClr val="accent1"/>
-        </a:fillRef>
-        <a:effectRef idx="2">
-          <a:schemeClr val="accent1"/>
-        </a:effectRef>
-        <a:fontRef idx="minor">
-          <a:schemeClr val="lt1"/>
-        </a:fontRef>
-      </a:style>
-    </a:spDef>
     <a:lnDef>
       <a:spPr/>
       <a:bodyPr/>
@@ -17537,5 +17704,10 @@
     </a:lnDef>
   </a:objectDefaults>
   <a:extraClrSchemeLst/>
+  <a:extLst>
+    <a:ext uri="{05A4C25C-085E-4340-85A3-A5531E510DB2}">
+      <thm15:themeFamily xmlns:thm15="http://schemas.microsoft.com/office/thememl/2012/main" name="Office Theme" id="{2E142A2C-CD16-42D6-873A-C26D2A0506FA}" vid="{1BDDFF52-6CD6-40A5-AB3C-68EB2F1E4D0A}"/>
+    </a:ext>
+  </a:extLst>
 </a:theme>
 </file>
</xml_diff>

<commit_message>
Sync deck source to the user's pptx edits (title, authors, roadmap)
User edited lab3_presentation.pptx directly:
- Title slide renamed to "CV2X Indoor Localization with WiFi Fingerprints" with
  both authors (314831017 王瑋琛 · 314831024 李朋逸).
- Roadmap title shortened to "Four required sections".

Diff of the pptx vs deck_v3.json confirmed only those two slides changed; all
notes and other slides are byte-identical. Verified visually (title hero +
roadmap card render cleanly; live-demo ▶ placeholder still present, no video
embedded yet).

Synced deck_v3.json + regenerated PRESENTATION_SCRIPT.md to match, and refreshed
the PDF from the user's pptx. The pptx itself is committed as-is (not rebuilt),
preserving the manual edits.

Co-Authored-By: Claude Opus 4.8 (1M context) <noreply@anthropic.com>
</commit_message>
<xml_diff>
--- a/lab3/outputs/slides/lab3_presentation.pptx
+++ b/lab3/outputs/slides/lab3_presentation.pptx
@@ -4,42 +4,45 @@
   <p:sldMasterIdLst>
     <p:sldMasterId id="2147483648" r:id="rId1"/>
   </p:sldMasterIdLst>
+  <p:notesMasterIdLst>
+    <p:notesMasterId r:id="rId35"/>
+  </p:notesMasterIdLst>
   <p:sldIdLst>
-    <p:sldId id="256" r:id="rId7"/>
-    <p:sldId id="257" r:id="rId9"/>
-    <p:sldId id="258" r:id="rId10"/>
-    <p:sldId id="259" r:id="rId11"/>
-    <p:sldId id="260" r:id="rId12"/>
-    <p:sldId id="261" r:id="rId13"/>
-    <p:sldId id="262" r:id="rId14"/>
-    <p:sldId id="263" r:id="rId15"/>
-    <p:sldId id="264" r:id="rId16"/>
-    <p:sldId id="265" r:id="rId17"/>
-    <p:sldId id="266" r:id="rId18"/>
-    <p:sldId id="267" r:id="rId19"/>
-    <p:sldId id="268" r:id="rId20"/>
-    <p:sldId id="269" r:id="rId21"/>
-    <p:sldId id="270" r:id="rId22"/>
-    <p:sldId id="271" r:id="rId23"/>
-    <p:sldId id="272" r:id="rId24"/>
-    <p:sldId id="273" r:id="rId25"/>
-    <p:sldId id="274" r:id="rId26"/>
-    <p:sldId id="275" r:id="rId27"/>
-    <p:sldId id="276" r:id="rId28"/>
-    <p:sldId id="277" r:id="rId29"/>
-    <p:sldId id="278" r:id="rId30"/>
-    <p:sldId id="279" r:id="rId31"/>
-    <p:sldId id="280" r:id="rId32"/>
-    <p:sldId id="281" r:id="rId33"/>
-    <p:sldId id="282" r:id="rId34"/>
-    <p:sldId id="283" r:id="rId35"/>
-    <p:sldId id="284" r:id="rId36"/>
-    <p:sldId id="285" r:id="rId37"/>
-    <p:sldId id="286" r:id="rId38"/>
-    <p:sldId id="287" r:id="rId39"/>
-    <p:sldId id="288" r:id="rId40"/>
+    <p:sldId id="256" r:id="rId2"/>
+    <p:sldId id="257" r:id="rId3"/>
+    <p:sldId id="258" r:id="rId4"/>
+    <p:sldId id="259" r:id="rId5"/>
+    <p:sldId id="260" r:id="rId6"/>
+    <p:sldId id="261" r:id="rId7"/>
+    <p:sldId id="262" r:id="rId8"/>
+    <p:sldId id="263" r:id="rId9"/>
+    <p:sldId id="264" r:id="rId10"/>
+    <p:sldId id="265" r:id="rId11"/>
+    <p:sldId id="266" r:id="rId12"/>
+    <p:sldId id="267" r:id="rId13"/>
+    <p:sldId id="268" r:id="rId14"/>
+    <p:sldId id="269" r:id="rId15"/>
+    <p:sldId id="270" r:id="rId16"/>
+    <p:sldId id="271" r:id="rId17"/>
+    <p:sldId id="272" r:id="rId18"/>
+    <p:sldId id="273" r:id="rId19"/>
+    <p:sldId id="274" r:id="rId20"/>
+    <p:sldId id="275" r:id="rId21"/>
+    <p:sldId id="276" r:id="rId22"/>
+    <p:sldId id="277" r:id="rId23"/>
+    <p:sldId id="278" r:id="rId24"/>
+    <p:sldId id="279" r:id="rId25"/>
+    <p:sldId id="280" r:id="rId26"/>
+    <p:sldId id="281" r:id="rId27"/>
+    <p:sldId id="282" r:id="rId28"/>
+    <p:sldId id="283" r:id="rId29"/>
+    <p:sldId id="284" r:id="rId30"/>
+    <p:sldId id="285" r:id="rId31"/>
+    <p:sldId id="286" r:id="rId32"/>
+    <p:sldId id="287" r:id="rId33"/>
+    <p:sldId id="288" r:id="rId34"/>
   </p:sldIdLst>
-  <p:sldSz cx="12191695" cy="6858000" type="screen4x3"/>
+  <p:sldSz cx="12192000" cy="6858000"/>
   <p:notesSz cx="6858000" cy="9144000"/>
   <p:defaultTextStyle>
     <a:defPPr>
@@ -136,11 +139,27 @@
       </a:defRPr>
     </a:lvl9pPr>
   </p:defaultTextStyle>
+  <p:extLst>
+    <p:ext uri="{EFAFB233-063F-42B5-8137-9DF3F51BA10A}">
+      <p15:sldGuideLst xmlns:p15="http://schemas.microsoft.com/office/powerpoint/2012/main">
+        <p15:guide id="1" orient="horz" pos="2160">
+          <p15:clr>
+            <a:srgbClr val="A4A3A4"/>
+          </p15:clr>
+        </p15:guide>
+        <p15:guide id="2" pos="2880">
+          <p15:clr>
+            <a:srgbClr val="A4A3A4"/>
+          </p15:clr>
+        </p15:guide>
+      </p15:sldGuideLst>
+    </p:ext>
+  </p:extLst>
 </p:presentation>
 </file>
 
 <file path=ppt/notesMasters/notesMaster1.xml><?xml version="1.0" encoding="utf-8"?>
-<p:notesMaster xmlns:a="http://schemas.openxmlformats.org/drawingml/2006/main" xmlns:p="http://schemas.openxmlformats.org/presentationml/2006/main" xmlns:r="http://schemas.openxmlformats.org/officeDocument/2006/relationships">
+<p:notesMaster xmlns:a="http://schemas.openxmlformats.org/drawingml/2006/main" xmlns:r="http://schemas.openxmlformats.org/officeDocument/2006/relationships" xmlns:p="http://schemas.openxmlformats.org/presentationml/2006/main">
   <p:cSld>
     <p:bg>
       <p:bgRef idx="1001">
@@ -161,241 +180,16 @@
           <a:chExt cx="0" cy="0"/>
         </a:xfrm>
       </p:grpSpPr>
-      <p:sp>
-        <p:nvSpPr>
-          <p:cNvPr id="2" name="Header Placeholder 1"/>
-          <p:cNvSpPr>
-            <a:spLocks noGrp="1"/>
-          </p:cNvSpPr>
-          <p:nvPr>
-            <p:ph type="hdr" sz="quarter"/>
-          </p:nvPr>
-        </p:nvSpPr>
-        <p:spPr>
-          <a:xfrm>
-            <a:off x="0" y="0"/>
-            <a:ext cx="2971800" cy="457200"/>
-          </a:xfrm>
-          <a:prstGeom prst="rect">
-            <a:avLst/>
-          </a:prstGeom>
-        </p:spPr>
-        <p:txBody>
-          <a:bodyPr vert="horz" lIns="91440" tIns="45720" rIns="91440" bIns="45720" rtlCol="0"/>
-          <a:lstStyle>
-            <a:lvl1pPr algn="l">
-              <a:defRPr sz="1200"/>
-            </a:lvl1pPr>
-          </a:lstStyle>
-          <a:p>
-            <a:endParaRPr lang="en-US"/>
-          </a:p>
-        </p:txBody>
-      </p:sp>
-      <p:sp>
-        <p:nvSpPr>
-          <p:cNvPr id="3" name="Date Placeholder 2"/>
-          <p:cNvSpPr>
-            <a:spLocks noGrp="1"/>
-          </p:cNvSpPr>
-          <p:nvPr>
-            <p:ph type="dt" idx="1"/>
-          </p:nvPr>
-        </p:nvSpPr>
-        <p:spPr>
-          <a:xfrm>
-            <a:off x="3884613" y="0"/>
-            <a:ext cx="2971800" cy="457200"/>
-          </a:xfrm>
-          <a:prstGeom prst="rect">
-            <a:avLst/>
-          </a:prstGeom>
-        </p:spPr>
-        <p:txBody>
-          <a:bodyPr vert="horz" lIns="91440" tIns="45720" rIns="91440" bIns="45720" rtlCol="0"/>
-          <a:lstStyle>
-            <a:lvl1pPr algn="r">
-              <a:defRPr sz="1200"/>
-            </a:lvl1pPr>
-          </a:lstStyle>
-          <a:p>
-            <a:fld id="{0F89C1C7-3DCD-1040-A9CF-14679D8B5DDD}" type="datetimeFigureOut">
-              <a:rPr lang="en-US" smtClean="0"/>
-              <a:t>10/17/16</a:t>
-            </a:fld>
-            <a:endParaRPr lang="en-US"/>
-          </a:p>
-        </p:txBody>
-      </p:sp>
-      <p:sp>
-        <p:nvSpPr>
-          <p:cNvPr id="4" name="Slide Image Placeholder 3"/>
-          <p:cNvSpPr>
-            <a:spLocks noGrp="1" noRot="1" noChangeAspect="1"/>
-          </p:cNvSpPr>
-          <p:nvPr>
-            <p:ph type="sldImg" idx="2"/>
-          </p:nvPr>
-        </p:nvSpPr>
-        <p:spPr>
-          <a:xfrm>
-            <a:off x="1143000" y="685800"/>
-            <a:ext cx="4572000" cy="3429000"/>
-          </a:xfrm>
-          <a:prstGeom prst="rect">
-            <a:avLst/>
-          </a:prstGeom>
-          <a:noFill/>
-          <a:ln w="12700">
-            <a:solidFill>
-              <a:prstClr val="black"/>
-            </a:solidFill>
-          </a:ln>
-        </p:spPr>
-        <p:txBody>
-          <a:bodyPr vert="horz" lIns="91440" tIns="45720" rIns="91440" bIns="45720" rtlCol="0" anchor="ctr"/>
-          <a:lstStyle/>
-          <a:p>
-            <a:endParaRPr lang="en-US"/>
-          </a:p>
-        </p:txBody>
-      </p:sp>
-      <p:sp>
-        <p:nvSpPr>
-          <p:cNvPr id="5" name="Notes Placeholder 4"/>
-          <p:cNvSpPr>
-            <a:spLocks noGrp="1"/>
-          </p:cNvSpPr>
-          <p:nvPr>
-            <p:ph type="body" sz="quarter" idx="3"/>
-          </p:nvPr>
-        </p:nvSpPr>
-        <p:spPr>
-          <a:xfrm>
-            <a:off x="685800" y="4343400"/>
-            <a:ext cx="5486400" cy="4114800"/>
-          </a:xfrm>
-          <a:prstGeom prst="rect">
-            <a:avLst/>
-          </a:prstGeom>
-        </p:spPr>
-        <p:txBody>
-          <a:bodyPr vert="horz" lIns="91440" tIns="45720" rIns="91440" bIns="45720" rtlCol="0"/>
-          <a:lstStyle/>
-          <a:p>
-            <a:pPr lvl="0"/>
-            <a:r>
-              <a:rPr lang="en-US" smtClean="0"/>
-              <a:t>Click to edit Master text styles</a:t>
-            </a:r>
-          </a:p>
-          <a:p>
-            <a:pPr lvl="1"/>
-            <a:r>
-              <a:rPr lang="en-US" smtClean="0"/>
-              <a:t>Second level</a:t>
-            </a:r>
-          </a:p>
-          <a:p>
-            <a:pPr lvl="2"/>
-            <a:r>
-              <a:rPr lang="en-US" smtClean="0"/>
-              <a:t>Third level</a:t>
-            </a:r>
-          </a:p>
-          <a:p>
-            <a:pPr lvl="3"/>
-            <a:r>
-              <a:rPr lang="en-US" smtClean="0"/>
-              <a:t>Fourth level</a:t>
-            </a:r>
-          </a:p>
-          <a:p>
-            <a:pPr lvl="4"/>
-            <a:r>
-              <a:rPr lang="en-US" smtClean="0"/>
-              <a:t>Fifth level</a:t>
-            </a:r>
-            <a:endParaRPr lang="en-US"/>
-          </a:p>
-        </p:txBody>
-      </p:sp>
-      <p:sp>
-        <p:nvSpPr>
-          <p:cNvPr id="6" name="Footer Placeholder 5"/>
-          <p:cNvSpPr>
-            <a:spLocks noGrp="1"/>
-          </p:cNvSpPr>
-          <p:nvPr>
-            <p:ph type="ftr" sz="quarter" idx="4"/>
-          </p:nvPr>
-        </p:nvSpPr>
-        <p:spPr>
-          <a:xfrm>
-            <a:off x="0" y="8685213"/>
-            <a:ext cx="2971800" cy="457200"/>
-          </a:xfrm>
-          <a:prstGeom prst="rect">
-            <a:avLst/>
-          </a:prstGeom>
-        </p:spPr>
-        <p:txBody>
-          <a:bodyPr vert="horz" lIns="91440" tIns="45720" rIns="91440" bIns="45720" rtlCol="0" anchor="b"/>
-          <a:lstStyle>
-            <a:lvl1pPr algn="l">
-              <a:defRPr sz="1200"/>
-            </a:lvl1pPr>
-          </a:lstStyle>
-          <a:p>
-            <a:endParaRPr lang="en-US"/>
-          </a:p>
-        </p:txBody>
-      </p:sp>
-      <p:sp>
-        <p:nvSpPr>
-          <p:cNvPr id="7" name="Slide Number Placeholder 6"/>
-          <p:cNvSpPr>
-            <a:spLocks noGrp="1"/>
-          </p:cNvSpPr>
-          <p:nvPr>
-            <p:ph type="sldNum" sz="quarter" idx="5"/>
-          </p:nvPr>
-        </p:nvSpPr>
-        <p:spPr>
-          <a:xfrm>
-            <a:off x="3884613" y="8685213"/>
-            <a:ext cx="2971800" cy="457200"/>
-          </a:xfrm>
-          <a:prstGeom prst="rect">
-            <a:avLst/>
-          </a:prstGeom>
-        </p:spPr>
-        <p:txBody>
-          <a:bodyPr vert="horz" lIns="91440" tIns="45720" rIns="91440" bIns="45720" rtlCol="0" anchor="b"/>
-          <a:lstStyle>
-            <a:lvl1pPr algn="r">
-              <a:defRPr sz="1200"/>
-            </a:lvl1pPr>
-          </a:lstStyle>
-          <a:p>
-            <a:fld id="{BB5E49A5-4136-284D-997B-48E1D791AD67}" type="slidenum">
-              <a:rPr lang="en-US" smtClean="0"/>
-              <a:t>‹#›</a:t>
-            </a:fld>
-            <a:endParaRPr lang="en-US"/>
-          </a:p>
-        </p:txBody>
-      </p:sp>
     </p:spTree>
     <p:extLst>
       <p:ext uri="{BB962C8B-B14F-4D97-AF65-F5344CB8AC3E}">
-        <p14:creationId xmlns:p14="http://schemas.microsoft.com/office/powerpoint/2010/main" val="2623252185"/>
+        <p14:creationId xmlns:p14="http://schemas.microsoft.com/office/powerpoint/2010/main" val="1639267416"/>
       </p:ext>
     </p:extLst>
   </p:cSld>
   <p:clrMap bg1="lt1" tx1="dk1" bg2="lt2" tx2="dk2" accent1="accent1" accent2="accent2" accent3="accent3" accent4="accent4" accent5="accent5" accent6="accent6" hlink="hlink" folHlink="folHlink"/>
   <p:notesStyle>
-    <a:lvl1pPr marL="0" algn="l" defTabSz="457200" rtl="0" eaLnBrk="1" latinLnBrk="0" hangingPunct="1">
+    <a:lvl1pPr marL="0" algn="l" defTabSz="914400" rtl="0" eaLnBrk="1" latinLnBrk="0" hangingPunct="1">
       <a:defRPr sz="1200" kern="1200">
         <a:solidFill>
           <a:schemeClr val="tx1"/>
@@ -405,7 +199,7 @@
         <a:cs typeface="+mn-cs"/>
       </a:defRPr>
     </a:lvl1pPr>
-    <a:lvl2pPr marL="457200" algn="l" defTabSz="457200" rtl="0" eaLnBrk="1" latinLnBrk="0" hangingPunct="1">
+    <a:lvl2pPr marL="457200" algn="l" defTabSz="914400" rtl="0" eaLnBrk="1" latinLnBrk="0" hangingPunct="1">
       <a:defRPr sz="1200" kern="1200">
         <a:solidFill>
           <a:schemeClr val="tx1"/>
@@ -415,7 +209,7 @@
         <a:cs typeface="+mn-cs"/>
       </a:defRPr>
     </a:lvl2pPr>
-    <a:lvl3pPr marL="914400" algn="l" defTabSz="457200" rtl="0" eaLnBrk="1" latinLnBrk="0" hangingPunct="1">
+    <a:lvl3pPr marL="914400" algn="l" defTabSz="914400" rtl="0" eaLnBrk="1" latinLnBrk="0" hangingPunct="1">
       <a:defRPr sz="1200" kern="1200">
         <a:solidFill>
           <a:schemeClr val="tx1"/>
@@ -425,7 +219,7 @@
         <a:cs typeface="+mn-cs"/>
       </a:defRPr>
     </a:lvl3pPr>
-    <a:lvl4pPr marL="1371600" algn="l" defTabSz="457200" rtl="0" eaLnBrk="1" latinLnBrk="0" hangingPunct="1">
+    <a:lvl4pPr marL="1371600" algn="l" defTabSz="914400" rtl="0" eaLnBrk="1" latinLnBrk="0" hangingPunct="1">
       <a:defRPr sz="1200" kern="1200">
         <a:solidFill>
           <a:schemeClr val="tx1"/>
@@ -435,7 +229,7 @@
         <a:cs typeface="+mn-cs"/>
       </a:defRPr>
     </a:lvl4pPr>
-    <a:lvl5pPr marL="1828800" algn="l" defTabSz="457200" rtl="0" eaLnBrk="1" latinLnBrk="0" hangingPunct="1">
+    <a:lvl5pPr marL="1828800" algn="l" defTabSz="914400" rtl="0" eaLnBrk="1" latinLnBrk="0" hangingPunct="1">
       <a:defRPr sz="1200" kern="1200">
         <a:solidFill>
           <a:schemeClr val="tx1"/>
@@ -445,7 +239,7 @@
         <a:cs typeface="+mn-cs"/>
       </a:defRPr>
     </a:lvl5pPr>
-    <a:lvl6pPr marL="2286000" algn="l" defTabSz="457200" rtl="0" eaLnBrk="1" latinLnBrk="0" hangingPunct="1">
+    <a:lvl6pPr marL="2286000" algn="l" defTabSz="914400" rtl="0" eaLnBrk="1" latinLnBrk="0" hangingPunct="1">
       <a:defRPr sz="1200" kern="1200">
         <a:solidFill>
           <a:schemeClr val="tx1"/>
@@ -455,7 +249,7 @@
         <a:cs typeface="+mn-cs"/>
       </a:defRPr>
     </a:lvl6pPr>
-    <a:lvl7pPr marL="2743200" algn="l" defTabSz="457200" rtl="0" eaLnBrk="1" latinLnBrk="0" hangingPunct="1">
+    <a:lvl7pPr marL="2743200" algn="l" defTabSz="914400" rtl="0" eaLnBrk="1" latinLnBrk="0" hangingPunct="1">
       <a:defRPr sz="1200" kern="1200">
         <a:solidFill>
           <a:schemeClr val="tx1"/>
@@ -465,7 +259,7 @@
         <a:cs typeface="+mn-cs"/>
       </a:defRPr>
     </a:lvl7pPr>
-    <a:lvl8pPr marL="3200400" algn="l" defTabSz="457200" rtl="0" eaLnBrk="1" latinLnBrk="0" hangingPunct="1">
+    <a:lvl8pPr marL="3200400" algn="l" defTabSz="914400" rtl="0" eaLnBrk="1" latinLnBrk="0" hangingPunct="1">
       <a:defRPr sz="1200" kern="1200">
         <a:solidFill>
           <a:schemeClr val="tx1"/>
@@ -475,7 +269,7 @@
         <a:cs typeface="+mn-cs"/>
       </a:defRPr>
     </a:lvl8pPr>
-    <a:lvl9pPr marL="3657600" algn="l" defTabSz="457200" rtl="0" eaLnBrk="1" latinLnBrk="0" hangingPunct="1">
+    <a:lvl9pPr marL="3657600" algn="l" defTabSz="914400" rtl="0" eaLnBrk="1" latinLnBrk="0" hangingPunct="1">
       <a:defRPr sz="1200" kern="1200">
         <a:solidFill>
           <a:schemeClr val="tx1"/>
@@ -490,7 +284,7 @@
 </file>
 
 <file path=ppt/notesSlides/notesSlide1.xml><?xml version="1.0" encoding="utf-8"?>
-<p:notes xmlns:a="http://schemas.openxmlformats.org/drawingml/2006/main" xmlns:p="http://schemas.openxmlformats.org/presentationml/2006/main" xmlns:r="http://schemas.openxmlformats.org/officeDocument/2006/relationships">
+<p:notes xmlns:a="http://schemas.openxmlformats.org/drawingml/2006/main" xmlns:r="http://schemas.openxmlformats.org/officeDocument/2006/relationships" xmlns:p="http://schemas.openxmlformats.org/presentationml/2006/main">
   <p:cSld>
     <p:spTree>
       <p:nvGrpSpPr>
@@ -510,7 +304,7 @@
         <p:nvSpPr>
           <p:cNvPr id="2" name="Slide Image Placeholder 1"/>
           <p:cNvSpPr>
-            <a:spLocks noGrp="1"/>
+            <a:spLocks noGrp="1" noRot="1" noChangeAspect="1"/>
           </p:cNvSpPr>
           <p:nvPr>
             <p:ph type="sldImg" idx="2"/>
@@ -525,7 +319,7 @@
             <a:spLocks noGrp="1"/>
           </p:cNvSpPr>
           <p:nvPr>
-            <p:ph type="body" idx="3" sz="quarter"/>
+            <p:ph type="body" sz="quarter" idx="3"/>
           </p:nvPr>
         </p:nvSpPr>
         <p:spPr/>
@@ -546,7 +340,7 @@
             <a:spLocks noGrp="1"/>
           </p:cNvSpPr>
           <p:nvPr>
-            <p:ph type="sldNum" idx="5" sz="quarter"/>
+            <p:ph type="sldNum" sz="quarter" idx="5"/>
           </p:nvPr>
         </p:nvSpPr>
         <p:spPr/>
@@ -560,7 +354,7 @@
 </file>
 
 <file path=ppt/notesSlides/notesSlide10.xml><?xml version="1.0" encoding="utf-8"?>
-<p:notes xmlns:a="http://schemas.openxmlformats.org/drawingml/2006/main" xmlns:p="http://schemas.openxmlformats.org/presentationml/2006/main" xmlns:r="http://schemas.openxmlformats.org/officeDocument/2006/relationships">
+<p:notes xmlns:a="http://schemas.openxmlformats.org/drawingml/2006/main" xmlns:r="http://schemas.openxmlformats.org/officeDocument/2006/relationships" xmlns:p="http://schemas.openxmlformats.org/presentationml/2006/main">
   <p:cSld>
     <p:spTree>
       <p:nvGrpSpPr>
@@ -580,7 +374,7 @@
         <p:nvSpPr>
           <p:cNvPr id="2" name="Slide Image Placeholder 1"/>
           <p:cNvSpPr>
-            <a:spLocks noGrp="1"/>
+            <a:spLocks noGrp="1" noRot="1" noChangeAspect="1"/>
           </p:cNvSpPr>
           <p:nvPr>
             <p:ph type="sldImg" idx="2"/>
@@ -595,7 +389,7 @@
             <a:spLocks noGrp="1"/>
           </p:cNvSpPr>
           <p:nvPr>
-            <p:ph type="body" idx="3" sz="quarter"/>
+            <p:ph type="body" sz="quarter" idx="3"/>
           </p:nvPr>
         </p:nvSpPr>
         <p:spPr/>
@@ -616,7 +410,7 @@
             <a:spLocks noGrp="1"/>
           </p:cNvSpPr>
           <p:nvPr>
-            <p:ph type="sldNum" idx="5" sz="quarter"/>
+            <p:ph type="sldNum" sz="quarter" idx="5"/>
           </p:nvPr>
         </p:nvSpPr>
         <p:spPr/>
@@ -630,7 +424,7 @@
 </file>
 
 <file path=ppt/notesSlides/notesSlide11.xml><?xml version="1.0" encoding="utf-8"?>
-<p:notes xmlns:a="http://schemas.openxmlformats.org/drawingml/2006/main" xmlns:p="http://schemas.openxmlformats.org/presentationml/2006/main" xmlns:r="http://schemas.openxmlformats.org/officeDocument/2006/relationships">
+<p:notes xmlns:a="http://schemas.openxmlformats.org/drawingml/2006/main" xmlns:r="http://schemas.openxmlformats.org/officeDocument/2006/relationships" xmlns:p="http://schemas.openxmlformats.org/presentationml/2006/main">
   <p:cSld>
     <p:spTree>
       <p:nvGrpSpPr>
@@ -650,7 +444,7 @@
         <p:nvSpPr>
           <p:cNvPr id="2" name="Slide Image Placeholder 1"/>
           <p:cNvSpPr>
-            <a:spLocks noGrp="1"/>
+            <a:spLocks noGrp="1" noRot="1" noChangeAspect="1"/>
           </p:cNvSpPr>
           <p:nvPr>
             <p:ph type="sldImg" idx="2"/>
@@ -665,7 +459,7 @@
             <a:spLocks noGrp="1"/>
           </p:cNvSpPr>
           <p:nvPr>
-            <p:ph type="body" idx="3" sz="quarter"/>
+            <p:ph type="body" sz="quarter" idx="3"/>
           </p:nvPr>
         </p:nvSpPr>
         <p:spPr/>
@@ -686,7 +480,7 @@
             <a:spLocks noGrp="1"/>
           </p:cNvSpPr>
           <p:nvPr>
-            <p:ph type="sldNum" idx="5" sz="quarter"/>
+            <p:ph type="sldNum" sz="quarter" idx="5"/>
           </p:nvPr>
         </p:nvSpPr>
         <p:spPr/>
@@ -700,7 +494,7 @@
 </file>
 
 <file path=ppt/notesSlides/notesSlide12.xml><?xml version="1.0" encoding="utf-8"?>
-<p:notes xmlns:a="http://schemas.openxmlformats.org/drawingml/2006/main" xmlns:p="http://schemas.openxmlformats.org/presentationml/2006/main" xmlns:r="http://schemas.openxmlformats.org/officeDocument/2006/relationships">
+<p:notes xmlns:a="http://schemas.openxmlformats.org/drawingml/2006/main" xmlns:r="http://schemas.openxmlformats.org/officeDocument/2006/relationships" xmlns:p="http://schemas.openxmlformats.org/presentationml/2006/main">
   <p:cSld>
     <p:spTree>
       <p:nvGrpSpPr>
@@ -720,7 +514,7 @@
         <p:nvSpPr>
           <p:cNvPr id="2" name="Slide Image Placeholder 1"/>
           <p:cNvSpPr>
-            <a:spLocks noGrp="1"/>
+            <a:spLocks noGrp="1" noRot="1" noChangeAspect="1"/>
           </p:cNvSpPr>
           <p:nvPr>
             <p:ph type="sldImg" idx="2"/>
@@ -735,7 +529,7 @@
             <a:spLocks noGrp="1"/>
           </p:cNvSpPr>
           <p:nvPr>
-            <p:ph type="body" idx="3" sz="quarter"/>
+            <p:ph type="body" sz="quarter" idx="3"/>
           </p:nvPr>
         </p:nvSpPr>
         <p:spPr/>
@@ -756,7 +550,7 @@
             <a:spLocks noGrp="1"/>
           </p:cNvSpPr>
           <p:nvPr>
-            <p:ph type="sldNum" idx="5" sz="quarter"/>
+            <p:ph type="sldNum" sz="quarter" idx="5"/>
           </p:nvPr>
         </p:nvSpPr>
         <p:spPr/>
@@ -770,7 +564,7 @@
 </file>
 
 <file path=ppt/notesSlides/notesSlide13.xml><?xml version="1.0" encoding="utf-8"?>
-<p:notes xmlns:a="http://schemas.openxmlformats.org/drawingml/2006/main" xmlns:p="http://schemas.openxmlformats.org/presentationml/2006/main" xmlns:r="http://schemas.openxmlformats.org/officeDocument/2006/relationships">
+<p:notes xmlns:a="http://schemas.openxmlformats.org/drawingml/2006/main" xmlns:r="http://schemas.openxmlformats.org/officeDocument/2006/relationships" xmlns:p="http://schemas.openxmlformats.org/presentationml/2006/main">
   <p:cSld>
     <p:spTree>
       <p:nvGrpSpPr>
@@ -790,7 +584,7 @@
         <p:nvSpPr>
           <p:cNvPr id="2" name="Slide Image Placeholder 1"/>
           <p:cNvSpPr>
-            <a:spLocks noGrp="1"/>
+            <a:spLocks noGrp="1" noRot="1" noChangeAspect="1"/>
           </p:cNvSpPr>
           <p:nvPr>
             <p:ph type="sldImg" idx="2"/>
@@ -805,7 +599,7 @@
             <a:spLocks noGrp="1"/>
           </p:cNvSpPr>
           <p:nvPr>
-            <p:ph type="body" idx="3" sz="quarter"/>
+            <p:ph type="body" sz="quarter" idx="3"/>
           </p:nvPr>
         </p:nvSpPr>
         <p:spPr/>
@@ -826,7 +620,7 @@
             <a:spLocks noGrp="1"/>
           </p:cNvSpPr>
           <p:nvPr>
-            <p:ph type="sldNum" idx="5" sz="quarter"/>
+            <p:ph type="sldNum" sz="quarter" idx="5"/>
           </p:nvPr>
         </p:nvSpPr>
         <p:spPr/>
@@ -840,7 +634,7 @@
 </file>
 
 <file path=ppt/notesSlides/notesSlide14.xml><?xml version="1.0" encoding="utf-8"?>
-<p:notes xmlns:a="http://schemas.openxmlformats.org/drawingml/2006/main" xmlns:p="http://schemas.openxmlformats.org/presentationml/2006/main" xmlns:r="http://schemas.openxmlformats.org/officeDocument/2006/relationships">
+<p:notes xmlns:a="http://schemas.openxmlformats.org/drawingml/2006/main" xmlns:r="http://schemas.openxmlformats.org/officeDocument/2006/relationships" xmlns:p="http://schemas.openxmlformats.org/presentationml/2006/main">
   <p:cSld>
     <p:spTree>
       <p:nvGrpSpPr>
@@ -860,7 +654,7 @@
         <p:nvSpPr>
           <p:cNvPr id="2" name="Slide Image Placeholder 1"/>
           <p:cNvSpPr>
-            <a:spLocks noGrp="1"/>
+            <a:spLocks noGrp="1" noRot="1" noChangeAspect="1"/>
           </p:cNvSpPr>
           <p:nvPr>
             <p:ph type="sldImg" idx="2"/>
@@ -875,7 +669,7 @@
             <a:spLocks noGrp="1"/>
           </p:cNvSpPr>
           <p:nvPr>
-            <p:ph type="body" idx="3" sz="quarter"/>
+            <p:ph type="body" sz="quarter" idx="3"/>
           </p:nvPr>
         </p:nvSpPr>
         <p:spPr/>
@@ -896,7 +690,7 @@
             <a:spLocks noGrp="1"/>
           </p:cNvSpPr>
           <p:nvPr>
-            <p:ph type="sldNum" idx="5" sz="quarter"/>
+            <p:ph type="sldNum" sz="quarter" idx="5"/>
           </p:nvPr>
         </p:nvSpPr>
         <p:spPr/>
@@ -910,7 +704,7 @@
 </file>
 
 <file path=ppt/notesSlides/notesSlide15.xml><?xml version="1.0" encoding="utf-8"?>
-<p:notes xmlns:a="http://schemas.openxmlformats.org/drawingml/2006/main" xmlns:p="http://schemas.openxmlformats.org/presentationml/2006/main" xmlns:r="http://schemas.openxmlformats.org/officeDocument/2006/relationships">
+<p:notes xmlns:a="http://schemas.openxmlformats.org/drawingml/2006/main" xmlns:r="http://schemas.openxmlformats.org/officeDocument/2006/relationships" xmlns:p="http://schemas.openxmlformats.org/presentationml/2006/main">
   <p:cSld>
     <p:spTree>
       <p:nvGrpSpPr>
@@ -930,7 +724,7 @@
         <p:nvSpPr>
           <p:cNvPr id="2" name="Slide Image Placeholder 1"/>
           <p:cNvSpPr>
-            <a:spLocks noGrp="1"/>
+            <a:spLocks noGrp="1" noRot="1" noChangeAspect="1"/>
           </p:cNvSpPr>
           <p:nvPr>
             <p:ph type="sldImg" idx="2"/>
@@ -945,7 +739,7 @@
             <a:spLocks noGrp="1"/>
           </p:cNvSpPr>
           <p:nvPr>
-            <p:ph type="body" idx="3" sz="quarter"/>
+            <p:ph type="body" sz="quarter" idx="3"/>
           </p:nvPr>
         </p:nvSpPr>
         <p:spPr/>
@@ -966,7 +760,7 @@
             <a:spLocks noGrp="1"/>
           </p:cNvSpPr>
           <p:nvPr>
-            <p:ph type="sldNum" idx="5" sz="quarter"/>
+            <p:ph type="sldNum" sz="quarter" idx="5"/>
           </p:nvPr>
         </p:nvSpPr>
         <p:spPr/>
@@ -980,7 +774,7 @@
 </file>
 
 <file path=ppt/notesSlides/notesSlide16.xml><?xml version="1.0" encoding="utf-8"?>
-<p:notes xmlns:a="http://schemas.openxmlformats.org/drawingml/2006/main" xmlns:p="http://schemas.openxmlformats.org/presentationml/2006/main" xmlns:r="http://schemas.openxmlformats.org/officeDocument/2006/relationships">
+<p:notes xmlns:a="http://schemas.openxmlformats.org/drawingml/2006/main" xmlns:r="http://schemas.openxmlformats.org/officeDocument/2006/relationships" xmlns:p="http://schemas.openxmlformats.org/presentationml/2006/main">
   <p:cSld>
     <p:spTree>
       <p:nvGrpSpPr>
@@ -1000,7 +794,7 @@
         <p:nvSpPr>
           <p:cNvPr id="2" name="Slide Image Placeholder 1"/>
           <p:cNvSpPr>
-            <a:spLocks noGrp="1"/>
+            <a:spLocks noGrp="1" noRot="1" noChangeAspect="1"/>
           </p:cNvSpPr>
           <p:nvPr>
             <p:ph type="sldImg" idx="2"/>
@@ -1015,7 +809,7 @@
             <a:spLocks noGrp="1"/>
           </p:cNvSpPr>
           <p:nvPr>
-            <p:ph type="body" idx="3" sz="quarter"/>
+            <p:ph type="body" sz="quarter" idx="3"/>
           </p:nvPr>
         </p:nvSpPr>
         <p:spPr/>
@@ -1036,7 +830,7 @@
             <a:spLocks noGrp="1"/>
           </p:cNvSpPr>
           <p:nvPr>
-            <p:ph type="sldNum" idx="5" sz="quarter"/>
+            <p:ph type="sldNum" sz="quarter" idx="5"/>
           </p:nvPr>
         </p:nvSpPr>
         <p:spPr/>
@@ -1050,7 +844,7 @@
 </file>
 
 <file path=ppt/notesSlides/notesSlide17.xml><?xml version="1.0" encoding="utf-8"?>
-<p:notes xmlns:a="http://schemas.openxmlformats.org/drawingml/2006/main" xmlns:p="http://schemas.openxmlformats.org/presentationml/2006/main" xmlns:r="http://schemas.openxmlformats.org/officeDocument/2006/relationships">
+<p:notes xmlns:a="http://schemas.openxmlformats.org/drawingml/2006/main" xmlns:r="http://schemas.openxmlformats.org/officeDocument/2006/relationships" xmlns:p="http://schemas.openxmlformats.org/presentationml/2006/main">
   <p:cSld>
     <p:spTree>
       <p:nvGrpSpPr>
@@ -1070,7 +864,7 @@
         <p:nvSpPr>
           <p:cNvPr id="2" name="Slide Image Placeholder 1"/>
           <p:cNvSpPr>
-            <a:spLocks noGrp="1"/>
+            <a:spLocks noGrp="1" noRot="1" noChangeAspect="1"/>
           </p:cNvSpPr>
           <p:nvPr>
             <p:ph type="sldImg" idx="2"/>
@@ -1085,7 +879,7 @@
             <a:spLocks noGrp="1"/>
           </p:cNvSpPr>
           <p:nvPr>
-            <p:ph type="body" idx="3" sz="quarter"/>
+            <p:ph type="body" sz="quarter" idx="3"/>
           </p:nvPr>
         </p:nvSpPr>
         <p:spPr/>
@@ -1106,7 +900,7 @@
             <a:spLocks noGrp="1"/>
           </p:cNvSpPr>
           <p:nvPr>
-            <p:ph type="sldNum" idx="5" sz="quarter"/>
+            <p:ph type="sldNum" sz="quarter" idx="5"/>
           </p:nvPr>
         </p:nvSpPr>
         <p:spPr/>
@@ -1120,7 +914,7 @@
 </file>
 
 <file path=ppt/notesSlides/notesSlide18.xml><?xml version="1.0" encoding="utf-8"?>
-<p:notes xmlns:a="http://schemas.openxmlformats.org/drawingml/2006/main" xmlns:p="http://schemas.openxmlformats.org/presentationml/2006/main" xmlns:r="http://schemas.openxmlformats.org/officeDocument/2006/relationships">
+<p:notes xmlns:a="http://schemas.openxmlformats.org/drawingml/2006/main" xmlns:r="http://schemas.openxmlformats.org/officeDocument/2006/relationships" xmlns:p="http://schemas.openxmlformats.org/presentationml/2006/main">
   <p:cSld>
     <p:spTree>
       <p:nvGrpSpPr>
@@ -1140,7 +934,7 @@
         <p:nvSpPr>
           <p:cNvPr id="2" name="Slide Image Placeholder 1"/>
           <p:cNvSpPr>
-            <a:spLocks noGrp="1"/>
+            <a:spLocks noGrp="1" noRot="1" noChangeAspect="1"/>
           </p:cNvSpPr>
           <p:nvPr>
             <p:ph type="sldImg" idx="2"/>
@@ -1155,7 +949,7 @@
             <a:spLocks noGrp="1"/>
           </p:cNvSpPr>
           <p:nvPr>
-            <p:ph type="body" idx="3" sz="quarter"/>
+            <p:ph type="body" sz="quarter" idx="3"/>
           </p:nvPr>
         </p:nvSpPr>
         <p:spPr/>
@@ -1176,7 +970,7 @@
             <a:spLocks noGrp="1"/>
           </p:cNvSpPr>
           <p:nvPr>
-            <p:ph type="sldNum" idx="5" sz="quarter"/>
+            <p:ph type="sldNum" sz="quarter" idx="5"/>
           </p:nvPr>
         </p:nvSpPr>
         <p:spPr/>
@@ -1190,7 +984,7 @@
 </file>
 
 <file path=ppt/notesSlides/notesSlide19.xml><?xml version="1.0" encoding="utf-8"?>
-<p:notes xmlns:a="http://schemas.openxmlformats.org/drawingml/2006/main" xmlns:p="http://schemas.openxmlformats.org/presentationml/2006/main" xmlns:r="http://schemas.openxmlformats.org/officeDocument/2006/relationships">
+<p:notes xmlns:a="http://schemas.openxmlformats.org/drawingml/2006/main" xmlns:r="http://schemas.openxmlformats.org/officeDocument/2006/relationships" xmlns:p="http://schemas.openxmlformats.org/presentationml/2006/main">
   <p:cSld>
     <p:spTree>
       <p:nvGrpSpPr>
@@ -1210,7 +1004,7 @@
         <p:nvSpPr>
           <p:cNvPr id="2" name="Slide Image Placeholder 1"/>
           <p:cNvSpPr>
-            <a:spLocks noGrp="1"/>
+            <a:spLocks noGrp="1" noRot="1" noChangeAspect="1"/>
           </p:cNvSpPr>
           <p:nvPr>
             <p:ph type="sldImg" idx="2"/>
@@ -1225,7 +1019,7 @@
             <a:spLocks noGrp="1"/>
           </p:cNvSpPr>
           <p:nvPr>
-            <p:ph type="body" idx="3" sz="quarter"/>
+            <p:ph type="body" sz="quarter" idx="3"/>
           </p:nvPr>
         </p:nvSpPr>
         <p:spPr/>
@@ -1246,7 +1040,7 @@
             <a:spLocks noGrp="1"/>
           </p:cNvSpPr>
           <p:nvPr>
-            <p:ph type="sldNum" idx="5" sz="quarter"/>
+            <p:ph type="sldNum" sz="quarter" idx="5"/>
           </p:nvPr>
         </p:nvSpPr>
         <p:spPr/>
@@ -1260,7 +1054,7 @@
 </file>
 
 <file path=ppt/notesSlides/notesSlide2.xml><?xml version="1.0" encoding="utf-8"?>
-<p:notes xmlns:a="http://schemas.openxmlformats.org/drawingml/2006/main" xmlns:p="http://schemas.openxmlformats.org/presentationml/2006/main" xmlns:r="http://schemas.openxmlformats.org/officeDocument/2006/relationships">
+<p:notes xmlns:a="http://schemas.openxmlformats.org/drawingml/2006/main" xmlns:r="http://schemas.openxmlformats.org/officeDocument/2006/relationships" xmlns:p="http://schemas.openxmlformats.org/presentationml/2006/main">
   <p:cSld>
     <p:spTree>
       <p:nvGrpSpPr>
@@ -1280,7 +1074,7 @@
         <p:nvSpPr>
           <p:cNvPr id="2" name="Slide Image Placeholder 1"/>
           <p:cNvSpPr>
-            <a:spLocks noGrp="1"/>
+            <a:spLocks noGrp="1" noRot="1" noChangeAspect="1"/>
           </p:cNvSpPr>
           <p:nvPr>
             <p:ph type="sldImg" idx="2"/>
@@ -1295,7 +1089,7 @@
             <a:spLocks noGrp="1"/>
           </p:cNvSpPr>
           <p:nvPr>
-            <p:ph type="body" idx="3" sz="quarter"/>
+            <p:ph type="body" sz="quarter" idx="3"/>
           </p:nvPr>
         </p:nvSpPr>
         <p:spPr/>
@@ -1316,7 +1110,7 @@
             <a:spLocks noGrp="1"/>
           </p:cNvSpPr>
           <p:nvPr>
-            <p:ph type="sldNum" idx="5" sz="quarter"/>
+            <p:ph type="sldNum" sz="quarter" idx="5"/>
           </p:nvPr>
         </p:nvSpPr>
         <p:spPr/>
@@ -1330,7 +1124,7 @@
 </file>
 
 <file path=ppt/notesSlides/notesSlide20.xml><?xml version="1.0" encoding="utf-8"?>
-<p:notes xmlns:a="http://schemas.openxmlformats.org/drawingml/2006/main" xmlns:p="http://schemas.openxmlformats.org/presentationml/2006/main" xmlns:r="http://schemas.openxmlformats.org/officeDocument/2006/relationships">
+<p:notes xmlns:a="http://schemas.openxmlformats.org/drawingml/2006/main" xmlns:r="http://schemas.openxmlformats.org/officeDocument/2006/relationships" xmlns:p="http://schemas.openxmlformats.org/presentationml/2006/main">
   <p:cSld>
     <p:spTree>
       <p:nvGrpSpPr>
@@ -1350,7 +1144,7 @@
         <p:nvSpPr>
           <p:cNvPr id="2" name="Slide Image Placeholder 1"/>
           <p:cNvSpPr>
-            <a:spLocks noGrp="1"/>
+            <a:spLocks noGrp="1" noRot="1" noChangeAspect="1"/>
           </p:cNvSpPr>
           <p:nvPr>
             <p:ph type="sldImg" idx="2"/>
@@ -1365,7 +1159,7 @@
             <a:spLocks noGrp="1"/>
           </p:cNvSpPr>
           <p:nvPr>
-            <p:ph type="body" idx="3" sz="quarter"/>
+            <p:ph type="body" sz="quarter" idx="3"/>
           </p:nvPr>
         </p:nvSpPr>
         <p:spPr/>
@@ -1386,7 +1180,7 @@
             <a:spLocks noGrp="1"/>
           </p:cNvSpPr>
           <p:nvPr>
-            <p:ph type="sldNum" idx="5" sz="quarter"/>
+            <p:ph type="sldNum" sz="quarter" idx="5"/>
           </p:nvPr>
         </p:nvSpPr>
         <p:spPr/>
@@ -1400,7 +1194,7 @@
 </file>
 
 <file path=ppt/notesSlides/notesSlide21.xml><?xml version="1.0" encoding="utf-8"?>
-<p:notes xmlns:a="http://schemas.openxmlformats.org/drawingml/2006/main" xmlns:p="http://schemas.openxmlformats.org/presentationml/2006/main" xmlns:r="http://schemas.openxmlformats.org/officeDocument/2006/relationships">
+<p:notes xmlns:a="http://schemas.openxmlformats.org/drawingml/2006/main" xmlns:r="http://schemas.openxmlformats.org/officeDocument/2006/relationships" xmlns:p="http://schemas.openxmlformats.org/presentationml/2006/main">
   <p:cSld>
     <p:spTree>
       <p:nvGrpSpPr>
@@ -1420,7 +1214,7 @@
         <p:nvSpPr>
           <p:cNvPr id="2" name="Slide Image Placeholder 1"/>
           <p:cNvSpPr>
-            <a:spLocks noGrp="1"/>
+            <a:spLocks noGrp="1" noRot="1" noChangeAspect="1"/>
           </p:cNvSpPr>
           <p:nvPr>
             <p:ph type="sldImg" idx="2"/>
@@ -1435,7 +1229,7 @@
             <a:spLocks noGrp="1"/>
           </p:cNvSpPr>
           <p:nvPr>
-            <p:ph type="body" idx="3" sz="quarter"/>
+            <p:ph type="body" sz="quarter" idx="3"/>
           </p:nvPr>
         </p:nvSpPr>
         <p:spPr/>
@@ -1456,7 +1250,7 @@
             <a:spLocks noGrp="1"/>
           </p:cNvSpPr>
           <p:nvPr>
-            <p:ph type="sldNum" idx="5" sz="quarter"/>
+            <p:ph type="sldNum" sz="quarter" idx="5"/>
           </p:nvPr>
         </p:nvSpPr>
         <p:spPr/>
@@ -1470,7 +1264,7 @@
 </file>
 
 <file path=ppt/notesSlides/notesSlide22.xml><?xml version="1.0" encoding="utf-8"?>
-<p:notes xmlns:a="http://schemas.openxmlformats.org/drawingml/2006/main" xmlns:p="http://schemas.openxmlformats.org/presentationml/2006/main" xmlns:r="http://schemas.openxmlformats.org/officeDocument/2006/relationships">
+<p:notes xmlns:a="http://schemas.openxmlformats.org/drawingml/2006/main" xmlns:r="http://schemas.openxmlformats.org/officeDocument/2006/relationships" xmlns:p="http://schemas.openxmlformats.org/presentationml/2006/main">
   <p:cSld>
     <p:spTree>
       <p:nvGrpSpPr>
@@ -1490,7 +1284,7 @@
         <p:nvSpPr>
           <p:cNvPr id="2" name="Slide Image Placeholder 1"/>
           <p:cNvSpPr>
-            <a:spLocks noGrp="1"/>
+            <a:spLocks noGrp="1" noRot="1" noChangeAspect="1"/>
           </p:cNvSpPr>
           <p:nvPr>
             <p:ph type="sldImg" idx="2"/>
@@ -1505,7 +1299,7 @@
             <a:spLocks noGrp="1"/>
           </p:cNvSpPr>
           <p:nvPr>
-            <p:ph type="body" idx="3" sz="quarter"/>
+            <p:ph type="body" sz="quarter" idx="3"/>
           </p:nvPr>
         </p:nvSpPr>
         <p:spPr/>
@@ -1526,7 +1320,7 @@
             <a:spLocks noGrp="1"/>
           </p:cNvSpPr>
           <p:nvPr>
-            <p:ph type="sldNum" idx="5" sz="quarter"/>
+            <p:ph type="sldNum" sz="quarter" idx="5"/>
           </p:nvPr>
         </p:nvSpPr>
         <p:spPr/>
@@ -1540,7 +1334,7 @@
 </file>
 
 <file path=ppt/notesSlides/notesSlide23.xml><?xml version="1.0" encoding="utf-8"?>
-<p:notes xmlns:a="http://schemas.openxmlformats.org/drawingml/2006/main" xmlns:p="http://schemas.openxmlformats.org/presentationml/2006/main" xmlns:r="http://schemas.openxmlformats.org/officeDocument/2006/relationships">
+<p:notes xmlns:a="http://schemas.openxmlformats.org/drawingml/2006/main" xmlns:r="http://schemas.openxmlformats.org/officeDocument/2006/relationships" xmlns:p="http://schemas.openxmlformats.org/presentationml/2006/main">
   <p:cSld>
     <p:spTree>
       <p:nvGrpSpPr>
@@ -1560,7 +1354,7 @@
         <p:nvSpPr>
           <p:cNvPr id="2" name="Slide Image Placeholder 1"/>
           <p:cNvSpPr>
-            <a:spLocks noGrp="1"/>
+            <a:spLocks noGrp="1" noRot="1" noChangeAspect="1"/>
           </p:cNvSpPr>
           <p:nvPr>
             <p:ph type="sldImg" idx="2"/>
@@ -1575,7 +1369,7 @@
             <a:spLocks noGrp="1"/>
           </p:cNvSpPr>
           <p:nvPr>
-            <p:ph type="body" idx="3" sz="quarter"/>
+            <p:ph type="body" sz="quarter" idx="3"/>
           </p:nvPr>
         </p:nvSpPr>
         <p:spPr/>
@@ -1596,7 +1390,7 @@
             <a:spLocks noGrp="1"/>
           </p:cNvSpPr>
           <p:nvPr>
-            <p:ph type="sldNum" idx="5" sz="quarter"/>
+            <p:ph type="sldNum" sz="quarter" idx="5"/>
           </p:nvPr>
         </p:nvSpPr>
         <p:spPr/>
@@ -1610,7 +1404,7 @@
 </file>
 
 <file path=ppt/notesSlides/notesSlide24.xml><?xml version="1.0" encoding="utf-8"?>
-<p:notes xmlns:a="http://schemas.openxmlformats.org/drawingml/2006/main" xmlns:p="http://schemas.openxmlformats.org/presentationml/2006/main" xmlns:r="http://schemas.openxmlformats.org/officeDocument/2006/relationships">
+<p:notes xmlns:a="http://schemas.openxmlformats.org/drawingml/2006/main" xmlns:r="http://schemas.openxmlformats.org/officeDocument/2006/relationships" xmlns:p="http://schemas.openxmlformats.org/presentationml/2006/main">
   <p:cSld>
     <p:spTree>
       <p:nvGrpSpPr>
@@ -1630,7 +1424,7 @@
         <p:nvSpPr>
           <p:cNvPr id="2" name="Slide Image Placeholder 1"/>
           <p:cNvSpPr>
-            <a:spLocks noGrp="1"/>
+            <a:spLocks noGrp="1" noRot="1" noChangeAspect="1"/>
           </p:cNvSpPr>
           <p:nvPr>
             <p:ph type="sldImg" idx="2"/>
@@ -1645,7 +1439,7 @@
             <a:spLocks noGrp="1"/>
           </p:cNvSpPr>
           <p:nvPr>
-            <p:ph type="body" idx="3" sz="quarter"/>
+            <p:ph type="body" sz="quarter" idx="3"/>
           </p:nvPr>
         </p:nvSpPr>
         <p:spPr/>
@@ -1666,7 +1460,7 @@
             <a:spLocks noGrp="1"/>
           </p:cNvSpPr>
           <p:nvPr>
-            <p:ph type="sldNum" idx="5" sz="quarter"/>
+            <p:ph type="sldNum" sz="quarter" idx="5"/>
           </p:nvPr>
         </p:nvSpPr>
         <p:spPr/>
@@ -1680,7 +1474,7 @@
 </file>
 
 <file path=ppt/notesSlides/notesSlide25.xml><?xml version="1.0" encoding="utf-8"?>
-<p:notes xmlns:a="http://schemas.openxmlformats.org/drawingml/2006/main" xmlns:p="http://schemas.openxmlformats.org/presentationml/2006/main" xmlns:r="http://schemas.openxmlformats.org/officeDocument/2006/relationships">
+<p:notes xmlns:a="http://schemas.openxmlformats.org/drawingml/2006/main" xmlns:r="http://schemas.openxmlformats.org/officeDocument/2006/relationships" xmlns:p="http://schemas.openxmlformats.org/presentationml/2006/main">
   <p:cSld>
     <p:spTree>
       <p:nvGrpSpPr>
@@ -1700,7 +1494,7 @@
         <p:nvSpPr>
           <p:cNvPr id="2" name="Slide Image Placeholder 1"/>
           <p:cNvSpPr>
-            <a:spLocks noGrp="1"/>
+            <a:spLocks noGrp="1" noRot="1" noChangeAspect="1"/>
           </p:cNvSpPr>
           <p:nvPr>
             <p:ph type="sldImg" idx="2"/>
@@ -1715,7 +1509,7 @@
             <a:spLocks noGrp="1"/>
           </p:cNvSpPr>
           <p:nvPr>
-            <p:ph type="body" idx="3" sz="quarter"/>
+            <p:ph type="body" sz="quarter" idx="3"/>
           </p:nvPr>
         </p:nvSpPr>
         <p:spPr/>
@@ -1736,7 +1530,7 @@
             <a:spLocks noGrp="1"/>
           </p:cNvSpPr>
           <p:nvPr>
-            <p:ph type="sldNum" idx="5" sz="quarter"/>
+            <p:ph type="sldNum" sz="quarter" idx="5"/>
           </p:nvPr>
         </p:nvSpPr>
         <p:spPr/>
@@ -1750,7 +1544,7 @@
 </file>
 
 <file path=ppt/notesSlides/notesSlide26.xml><?xml version="1.0" encoding="utf-8"?>
-<p:notes xmlns:a="http://schemas.openxmlformats.org/drawingml/2006/main" xmlns:p="http://schemas.openxmlformats.org/presentationml/2006/main" xmlns:r="http://schemas.openxmlformats.org/officeDocument/2006/relationships">
+<p:notes xmlns:a="http://schemas.openxmlformats.org/drawingml/2006/main" xmlns:r="http://schemas.openxmlformats.org/officeDocument/2006/relationships" xmlns:p="http://schemas.openxmlformats.org/presentationml/2006/main">
   <p:cSld>
     <p:spTree>
       <p:nvGrpSpPr>
@@ -1770,7 +1564,7 @@
         <p:nvSpPr>
           <p:cNvPr id="2" name="Slide Image Placeholder 1"/>
           <p:cNvSpPr>
-            <a:spLocks noGrp="1"/>
+            <a:spLocks noGrp="1" noRot="1" noChangeAspect="1"/>
           </p:cNvSpPr>
           <p:nvPr>
             <p:ph type="sldImg" idx="2"/>
@@ -1785,7 +1579,7 @@
             <a:spLocks noGrp="1"/>
           </p:cNvSpPr>
           <p:nvPr>
-            <p:ph type="body" idx="3" sz="quarter"/>
+            <p:ph type="body" sz="quarter" idx="3"/>
           </p:nvPr>
         </p:nvSpPr>
         <p:spPr/>
@@ -1806,7 +1600,7 @@
             <a:spLocks noGrp="1"/>
           </p:cNvSpPr>
           <p:nvPr>
-            <p:ph type="sldNum" idx="5" sz="quarter"/>
+            <p:ph type="sldNum" sz="quarter" idx="5"/>
           </p:nvPr>
         </p:nvSpPr>
         <p:spPr/>
@@ -1820,7 +1614,7 @@
 </file>
 
 <file path=ppt/notesSlides/notesSlide27.xml><?xml version="1.0" encoding="utf-8"?>
-<p:notes xmlns:a="http://schemas.openxmlformats.org/drawingml/2006/main" xmlns:p="http://schemas.openxmlformats.org/presentationml/2006/main" xmlns:r="http://schemas.openxmlformats.org/officeDocument/2006/relationships">
+<p:notes xmlns:a="http://schemas.openxmlformats.org/drawingml/2006/main" xmlns:r="http://schemas.openxmlformats.org/officeDocument/2006/relationships" xmlns:p="http://schemas.openxmlformats.org/presentationml/2006/main">
   <p:cSld>
     <p:spTree>
       <p:nvGrpSpPr>
@@ -1840,7 +1634,7 @@
         <p:nvSpPr>
           <p:cNvPr id="2" name="Slide Image Placeholder 1"/>
           <p:cNvSpPr>
-            <a:spLocks noGrp="1"/>
+            <a:spLocks noGrp="1" noRot="1" noChangeAspect="1"/>
           </p:cNvSpPr>
           <p:nvPr>
             <p:ph type="sldImg" idx="2"/>
@@ -1855,7 +1649,7 @@
             <a:spLocks noGrp="1"/>
           </p:cNvSpPr>
           <p:nvPr>
-            <p:ph type="body" idx="3" sz="quarter"/>
+            <p:ph type="body" sz="quarter" idx="3"/>
           </p:nvPr>
         </p:nvSpPr>
         <p:spPr/>
@@ -1876,7 +1670,7 @@
             <a:spLocks noGrp="1"/>
           </p:cNvSpPr>
           <p:nvPr>
-            <p:ph type="sldNum" idx="5" sz="quarter"/>
+            <p:ph type="sldNum" sz="quarter" idx="5"/>
           </p:nvPr>
         </p:nvSpPr>
         <p:spPr/>
@@ -1890,7 +1684,7 @@
 </file>
 
 <file path=ppt/notesSlides/notesSlide28.xml><?xml version="1.0" encoding="utf-8"?>
-<p:notes xmlns:a="http://schemas.openxmlformats.org/drawingml/2006/main" xmlns:p="http://schemas.openxmlformats.org/presentationml/2006/main" xmlns:r="http://schemas.openxmlformats.org/officeDocument/2006/relationships">
+<p:notes xmlns:a="http://schemas.openxmlformats.org/drawingml/2006/main" xmlns:r="http://schemas.openxmlformats.org/officeDocument/2006/relationships" xmlns:p="http://schemas.openxmlformats.org/presentationml/2006/main">
   <p:cSld>
     <p:spTree>
       <p:nvGrpSpPr>
@@ -1910,7 +1704,7 @@
         <p:nvSpPr>
           <p:cNvPr id="2" name="Slide Image Placeholder 1"/>
           <p:cNvSpPr>
-            <a:spLocks noGrp="1"/>
+            <a:spLocks noGrp="1" noRot="1" noChangeAspect="1"/>
           </p:cNvSpPr>
           <p:nvPr>
             <p:ph type="sldImg" idx="2"/>
@@ -1925,7 +1719,7 @@
             <a:spLocks noGrp="1"/>
           </p:cNvSpPr>
           <p:nvPr>
-            <p:ph type="body" idx="3" sz="quarter"/>
+            <p:ph type="body" sz="quarter" idx="3"/>
           </p:nvPr>
         </p:nvSpPr>
         <p:spPr/>
@@ -1946,7 +1740,7 @@
             <a:spLocks noGrp="1"/>
           </p:cNvSpPr>
           <p:nvPr>
-            <p:ph type="sldNum" idx="5" sz="quarter"/>
+            <p:ph type="sldNum" sz="quarter" idx="5"/>
           </p:nvPr>
         </p:nvSpPr>
         <p:spPr/>
@@ -1960,7 +1754,7 @@
 </file>
 
 <file path=ppt/notesSlides/notesSlide29.xml><?xml version="1.0" encoding="utf-8"?>
-<p:notes xmlns:a="http://schemas.openxmlformats.org/drawingml/2006/main" xmlns:p="http://schemas.openxmlformats.org/presentationml/2006/main" xmlns:r="http://schemas.openxmlformats.org/officeDocument/2006/relationships">
+<p:notes xmlns:a="http://schemas.openxmlformats.org/drawingml/2006/main" xmlns:r="http://schemas.openxmlformats.org/officeDocument/2006/relationships" xmlns:p="http://schemas.openxmlformats.org/presentationml/2006/main">
   <p:cSld>
     <p:spTree>
       <p:nvGrpSpPr>
@@ -1980,7 +1774,7 @@
         <p:nvSpPr>
           <p:cNvPr id="2" name="Slide Image Placeholder 1"/>
           <p:cNvSpPr>
-            <a:spLocks noGrp="1"/>
+            <a:spLocks noGrp="1" noRot="1" noChangeAspect="1"/>
           </p:cNvSpPr>
           <p:nvPr>
             <p:ph type="sldImg" idx="2"/>
@@ -1995,7 +1789,7 @@
             <a:spLocks noGrp="1"/>
           </p:cNvSpPr>
           <p:nvPr>
-            <p:ph type="body" idx="3" sz="quarter"/>
+            <p:ph type="body" sz="quarter" idx="3"/>
           </p:nvPr>
         </p:nvSpPr>
         <p:spPr/>
@@ -2016,7 +1810,7 @@
             <a:spLocks noGrp="1"/>
           </p:cNvSpPr>
           <p:nvPr>
-            <p:ph type="sldNum" idx="5" sz="quarter"/>
+            <p:ph type="sldNum" sz="quarter" idx="5"/>
           </p:nvPr>
         </p:nvSpPr>
         <p:spPr/>
@@ -2030,7 +1824,7 @@
 </file>
 
 <file path=ppt/notesSlides/notesSlide3.xml><?xml version="1.0" encoding="utf-8"?>
-<p:notes xmlns:a="http://schemas.openxmlformats.org/drawingml/2006/main" xmlns:p="http://schemas.openxmlformats.org/presentationml/2006/main" xmlns:r="http://schemas.openxmlformats.org/officeDocument/2006/relationships">
+<p:notes xmlns:a="http://schemas.openxmlformats.org/drawingml/2006/main" xmlns:r="http://schemas.openxmlformats.org/officeDocument/2006/relationships" xmlns:p="http://schemas.openxmlformats.org/presentationml/2006/main">
   <p:cSld>
     <p:spTree>
       <p:nvGrpSpPr>
@@ -2050,7 +1844,7 @@
         <p:nvSpPr>
           <p:cNvPr id="2" name="Slide Image Placeholder 1"/>
           <p:cNvSpPr>
-            <a:spLocks noGrp="1"/>
+            <a:spLocks noGrp="1" noRot="1" noChangeAspect="1"/>
           </p:cNvSpPr>
           <p:nvPr>
             <p:ph type="sldImg" idx="2"/>
@@ -2065,7 +1859,7 @@
             <a:spLocks noGrp="1"/>
           </p:cNvSpPr>
           <p:nvPr>
-            <p:ph type="body" idx="3" sz="quarter"/>
+            <p:ph type="body" sz="quarter" idx="3"/>
           </p:nvPr>
         </p:nvSpPr>
         <p:spPr/>
@@ -2086,7 +1880,7 @@
             <a:spLocks noGrp="1"/>
           </p:cNvSpPr>
           <p:nvPr>
-            <p:ph type="sldNum" idx="5" sz="quarter"/>
+            <p:ph type="sldNum" sz="quarter" idx="5"/>
           </p:nvPr>
         </p:nvSpPr>
         <p:spPr/>
@@ -2100,7 +1894,7 @@
 </file>
 
 <file path=ppt/notesSlides/notesSlide30.xml><?xml version="1.0" encoding="utf-8"?>
-<p:notes xmlns:a="http://schemas.openxmlformats.org/drawingml/2006/main" xmlns:p="http://schemas.openxmlformats.org/presentationml/2006/main" xmlns:r="http://schemas.openxmlformats.org/officeDocument/2006/relationships">
+<p:notes xmlns:a="http://schemas.openxmlformats.org/drawingml/2006/main" xmlns:r="http://schemas.openxmlformats.org/officeDocument/2006/relationships" xmlns:p="http://schemas.openxmlformats.org/presentationml/2006/main">
   <p:cSld>
     <p:spTree>
       <p:nvGrpSpPr>
@@ -2120,7 +1914,7 @@
         <p:nvSpPr>
           <p:cNvPr id="2" name="Slide Image Placeholder 1"/>
           <p:cNvSpPr>
-            <a:spLocks noGrp="1"/>
+            <a:spLocks noGrp="1" noRot="1" noChangeAspect="1"/>
           </p:cNvSpPr>
           <p:nvPr>
             <p:ph type="sldImg" idx="2"/>
@@ -2135,7 +1929,7 @@
             <a:spLocks noGrp="1"/>
           </p:cNvSpPr>
           <p:nvPr>
-            <p:ph type="body" idx="3" sz="quarter"/>
+            <p:ph type="body" sz="quarter" idx="3"/>
           </p:nvPr>
         </p:nvSpPr>
         <p:spPr/>
@@ -2156,7 +1950,7 @@
             <a:spLocks noGrp="1"/>
           </p:cNvSpPr>
           <p:nvPr>
-            <p:ph type="sldNum" idx="5" sz="quarter"/>
+            <p:ph type="sldNum" sz="quarter" idx="5"/>
           </p:nvPr>
         </p:nvSpPr>
         <p:spPr/>
@@ -2170,7 +1964,7 @@
 </file>
 
 <file path=ppt/notesSlides/notesSlide31.xml><?xml version="1.0" encoding="utf-8"?>
-<p:notes xmlns:a="http://schemas.openxmlformats.org/drawingml/2006/main" xmlns:p="http://schemas.openxmlformats.org/presentationml/2006/main" xmlns:r="http://schemas.openxmlformats.org/officeDocument/2006/relationships">
+<p:notes xmlns:a="http://schemas.openxmlformats.org/drawingml/2006/main" xmlns:r="http://schemas.openxmlformats.org/officeDocument/2006/relationships" xmlns:p="http://schemas.openxmlformats.org/presentationml/2006/main">
   <p:cSld>
     <p:spTree>
       <p:nvGrpSpPr>
@@ -2190,7 +1984,7 @@
         <p:nvSpPr>
           <p:cNvPr id="2" name="Slide Image Placeholder 1"/>
           <p:cNvSpPr>
-            <a:spLocks noGrp="1"/>
+            <a:spLocks noGrp="1" noRot="1" noChangeAspect="1"/>
           </p:cNvSpPr>
           <p:nvPr>
             <p:ph type="sldImg" idx="2"/>
@@ -2205,7 +1999,7 @@
             <a:spLocks noGrp="1"/>
           </p:cNvSpPr>
           <p:nvPr>
-            <p:ph type="body" idx="3" sz="quarter"/>
+            <p:ph type="body" sz="quarter" idx="3"/>
           </p:nvPr>
         </p:nvSpPr>
         <p:spPr/>
@@ -2226,7 +2020,7 @@
             <a:spLocks noGrp="1"/>
           </p:cNvSpPr>
           <p:nvPr>
-            <p:ph type="sldNum" idx="5" sz="quarter"/>
+            <p:ph type="sldNum" sz="quarter" idx="5"/>
           </p:nvPr>
         </p:nvSpPr>
         <p:spPr/>
@@ -2240,7 +2034,7 @@
 </file>
 
 <file path=ppt/notesSlides/notesSlide32.xml><?xml version="1.0" encoding="utf-8"?>
-<p:notes xmlns:a="http://schemas.openxmlformats.org/drawingml/2006/main" xmlns:p="http://schemas.openxmlformats.org/presentationml/2006/main" xmlns:r="http://schemas.openxmlformats.org/officeDocument/2006/relationships">
+<p:notes xmlns:a="http://schemas.openxmlformats.org/drawingml/2006/main" xmlns:r="http://schemas.openxmlformats.org/officeDocument/2006/relationships" xmlns:p="http://schemas.openxmlformats.org/presentationml/2006/main">
   <p:cSld>
     <p:spTree>
       <p:nvGrpSpPr>
@@ -2260,7 +2054,7 @@
         <p:nvSpPr>
           <p:cNvPr id="2" name="Slide Image Placeholder 1"/>
           <p:cNvSpPr>
-            <a:spLocks noGrp="1"/>
+            <a:spLocks noGrp="1" noRot="1" noChangeAspect="1"/>
           </p:cNvSpPr>
           <p:nvPr>
             <p:ph type="sldImg" idx="2"/>
@@ -2275,7 +2069,7 @@
             <a:spLocks noGrp="1"/>
           </p:cNvSpPr>
           <p:nvPr>
-            <p:ph type="body" idx="3" sz="quarter"/>
+            <p:ph type="body" sz="quarter" idx="3"/>
           </p:nvPr>
         </p:nvSpPr>
         <p:spPr/>
@@ -2296,7 +2090,7 @@
             <a:spLocks noGrp="1"/>
           </p:cNvSpPr>
           <p:nvPr>
-            <p:ph type="sldNum" idx="5" sz="quarter"/>
+            <p:ph type="sldNum" sz="quarter" idx="5"/>
           </p:nvPr>
         </p:nvSpPr>
         <p:spPr/>
@@ -2310,7 +2104,7 @@
 </file>
 
 <file path=ppt/notesSlides/notesSlide33.xml><?xml version="1.0" encoding="utf-8"?>
-<p:notes xmlns:a="http://schemas.openxmlformats.org/drawingml/2006/main" xmlns:p="http://schemas.openxmlformats.org/presentationml/2006/main" xmlns:r="http://schemas.openxmlformats.org/officeDocument/2006/relationships">
+<p:notes xmlns:a="http://schemas.openxmlformats.org/drawingml/2006/main" xmlns:r="http://schemas.openxmlformats.org/officeDocument/2006/relationships" xmlns:p="http://schemas.openxmlformats.org/presentationml/2006/main">
   <p:cSld>
     <p:spTree>
       <p:nvGrpSpPr>
@@ -2330,7 +2124,7 @@
         <p:nvSpPr>
           <p:cNvPr id="2" name="Slide Image Placeholder 1"/>
           <p:cNvSpPr>
-            <a:spLocks noGrp="1"/>
+            <a:spLocks noGrp="1" noRot="1" noChangeAspect="1"/>
           </p:cNvSpPr>
           <p:nvPr>
             <p:ph type="sldImg" idx="2"/>
@@ -2345,7 +2139,7 @@
             <a:spLocks noGrp="1"/>
           </p:cNvSpPr>
           <p:nvPr>
-            <p:ph type="body" idx="3" sz="quarter"/>
+            <p:ph type="body" sz="quarter" idx="3"/>
           </p:nvPr>
         </p:nvSpPr>
         <p:spPr/>
@@ -2354,7 +2148,156 @@
           <a:lstStyle/>
           <a:p>
             <a:r>
-              <a:t>總結這整份報告。最直接的成果:我們把最樸素 KNN 基準的 1.57 公尺砍了一半,得到 0.752 公尺中位數(標準協定);在我們自己加碼的最嚴格巢狀交叉驗證下是 0.94——這兩個口徑我從第一張投影片用到最後一張、完全一致沒有矛盾,這點希望老師特別認可。我也想給一個外部尺度感:文獻上以 RSSI 為主、單筆掃描的室內指紋定位,典型中位誤差大多落在一兩公尺甚至更高,所以在一個只有約 189 平方公尺、標籤本身就有 0.3 公尺噪音的場域裡做到 0.75,是把誤差壓到接近標籤精度、屬於很有競爭力的結果。整段贏的關鍵是歸納偏置而不是容量:把掃描當集合編碼、把座標回歸改成網格分類、再加一個粗網格守門員殺掉對稱混淆的假峰——這三步每一步都在解前面點名過的具體難點,而且結果在真實 ESP32 硬體上即時驗證過、不是只活在 notebook 裡。但我最想被記住的是把嚴謹的驗證當成核心成果:我們主動抓出自己 0.650 的海市蜃樓,也照實報出 0.94 的巢狀交叉驗證,寧可報一個比較高但站得住的數字,也不要一個漂亮但偷看過答案的數字。最後未來方向講實在的:真正的 0.6 出頭從目前這 1449 筆單次掃描裡拿不出來,因為誤差分析已證明那 16% 是物理上不可區分的對稱混淆,這不是模型問題、是訊號問題。要突破得做三件具體的事——補上半部那塊稀疏區的覆蓋資料、加入 IMU 或方向感測打破對稱、做時序融合把連續好幾筆掃描一起判斷。一句話收尾,也是整份報告的精神:下一步的增益在新的訊號,不在更深的網路。謝謝大家,歡迎提問。</a:t>
+              <a:rPr dirty="0" err="1"/>
+              <a:t>總結這整份報告。最直接的成果:我們把最樸素</a:t>
+            </a:r>
+            <a:r>
+              <a:rPr dirty="0"/>
+              <a:t> KNN </a:t>
+            </a:r>
+            <a:r>
+              <a:rPr dirty="0" err="1"/>
+              <a:t>基準的</a:t>
+            </a:r>
+            <a:r>
+              <a:rPr dirty="0"/>
+              <a:t> 1.57 </a:t>
+            </a:r>
+            <a:r>
+              <a:rPr dirty="0" err="1"/>
+              <a:t>公尺砍了一半,得到</a:t>
+            </a:r>
+            <a:r>
+              <a:rPr dirty="0"/>
+              <a:t> 0.752 </a:t>
+            </a:r>
+            <a:r>
+              <a:rPr dirty="0" err="1"/>
+              <a:t>公尺中位數</a:t>
+            </a:r>
+            <a:r>
+              <a:rPr dirty="0"/>
+              <a:t>(</a:t>
+            </a:r>
+            <a:r>
+              <a:rPr dirty="0" err="1"/>
+              <a:t>標準協定</a:t>
+            </a:r>
+            <a:r>
+              <a:rPr dirty="0"/>
+              <a:t>);</a:t>
+            </a:r>
+            <a:r>
+              <a:rPr dirty="0" err="1"/>
+              <a:t>在我們自己加碼的最嚴格巢狀交叉驗證下是</a:t>
+            </a:r>
+            <a:r>
+              <a:rPr dirty="0"/>
+              <a:t> 0.94——</a:t>
+            </a:r>
+            <a:r>
+              <a:rPr dirty="0" err="1"/>
+              <a:t>這兩個口徑我從第一張投影片用到最後一張、完全一致沒有矛盾,這點希望老師特別認可。我也想給一個外部尺度感:文獻上以</a:t>
+            </a:r>
+            <a:r>
+              <a:rPr dirty="0"/>
+              <a:t> RSSI </a:t>
+            </a:r>
+            <a:r>
+              <a:rPr dirty="0" err="1"/>
+              <a:t>為主、單筆掃描的室內指紋定位,典型中位誤差大多落在一兩公尺甚至更高,所以在一個只有約</a:t>
+            </a:r>
+            <a:r>
+              <a:rPr dirty="0"/>
+              <a:t> 189 </a:t>
+            </a:r>
+            <a:r>
+              <a:rPr dirty="0" err="1"/>
+              <a:t>平方公尺、標籤本身就有</a:t>
+            </a:r>
+            <a:r>
+              <a:rPr dirty="0"/>
+              <a:t> 0.3 </a:t>
+            </a:r>
+            <a:r>
+              <a:rPr dirty="0" err="1"/>
+              <a:t>公尺噪音的場域裡做到</a:t>
+            </a:r>
+            <a:r>
+              <a:rPr dirty="0"/>
+              <a:t> 0.75,是把誤差壓到接近標籤精度、屬於很有競爭力的結果。整段贏的關鍵是歸納偏置而不是容量:把掃描當集合編碼、把座標回歸改成網格分類、再加一個粗網格守門員殺掉對稱混淆的假峰——</a:t>
+            </a:r>
+            <a:r>
+              <a:rPr dirty="0" err="1"/>
+              <a:t>這三步每一步都在解前面點名過的具體難點,而且結果在真實</a:t>
+            </a:r>
+            <a:r>
+              <a:rPr dirty="0"/>
+              <a:t> ESP32 </a:t>
+            </a:r>
+            <a:r>
+              <a:rPr dirty="0" err="1"/>
+              <a:t>硬體上即時驗證過、不是只活在</a:t>
+            </a:r>
+            <a:r>
+              <a:rPr dirty="0"/>
+              <a:t> notebook </a:t>
+            </a:r>
+            <a:r>
+              <a:rPr dirty="0" err="1"/>
+              <a:t>裡。但我最想被記住的是把嚴謹的驗證當成核心成果:我們主動抓出自己</a:t>
+            </a:r>
+            <a:r>
+              <a:rPr dirty="0"/>
+              <a:t> 0.650 </a:t>
+            </a:r>
+            <a:r>
+              <a:rPr dirty="0" err="1"/>
+              <a:t>的海市蜃樓,也照實報出</a:t>
+            </a:r>
+            <a:r>
+              <a:rPr dirty="0"/>
+              <a:t> 0.94 </a:t>
+            </a:r>
+            <a:r>
+              <a:rPr dirty="0" err="1"/>
+              <a:t>的巢狀交叉驗證,寧可報一個比較高但站得住的數字,也不要一個漂亮但偷看過答案的數字。最後未來方向講實在的:真正的</a:t>
+            </a:r>
+            <a:r>
+              <a:rPr dirty="0"/>
+              <a:t> 0.6 </a:t>
+            </a:r>
+            <a:r>
+              <a:rPr dirty="0" err="1"/>
+              <a:t>出頭從目前這</a:t>
+            </a:r>
+            <a:r>
+              <a:rPr dirty="0"/>
+              <a:t> 1449 </a:t>
+            </a:r>
+            <a:r>
+              <a:rPr dirty="0" err="1"/>
+              <a:t>筆單次掃描裡拿不出來,因為誤差分析已證明那</a:t>
+            </a:r>
+            <a:r>
+              <a:rPr dirty="0"/>
+              <a:t> 16% </a:t>
+            </a:r>
+            <a:r>
+              <a:rPr dirty="0" err="1"/>
+              <a:t>是物理上不可區分的對稱混淆,這不是模型問題、是訊號問題。要突破得做三件具體的事</a:t>
+            </a:r>
+            <a:r>
+              <a:rPr dirty="0"/>
+              <a:t>——</a:t>
+            </a:r>
+            <a:r>
+              <a:rPr dirty="0" err="1"/>
+              <a:t>補上半部那塊稀疏區的覆蓋資料、加入</a:t>
+            </a:r>
+            <a:r>
+              <a:rPr dirty="0"/>
+              <a:t> IMU 或方向感測打破對稱、做時序融合把連續好幾筆掃描一起判斷。一句話收尾,也是整份報告的精神:下一步的增益在新的訊號,不在更深的網路。謝謝大家,歡迎提問。</a:t>
             </a:r>
           </a:p>
         </p:txBody>
@@ -2366,7 +2309,7 @@
             <a:spLocks noGrp="1"/>
           </p:cNvSpPr>
           <p:nvPr>
-            <p:ph type="sldNum" idx="5" sz="quarter"/>
+            <p:ph type="sldNum" sz="quarter" idx="5"/>
           </p:nvPr>
         </p:nvSpPr>
         <p:spPr/>
@@ -2380,7 +2323,7 @@
 </file>
 
 <file path=ppt/notesSlides/notesSlide4.xml><?xml version="1.0" encoding="utf-8"?>
-<p:notes xmlns:a="http://schemas.openxmlformats.org/drawingml/2006/main" xmlns:p="http://schemas.openxmlformats.org/presentationml/2006/main" xmlns:r="http://schemas.openxmlformats.org/officeDocument/2006/relationships">
+<p:notes xmlns:a="http://schemas.openxmlformats.org/drawingml/2006/main" xmlns:r="http://schemas.openxmlformats.org/officeDocument/2006/relationships" xmlns:p="http://schemas.openxmlformats.org/presentationml/2006/main">
   <p:cSld>
     <p:spTree>
       <p:nvGrpSpPr>
@@ -2400,7 +2343,7 @@
         <p:nvSpPr>
           <p:cNvPr id="2" name="Slide Image Placeholder 1"/>
           <p:cNvSpPr>
-            <a:spLocks noGrp="1"/>
+            <a:spLocks noGrp="1" noRot="1" noChangeAspect="1"/>
           </p:cNvSpPr>
           <p:nvPr>
             <p:ph type="sldImg" idx="2"/>
@@ -2415,7 +2358,7 @@
             <a:spLocks noGrp="1"/>
           </p:cNvSpPr>
           <p:nvPr>
-            <p:ph type="body" idx="3" sz="quarter"/>
+            <p:ph type="body" sz="quarter" idx="3"/>
           </p:nvPr>
         </p:nvSpPr>
         <p:spPr/>
@@ -2427,7 +2370,9 @@
               <a:t>把題目定清楚。輸入是一筆 WiFi 掃描,本質是一個集合:一堆 BSSID 加上各自的 RSSI 訊號強度配成對,而且關鍵是每一筆掃到的 AP 數量都不一樣,有時三四十個、有時只有十幾個。輸出是機器人在這個 189.5 平方公尺實驗室地圖上的座標,單位是公尺。先說評估口徑,後面所有數字都用同一把尺:誤差指的是預測座標到 AMCL 地面真值的歐氏距離、單位公尺,我報的都是中位數。為什麼用 WiFi?因為室內收不到 GPS,而 WiFi 訊號到處都有、現成免裝,指紋定位就是業界最經典的室內備案。</a:t>
             </a:r>
           </a:p>
-          <a:p/>
+          <a:p>
+            <a:endParaRPr/>
+          </a:p>
           <a:p>
             <a:r>
               <a:t>重點是這題為什麼難,而且是四個難點同時並存、互相疊加,後面每一步我都會回來指其中一個。第一,輸入是變動長度的無序集合,不是固定向量,這是之後改用 Set Transformer 的理由。第二,RSSI 多峰又會混淆——房間裡兩個不同地點的訊號組合可能幾乎一模一樣,也就是 ambiguous RSSI,一個輸入對到兩個合理答案,這是後面把回歸改成網格分類的理由。第三,覆蓋稀疏,資料沿著機器人走過的路徑收、不是均勻鋪滿,上半部幾乎沒走到,這是後面用高斯過程補洞的理由。第四,地面真值是 ROS AMCL 給的,本身就帶約 0.3 公尺定位噪聲,這是準度的物理天花板,意思是再強的模型也不可能系統性地比標籤本身還準。預期會被問:既然 GPS 不行,為什麼不用藍牙信標或 UWB?那些都要額外佈建硬體跟成本,而 WiFi 是環境裡免費既有的訊號,這份工作的價值正是只靠現成 WiFi 加對的模型,就把誤差壓到接近標籤精度。</a:t>
@@ -2442,7 +2387,7 @@
             <a:spLocks noGrp="1"/>
           </p:cNvSpPr>
           <p:nvPr>
-            <p:ph type="sldNum" idx="5" sz="quarter"/>
+            <p:ph type="sldNum" sz="quarter" idx="5"/>
           </p:nvPr>
         </p:nvSpPr>
         <p:spPr/>
@@ -2456,7 +2401,7 @@
 </file>
 
 <file path=ppt/notesSlides/notesSlide5.xml><?xml version="1.0" encoding="utf-8"?>
-<p:notes xmlns:a="http://schemas.openxmlformats.org/drawingml/2006/main" xmlns:p="http://schemas.openxmlformats.org/presentationml/2006/main" xmlns:r="http://schemas.openxmlformats.org/officeDocument/2006/relationships">
+<p:notes xmlns:a="http://schemas.openxmlformats.org/drawingml/2006/main" xmlns:r="http://schemas.openxmlformats.org/officeDocument/2006/relationships" xmlns:p="http://schemas.openxmlformats.org/presentationml/2006/main">
   <p:cSld>
     <p:spTree>
       <p:nvGrpSpPr>
@@ -2476,7 +2421,7 @@
         <p:nvSpPr>
           <p:cNvPr id="2" name="Slide Image Placeholder 1"/>
           <p:cNvSpPr>
-            <a:spLocks noGrp="1"/>
+            <a:spLocks noGrp="1" noRot="1" noChangeAspect="1"/>
           </p:cNvSpPr>
           <p:nvPr>
             <p:ph type="sldImg" idx="2"/>
@@ -2491,7 +2436,7 @@
             <a:spLocks noGrp="1"/>
           </p:cNvSpPr>
           <p:nvPr>
-            <p:ph type="body" idx="3" sz="quarter"/>
+            <p:ph type="body" sz="quarter" idx="3"/>
           </p:nvPr>
         </p:nvSpPr>
         <p:spPr/>
@@ -2503,7 +2448,9 @@
               <a:t>(這張是深入剖析、屬於可快可慢的彈性投影片:若時間緊,口頭講兩句『一筆掃描就是一袋無序又變長的配對,硬塞成固定向量會塞進一堆假欄位』就推進;若有時間或被問到再展開。)後面整條技術路線的第一個轉折完全建立在一筆掃描長什麼樣這件事上,值得攤開。一筆原始掃描就是一袋無序的配對,像 ap_3f 強度 -52、ap_1a 強度 -67、ap_b2 強度 -78 這樣列下去,單位 dBm,越接近零代表訊號越強、離 AP 越近,大概落在 -40 到 -90 之間。注意兩個字:無序、變長。無序是這一袋裡誰先誰後完全沒意義;變長是不同掃描裝的 AP 數量不一樣,少則十幾個、多則三四十個。</a:t>
             </a:r>
           </a:p>
-          <a:p/>
+          <a:p>
+            <a:endParaRPr/>
+          </a:p>
           <a:p>
             <a:r>
               <a:t>更麻煩的是同一個位置連續掃兩次,列出的 AP 清單都不見得一樣——有的 AP 這次剛好掃到、下次因為通道忙或訊號瞬間掉到底噪就沒列進來。所以同一地點的兩筆掃描可能長度不同、成員也略有出入,卻該對到同一個座標。核心矛盾就在這:資料天生是無序、變長、成員會抖動的集合,可是傳統 MLP 只吃固定維度、有固定欄位順序的向量。硬塞會怎樣?KNN 跟第一版 MLP 就是先固定一張 80 個 AP 的詞彙表,把掃描攤成 80 維,某 AP 沒掃到就在那一格填 -100。問題是一筆典型掃描平均只點亮 27.7 個 AP,等於約三分之二的維度都是 -100 填充,模型有三分之二的輸入是假的、在學著忽略不存在的東西,白白浪費容量。結論一句、也承先啟後:資料本來就是集合,就該用對集合的模型去處理它——這直接預告下一段把每個 AP 當 token、用 Set Transformer 的轉折。預期追問:那把 RSSI 正規化成 0 到 1、缺席填 0 不就好?那只是換個數值,集合無序跟變長兩個本質問題還在,治標不治本。</a:t>
@@ -2518,7 +2465,7 @@
             <a:spLocks noGrp="1"/>
           </p:cNvSpPr>
           <p:nvPr>
-            <p:ph type="sldNum" idx="5" sz="quarter"/>
+            <p:ph type="sldNum" sz="quarter" idx="5"/>
           </p:nvPr>
         </p:nvSpPr>
         <p:spPr/>
@@ -2532,7 +2479,7 @@
 </file>
 
 <file path=ppt/notesSlides/notesSlide6.xml><?xml version="1.0" encoding="utf-8"?>
-<p:notes xmlns:a="http://schemas.openxmlformats.org/drawingml/2006/main" xmlns:p="http://schemas.openxmlformats.org/presentationml/2006/main" xmlns:r="http://schemas.openxmlformats.org/officeDocument/2006/relationships">
+<p:notes xmlns:a="http://schemas.openxmlformats.org/drawingml/2006/main" xmlns:r="http://schemas.openxmlformats.org/officeDocument/2006/relationships" xmlns:p="http://schemas.openxmlformats.org/presentationml/2006/main">
   <p:cSld>
     <p:spTree>
       <p:nvGrpSpPr>
@@ -2552,7 +2499,7 @@
         <p:nvSpPr>
           <p:cNvPr id="2" name="Slide Image Placeholder 1"/>
           <p:cNvSpPr>
-            <a:spLocks noGrp="1"/>
+            <a:spLocks noGrp="1" noRot="1" noChangeAspect="1"/>
           </p:cNvSpPr>
           <p:nvPr>
             <p:ph type="sldImg" idx="2"/>
@@ -2567,7 +2514,7 @@
             <a:spLocks noGrp="1"/>
           </p:cNvSpPr>
           <p:nvPr>
-            <p:ph type="body" idx="3" sz="quarter"/>
+            <p:ph type="body" sz="quarter" idx="3"/>
           </p:nvPr>
         </p:nvSpPr>
         <p:spPr/>
@@ -2588,7 +2535,7 @@
             <a:spLocks noGrp="1"/>
           </p:cNvSpPr>
           <p:nvPr>
-            <p:ph type="sldNum" idx="5" sz="quarter"/>
+            <p:ph type="sldNum" sz="quarter" idx="5"/>
           </p:nvPr>
         </p:nvSpPr>
         <p:spPr/>
@@ -2602,7 +2549,7 @@
 </file>
 
 <file path=ppt/notesSlides/notesSlide7.xml><?xml version="1.0" encoding="utf-8"?>
-<p:notes xmlns:a="http://schemas.openxmlformats.org/drawingml/2006/main" xmlns:p="http://schemas.openxmlformats.org/presentationml/2006/main" xmlns:r="http://schemas.openxmlformats.org/officeDocument/2006/relationships">
+<p:notes xmlns:a="http://schemas.openxmlformats.org/drawingml/2006/main" xmlns:r="http://schemas.openxmlformats.org/officeDocument/2006/relationships" xmlns:p="http://schemas.openxmlformats.org/presentationml/2006/main">
   <p:cSld>
     <p:spTree>
       <p:nvGrpSpPr>
@@ -2622,7 +2569,7 @@
         <p:nvSpPr>
           <p:cNvPr id="2" name="Slide Image Placeholder 1"/>
           <p:cNvSpPr>
-            <a:spLocks noGrp="1"/>
+            <a:spLocks noGrp="1" noRot="1" noChangeAspect="1"/>
           </p:cNvSpPr>
           <p:nvPr>
             <p:ph type="sldImg" idx="2"/>
@@ -2637,7 +2584,7 @@
             <a:spLocks noGrp="1"/>
           </p:cNvSpPr>
           <p:nvPr>
-            <p:ph type="body" idx="3" sz="quarter"/>
+            <p:ph type="body" sz="quarter" idx="3"/>
           </p:nvPr>
         </p:nvSpPr>
         <p:spPr/>
@@ -2658,7 +2605,7 @@
             <a:spLocks noGrp="1"/>
           </p:cNvSpPr>
           <p:nvPr>
-            <p:ph type="sldNum" idx="5" sz="quarter"/>
+            <p:ph type="sldNum" sz="quarter" idx="5"/>
           </p:nvPr>
         </p:nvSpPr>
         <p:spPr/>
@@ -2672,7 +2619,7 @@
 </file>
 
 <file path=ppt/notesSlides/notesSlide8.xml><?xml version="1.0" encoding="utf-8"?>
-<p:notes xmlns:a="http://schemas.openxmlformats.org/drawingml/2006/main" xmlns:p="http://schemas.openxmlformats.org/presentationml/2006/main" xmlns:r="http://schemas.openxmlformats.org/officeDocument/2006/relationships">
+<p:notes xmlns:a="http://schemas.openxmlformats.org/drawingml/2006/main" xmlns:r="http://schemas.openxmlformats.org/officeDocument/2006/relationships" xmlns:p="http://schemas.openxmlformats.org/presentationml/2006/main">
   <p:cSld>
     <p:spTree>
       <p:nvGrpSpPr>
@@ -2692,7 +2639,7 @@
         <p:nvSpPr>
           <p:cNvPr id="2" name="Slide Image Placeholder 1"/>
           <p:cNvSpPr>
-            <a:spLocks noGrp="1"/>
+            <a:spLocks noGrp="1" noRot="1" noChangeAspect="1"/>
           </p:cNvSpPr>
           <p:nvPr>
             <p:ph type="sldImg" idx="2"/>
@@ -2707,7 +2654,7 @@
             <a:spLocks noGrp="1"/>
           </p:cNvSpPr>
           <p:nvPr>
-            <p:ph type="body" idx="3" sz="quarter"/>
+            <p:ph type="body" sz="quarter" idx="3"/>
           </p:nvPr>
         </p:nvSpPr>
         <p:spPr/>
@@ -2728,7 +2675,7 @@
             <a:spLocks noGrp="1"/>
           </p:cNvSpPr>
           <p:nvPr>
-            <p:ph type="sldNum" idx="5" sz="quarter"/>
+            <p:ph type="sldNum" sz="quarter" idx="5"/>
           </p:nvPr>
         </p:nvSpPr>
         <p:spPr/>
@@ -2742,7 +2689,7 @@
 </file>
 
 <file path=ppt/notesSlides/notesSlide9.xml><?xml version="1.0" encoding="utf-8"?>
-<p:notes xmlns:a="http://schemas.openxmlformats.org/drawingml/2006/main" xmlns:p="http://schemas.openxmlformats.org/presentationml/2006/main" xmlns:r="http://schemas.openxmlformats.org/officeDocument/2006/relationships">
+<p:notes xmlns:a="http://schemas.openxmlformats.org/drawingml/2006/main" xmlns:r="http://schemas.openxmlformats.org/officeDocument/2006/relationships" xmlns:p="http://schemas.openxmlformats.org/presentationml/2006/main">
   <p:cSld>
     <p:spTree>
       <p:nvGrpSpPr>
@@ -2762,7 +2709,7 @@
         <p:nvSpPr>
           <p:cNvPr id="2" name="Slide Image Placeholder 1"/>
           <p:cNvSpPr>
-            <a:spLocks noGrp="1"/>
+            <a:spLocks noGrp="1" noRot="1" noChangeAspect="1"/>
           </p:cNvSpPr>
           <p:nvPr>
             <p:ph type="sldImg" idx="2"/>
@@ -2777,7 +2724,7 @@
             <a:spLocks noGrp="1"/>
           </p:cNvSpPr>
           <p:nvPr>
-            <p:ph type="body" idx="3" sz="quarter"/>
+            <p:ph type="body" sz="quarter" idx="3"/>
           </p:nvPr>
         </p:nvSpPr>
         <p:spPr/>
@@ -2798,7 +2745,7 @@
             <a:spLocks noGrp="1"/>
           </p:cNvSpPr>
           <p:nvPr>
-            <p:ph type="sldNum" idx="5" sz="quarter"/>
+            <p:ph type="sldNum" sz="quarter" idx="5"/>
           </p:nvPr>
         </p:nvSpPr>
         <p:spPr/>
@@ -2849,10 +2796,9 @@
           <a:lstStyle/>
           <a:p>
             <a:r>
-              <a:rPr lang="en-US" smtClean="0"/>
+              <a:rPr lang="en-US"/>
               <a:t>Click to edit Master title style</a:t>
             </a:r>
-            <a:endParaRPr lang="en-US"/>
           </a:p>
         </p:txBody>
       </p:sp>
@@ -2968,10 +2914,9 @@
           </a:lstStyle>
           <a:p>
             <a:r>
-              <a:rPr lang="en-US" smtClean="0"/>
+              <a:rPr lang="en-US"/>
               <a:t>Click to edit Master subtitle style</a:t>
             </a:r>
-            <a:endParaRPr lang="en-US"/>
           </a:p>
         </p:txBody>
       </p:sp>
@@ -2992,7 +2937,7 @@
           <a:p>
             <a:fld id="{5BCAD085-E8A6-8845-BD4E-CB4CCA059FC4}" type="datetimeFigureOut">
               <a:rPr lang="en-US" smtClean="0"/>
-              <a:t>1/27/13</a:t>
+              <a:t>6/8/2026</a:t>
             </a:fld>
             <a:endParaRPr lang="en-US"/>
           </a:p>
@@ -3086,10 +3031,9 @@
           <a:lstStyle/>
           <a:p>
             <a:r>
-              <a:rPr lang="en-US" smtClean="0"/>
+              <a:rPr lang="en-US"/>
               <a:t>Click to edit Master title style</a:t>
             </a:r>
-            <a:endParaRPr lang="en-US"/>
           </a:p>
         </p:txBody>
       </p:sp>
@@ -3110,38 +3054,37 @@
           <a:p>
             <a:pPr lvl="0"/>
             <a:r>
-              <a:rPr lang="en-US" smtClean="0"/>
+              <a:rPr lang="en-US"/>
               <a:t>Click to edit Master text styles</a:t>
             </a:r>
           </a:p>
           <a:p>
             <a:pPr lvl="1"/>
             <a:r>
-              <a:rPr lang="en-US" smtClean="0"/>
+              <a:rPr lang="en-US"/>
               <a:t>Second level</a:t>
             </a:r>
           </a:p>
           <a:p>
             <a:pPr lvl="2"/>
             <a:r>
-              <a:rPr lang="en-US" smtClean="0"/>
+              <a:rPr lang="en-US"/>
               <a:t>Third level</a:t>
             </a:r>
           </a:p>
           <a:p>
             <a:pPr lvl="3"/>
             <a:r>
-              <a:rPr lang="en-US" smtClean="0"/>
+              <a:rPr lang="en-US"/>
               <a:t>Fourth level</a:t>
             </a:r>
           </a:p>
           <a:p>
             <a:pPr lvl="4"/>
             <a:r>
-              <a:rPr lang="en-US" smtClean="0"/>
+              <a:rPr lang="en-US"/>
               <a:t>Fifth level</a:t>
             </a:r>
-            <a:endParaRPr lang="en-US"/>
           </a:p>
         </p:txBody>
       </p:sp>
@@ -3162,7 +3105,7 @@
           <a:p>
             <a:fld id="{5BCAD085-E8A6-8845-BD4E-CB4CCA059FC4}" type="datetimeFigureOut">
               <a:rPr lang="en-US" smtClean="0"/>
-              <a:t>1/27/13</a:t>
+              <a:t>6/8/2026</a:t>
             </a:fld>
             <a:endParaRPr lang="en-US"/>
           </a:p>
@@ -3261,10 +3204,9 @@
           <a:lstStyle/>
           <a:p>
             <a:r>
-              <a:rPr lang="en-US" smtClean="0"/>
+              <a:rPr lang="en-US"/>
               <a:t>Click to edit Master title style</a:t>
             </a:r>
-            <a:endParaRPr lang="en-US"/>
           </a:p>
         </p:txBody>
       </p:sp>
@@ -3290,38 +3232,37 @@
           <a:p>
             <a:pPr lvl="0"/>
             <a:r>
-              <a:rPr lang="en-US" smtClean="0"/>
+              <a:rPr lang="en-US"/>
               <a:t>Click to edit Master text styles</a:t>
             </a:r>
           </a:p>
           <a:p>
             <a:pPr lvl="1"/>
             <a:r>
-              <a:rPr lang="en-US" smtClean="0"/>
+              <a:rPr lang="en-US"/>
               <a:t>Second level</a:t>
             </a:r>
           </a:p>
           <a:p>
             <a:pPr lvl="2"/>
             <a:r>
-              <a:rPr lang="en-US" smtClean="0"/>
+              <a:rPr lang="en-US"/>
               <a:t>Third level</a:t>
             </a:r>
           </a:p>
           <a:p>
             <a:pPr lvl="3"/>
             <a:r>
-              <a:rPr lang="en-US" smtClean="0"/>
+              <a:rPr lang="en-US"/>
               <a:t>Fourth level</a:t>
             </a:r>
           </a:p>
           <a:p>
             <a:pPr lvl="4"/>
             <a:r>
-              <a:rPr lang="en-US" smtClean="0"/>
+              <a:rPr lang="en-US"/>
               <a:t>Fifth level</a:t>
             </a:r>
-            <a:endParaRPr lang="en-US"/>
           </a:p>
         </p:txBody>
       </p:sp>
@@ -3342,7 +3283,7 @@
           <a:p>
             <a:fld id="{5BCAD085-E8A6-8845-BD4E-CB4CCA059FC4}" type="datetimeFigureOut">
               <a:rPr lang="en-US" smtClean="0"/>
-              <a:t>1/27/13</a:t>
+              <a:t>6/8/2026</a:t>
             </a:fld>
             <a:endParaRPr lang="en-US"/>
           </a:p>
@@ -3436,10 +3377,9 @@
           <a:lstStyle/>
           <a:p>
             <a:r>
-              <a:rPr lang="en-US" smtClean="0"/>
+              <a:rPr lang="en-US"/>
               <a:t>Click to edit Master title style</a:t>
             </a:r>
-            <a:endParaRPr lang="en-US"/>
           </a:p>
         </p:txBody>
       </p:sp>
@@ -3460,38 +3400,37 @@
           <a:p>
             <a:pPr lvl="0"/>
             <a:r>
-              <a:rPr lang="en-US" smtClean="0"/>
+              <a:rPr lang="en-US"/>
               <a:t>Click to edit Master text styles</a:t>
             </a:r>
           </a:p>
           <a:p>
             <a:pPr lvl="1"/>
             <a:r>
-              <a:rPr lang="en-US" smtClean="0"/>
+              <a:rPr lang="en-US"/>
               <a:t>Second level</a:t>
             </a:r>
           </a:p>
           <a:p>
             <a:pPr lvl="2"/>
             <a:r>
-              <a:rPr lang="en-US" smtClean="0"/>
+              <a:rPr lang="en-US"/>
               <a:t>Third level</a:t>
             </a:r>
           </a:p>
           <a:p>
             <a:pPr lvl="3"/>
             <a:r>
-              <a:rPr lang="en-US" smtClean="0"/>
+              <a:rPr lang="en-US"/>
               <a:t>Fourth level</a:t>
             </a:r>
           </a:p>
           <a:p>
             <a:pPr lvl="4"/>
             <a:r>
-              <a:rPr lang="en-US" smtClean="0"/>
+              <a:rPr lang="en-US"/>
               <a:t>Fifth level</a:t>
             </a:r>
-            <a:endParaRPr lang="en-US"/>
           </a:p>
         </p:txBody>
       </p:sp>
@@ -3512,7 +3451,7 @@
           <a:p>
             <a:fld id="{5BCAD085-E8A6-8845-BD4E-CB4CCA059FC4}" type="datetimeFigureOut">
               <a:rPr lang="en-US" smtClean="0"/>
-              <a:t>1/27/13</a:t>
+              <a:t>6/8/2026</a:t>
             </a:fld>
             <a:endParaRPr lang="en-US"/>
           </a:p>
@@ -3615,10 +3554,9 @@
           </a:lstStyle>
           <a:p>
             <a:r>
-              <a:rPr lang="en-US" smtClean="0"/>
+              <a:rPr lang="en-US"/>
               <a:t>Click to edit Master title style</a:t>
             </a:r>
-            <a:endParaRPr lang="en-US"/>
           </a:p>
         </p:txBody>
       </p:sp>
@@ -3735,7 +3673,7 @@
           <a:p>
             <a:pPr lvl="0"/>
             <a:r>
-              <a:rPr lang="en-US" smtClean="0"/>
+              <a:rPr lang="en-US"/>
               <a:t>Click to edit Master text styles</a:t>
             </a:r>
           </a:p>
@@ -3758,7 +3696,7 @@
           <a:p>
             <a:fld id="{5BCAD085-E8A6-8845-BD4E-CB4CCA059FC4}" type="datetimeFigureOut">
               <a:rPr lang="en-US" smtClean="0"/>
-              <a:t>1/27/13</a:t>
+              <a:t>6/8/2026</a:t>
             </a:fld>
             <a:endParaRPr lang="en-US"/>
           </a:p>
@@ -3852,10 +3790,9 @@
           <a:lstStyle/>
           <a:p>
             <a:r>
-              <a:rPr lang="en-US" smtClean="0"/>
+              <a:rPr lang="en-US"/>
               <a:t>Click to edit Master title style</a:t>
             </a:r>
-            <a:endParaRPr lang="en-US"/>
           </a:p>
         </p:txBody>
       </p:sp>
@@ -3909,38 +3846,37 @@
           <a:p>
             <a:pPr lvl="0"/>
             <a:r>
-              <a:rPr lang="en-US" smtClean="0"/>
+              <a:rPr lang="en-US"/>
               <a:t>Click to edit Master text styles</a:t>
             </a:r>
           </a:p>
           <a:p>
             <a:pPr lvl="1"/>
             <a:r>
-              <a:rPr lang="en-US" smtClean="0"/>
+              <a:rPr lang="en-US"/>
               <a:t>Second level</a:t>
             </a:r>
           </a:p>
           <a:p>
             <a:pPr lvl="2"/>
             <a:r>
-              <a:rPr lang="en-US" smtClean="0"/>
+              <a:rPr lang="en-US"/>
               <a:t>Third level</a:t>
             </a:r>
           </a:p>
           <a:p>
             <a:pPr lvl="3"/>
             <a:r>
-              <a:rPr lang="en-US" smtClean="0"/>
+              <a:rPr lang="en-US"/>
               <a:t>Fourth level</a:t>
             </a:r>
           </a:p>
           <a:p>
             <a:pPr lvl="4"/>
             <a:r>
-              <a:rPr lang="en-US" smtClean="0"/>
+              <a:rPr lang="en-US"/>
               <a:t>Fifth level</a:t>
             </a:r>
-            <a:endParaRPr lang="en-US"/>
           </a:p>
         </p:txBody>
       </p:sp>
@@ -3994,38 +3930,37 @@
           <a:p>
             <a:pPr lvl="0"/>
             <a:r>
-              <a:rPr lang="en-US" smtClean="0"/>
+              <a:rPr lang="en-US"/>
               <a:t>Click to edit Master text styles</a:t>
             </a:r>
           </a:p>
           <a:p>
             <a:pPr lvl="1"/>
             <a:r>
-              <a:rPr lang="en-US" smtClean="0"/>
+              <a:rPr lang="en-US"/>
               <a:t>Second level</a:t>
             </a:r>
           </a:p>
           <a:p>
             <a:pPr lvl="2"/>
             <a:r>
-              <a:rPr lang="en-US" smtClean="0"/>
+              <a:rPr lang="en-US"/>
               <a:t>Third level</a:t>
             </a:r>
           </a:p>
           <a:p>
             <a:pPr lvl="3"/>
             <a:r>
-              <a:rPr lang="en-US" smtClean="0"/>
+              <a:rPr lang="en-US"/>
               <a:t>Fourth level</a:t>
             </a:r>
           </a:p>
           <a:p>
             <a:pPr lvl="4"/>
             <a:r>
-              <a:rPr lang="en-US" smtClean="0"/>
+              <a:rPr lang="en-US"/>
               <a:t>Fifth level</a:t>
             </a:r>
-            <a:endParaRPr lang="en-US"/>
           </a:p>
         </p:txBody>
       </p:sp>
@@ -4046,7 +3981,7 @@
           <a:p>
             <a:fld id="{5BCAD085-E8A6-8845-BD4E-CB4CCA059FC4}" type="datetimeFigureOut">
               <a:rPr lang="en-US" smtClean="0"/>
-              <a:t>1/27/13</a:t>
+              <a:t>6/8/2026</a:t>
             </a:fld>
             <a:endParaRPr lang="en-US"/>
           </a:p>
@@ -4144,10 +4079,9 @@
           </a:lstStyle>
           <a:p>
             <a:r>
-              <a:rPr lang="en-US" smtClean="0"/>
+              <a:rPr lang="en-US"/>
               <a:t>Click to edit Master title style</a:t>
             </a:r>
-            <a:endParaRPr lang="en-US"/>
           </a:p>
         </p:txBody>
       </p:sp>
@@ -4210,7 +4144,7 @@
           <a:p>
             <a:pPr lvl="0"/>
             <a:r>
-              <a:rPr lang="en-US" smtClean="0"/>
+              <a:rPr lang="en-US"/>
               <a:t>Click to edit Master text styles</a:t>
             </a:r>
           </a:p>
@@ -4266,38 +4200,37 @@
           <a:p>
             <a:pPr lvl="0"/>
             <a:r>
-              <a:rPr lang="en-US" smtClean="0"/>
+              <a:rPr lang="en-US"/>
               <a:t>Click to edit Master text styles</a:t>
             </a:r>
           </a:p>
           <a:p>
             <a:pPr lvl="1"/>
             <a:r>
-              <a:rPr lang="en-US" smtClean="0"/>
+              <a:rPr lang="en-US"/>
               <a:t>Second level</a:t>
             </a:r>
           </a:p>
           <a:p>
             <a:pPr lvl="2"/>
             <a:r>
-              <a:rPr lang="en-US" smtClean="0"/>
+              <a:rPr lang="en-US"/>
               <a:t>Third level</a:t>
             </a:r>
           </a:p>
           <a:p>
             <a:pPr lvl="3"/>
             <a:r>
-              <a:rPr lang="en-US" smtClean="0"/>
+              <a:rPr lang="en-US"/>
               <a:t>Fourth level</a:t>
             </a:r>
           </a:p>
           <a:p>
             <a:pPr lvl="4"/>
             <a:r>
-              <a:rPr lang="en-US" smtClean="0"/>
+              <a:rPr lang="en-US"/>
               <a:t>Fifth level</a:t>
             </a:r>
-            <a:endParaRPr lang="en-US"/>
           </a:p>
         </p:txBody>
       </p:sp>
@@ -4360,7 +4293,7 @@
           <a:p>
             <a:pPr lvl="0"/>
             <a:r>
-              <a:rPr lang="en-US" smtClean="0"/>
+              <a:rPr lang="en-US"/>
               <a:t>Click to edit Master text styles</a:t>
             </a:r>
           </a:p>
@@ -4416,38 +4349,37 @@
           <a:p>
             <a:pPr lvl="0"/>
             <a:r>
-              <a:rPr lang="en-US" smtClean="0"/>
+              <a:rPr lang="en-US"/>
               <a:t>Click to edit Master text styles</a:t>
             </a:r>
           </a:p>
           <a:p>
             <a:pPr lvl="1"/>
             <a:r>
-              <a:rPr lang="en-US" smtClean="0"/>
+              <a:rPr lang="en-US"/>
               <a:t>Second level</a:t>
             </a:r>
           </a:p>
           <a:p>
             <a:pPr lvl="2"/>
             <a:r>
-              <a:rPr lang="en-US" smtClean="0"/>
+              <a:rPr lang="en-US"/>
               <a:t>Third level</a:t>
             </a:r>
           </a:p>
           <a:p>
             <a:pPr lvl="3"/>
             <a:r>
-              <a:rPr lang="en-US" smtClean="0"/>
+              <a:rPr lang="en-US"/>
               <a:t>Fourth level</a:t>
             </a:r>
           </a:p>
           <a:p>
             <a:pPr lvl="4"/>
             <a:r>
-              <a:rPr lang="en-US" smtClean="0"/>
+              <a:rPr lang="en-US"/>
               <a:t>Fifth level</a:t>
             </a:r>
-            <a:endParaRPr lang="en-US"/>
           </a:p>
         </p:txBody>
       </p:sp>
@@ -4468,7 +4400,7 @@
           <a:p>
             <a:fld id="{5BCAD085-E8A6-8845-BD4E-CB4CCA059FC4}" type="datetimeFigureOut">
               <a:rPr lang="en-US" smtClean="0"/>
-              <a:t>1/27/13</a:t>
+              <a:t>6/8/2026</a:t>
             </a:fld>
             <a:endParaRPr lang="en-US"/>
           </a:p>
@@ -4562,10 +4494,9 @@
           <a:lstStyle/>
           <a:p>
             <a:r>
-              <a:rPr lang="en-US" smtClean="0"/>
+              <a:rPr lang="en-US"/>
               <a:t>Click to edit Master title style</a:t>
             </a:r>
-            <a:endParaRPr lang="en-US"/>
           </a:p>
         </p:txBody>
       </p:sp>
@@ -4586,7 +4517,7 @@
           <a:p>
             <a:fld id="{5BCAD085-E8A6-8845-BD4E-CB4CCA059FC4}" type="datetimeFigureOut">
               <a:rPr lang="en-US" smtClean="0"/>
-              <a:t>1/27/13</a:t>
+              <a:t>6/8/2026</a:t>
             </a:fld>
             <a:endParaRPr lang="en-US"/>
           </a:p>
@@ -4681,7 +4612,7 @@
           <a:p>
             <a:fld id="{5BCAD085-E8A6-8845-BD4E-CB4CCA059FC4}" type="datetimeFigureOut">
               <a:rPr lang="en-US" smtClean="0"/>
-              <a:t>1/27/13</a:t>
+              <a:t>6/8/2026</a:t>
             </a:fld>
             <a:endParaRPr lang="en-US"/>
           </a:p>
@@ -4784,10 +4715,9 @@
           </a:lstStyle>
           <a:p>
             <a:r>
-              <a:rPr lang="en-US" smtClean="0"/>
+              <a:rPr lang="en-US"/>
               <a:t>Click to edit Master title style</a:t>
             </a:r>
-            <a:endParaRPr lang="en-US"/>
           </a:p>
         </p:txBody>
       </p:sp>
@@ -4841,38 +4771,37 @@
           <a:p>
             <a:pPr lvl="0"/>
             <a:r>
-              <a:rPr lang="en-US" smtClean="0"/>
+              <a:rPr lang="en-US"/>
               <a:t>Click to edit Master text styles</a:t>
             </a:r>
           </a:p>
           <a:p>
             <a:pPr lvl="1"/>
             <a:r>
-              <a:rPr lang="en-US" smtClean="0"/>
+              <a:rPr lang="en-US"/>
               <a:t>Second level</a:t>
             </a:r>
           </a:p>
           <a:p>
             <a:pPr lvl="2"/>
             <a:r>
-              <a:rPr lang="en-US" smtClean="0"/>
+              <a:rPr lang="en-US"/>
               <a:t>Third level</a:t>
             </a:r>
           </a:p>
           <a:p>
             <a:pPr lvl="3"/>
             <a:r>
-              <a:rPr lang="en-US" smtClean="0"/>
+              <a:rPr lang="en-US"/>
               <a:t>Fourth level</a:t>
             </a:r>
           </a:p>
           <a:p>
             <a:pPr lvl="4"/>
             <a:r>
-              <a:rPr lang="en-US" smtClean="0"/>
+              <a:rPr lang="en-US"/>
               <a:t>Fifth level</a:t>
             </a:r>
-            <a:endParaRPr lang="en-US"/>
           </a:p>
         </p:txBody>
       </p:sp>
@@ -4935,7 +4864,7 @@
           <a:p>
             <a:pPr lvl="0"/>
             <a:r>
-              <a:rPr lang="en-US" smtClean="0"/>
+              <a:rPr lang="en-US"/>
               <a:t>Click to edit Master text styles</a:t>
             </a:r>
           </a:p>
@@ -4958,7 +4887,7 @@
           <a:p>
             <a:fld id="{5BCAD085-E8A6-8845-BD4E-CB4CCA059FC4}" type="datetimeFigureOut">
               <a:rPr lang="en-US" smtClean="0"/>
-              <a:t>1/27/13</a:t>
+              <a:t>6/8/2026</a:t>
             </a:fld>
             <a:endParaRPr lang="en-US"/>
           </a:p>
@@ -5061,10 +4990,9 @@
           </a:lstStyle>
           <a:p>
             <a:r>
-              <a:rPr lang="en-US" smtClean="0"/>
+              <a:rPr lang="en-US"/>
               <a:t>Click to edit Master title style</a:t>
             </a:r>
-            <a:endParaRPr lang="en-US"/>
           </a:p>
         </p:txBody>
       </p:sp>
@@ -5188,7 +5116,7 @@
           <a:p>
             <a:pPr lvl="0"/>
             <a:r>
-              <a:rPr lang="en-US" smtClean="0"/>
+              <a:rPr lang="en-US"/>
               <a:t>Click to edit Master text styles</a:t>
             </a:r>
           </a:p>
@@ -5211,7 +5139,7 @@
           <a:p>
             <a:fld id="{5BCAD085-E8A6-8845-BD4E-CB4CCA059FC4}" type="datetimeFigureOut">
               <a:rPr lang="en-US" smtClean="0"/>
-              <a:t>1/27/13</a:t>
+              <a:t>6/8/2026</a:t>
             </a:fld>
             <a:endParaRPr lang="en-US"/>
           </a:p>
@@ -5320,10 +5248,9 @@
           <a:lstStyle/>
           <a:p>
             <a:r>
-              <a:rPr lang="en-US" smtClean="0"/>
+              <a:rPr lang="en-US"/>
               <a:t>Click to edit Master title style</a:t>
             </a:r>
-            <a:endParaRPr lang="en-US"/>
           </a:p>
         </p:txBody>
       </p:sp>
@@ -5354,38 +5281,37 @@
           <a:p>
             <a:pPr lvl="0"/>
             <a:r>
-              <a:rPr lang="en-US" smtClean="0"/>
+              <a:rPr lang="en-US"/>
               <a:t>Click to edit Master text styles</a:t>
             </a:r>
           </a:p>
           <a:p>
             <a:pPr lvl="1"/>
             <a:r>
-              <a:rPr lang="en-US" smtClean="0"/>
+              <a:rPr lang="en-US"/>
               <a:t>Second level</a:t>
             </a:r>
           </a:p>
           <a:p>
             <a:pPr lvl="2"/>
             <a:r>
-              <a:rPr lang="en-US" smtClean="0"/>
+              <a:rPr lang="en-US"/>
               <a:t>Third level</a:t>
             </a:r>
           </a:p>
           <a:p>
             <a:pPr lvl="3"/>
             <a:r>
-              <a:rPr lang="en-US" smtClean="0"/>
+              <a:rPr lang="en-US"/>
               <a:t>Fourth level</a:t>
             </a:r>
           </a:p>
           <a:p>
             <a:pPr lvl="4"/>
             <a:r>
-              <a:rPr lang="en-US" smtClean="0"/>
+              <a:rPr lang="en-US"/>
               <a:t>Fifth level</a:t>
             </a:r>
-            <a:endParaRPr lang="en-US"/>
           </a:p>
         </p:txBody>
       </p:sp>
@@ -5424,7 +5350,7 @@
           <a:p>
             <a:fld id="{5BCAD085-E8A6-8845-BD4E-CB4CCA059FC4}" type="datetimeFigureOut">
               <a:rPr lang="en-US" smtClean="0"/>
-              <a:t>1/27/13</a:t>
+              <a:t>6/8/2026</a:t>
             </a:fld>
             <a:endParaRPr lang="en-US"/>
           </a:p>
@@ -5783,7 +5709,7 @@
 </file>
 
 <file path=ppt/slides/slide1.xml><?xml version="1.0" encoding="utf-8"?>
-<p:sld xmlns:a="http://schemas.openxmlformats.org/drawingml/2006/main" xmlns:p="http://schemas.openxmlformats.org/presentationml/2006/main" xmlns:r="http://schemas.openxmlformats.org/officeDocument/2006/relationships">
+<p:sld xmlns:a="http://schemas.openxmlformats.org/drawingml/2006/main" xmlns:r="http://schemas.openxmlformats.org/officeDocument/2006/relationships" xmlns:p="http://schemas.openxmlformats.org/presentationml/2006/main">
   <p:cSld>
     <p:spTree>
       <p:nvGrpSpPr>
@@ -5791,7 +5717,14 @@
         <p:cNvGrpSpPr/>
         <p:nvPr/>
       </p:nvGrpSpPr>
-      <p:grpSpPr/>
+      <p:grpSpPr>
+        <a:xfrm>
+          <a:off x="0" y="0"/>
+          <a:ext cx="0" cy="0"/>
+          <a:chOff x="0" y="0"/>
+          <a:chExt cx="0" cy="0"/>
+        </a:xfrm>
+      </p:grpSpPr>
       <p:sp>
         <p:nvSpPr>
           <p:cNvPr id="2" name="Rectangle 1"/>
@@ -5833,6 +5766,7 @@
           <a:lstStyle/>
           <a:p>
             <a:pPr algn="ctr"/>
+            <a:endParaRPr/>
           </a:p>
         </p:txBody>
       </p:sp>
@@ -5877,6 +5811,7 @@
           <a:lstStyle/>
           <a:p>
             <a:pPr algn="ctr"/>
+            <a:endParaRPr/>
           </a:p>
         </p:txBody>
       </p:sp>
@@ -5889,7 +5824,7 @@
         <p:spPr>
           <a:xfrm>
             <a:off x="731520" y="2468880"/>
-            <a:ext cx="10725912" cy="2011680"/>
+            <a:ext cx="10725912" cy="1323439"/>
           </a:xfrm>
           <a:prstGeom prst="rect">
             <a:avLst/>
@@ -5904,13 +5839,49 @@
           <a:p>
             <a:pPr algn="ctr"/>
             <a:r>
-              <a:rPr sz="4000" b="1">
+              <a:rPr lang="en-US" altLang="zh-TW" sz="4000" b="1" dirty="0">
                 <a:solidFill>
                   <a:srgbClr val="FFFFFF"/>
                 </a:solidFill>
               </a:rPr>
-              <a:t>From a 1.57 m KNN baseline to a 0.75 m cascade</a:t>
-            </a:r>
+              <a:t>CV2X </a:t>
+            </a:r>
+            <a:br>
+              <a:rPr lang="en-US" altLang="zh-TW" sz="4000" b="1" dirty="0">
+                <a:solidFill>
+                  <a:srgbClr val="FFFFFF"/>
+                </a:solidFill>
+              </a:rPr>
+            </a:br>
+            <a:r>
+              <a:rPr lang="en-US" altLang="zh-TW" sz="4000" b="1" dirty="0">
+                <a:solidFill>
+                  <a:srgbClr val="FFFFFF"/>
+                </a:solidFill>
+              </a:rPr>
+              <a:t>Indoor Localization with </a:t>
+            </a:r>
+            <a:r>
+              <a:rPr lang="en-US" altLang="zh-TW" sz="4000" b="1" dirty="0" err="1">
+                <a:solidFill>
+                  <a:srgbClr val="FFFFFF"/>
+                </a:solidFill>
+              </a:rPr>
+              <a:t>WiFi</a:t>
+            </a:r>
+            <a:r>
+              <a:rPr lang="en-US" altLang="zh-TW" sz="4000" b="1" dirty="0">
+                <a:solidFill>
+                  <a:srgbClr val="FFFFFF"/>
+                </a:solidFill>
+              </a:rPr>
+              <a:t> Fingerprints</a:t>
+            </a:r>
+            <a:endParaRPr sz="4000" b="1" dirty="0">
+              <a:solidFill>
+                <a:srgbClr val="FFFFFF"/>
+              </a:solidFill>
+            </a:endParaRPr>
           </a:p>
         </p:txBody>
       </p:sp>
@@ -5923,7 +5894,7 @@
         <p:spPr>
           <a:xfrm>
             <a:off x="914400" y="4572000"/>
-            <a:ext cx="10360152" cy="1097280"/>
+            <a:ext cx="10360152" cy="707886"/>
           </a:xfrm>
           <a:prstGeom prst="rect">
             <a:avLst/>
@@ -5938,13 +5909,50 @@
           <a:p>
             <a:pPr algn="ctr"/>
             <a:r>
-              <a:rPr sz="2000">
+              <a:rPr lang="en-US" altLang="zh-TW" sz="2000" dirty="0">
                 <a:solidFill>
                   <a:srgbClr val="6FB7F0"/>
                 </a:solidFill>
               </a:rPr>
-              <a:t>Standard protocol 0.75 m · strict nested-CV 0.94 m</a:t>
-            </a:r>
+              <a:t>314831017</a:t>
+            </a:r>
+            <a:r>
+              <a:rPr lang="zh-TW" altLang="en-US" sz="2000" dirty="0">
+                <a:solidFill>
+                  <a:srgbClr val="6FB7F0"/>
+                </a:solidFill>
+              </a:rPr>
+              <a:t> 王瑋琛</a:t>
+            </a:r>
+            <a:endParaRPr lang="en-US" altLang="zh-TW" sz="2000" dirty="0">
+              <a:solidFill>
+                <a:srgbClr val="6FB7F0"/>
+              </a:solidFill>
+            </a:endParaRPr>
+          </a:p>
+          <a:p>
+            <a:pPr algn="ctr"/>
+            <a:r>
+              <a:rPr lang="en-US" altLang="zh-TW" sz="2000" dirty="0">
+                <a:solidFill>
+                  <a:srgbClr val="6FB7F0"/>
+                </a:solidFill>
+              </a:rPr>
+              <a:t>314831024</a:t>
+            </a:r>
+            <a:r>
+              <a:rPr lang="zh-TW" altLang="en-US" sz="2000" dirty="0">
+                <a:solidFill>
+                  <a:srgbClr val="6FB7F0"/>
+                </a:solidFill>
+              </a:rPr>
+              <a:t> 李朋逸</a:t>
+            </a:r>
+            <a:endParaRPr sz="2000" dirty="0">
+              <a:solidFill>
+                <a:srgbClr val="6FB7F0"/>
+              </a:solidFill>
+            </a:endParaRPr>
           </a:p>
         </p:txBody>
       </p:sp>
@@ -5991,7 +5999,7 @@
 </file>
 
 <file path=ppt/slides/slide10.xml><?xml version="1.0" encoding="utf-8"?>
-<p:sld xmlns:a="http://schemas.openxmlformats.org/drawingml/2006/main" xmlns:p="http://schemas.openxmlformats.org/presentationml/2006/main" xmlns:r="http://schemas.openxmlformats.org/officeDocument/2006/relationships">
+<p:sld xmlns:a="http://schemas.openxmlformats.org/drawingml/2006/main" xmlns:r="http://schemas.openxmlformats.org/officeDocument/2006/relationships" xmlns:p="http://schemas.openxmlformats.org/presentationml/2006/main">
   <p:cSld>
     <p:spTree>
       <p:nvGrpSpPr>
@@ -5999,7 +6007,14 @@
         <p:cNvGrpSpPr/>
         <p:nvPr/>
       </p:nvGrpSpPr>
-      <p:grpSpPr/>
+      <p:grpSpPr>
+        <a:xfrm>
+          <a:off x="0" y="0"/>
+          <a:ext cx="0" cy="0"/>
+          <a:chOff x="0" y="0"/>
+          <a:chExt cx="0" cy="0"/>
+        </a:xfrm>
+      </p:grpSpPr>
       <p:sp>
         <p:nvSpPr>
           <p:cNvPr id="2" name="TextBox 1"/>
@@ -6157,7 +6172,7 @@
           <p:nvPr/>
         </p:nvPicPr>
         <p:blipFill>
-          <a:blip r:embed="rId2"/>
+          <a:blip r:embed="rId3"/>
           <a:stretch>
             <a:fillRect/>
           </a:stretch>
@@ -6213,6 +6228,7 @@
           <a:lstStyle/>
           <a:p>
             <a:pPr algn="ctr"/>
+            <a:endParaRPr/>
           </a:p>
         </p:txBody>
       </p:sp>
@@ -6327,7 +6343,7 @@
 </file>
 
 <file path=ppt/slides/slide11.xml><?xml version="1.0" encoding="utf-8"?>
-<p:sld xmlns:a="http://schemas.openxmlformats.org/drawingml/2006/main" xmlns:p="http://schemas.openxmlformats.org/presentationml/2006/main" xmlns:r="http://schemas.openxmlformats.org/officeDocument/2006/relationships">
+<p:sld xmlns:a="http://schemas.openxmlformats.org/drawingml/2006/main" xmlns:r="http://schemas.openxmlformats.org/officeDocument/2006/relationships" xmlns:p="http://schemas.openxmlformats.org/presentationml/2006/main">
   <p:cSld>
     <p:spTree>
       <p:nvGrpSpPr>
@@ -6335,7 +6351,14 @@
         <p:cNvGrpSpPr/>
         <p:nvPr/>
       </p:nvGrpSpPr>
-      <p:grpSpPr/>
+      <p:grpSpPr>
+        <a:xfrm>
+          <a:off x="0" y="0"/>
+          <a:ext cx="0" cy="0"/>
+          <a:chOff x="0" y="0"/>
+          <a:chExt cx="0" cy="0"/>
+        </a:xfrm>
+      </p:grpSpPr>
       <p:sp>
         <p:nvSpPr>
           <p:cNvPr id="2" name="Rectangle 1"/>
@@ -6377,6 +6400,7 @@
           <a:lstStyle/>
           <a:p>
             <a:pPr algn="ctr"/>
+            <a:endParaRPr/>
           </a:p>
         </p:txBody>
       </p:sp>
@@ -6489,6 +6513,7 @@
           <a:lstStyle/>
           <a:p>
             <a:pPr algn="ctr"/>
+            <a:endParaRPr/>
           </a:p>
         </p:txBody>
       </p:sp>
@@ -6535,7 +6560,7 @@
 </file>
 
 <file path=ppt/slides/slide12.xml><?xml version="1.0" encoding="utf-8"?>
-<p:sld xmlns:a="http://schemas.openxmlformats.org/drawingml/2006/main" xmlns:p="http://schemas.openxmlformats.org/presentationml/2006/main" xmlns:r="http://schemas.openxmlformats.org/officeDocument/2006/relationships">
+<p:sld xmlns:a="http://schemas.openxmlformats.org/drawingml/2006/main" xmlns:r="http://schemas.openxmlformats.org/officeDocument/2006/relationships" xmlns:p="http://schemas.openxmlformats.org/presentationml/2006/main">
   <p:cSld>
     <p:spTree>
       <p:nvGrpSpPr>
@@ -6543,7 +6568,14 @@
         <p:cNvGrpSpPr/>
         <p:nvPr/>
       </p:nvGrpSpPr>
-      <p:grpSpPr/>
+      <p:grpSpPr>
+        <a:xfrm>
+          <a:off x="0" y="0"/>
+          <a:ext cx="0" cy="0"/>
+          <a:chOff x="0" y="0"/>
+          <a:chExt cx="0" cy="0"/>
+        </a:xfrm>
+      </p:grpSpPr>
       <p:sp>
         <p:nvSpPr>
           <p:cNvPr id="2" name="TextBox 1"/>
@@ -6701,7 +6733,7 @@
           <p:nvPr/>
         </p:nvPicPr>
         <p:blipFill>
-          <a:blip r:embed="rId2"/>
+          <a:blip r:embed="rId3"/>
           <a:stretch>
             <a:fillRect/>
           </a:stretch>
@@ -6757,6 +6789,7 @@
           <a:lstStyle/>
           <a:p>
             <a:pPr algn="ctr"/>
+            <a:endParaRPr/>
           </a:p>
         </p:txBody>
       </p:sp>
@@ -6871,7 +6904,7 @@
 </file>
 
 <file path=ppt/slides/slide13.xml><?xml version="1.0" encoding="utf-8"?>
-<p:sld xmlns:a="http://schemas.openxmlformats.org/drawingml/2006/main" xmlns:p="http://schemas.openxmlformats.org/presentationml/2006/main" xmlns:r="http://schemas.openxmlformats.org/officeDocument/2006/relationships">
+<p:sld xmlns:a="http://schemas.openxmlformats.org/drawingml/2006/main" xmlns:r="http://schemas.openxmlformats.org/officeDocument/2006/relationships" xmlns:p="http://schemas.openxmlformats.org/presentationml/2006/main">
   <p:cSld>
     <p:spTree>
       <p:nvGrpSpPr>
@@ -6879,7 +6912,14 @@
         <p:cNvGrpSpPr/>
         <p:nvPr/>
       </p:nvGrpSpPr>
-      <p:grpSpPr/>
+      <p:grpSpPr>
+        <a:xfrm>
+          <a:off x="0" y="0"/>
+          <a:ext cx="0" cy="0"/>
+          <a:chOff x="0" y="0"/>
+          <a:chExt cx="0" cy="0"/>
+        </a:xfrm>
+      </p:grpSpPr>
       <p:sp>
         <p:nvSpPr>
           <p:cNvPr id="2" name="TextBox 1"/>
@@ -7037,7 +7077,7 @@
           <p:nvPr/>
         </p:nvPicPr>
         <p:blipFill>
-          <a:blip r:embed="rId2"/>
+          <a:blip r:embed="rId3"/>
           <a:stretch>
             <a:fillRect/>
           </a:stretch>
@@ -7093,6 +7133,7 @@
           <a:lstStyle/>
           <a:p>
             <a:pPr algn="ctr"/>
+            <a:endParaRPr/>
           </a:p>
         </p:txBody>
       </p:sp>
@@ -7207,7 +7248,7 @@
 </file>
 
 <file path=ppt/slides/slide14.xml><?xml version="1.0" encoding="utf-8"?>
-<p:sld xmlns:a="http://schemas.openxmlformats.org/drawingml/2006/main" xmlns:p="http://schemas.openxmlformats.org/presentationml/2006/main" xmlns:r="http://schemas.openxmlformats.org/officeDocument/2006/relationships">
+<p:sld xmlns:a="http://schemas.openxmlformats.org/drawingml/2006/main" xmlns:r="http://schemas.openxmlformats.org/officeDocument/2006/relationships" xmlns:p="http://schemas.openxmlformats.org/presentationml/2006/main">
   <p:cSld>
     <p:spTree>
       <p:nvGrpSpPr>
@@ -7215,7 +7256,14 @@
         <p:cNvGrpSpPr/>
         <p:nvPr/>
       </p:nvGrpSpPr>
-      <p:grpSpPr/>
+      <p:grpSpPr>
+        <a:xfrm>
+          <a:off x="0" y="0"/>
+          <a:ext cx="0" cy="0"/>
+          <a:chOff x="0" y="0"/>
+          <a:chExt cx="0" cy="0"/>
+        </a:xfrm>
+      </p:grpSpPr>
       <p:sp>
         <p:nvSpPr>
           <p:cNvPr id="2" name="TextBox 1"/>
@@ -7323,6 +7371,7 @@
           <a:lstStyle/>
           <a:p>
             <a:pPr algn="ctr"/>
+            <a:endParaRPr/>
           </a:p>
         </p:txBody>
       </p:sp>
@@ -7367,6 +7416,7 @@
           <a:lstStyle/>
           <a:p>
             <a:pPr algn="ctr"/>
+            <a:endParaRPr/>
           </a:p>
         </p:txBody>
       </p:sp>
@@ -7526,6 +7576,7 @@
           <a:lstStyle/>
           <a:p>
             <a:pPr algn="ctr"/>
+            <a:endParaRPr/>
           </a:p>
         </p:txBody>
       </p:sp>
@@ -7640,7 +7691,7 @@
 </file>
 
 <file path=ppt/slides/slide15.xml><?xml version="1.0" encoding="utf-8"?>
-<p:sld xmlns:a="http://schemas.openxmlformats.org/drawingml/2006/main" xmlns:p="http://schemas.openxmlformats.org/presentationml/2006/main" xmlns:r="http://schemas.openxmlformats.org/officeDocument/2006/relationships">
+<p:sld xmlns:a="http://schemas.openxmlformats.org/drawingml/2006/main" xmlns:r="http://schemas.openxmlformats.org/officeDocument/2006/relationships" xmlns:p="http://schemas.openxmlformats.org/presentationml/2006/main">
   <p:cSld>
     <p:spTree>
       <p:nvGrpSpPr>
@@ -7648,7 +7699,14 @@
         <p:cNvGrpSpPr/>
         <p:nvPr/>
       </p:nvGrpSpPr>
-      <p:grpSpPr/>
+      <p:grpSpPr>
+        <a:xfrm>
+          <a:off x="0" y="0"/>
+          <a:ext cx="0" cy="0"/>
+          <a:chOff x="0" y="0"/>
+          <a:chExt cx="0" cy="0"/>
+        </a:xfrm>
+      </p:grpSpPr>
       <p:sp>
         <p:nvSpPr>
           <p:cNvPr id="2" name="TextBox 1"/>
@@ -7806,7 +7864,7 @@
           <p:nvPr/>
         </p:nvPicPr>
         <p:blipFill>
-          <a:blip r:embed="rId2"/>
+          <a:blip r:embed="rId3"/>
           <a:stretch>
             <a:fillRect/>
           </a:stretch>
@@ -7862,6 +7920,7 @@
           <a:lstStyle/>
           <a:p>
             <a:pPr algn="ctr"/>
+            <a:endParaRPr/>
           </a:p>
         </p:txBody>
       </p:sp>
@@ -7976,7 +8035,7 @@
 </file>
 
 <file path=ppt/slides/slide16.xml><?xml version="1.0" encoding="utf-8"?>
-<p:sld xmlns:a="http://schemas.openxmlformats.org/drawingml/2006/main" xmlns:p="http://schemas.openxmlformats.org/presentationml/2006/main" xmlns:r="http://schemas.openxmlformats.org/officeDocument/2006/relationships">
+<p:sld xmlns:a="http://schemas.openxmlformats.org/drawingml/2006/main" xmlns:r="http://schemas.openxmlformats.org/officeDocument/2006/relationships" xmlns:p="http://schemas.openxmlformats.org/presentationml/2006/main">
   <p:cSld>
     <p:spTree>
       <p:nvGrpSpPr>
@@ -7984,7 +8043,14 @@
         <p:cNvGrpSpPr/>
         <p:nvPr/>
       </p:nvGrpSpPr>
-      <p:grpSpPr/>
+      <p:grpSpPr>
+        <a:xfrm>
+          <a:off x="0" y="0"/>
+          <a:ext cx="0" cy="0"/>
+          <a:chOff x="0" y="0"/>
+          <a:chExt cx="0" cy="0"/>
+        </a:xfrm>
+      </p:grpSpPr>
       <p:sp>
         <p:nvSpPr>
           <p:cNvPr id="2" name="TextBox 1"/>
@@ -8142,7 +8208,7 @@
           <p:nvPr/>
         </p:nvPicPr>
         <p:blipFill>
-          <a:blip r:embed="rId2"/>
+          <a:blip r:embed="rId3"/>
           <a:stretch>
             <a:fillRect/>
           </a:stretch>
@@ -8198,6 +8264,7 @@
           <a:lstStyle/>
           <a:p>
             <a:pPr algn="ctr"/>
+            <a:endParaRPr/>
           </a:p>
         </p:txBody>
       </p:sp>
@@ -8312,7 +8379,7 @@
 </file>
 
 <file path=ppt/slides/slide17.xml><?xml version="1.0" encoding="utf-8"?>
-<p:sld xmlns:a="http://schemas.openxmlformats.org/drawingml/2006/main" xmlns:p="http://schemas.openxmlformats.org/presentationml/2006/main" xmlns:r="http://schemas.openxmlformats.org/officeDocument/2006/relationships">
+<p:sld xmlns:a="http://schemas.openxmlformats.org/drawingml/2006/main" xmlns:r="http://schemas.openxmlformats.org/officeDocument/2006/relationships" xmlns:p="http://schemas.openxmlformats.org/presentationml/2006/main">
   <p:cSld>
     <p:spTree>
       <p:nvGrpSpPr>
@@ -8320,7 +8387,14 @@
         <p:cNvGrpSpPr/>
         <p:nvPr/>
       </p:nvGrpSpPr>
-      <p:grpSpPr/>
+      <p:grpSpPr>
+        <a:xfrm>
+          <a:off x="0" y="0"/>
+          <a:ext cx="0" cy="0"/>
+          <a:chOff x="0" y="0"/>
+          <a:chExt cx="0" cy="0"/>
+        </a:xfrm>
+      </p:grpSpPr>
       <p:sp>
         <p:nvSpPr>
           <p:cNvPr id="2" name="TextBox 1"/>
@@ -8478,7 +8552,7 @@
           <p:nvPr/>
         </p:nvPicPr>
         <p:blipFill>
-          <a:blip r:embed="rId2"/>
+          <a:blip r:embed="rId3"/>
           <a:stretch>
             <a:fillRect/>
           </a:stretch>
@@ -8534,6 +8608,7 @@
           <a:lstStyle/>
           <a:p>
             <a:pPr algn="ctr"/>
+            <a:endParaRPr/>
           </a:p>
         </p:txBody>
       </p:sp>
@@ -8648,7 +8723,7 @@
 </file>
 
 <file path=ppt/slides/slide18.xml><?xml version="1.0" encoding="utf-8"?>
-<p:sld xmlns:a="http://schemas.openxmlformats.org/drawingml/2006/main" xmlns:p="http://schemas.openxmlformats.org/presentationml/2006/main" xmlns:r="http://schemas.openxmlformats.org/officeDocument/2006/relationships">
+<p:sld xmlns:a="http://schemas.openxmlformats.org/drawingml/2006/main" xmlns:r="http://schemas.openxmlformats.org/officeDocument/2006/relationships" xmlns:p="http://schemas.openxmlformats.org/presentationml/2006/main">
   <p:cSld>
     <p:spTree>
       <p:nvGrpSpPr>
@@ -8656,7 +8731,14 @@
         <p:cNvGrpSpPr/>
         <p:nvPr/>
       </p:nvGrpSpPr>
-      <p:grpSpPr/>
+      <p:grpSpPr>
+        <a:xfrm>
+          <a:off x="0" y="0"/>
+          <a:ext cx="0" cy="0"/>
+          <a:chOff x="0" y="0"/>
+          <a:chExt cx="0" cy="0"/>
+        </a:xfrm>
+      </p:grpSpPr>
       <p:sp>
         <p:nvSpPr>
           <p:cNvPr id="2" name="TextBox 1"/>
@@ -8814,7 +8896,7 @@
           <p:nvPr/>
         </p:nvPicPr>
         <p:blipFill>
-          <a:blip r:embed="rId2"/>
+          <a:blip r:embed="rId3"/>
           <a:stretch>
             <a:fillRect/>
           </a:stretch>
@@ -8870,6 +8952,7 @@
           <a:lstStyle/>
           <a:p>
             <a:pPr algn="ctr"/>
+            <a:endParaRPr/>
           </a:p>
         </p:txBody>
       </p:sp>
@@ -8984,7 +9067,7 @@
 </file>
 
 <file path=ppt/slides/slide19.xml><?xml version="1.0" encoding="utf-8"?>
-<p:sld xmlns:a="http://schemas.openxmlformats.org/drawingml/2006/main" xmlns:p="http://schemas.openxmlformats.org/presentationml/2006/main" xmlns:r="http://schemas.openxmlformats.org/officeDocument/2006/relationships">
+<p:sld xmlns:a="http://schemas.openxmlformats.org/drawingml/2006/main" xmlns:r="http://schemas.openxmlformats.org/officeDocument/2006/relationships" xmlns:p="http://schemas.openxmlformats.org/presentationml/2006/main">
   <p:cSld>
     <p:spTree>
       <p:nvGrpSpPr>
@@ -8992,7 +9075,14 @@
         <p:cNvGrpSpPr/>
         <p:nvPr/>
       </p:nvGrpSpPr>
-      <p:grpSpPr/>
+      <p:grpSpPr>
+        <a:xfrm>
+          <a:off x="0" y="0"/>
+          <a:ext cx="0" cy="0"/>
+          <a:chOff x="0" y="0"/>
+          <a:chExt cx="0" cy="0"/>
+        </a:xfrm>
+      </p:grpSpPr>
       <p:sp>
         <p:nvSpPr>
           <p:cNvPr id="2" name="TextBox 1"/>
@@ -9150,7 +9240,7 @@
           <p:nvPr/>
         </p:nvPicPr>
         <p:blipFill>
-          <a:blip r:embed="rId2"/>
+          <a:blip r:embed="rId3"/>
           <a:stretch>
             <a:fillRect/>
           </a:stretch>
@@ -9206,6 +9296,7 @@
           <a:lstStyle/>
           <a:p>
             <a:pPr algn="ctr"/>
+            <a:endParaRPr/>
           </a:p>
         </p:txBody>
       </p:sp>
@@ -9320,7 +9411,7 @@
 </file>
 
 <file path=ppt/slides/slide2.xml><?xml version="1.0" encoding="utf-8"?>
-<p:sld xmlns:a="http://schemas.openxmlformats.org/drawingml/2006/main" xmlns:p="http://schemas.openxmlformats.org/presentationml/2006/main" xmlns:r="http://schemas.openxmlformats.org/officeDocument/2006/relationships">
+<p:sld xmlns:a="http://schemas.openxmlformats.org/drawingml/2006/main" xmlns:r="http://schemas.openxmlformats.org/officeDocument/2006/relationships" xmlns:p="http://schemas.openxmlformats.org/presentationml/2006/main">
   <p:cSld>
     <p:spTree>
       <p:nvGrpSpPr>
@@ -9328,7 +9419,14 @@
         <p:cNvGrpSpPr/>
         <p:nvPr/>
       </p:nvGrpSpPr>
-      <p:grpSpPr/>
+      <p:grpSpPr>
+        <a:xfrm>
+          <a:off x="0" y="0"/>
+          <a:ext cx="0" cy="0"/>
+          <a:chOff x="0" y="0"/>
+          <a:chExt cx="0" cy="0"/>
+        </a:xfrm>
+      </p:grpSpPr>
       <p:sp>
         <p:nvSpPr>
           <p:cNvPr id="2" name="TextBox 1"/>
@@ -9338,7 +9436,7 @@
         <p:spPr>
           <a:xfrm>
             <a:off x="457200" y="320040"/>
-            <a:ext cx="11274552" cy="868680"/>
+            <a:ext cx="11274552" cy="507831"/>
           </a:xfrm>
           <a:prstGeom prst="rect">
             <a:avLst/>
@@ -9352,12 +9450,12 @@
           <a:lstStyle/>
           <a:p>
             <a:r>
-              <a:rPr sz="2700" b="1">
+              <a:rPr sz="2700" b="1" dirty="0">
                 <a:solidFill>
                   <a:srgbClr val="1F2D3D"/>
                 </a:solidFill>
               </a:rPr>
-              <a:t>Four required sections, told as one engineering story</a:t>
+              <a:t>Four required sections</a:t>
             </a:r>
           </a:p>
         </p:txBody>
@@ -9436,6 +9534,7 @@
           <a:lstStyle/>
           <a:p>
             <a:pPr algn="ctr"/>
+            <a:endParaRPr/>
           </a:p>
         </p:txBody>
       </p:sp>
@@ -9480,6 +9579,7 @@
           <a:lstStyle/>
           <a:p>
             <a:pPr algn="ctr"/>
+            <a:endParaRPr/>
           </a:p>
         </p:txBody>
       </p:sp>
@@ -9639,6 +9739,7 @@
           <a:lstStyle/>
           <a:p>
             <a:pPr algn="ctr"/>
+            <a:endParaRPr/>
           </a:p>
         </p:txBody>
       </p:sp>
@@ -9719,7 +9820,7 @@
 </file>
 
 <file path=ppt/slides/slide20.xml><?xml version="1.0" encoding="utf-8"?>
-<p:sld xmlns:a="http://schemas.openxmlformats.org/drawingml/2006/main" xmlns:p="http://schemas.openxmlformats.org/presentationml/2006/main" xmlns:r="http://schemas.openxmlformats.org/officeDocument/2006/relationships">
+<p:sld xmlns:a="http://schemas.openxmlformats.org/drawingml/2006/main" xmlns:r="http://schemas.openxmlformats.org/officeDocument/2006/relationships" xmlns:p="http://schemas.openxmlformats.org/presentationml/2006/main">
   <p:cSld>
     <p:spTree>
       <p:nvGrpSpPr>
@@ -9727,7 +9828,14 @@
         <p:cNvGrpSpPr/>
         <p:nvPr/>
       </p:nvGrpSpPr>
-      <p:grpSpPr/>
+      <p:grpSpPr>
+        <a:xfrm>
+          <a:off x="0" y="0"/>
+          <a:ext cx="0" cy="0"/>
+          <a:chOff x="0" y="0"/>
+          <a:chExt cx="0" cy="0"/>
+        </a:xfrm>
+      </p:grpSpPr>
       <p:sp>
         <p:nvSpPr>
           <p:cNvPr id="2" name="TextBox 1"/>
@@ -9885,7 +9993,7 @@
           <p:nvPr/>
         </p:nvPicPr>
         <p:blipFill>
-          <a:blip r:embed="rId2"/>
+          <a:blip r:embed="rId3"/>
           <a:stretch>
             <a:fillRect/>
           </a:stretch>
@@ -9941,6 +10049,7 @@
           <a:lstStyle/>
           <a:p>
             <a:pPr algn="ctr"/>
+            <a:endParaRPr/>
           </a:p>
         </p:txBody>
       </p:sp>
@@ -10055,7 +10164,7 @@
 </file>
 
 <file path=ppt/slides/slide21.xml><?xml version="1.0" encoding="utf-8"?>
-<p:sld xmlns:a="http://schemas.openxmlformats.org/drawingml/2006/main" xmlns:p="http://schemas.openxmlformats.org/presentationml/2006/main" xmlns:r="http://schemas.openxmlformats.org/officeDocument/2006/relationships">
+<p:sld xmlns:a="http://schemas.openxmlformats.org/drawingml/2006/main" xmlns:r="http://schemas.openxmlformats.org/officeDocument/2006/relationships" xmlns:p="http://schemas.openxmlformats.org/presentationml/2006/main">
   <p:cSld>
     <p:spTree>
       <p:nvGrpSpPr>
@@ -10063,7 +10172,14 @@
         <p:cNvGrpSpPr/>
         <p:nvPr/>
       </p:nvGrpSpPr>
-      <p:grpSpPr/>
+      <p:grpSpPr>
+        <a:xfrm>
+          <a:off x="0" y="0"/>
+          <a:ext cx="0" cy="0"/>
+          <a:chOff x="0" y="0"/>
+          <a:chExt cx="0" cy="0"/>
+        </a:xfrm>
+      </p:grpSpPr>
       <p:sp>
         <p:nvSpPr>
           <p:cNvPr id="2" name="TextBox 1"/>
@@ -10221,7 +10337,7 @@
           <p:nvPr/>
         </p:nvPicPr>
         <p:blipFill>
-          <a:blip r:embed="rId2"/>
+          <a:blip r:embed="rId3"/>
           <a:stretch>
             <a:fillRect/>
           </a:stretch>
@@ -10277,6 +10393,7 @@
           <a:lstStyle/>
           <a:p>
             <a:pPr algn="ctr"/>
+            <a:endParaRPr/>
           </a:p>
         </p:txBody>
       </p:sp>
@@ -10391,7 +10508,7 @@
 </file>
 
 <file path=ppt/slides/slide22.xml><?xml version="1.0" encoding="utf-8"?>
-<p:sld xmlns:a="http://schemas.openxmlformats.org/drawingml/2006/main" xmlns:p="http://schemas.openxmlformats.org/presentationml/2006/main" xmlns:r="http://schemas.openxmlformats.org/officeDocument/2006/relationships">
+<p:sld xmlns:a="http://schemas.openxmlformats.org/drawingml/2006/main" xmlns:r="http://schemas.openxmlformats.org/officeDocument/2006/relationships" xmlns:p="http://schemas.openxmlformats.org/presentationml/2006/main">
   <p:cSld>
     <p:spTree>
       <p:nvGrpSpPr>
@@ -10399,7 +10516,14 @@
         <p:cNvGrpSpPr/>
         <p:nvPr/>
       </p:nvGrpSpPr>
-      <p:grpSpPr/>
+      <p:grpSpPr>
+        <a:xfrm>
+          <a:off x="0" y="0"/>
+          <a:ext cx="0" cy="0"/>
+          <a:chOff x="0" y="0"/>
+          <a:chExt cx="0" cy="0"/>
+        </a:xfrm>
+      </p:grpSpPr>
       <p:sp>
         <p:nvSpPr>
           <p:cNvPr id="2" name="TextBox 1"/>
@@ -10557,7 +10681,7 @@
           <p:nvPr/>
         </p:nvPicPr>
         <p:blipFill>
-          <a:blip r:embed="rId2"/>
+          <a:blip r:embed="rId3"/>
           <a:stretch>
             <a:fillRect/>
           </a:stretch>
@@ -10613,6 +10737,7 @@
           <a:lstStyle/>
           <a:p>
             <a:pPr algn="ctr"/>
+            <a:endParaRPr/>
           </a:p>
         </p:txBody>
       </p:sp>
@@ -10727,7 +10852,7 @@
 </file>
 
 <file path=ppt/slides/slide23.xml><?xml version="1.0" encoding="utf-8"?>
-<p:sld xmlns:a="http://schemas.openxmlformats.org/drawingml/2006/main" xmlns:p="http://schemas.openxmlformats.org/presentationml/2006/main" xmlns:r="http://schemas.openxmlformats.org/officeDocument/2006/relationships">
+<p:sld xmlns:a="http://schemas.openxmlformats.org/drawingml/2006/main" xmlns:r="http://schemas.openxmlformats.org/officeDocument/2006/relationships" xmlns:p="http://schemas.openxmlformats.org/presentationml/2006/main">
   <p:cSld>
     <p:spTree>
       <p:nvGrpSpPr>
@@ -10735,7 +10860,14 @@
         <p:cNvGrpSpPr/>
         <p:nvPr/>
       </p:nvGrpSpPr>
-      <p:grpSpPr/>
+      <p:grpSpPr>
+        <a:xfrm>
+          <a:off x="0" y="0"/>
+          <a:ext cx="0" cy="0"/>
+          <a:chOff x="0" y="0"/>
+          <a:chExt cx="0" cy="0"/>
+        </a:xfrm>
+      </p:grpSpPr>
       <p:sp>
         <p:nvSpPr>
           <p:cNvPr id="2" name="Rectangle 1"/>
@@ -10777,6 +10909,7 @@
           <a:lstStyle/>
           <a:p>
             <a:pPr algn="ctr"/>
+            <a:endParaRPr/>
           </a:p>
         </p:txBody>
       </p:sp>
@@ -10889,6 +11022,7 @@
           <a:lstStyle/>
           <a:p>
             <a:pPr algn="ctr"/>
+            <a:endParaRPr/>
           </a:p>
         </p:txBody>
       </p:sp>
@@ -10935,7 +11069,7 @@
 </file>
 
 <file path=ppt/slides/slide24.xml><?xml version="1.0" encoding="utf-8"?>
-<p:sld xmlns:a="http://schemas.openxmlformats.org/drawingml/2006/main" xmlns:p="http://schemas.openxmlformats.org/presentationml/2006/main" xmlns:r="http://schemas.openxmlformats.org/officeDocument/2006/relationships">
+<p:sld xmlns:a="http://schemas.openxmlformats.org/drawingml/2006/main" xmlns:r="http://schemas.openxmlformats.org/officeDocument/2006/relationships" xmlns:p="http://schemas.openxmlformats.org/presentationml/2006/main">
   <p:cSld>
     <p:spTree>
       <p:nvGrpSpPr>
@@ -10943,7 +11077,14 @@
         <p:cNvGrpSpPr/>
         <p:nvPr/>
       </p:nvGrpSpPr>
-      <p:grpSpPr/>
+      <p:grpSpPr>
+        <a:xfrm>
+          <a:off x="0" y="0"/>
+          <a:ext cx="0" cy="0"/>
+          <a:chOff x="0" y="0"/>
+          <a:chExt cx="0" cy="0"/>
+        </a:xfrm>
+      </p:grpSpPr>
       <p:sp>
         <p:nvSpPr>
           <p:cNvPr id="2" name="TextBox 1"/>
@@ -11101,7 +11242,7 @@
           <p:nvPr/>
         </p:nvPicPr>
         <p:blipFill>
-          <a:blip r:embed="rId2"/>
+          <a:blip r:embed="rId3"/>
           <a:stretch>
             <a:fillRect/>
           </a:stretch>
@@ -11157,6 +11298,7 @@
           <a:lstStyle/>
           <a:p>
             <a:pPr algn="ctr"/>
+            <a:endParaRPr/>
           </a:p>
         </p:txBody>
       </p:sp>
@@ -11271,7 +11413,7 @@
 </file>
 
 <file path=ppt/slides/slide25.xml><?xml version="1.0" encoding="utf-8"?>
-<p:sld xmlns:a="http://schemas.openxmlformats.org/drawingml/2006/main" xmlns:p="http://schemas.openxmlformats.org/presentationml/2006/main" xmlns:r="http://schemas.openxmlformats.org/officeDocument/2006/relationships">
+<p:sld xmlns:a="http://schemas.openxmlformats.org/drawingml/2006/main" xmlns:r="http://schemas.openxmlformats.org/officeDocument/2006/relationships" xmlns:p="http://schemas.openxmlformats.org/presentationml/2006/main">
   <p:cSld>
     <p:spTree>
       <p:nvGrpSpPr>
@@ -11279,7 +11421,14 @@
         <p:cNvGrpSpPr/>
         <p:nvPr/>
       </p:nvGrpSpPr>
-      <p:grpSpPr/>
+      <p:grpSpPr>
+        <a:xfrm>
+          <a:off x="0" y="0"/>
+          <a:ext cx="0" cy="0"/>
+          <a:chOff x="0" y="0"/>
+          <a:chExt cx="0" cy="0"/>
+        </a:xfrm>
+      </p:grpSpPr>
       <p:sp>
         <p:nvSpPr>
           <p:cNvPr id="2" name="TextBox 1"/>
@@ -11437,7 +11586,7 @@
           <p:nvPr/>
         </p:nvPicPr>
         <p:blipFill>
-          <a:blip r:embed="rId2"/>
+          <a:blip r:embed="rId3"/>
           <a:stretch>
             <a:fillRect/>
           </a:stretch>
@@ -11493,6 +11642,7 @@
           <a:lstStyle/>
           <a:p>
             <a:pPr algn="ctr"/>
+            <a:endParaRPr/>
           </a:p>
         </p:txBody>
       </p:sp>
@@ -11607,7 +11757,7 @@
 </file>
 
 <file path=ppt/slides/slide26.xml><?xml version="1.0" encoding="utf-8"?>
-<p:sld xmlns:a="http://schemas.openxmlformats.org/drawingml/2006/main" xmlns:p="http://schemas.openxmlformats.org/presentationml/2006/main" xmlns:r="http://schemas.openxmlformats.org/officeDocument/2006/relationships">
+<p:sld xmlns:a="http://schemas.openxmlformats.org/drawingml/2006/main" xmlns:r="http://schemas.openxmlformats.org/officeDocument/2006/relationships" xmlns:p="http://schemas.openxmlformats.org/presentationml/2006/main">
   <p:cSld>
     <p:spTree>
       <p:nvGrpSpPr>
@@ -11615,7 +11765,14 @@
         <p:cNvGrpSpPr/>
         <p:nvPr/>
       </p:nvGrpSpPr>
-      <p:grpSpPr/>
+      <p:grpSpPr>
+        <a:xfrm>
+          <a:off x="0" y="0"/>
+          <a:ext cx="0" cy="0"/>
+          <a:chOff x="0" y="0"/>
+          <a:chExt cx="0" cy="0"/>
+        </a:xfrm>
+      </p:grpSpPr>
       <p:sp>
         <p:nvSpPr>
           <p:cNvPr id="2" name="TextBox 1"/>
@@ -11773,7 +11930,7 @@
           <p:nvPr/>
         </p:nvPicPr>
         <p:blipFill>
-          <a:blip r:embed="rId2"/>
+          <a:blip r:embed="rId3"/>
           <a:stretch>
             <a:fillRect/>
           </a:stretch>
@@ -11829,6 +11986,7 @@
           <a:lstStyle/>
           <a:p>
             <a:pPr algn="ctr"/>
+            <a:endParaRPr/>
           </a:p>
         </p:txBody>
       </p:sp>
@@ -11943,7 +12101,7 @@
 </file>
 
 <file path=ppt/slides/slide27.xml><?xml version="1.0" encoding="utf-8"?>
-<p:sld xmlns:a="http://schemas.openxmlformats.org/drawingml/2006/main" xmlns:p="http://schemas.openxmlformats.org/presentationml/2006/main" xmlns:r="http://schemas.openxmlformats.org/officeDocument/2006/relationships">
+<p:sld xmlns:a="http://schemas.openxmlformats.org/drawingml/2006/main" xmlns:r="http://schemas.openxmlformats.org/officeDocument/2006/relationships" xmlns:p="http://schemas.openxmlformats.org/presentationml/2006/main">
   <p:cSld>
     <p:spTree>
       <p:nvGrpSpPr>
@@ -11951,7 +12109,14 @@
         <p:cNvGrpSpPr/>
         <p:nvPr/>
       </p:nvGrpSpPr>
-      <p:grpSpPr/>
+      <p:grpSpPr>
+        <a:xfrm>
+          <a:off x="0" y="0"/>
+          <a:ext cx="0" cy="0"/>
+          <a:chOff x="0" y="0"/>
+          <a:chExt cx="0" cy="0"/>
+        </a:xfrm>
+      </p:grpSpPr>
       <p:sp>
         <p:nvSpPr>
           <p:cNvPr id="2" name="TextBox 1"/>
@@ -12109,7 +12274,7 @@
           <p:nvPr/>
         </p:nvPicPr>
         <p:blipFill>
-          <a:blip r:embed="rId2"/>
+          <a:blip r:embed="rId3"/>
           <a:stretch>
             <a:fillRect/>
           </a:stretch>
@@ -12165,6 +12330,7 @@
           <a:lstStyle/>
           <a:p>
             <a:pPr algn="ctr"/>
+            <a:endParaRPr/>
           </a:p>
         </p:txBody>
       </p:sp>
@@ -12279,7 +12445,7 @@
 </file>
 
 <file path=ppt/slides/slide28.xml><?xml version="1.0" encoding="utf-8"?>
-<p:sld xmlns:a="http://schemas.openxmlformats.org/drawingml/2006/main" xmlns:p="http://schemas.openxmlformats.org/presentationml/2006/main" xmlns:r="http://schemas.openxmlformats.org/officeDocument/2006/relationships">
+<p:sld xmlns:a="http://schemas.openxmlformats.org/drawingml/2006/main" xmlns:r="http://schemas.openxmlformats.org/officeDocument/2006/relationships" xmlns:p="http://schemas.openxmlformats.org/presentationml/2006/main">
   <p:cSld>
     <p:spTree>
       <p:nvGrpSpPr>
@@ -12287,7 +12453,14 @@
         <p:cNvGrpSpPr/>
         <p:nvPr/>
       </p:nvGrpSpPr>
-      <p:grpSpPr/>
+      <p:grpSpPr>
+        <a:xfrm>
+          <a:off x="0" y="0"/>
+          <a:ext cx="0" cy="0"/>
+          <a:chOff x="0" y="0"/>
+          <a:chExt cx="0" cy="0"/>
+        </a:xfrm>
+      </p:grpSpPr>
       <p:sp>
         <p:nvSpPr>
           <p:cNvPr id="2" name="TextBox 1"/>
@@ -12445,7 +12618,7 @@
           <p:nvPr/>
         </p:nvPicPr>
         <p:blipFill>
-          <a:blip r:embed="rId2"/>
+          <a:blip r:embed="rId3"/>
           <a:stretch>
             <a:fillRect/>
           </a:stretch>
@@ -12501,6 +12674,7 @@
           <a:lstStyle/>
           <a:p>
             <a:pPr algn="ctr"/>
+            <a:endParaRPr/>
           </a:p>
         </p:txBody>
       </p:sp>
@@ -12615,7 +12789,7 @@
 </file>
 
 <file path=ppt/slides/slide29.xml><?xml version="1.0" encoding="utf-8"?>
-<p:sld xmlns:a="http://schemas.openxmlformats.org/drawingml/2006/main" xmlns:p="http://schemas.openxmlformats.org/presentationml/2006/main" xmlns:r="http://schemas.openxmlformats.org/officeDocument/2006/relationships">
+<p:sld xmlns:a="http://schemas.openxmlformats.org/drawingml/2006/main" xmlns:r="http://schemas.openxmlformats.org/officeDocument/2006/relationships" xmlns:p="http://schemas.openxmlformats.org/presentationml/2006/main">
   <p:cSld>
     <p:spTree>
       <p:nvGrpSpPr>
@@ -12623,7 +12797,14 @@
         <p:cNvGrpSpPr/>
         <p:nvPr/>
       </p:nvGrpSpPr>
-      <p:grpSpPr/>
+      <p:grpSpPr>
+        <a:xfrm>
+          <a:off x="0" y="0"/>
+          <a:ext cx="0" cy="0"/>
+          <a:chOff x="0" y="0"/>
+          <a:chExt cx="0" cy="0"/>
+        </a:xfrm>
+      </p:grpSpPr>
       <p:sp>
         <p:nvSpPr>
           <p:cNvPr id="2" name="TextBox 1"/>
@@ -12781,7 +12962,7 @@
           <p:nvPr/>
         </p:nvPicPr>
         <p:blipFill>
-          <a:blip r:embed="rId2"/>
+          <a:blip r:embed="rId3"/>
           <a:stretch>
             <a:fillRect/>
           </a:stretch>
@@ -12837,6 +13018,7 @@
           <a:lstStyle/>
           <a:p>
             <a:pPr algn="ctr"/>
+            <a:endParaRPr/>
           </a:p>
         </p:txBody>
       </p:sp>
@@ -12951,7 +13133,7 @@
 </file>
 
 <file path=ppt/slides/slide3.xml><?xml version="1.0" encoding="utf-8"?>
-<p:sld xmlns:a="http://schemas.openxmlformats.org/drawingml/2006/main" xmlns:p="http://schemas.openxmlformats.org/presentationml/2006/main" xmlns:r="http://schemas.openxmlformats.org/officeDocument/2006/relationships">
+<p:sld xmlns:a="http://schemas.openxmlformats.org/drawingml/2006/main" xmlns:r="http://schemas.openxmlformats.org/officeDocument/2006/relationships" xmlns:p="http://schemas.openxmlformats.org/presentationml/2006/main">
   <p:cSld>
     <p:spTree>
       <p:nvGrpSpPr>
@@ -12959,7 +13141,14 @@
         <p:cNvGrpSpPr/>
         <p:nvPr/>
       </p:nvGrpSpPr>
-      <p:grpSpPr/>
+      <p:grpSpPr>
+        <a:xfrm>
+          <a:off x="0" y="0"/>
+          <a:ext cx="0" cy="0"/>
+          <a:chOff x="0" y="0"/>
+          <a:chExt cx="0" cy="0"/>
+        </a:xfrm>
+      </p:grpSpPr>
       <p:sp>
         <p:nvSpPr>
           <p:cNvPr id="2" name="Rectangle 1"/>
@@ -13001,6 +13190,7 @@
           <a:lstStyle/>
           <a:p>
             <a:pPr algn="ctr"/>
+            <a:endParaRPr/>
           </a:p>
         </p:txBody>
       </p:sp>
@@ -13113,6 +13303,7 @@
           <a:lstStyle/>
           <a:p>
             <a:pPr algn="ctr"/>
+            <a:endParaRPr/>
           </a:p>
         </p:txBody>
       </p:sp>
@@ -13159,7 +13350,7 @@
 </file>
 
 <file path=ppt/slides/slide30.xml><?xml version="1.0" encoding="utf-8"?>
-<p:sld xmlns:a="http://schemas.openxmlformats.org/drawingml/2006/main" xmlns:p="http://schemas.openxmlformats.org/presentationml/2006/main" xmlns:r="http://schemas.openxmlformats.org/officeDocument/2006/relationships">
+<p:sld xmlns:a="http://schemas.openxmlformats.org/drawingml/2006/main" xmlns:r="http://schemas.openxmlformats.org/officeDocument/2006/relationships" xmlns:p="http://schemas.openxmlformats.org/presentationml/2006/main">
   <p:cSld>
     <p:spTree>
       <p:nvGrpSpPr>
@@ -13167,7 +13358,14 @@
         <p:cNvGrpSpPr/>
         <p:nvPr/>
       </p:nvGrpSpPr>
-      <p:grpSpPr/>
+      <p:grpSpPr>
+        <a:xfrm>
+          <a:off x="0" y="0"/>
+          <a:ext cx="0" cy="0"/>
+          <a:chOff x="0" y="0"/>
+          <a:chExt cx="0" cy="0"/>
+        </a:xfrm>
+      </p:grpSpPr>
       <p:sp>
         <p:nvSpPr>
           <p:cNvPr id="2" name="TextBox 1"/>
@@ -13325,7 +13523,7 @@
           <p:nvPr/>
         </p:nvPicPr>
         <p:blipFill>
-          <a:blip r:embed="rId2"/>
+          <a:blip r:embed="rId3"/>
           <a:stretch>
             <a:fillRect/>
           </a:stretch>
@@ -13381,6 +13579,7 @@
           <a:lstStyle/>
           <a:p>
             <a:pPr algn="ctr"/>
+            <a:endParaRPr/>
           </a:p>
         </p:txBody>
       </p:sp>
@@ -13495,7 +13694,7 @@
 </file>
 
 <file path=ppt/slides/slide31.xml><?xml version="1.0" encoding="utf-8"?>
-<p:sld xmlns:a="http://schemas.openxmlformats.org/drawingml/2006/main" xmlns:p="http://schemas.openxmlformats.org/presentationml/2006/main" xmlns:r="http://schemas.openxmlformats.org/officeDocument/2006/relationships">
+<p:sld xmlns:a="http://schemas.openxmlformats.org/drawingml/2006/main" xmlns:r="http://schemas.openxmlformats.org/officeDocument/2006/relationships" xmlns:p="http://schemas.openxmlformats.org/presentationml/2006/main">
   <p:cSld>
     <p:spTree>
       <p:nvGrpSpPr>
@@ -13503,7 +13702,14 @@
         <p:cNvGrpSpPr/>
         <p:nvPr/>
       </p:nvGrpSpPr>
-      <p:grpSpPr/>
+      <p:grpSpPr>
+        <a:xfrm>
+          <a:off x="0" y="0"/>
+          <a:ext cx="0" cy="0"/>
+          <a:chOff x="0" y="0"/>
+          <a:chExt cx="0" cy="0"/>
+        </a:xfrm>
+      </p:grpSpPr>
       <p:sp>
         <p:nvSpPr>
           <p:cNvPr id="2" name="TextBox 1"/>
@@ -13661,7 +13867,7 @@
           <p:nvPr/>
         </p:nvPicPr>
         <p:blipFill>
-          <a:blip r:embed="rId2"/>
+          <a:blip r:embed="rId3"/>
           <a:stretch>
             <a:fillRect/>
           </a:stretch>
@@ -13717,6 +13923,7 @@
           <a:lstStyle/>
           <a:p>
             <a:pPr algn="ctr"/>
+            <a:endParaRPr/>
           </a:p>
         </p:txBody>
       </p:sp>
@@ -13831,7 +14038,7 @@
 </file>
 
 <file path=ppt/slides/slide32.xml><?xml version="1.0" encoding="utf-8"?>
-<p:sld xmlns:a="http://schemas.openxmlformats.org/drawingml/2006/main" xmlns:p="http://schemas.openxmlformats.org/presentationml/2006/main" xmlns:r="http://schemas.openxmlformats.org/officeDocument/2006/relationships">
+<p:sld xmlns:a="http://schemas.openxmlformats.org/drawingml/2006/main" xmlns:r="http://schemas.openxmlformats.org/officeDocument/2006/relationships" xmlns:p="http://schemas.openxmlformats.org/presentationml/2006/main">
   <p:cSld>
     <p:spTree>
       <p:nvGrpSpPr>
@@ -13839,7 +14046,14 @@
         <p:cNvGrpSpPr/>
         <p:nvPr/>
       </p:nvGrpSpPr>
-      <p:grpSpPr/>
+      <p:grpSpPr>
+        <a:xfrm>
+          <a:off x="0" y="0"/>
+          <a:ext cx="0" cy="0"/>
+          <a:chOff x="0" y="0"/>
+          <a:chExt cx="0" cy="0"/>
+        </a:xfrm>
+      </p:grpSpPr>
       <p:sp>
         <p:nvSpPr>
           <p:cNvPr id="2" name="TextBox 1"/>
@@ -13997,7 +14211,7 @@
           <p:nvPr/>
         </p:nvPicPr>
         <p:blipFill>
-          <a:blip r:embed="rId2"/>
+          <a:blip r:embed="rId3"/>
           <a:stretch>
             <a:fillRect/>
           </a:stretch>
@@ -14054,6 +14268,7 @@
           <a:lstStyle/>
           <a:p>
             <a:pPr algn="ctr"/>
+            <a:endParaRPr/>
           </a:p>
         </p:txBody>
       </p:sp>
@@ -14097,6 +14312,7 @@
           <a:lstStyle/>
           <a:p>
             <a:pPr algn="ctr"/>
+            <a:endParaRPr/>
           </a:p>
         </p:txBody>
       </p:sp>
@@ -14175,6 +14391,7 @@
           <a:lstStyle/>
           <a:p>
             <a:pPr algn="ctr"/>
+            <a:endParaRPr/>
           </a:p>
         </p:txBody>
       </p:sp>
@@ -14289,7 +14506,7 @@
 </file>
 
 <file path=ppt/slides/slide33.xml><?xml version="1.0" encoding="utf-8"?>
-<p:sld xmlns:a="http://schemas.openxmlformats.org/drawingml/2006/main" xmlns:p="http://schemas.openxmlformats.org/presentationml/2006/main" xmlns:r="http://schemas.openxmlformats.org/officeDocument/2006/relationships">
+<p:sld xmlns:a="http://schemas.openxmlformats.org/drawingml/2006/main" xmlns:r="http://schemas.openxmlformats.org/officeDocument/2006/relationships" xmlns:p="http://schemas.openxmlformats.org/presentationml/2006/main">
   <p:cSld>
     <p:spTree>
       <p:nvGrpSpPr>
@@ -14297,7 +14514,14 @@
         <p:cNvGrpSpPr/>
         <p:nvPr/>
       </p:nvGrpSpPr>
-      <p:grpSpPr/>
+      <p:grpSpPr>
+        <a:xfrm>
+          <a:off x="0" y="0"/>
+          <a:ext cx="0" cy="0"/>
+          <a:chOff x="0" y="0"/>
+          <a:chExt cx="0" cy="0"/>
+        </a:xfrm>
+      </p:grpSpPr>
       <p:sp>
         <p:nvSpPr>
           <p:cNvPr id="2" name="TextBox 1"/>
@@ -14455,7 +14679,7 @@
           <p:nvPr/>
         </p:nvPicPr>
         <p:blipFill>
-          <a:blip r:embed="rId2"/>
+          <a:blip r:embed="rId3"/>
           <a:stretch>
             <a:fillRect/>
           </a:stretch>
@@ -14511,6 +14735,7 @@
           <a:lstStyle/>
           <a:p>
             <a:pPr algn="ctr"/>
+            <a:endParaRPr/>
           </a:p>
         </p:txBody>
       </p:sp>
@@ -14625,7 +14850,7 @@
 </file>
 
 <file path=ppt/slides/slide4.xml><?xml version="1.0" encoding="utf-8"?>
-<p:sld xmlns:a="http://schemas.openxmlformats.org/drawingml/2006/main" xmlns:p="http://schemas.openxmlformats.org/presentationml/2006/main" xmlns:r="http://schemas.openxmlformats.org/officeDocument/2006/relationships">
+<p:sld xmlns:a="http://schemas.openxmlformats.org/drawingml/2006/main" xmlns:r="http://schemas.openxmlformats.org/officeDocument/2006/relationships" xmlns:p="http://schemas.openxmlformats.org/presentationml/2006/main">
   <p:cSld>
     <p:spTree>
       <p:nvGrpSpPr>
@@ -14633,7 +14858,14 @@
         <p:cNvGrpSpPr/>
         <p:nvPr/>
       </p:nvGrpSpPr>
-      <p:grpSpPr/>
+      <p:grpSpPr>
+        <a:xfrm>
+          <a:off x="0" y="0"/>
+          <a:ext cx="0" cy="0"/>
+          <a:chOff x="0" y="0"/>
+          <a:chExt cx="0" cy="0"/>
+        </a:xfrm>
+      </p:grpSpPr>
       <p:sp>
         <p:nvSpPr>
           <p:cNvPr id="2" name="TextBox 1"/>
@@ -14741,6 +14973,7 @@
           <a:lstStyle/>
           <a:p>
             <a:pPr algn="ctr"/>
+            <a:endParaRPr/>
           </a:p>
         </p:txBody>
       </p:sp>
@@ -14785,6 +15018,7 @@
           <a:lstStyle/>
           <a:p>
             <a:pPr algn="ctr"/>
+            <a:endParaRPr/>
           </a:p>
         </p:txBody>
       </p:sp>
@@ -14944,6 +15178,7 @@
           <a:lstStyle/>
           <a:p>
             <a:pPr algn="ctr"/>
+            <a:endParaRPr/>
           </a:p>
         </p:txBody>
       </p:sp>
@@ -15058,7 +15293,7 @@
 </file>
 
 <file path=ppt/slides/slide5.xml><?xml version="1.0" encoding="utf-8"?>
-<p:sld xmlns:a="http://schemas.openxmlformats.org/drawingml/2006/main" xmlns:p="http://schemas.openxmlformats.org/presentationml/2006/main" xmlns:r="http://schemas.openxmlformats.org/officeDocument/2006/relationships">
+<p:sld xmlns:a="http://schemas.openxmlformats.org/drawingml/2006/main" xmlns:r="http://schemas.openxmlformats.org/officeDocument/2006/relationships" xmlns:p="http://schemas.openxmlformats.org/presentationml/2006/main">
   <p:cSld>
     <p:spTree>
       <p:nvGrpSpPr>
@@ -15066,7 +15301,14 @@
         <p:cNvGrpSpPr/>
         <p:nvPr/>
       </p:nvGrpSpPr>
-      <p:grpSpPr/>
+      <p:grpSpPr>
+        <a:xfrm>
+          <a:off x="0" y="0"/>
+          <a:ext cx="0" cy="0"/>
+          <a:chOff x="0" y="0"/>
+          <a:chExt cx="0" cy="0"/>
+        </a:xfrm>
+      </p:grpSpPr>
       <p:sp>
         <p:nvSpPr>
           <p:cNvPr id="2" name="TextBox 1"/>
@@ -15174,6 +15416,7 @@
           <a:lstStyle/>
           <a:p>
             <a:pPr algn="ctr"/>
+            <a:endParaRPr/>
           </a:p>
         </p:txBody>
       </p:sp>
@@ -15218,6 +15461,7 @@
           <a:lstStyle/>
           <a:p>
             <a:pPr algn="ctr"/>
+            <a:endParaRPr/>
           </a:p>
         </p:txBody>
       </p:sp>
@@ -15377,6 +15621,7 @@
           <a:lstStyle/>
           <a:p>
             <a:pPr algn="ctr"/>
+            <a:endParaRPr/>
           </a:p>
         </p:txBody>
       </p:sp>
@@ -15491,7 +15736,7 @@
 </file>
 
 <file path=ppt/slides/slide6.xml><?xml version="1.0" encoding="utf-8"?>
-<p:sld xmlns:a="http://schemas.openxmlformats.org/drawingml/2006/main" xmlns:p="http://schemas.openxmlformats.org/presentationml/2006/main" xmlns:r="http://schemas.openxmlformats.org/officeDocument/2006/relationships">
+<p:sld xmlns:a="http://schemas.openxmlformats.org/drawingml/2006/main" xmlns:r="http://schemas.openxmlformats.org/officeDocument/2006/relationships" xmlns:p="http://schemas.openxmlformats.org/presentationml/2006/main">
   <p:cSld>
     <p:spTree>
       <p:nvGrpSpPr>
@@ -15499,7 +15744,14 @@
         <p:cNvGrpSpPr/>
         <p:nvPr/>
       </p:nvGrpSpPr>
-      <p:grpSpPr/>
+      <p:grpSpPr>
+        <a:xfrm>
+          <a:off x="0" y="0"/>
+          <a:ext cx="0" cy="0"/>
+          <a:chOff x="0" y="0"/>
+          <a:chExt cx="0" cy="0"/>
+        </a:xfrm>
+      </p:grpSpPr>
       <p:sp>
         <p:nvSpPr>
           <p:cNvPr id="2" name="Rectangle 1"/>
@@ -15541,6 +15793,7 @@
           <a:lstStyle/>
           <a:p>
             <a:pPr algn="ctr"/>
+            <a:endParaRPr/>
           </a:p>
         </p:txBody>
       </p:sp>
@@ -15653,6 +15906,7 @@
           <a:lstStyle/>
           <a:p>
             <a:pPr algn="ctr"/>
+            <a:endParaRPr/>
           </a:p>
         </p:txBody>
       </p:sp>
@@ -15699,7 +15953,7 @@
 </file>
 
 <file path=ppt/slides/slide7.xml><?xml version="1.0" encoding="utf-8"?>
-<p:sld xmlns:a="http://schemas.openxmlformats.org/drawingml/2006/main" xmlns:p="http://schemas.openxmlformats.org/presentationml/2006/main" xmlns:r="http://schemas.openxmlformats.org/officeDocument/2006/relationships">
+<p:sld xmlns:a="http://schemas.openxmlformats.org/drawingml/2006/main" xmlns:r="http://schemas.openxmlformats.org/officeDocument/2006/relationships" xmlns:p="http://schemas.openxmlformats.org/presentationml/2006/main">
   <p:cSld>
     <p:spTree>
       <p:nvGrpSpPr>
@@ -15707,7 +15961,14 @@
         <p:cNvGrpSpPr/>
         <p:nvPr/>
       </p:nvGrpSpPr>
-      <p:grpSpPr/>
+      <p:grpSpPr>
+        <a:xfrm>
+          <a:off x="0" y="0"/>
+          <a:ext cx="0" cy="0"/>
+          <a:chOff x="0" y="0"/>
+          <a:chExt cx="0" cy="0"/>
+        </a:xfrm>
+      </p:grpSpPr>
       <p:sp>
         <p:nvSpPr>
           <p:cNvPr id="2" name="TextBox 1"/>
@@ -15815,6 +16076,7 @@
           <a:lstStyle/>
           <a:p>
             <a:pPr algn="ctr"/>
+            <a:endParaRPr/>
           </a:p>
         </p:txBody>
       </p:sp>
@@ -15859,6 +16121,7 @@
           <a:lstStyle/>
           <a:p>
             <a:pPr algn="ctr"/>
+            <a:endParaRPr/>
           </a:p>
         </p:txBody>
       </p:sp>
@@ -16018,6 +16281,7 @@
           <a:lstStyle/>
           <a:p>
             <a:pPr algn="ctr"/>
+            <a:endParaRPr/>
           </a:p>
         </p:txBody>
       </p:sp>
@@ -16132,7 +16396,7 @@
 </file>
 
 <file path=ppt/slides/slide8.xml><?xml version="1.0" encoding="utf-8"?>
-<p:sld xmlns:a="http://schemas.openxmlformats.org/drawingml/2006/main" xmlns:p="http://schemas.openxmlformats.org/presentationml/2006/main" xmlns:r="http://schemas.openxmlformats.org/officeDocument/2006/relationships">
+<p:sld xmlns:a="http://schemas.openxmlformats.org/drawingml/2006/main" xmlns:r="http://schemas.openxmlformats.org/officeDocument/2006/relationships" xmlns:p="http://schemas.openxmlformats.org/presentationml/2006/main">
   <p:cSld>
     <p:spTree>
       <p:nvGrpSpPr>
@@ -16140,7 +16404,14 @@
         <p:cNvGrpSpPr/>
         <p:nvPr/>
       </p:nvGrpSpPr>
-      <p:grpSpPr/>
+      <p:grpSpPr>
+        <a:xfrm>
+          <a:off x="0" y="0"/>
+          <a:ext cx="0" cy="0"/>
+          <a:chOff x="0" y="0"/>
+          <a:chExt cx="0" cy="0"/>
+        </a:xfrm>
+      </p:grpSpPr>
       <p:sp>
         <p:nvSpPr>
           <p:cNvPr id="2" name="TextBox 1"/>
@@ -16298,7 +16569,7 @@
           <p:nvPr/>
         </p:nvPicPr>
         <p:blipFill>
-          <a:blip r:embed="rId2"/>
+          <a:blip r:embed="rId3"/>
           <a:stretch>
             <a:fillRect/>
           </a:stretch>
@@ -16354,6 +16625,7 @@
           <a:lstStyle/>
           <a:p>
             <a:pPr algn="ctr"/>
+            <a:endParaRPr/>
           </a:p>
         </p:txBody>
       </p:sp>
@@ -16468,7 +16740,7 @@
 </file>
 
 <file path=ppt/slides/slide9.xml><?xml version="1.0" encoding="utf-8"?>
-<p:sld xmlns:a="http://schemas.openxmlformats.org/drawingml/2006/main" xmlns:p="http://schemas.openxmlformats.org/presentationml/2006/main" xmlns:r="http://schemas.openxmlformats.org/officeDocument/2006/relationships">
+<p:sld xmlns:a="http://schemas.openxmlformats.org/drawingml/2006/main" xmlns:r="http://schemas.openxmlformats.org/officeDocument/2006/relationships" xmlns:p="http://schemas.openxmlformats.org/presentationml/2006/main">
   <p:cSld>
     <p:spTree>
       <p:nvGrpSpPr>
@@ -16476,7 +16748,14 @@
         <p:cNvGrpSpPr/>
         <p:nvPr/>
       </p:nvGrpSpPr>
-      <p:grpSpPr/>
+      <p:grpSpPr>
+        <a:xfrm>
+          <a:off x="0" y="0"/>
+          <a:ext cx="0" cy="0"/>
+          <a:chOff x="0" y="0"/>
+          <a:chExt cx="0" cy="0"/>
+        </a:xfrm>
+      </p:grpSpPr>
       <p:sp>
         <p:nvSpPr>
           <p:cNvPr id="2" name="TextBox 1"/>
@@ -16584,6 +16863,7 @@
           <a:lstStyle/>
           <a:p>
             <a:pPr algn="ctr"/>
+            <a:endParaRPr/>
           </a:p>
         </p:txBody>
       </p:sp>
@@ -16628,6 +16908,7 @@
           <a:lstStyle/>
           <a:p>
             <a:pPr algn="ctr"/>
+            <a:endParaRPr/>
           </a:p>
         </p:txBody>
       </p:sp>
@@ -16787,6 +17068,7 @@
           <a:lstStyle/>
           <a:p>
             <a:pPr algn="ctr"/>
+            <a:endParaRPr/>
           </a:p>
         </p:txBody>
       </p:sp>
@@ -17221,7 +17503,7 @@
 </file>
 
 <file path=ppt/theme/theme2.xml><?xml version="1.0" encoding="utf-8"?>
-<a:theme xmlns:a="http://schemas.openxmlformats.org/drawingml/2006/main" name="Office Theme">
+<a:theme xmlns:a="http://schemas.openxmlformats.org/drawingml/2006/main" name="Office 佈景主題">
   <a:themeElements>
     <a:clrScheme name="Office">
       <a:dk1>
@@ -17231,44 +17513,44 @@
         <a:sysClr val="window" lastClr="FFFFFF"/>
       </a:lt1>
       <a:dk2>
-        <a:srgbClr val="1F497D"/>
+        <a:srgbClr val="0E2841"/>
       </a:dk2>
       <a:lt2>
-        <a:srgbClr val="EEECE1"/>
+        <a:srgbClr val="E8E8E8"/>
       </a:lt2>
       <a:accent1>
-        <a:srgbClr val="4F81BD"/>
+        <a:srgbClr val="156082"/>
       </a:accent1>
       <a:accent2>
-        <a:srgbClr val="C0504D"/>
+        <a:srgbClr val="E97132"/>
       </a:accent2>
       <a:accent3>
-        <a:srgbClr val="9BBB59"/>
+        <a:srgbClr val="196B24"/>
       </a:accent3>
       <a:accent4>
-        <a:srgbClr val="8064A2"/>
+        <a:srgbClr val="0F9ED5"/>
       </a:accent4>
       <a:accent5>
-        <a:srgbClr val="4BACC6"/>
+        <a:srgbClr val="A02B93"/>
       </a:accent5>
       <a:accent6>
-        <a:srgbClr val="F79646"/>
+        <a:srgbClr val="4EA72E"/>
       </a:accent6>
       <a:hlink>
-        <a:srgbClr val="0000FF"/>
+        <a:srgbClr val="467886"/>
       </a:hlink>
       <a:folHlink>
-        <a:srgbClr val="800080"/>
+        <a:srgbClr val="96607D"/>
       </a:folHlink>
     </a:clrScheme>
     <a:fontScheme name="Office">
       <a:majorFont>
-        <a:latin typeface="Calibri"/>
+        <a:latin typeface="Aptos Display" panose="02110004020202020204"/>
         <a:ea typeface=""/>
         <a:cs typeface=""/>
-        <a:font script="Jpan" typeface="ＭＳ Ｐゴシック"/>
+        <a:font script="Jpan" typeface="游ゴシック Light"/>
         <a:font script="Hang" typeface="맑은 고딕"/>
-        <a:font script="Hans" typeface="宋体"/>
+        <a:font script="Hans" typeface="等线 Light"/>
         <a:font script="Hant" typeface="新細明體"/>
         <a:font script="Arab" typeface="Times New Roman"/>
         <a:font script="Hebr" typeface="Times New Roman"/>
@@ -17296,14 +17578,31 @@
         <a:font script="Viet" typeface="Times New Roman"/>
         <a:font script="Uigh" typeface="Microsoft Uighur"/>
         <a:font script="Geor" typeface="Sylfaen"/>
+        <a:font script="Armn" typeface="Arial"/>
+        <a:font script="Bugi" typeface="Leelawadee UI"/>
+        <a:font script="Bopo" typeface="Microsoft JhengHei"/>
+        <a:font script="Java" typeface="Javanese Text"/>
+        <a:font script="Lisu" typeface="Segoe UI"/>
+        <a:font script="Mymr" typeface="Myanmar Text"/>
+        <a:font script="Nkoo" typeface="Ebrima"/>
+        <a:font script="Olck" typeface="Nirmala UI"/>
+        <a:font script="Osma" typeface="Ebrima"/>
+        <a:font script="Phag" typeface="Phagspa"/>
+        <a:font script="Syrn" typeface="Estrangelo Edessa"/>
+        <a:font script="Syrj" typeface="Estrangelo Edessa"/>
+        <a:font script="Syre" typeface="Estrangelo Edessa"/>
+        <a:font script="Sora" typeface="Nirmala UI"/>
+        <a:font script="Tale" typeface="Microsoft Tai Le"/>
+        <a:font script="Talu" typeface="Microsoft New Tai Lue"/>
+        <a:font script="Tfng" typeface="Ebrima"/>
       </a:majorFont>
       <a:minorFont>
-        <a:latin typeface="Calibri"/>
+        <a:latin typeface="Aptos" panose="02110004020202020204"/>
         <a:ea typeface=""/>
         <a:cs typeface=""/>
-        <a:font script="Jpan" typeface="ＭＳ Ｐゴシック"/>
+        <a:font script="Jpan" typeface="游ゴシック"/>
         <a:font script="Hang" typeface="맑은 고딕"/>
-        <a:font script="Hans" typeface="宋体"/>
+        <a:font script="Hans" typeface="等线"/>
         <a:font script="Hant" typeface="新細明體"/>
         <a:font script="Arab" typeface="Arial"/>
         <a:font script="Hebr" typeface="Arial"/>
@@ -17331,6 +17630,23 @@
         <a:font script="Viet" typeface="Arial"/>
         <a:font script="Uigh" typeface="Microsoft Uighur"/>
         <a:font script="Geor" typeface="Sylfaen"/>
+        <a:font script="Armn" typeface="Arial"/>
+        <a:font script="Bugi" typeface="Leelawadee UI"/>
+        <a:font script="Bopo" typeface="Microsoft JhengHei"/>
+        <a:font script="Java" typeface="Javanese Text"/>
+        <a:font script="Lisu" typeface="Segoe UI"/>
+        <a:font script="Mymr" typeface="Myanmar Text"/>
+        <a:font script="Nkoo" typeface="Ebrima"/>
+        <a:font script="Olck" typeface="Nirmala UI"/>
+        <a:font script="Osma" typeface="Ebrima"/>
+        <a:font script="Phag" typeface="Phagspa"/>
+        <a:font script="Syrn" typeface="Estrangelo Edessa"/>
+        <a:font script="Syrj" typeface="Estrangelo Edessa"/>
+        <a:font script="Syre" typeface="Estrangelo Edessa"/>
+        <a:font script="Sora" typeface="Nirmala UI"/>
+        <a:font script="Tale" typeface="Microsoft Tai Le"/>
+        <a:font script="Talu" typeface="Microsoft New Tai Lue"/>
+        <a:font script="Tfng" typeface="Ebrima"/>
       </a:minorFont>
     </a:fontScheme>
     <a:fmtScheme name="Office">
@@ -17342,180 +17658,136 @@
           <a:gsLst>
             <a:gs pos="0">
               <a:schemeClr val="phClr">
-                <a:tint val="50000"/>
-                <a:satMod val="300000"/>
+                <a:lumMod val="110000"/>
+                <a:satMod val="105000"/>
+                <a:tint val="67000"/>
               </a:schemeClr>
             </a:gs>
-            <a:gs pos="35000">
+            <a:gs pos="50000">
               <a:schemeClr val="phClr">
-                <a:tint val="37000"/>
-                <a:satMod val="300000"/>
+                <a:lumMod val="105000"/>
+                <a:satMod val="103000"/>
+                <a:tint val="73000"/>
               </a:schemeClr>
             </a:gs>
             <a:gs pos="100000">
               <a:schemeClr val="phClr">
-                <a:tint val="15000"/>
-                <a:satMod val="350000"/>
+                <a:lumMod val="105000"/>
+                <a:satMod val="109000"/>
+                <a:tint val="81000"/>
               </a:schemeClr>
             </a:gs>
           </a:gsLst>
-          <a:lin ang="16200000" scaled="1"/>
+          <a:lin ang="5400000" scaled="0"/>
         </a:gradFill>
         <a:gradFill rotWithShape="1">
           <a:gsLst>
             <a:gs pos="0">
               <a:schemeClr val="phClr">
-                <a:tint val="100000"/>
+                <a:satMod val="103000"/>
+                <a:lumMod val="102000"/>
+                <a:tint val="94000"/>
+              </a:schemeClr>
+            </a:gs>
+            <a:gs pos="50000">
+              <a:schemeClr val="phClr">
+                <a:satMod val="110000"/>
+                <a:lumMod val="100000"/>
                 <a:shade val="100000"/>
-                <a:satMod val="130000"/>
               </a:schemeClr>
             </a:gs>
             <a:gs pos="100000">
               <a:schemeClr val="phClr">
-                <a:tint val="50000"/>
-                <a:shade val="100000"/>
-                <a:satMod val="350000"/>
+                <a:lumMod val="99000"/>
+                <a:satMod val="120000"/>
+                <a:shade val="78000"/>
               </a:schemeClr>
             </a:gs>
           </a:gsLst>
-          <a:lin ang="16200000" scaled="0"/>
+          <a:lin ang="5400000" scaled="0"/>
         </a:gradFill>
       </a:fillStyleLst>
       <a:lnStyleLst>
-        <a:ln w="9525" cap="flat" cmpd="sng" algn="ctr">
+        <a:ln w="12700" cap="flat" cmpd="sng" algn="ctr">
           <a:solidFill>
-            <a:schemeClr val="phClr">
-              <a:shade val="95000"/>
-              <a:satMod val="105000"/>
-            </a:schemeClr>
+            <a:schemeClr val="phClr"/>
           </a:solidFill>
           <a:prstDash val="solid"/>
+          <a:miter lim="800000"/>
+        </a:ln>
+        <a:ln w="19050" cap="flat" cmpd="sng" algn="ctr">
+          <a:solidFill>
+            <a:schemeClr val="phClr"/>
+          </a:solidFill>
+          <a:prstDash val="solid"/>
+          <a:miter lim="800000"/>
         </a:ln>
         <a:ln w="25400" cap="flat" cmpd="sng" algn="ctr">
           <a:solidFill>
             <a:schemeClr val="phClr"/>
           </a:solidFill>
           <a:prstDash val="solid"/>
-        </a:ln>
-        <a:ln w="38100" cap="flat" cmpd="sng" algn="ctr">
-          <a:solidFill>
-            <a:schemeClr val="phClr"/>
-          </a:solidFill>
-          <a:prstDash val="solid"/>
+          <a:miter lim="800000"/>
         </a:ln>
       </a:lnStyleLst>
       <a:effectStyleLst>
         <a:effectStyle>
+          <a:effectLst/>
+        </a:effectStyle>
+        <a:effectStyle>
+          <a:effectLst/>
+        </a:effectStyle>
+        <a:effectStyle>
           <a:effectLst>
-            <a:outerShdw blurRad="40000" dist="20000" dir="5400000" rotWithShape="0">
+            <a:outerShdw blurRad="57150" dist="19050" dir="5400000" algn="ctr" rotWithShape="0">
               <a:srgbClr val="000000">
-                <a:alpha val="38000"/>
+                <a:alpha val="63000"/>
               </a:srgbClr>
             </a:outerShdw>
           </a:effectLst>
-        </a:effectStyle>
-        <a:effectStyle>
-          <a:effectLst>
-            <a:outerShdw blurRad="40000" dist="23000" dir="5400000" rotWithShape="0">
-              <a:srgbClr val="000000">
-                <a:alpha val="35000"/>
-              </a:srgbClr>
-            </a:outerShdw>
-          </a:effectLst>
-        </a:effectStyle>
-        <a:effectStyle>
-          <a:effectLst>
-            <a:outerShdw blurRad="40000" dist="23000" dir="5400000" rotWithShape="0">
-              <a:srgbClr val="000000">
-                <a:alpha val="35000"/>
-              </a:srgbClr>
-            </a:outerShdw>
-          </a:effectLst>
-          <a:scene3d>
-            <a:camera prst="orthographicFront">
-              <a:rot lat="0" lon="0" rev="0"/>
-            </a:camera>
-            <a:lightRig rig="threePt" dir="t">
-              <a:rot lat="0" lon="0" rev="1200000"/>
-            </a:lightRig>
-          </a:scene3d>
-          <a:sp3d>
-            <a:bevelT w="63500" h="25400"/>
-          </a:sp3d>
         </a:effectStyle>
       </a:effectStyleLst>
       <a:bgFillStyleLst>
         <a:solidFill>
           <a:schemeClr val="phClr"/>
         </a:solidFill>
+        <a:solidFill>
+          <a:schemeClr val="phClr">
+            <a:tint val="95000"/>
+            <a:satMod val="170000"/>
+          </a:schemeClr>
+        </a:solidFill>
         <a:gradFill rotWithShape="1">
           <a:gsLst>
             <a:gs pos="0">
               <a:schemeClr val="phClr">
-                <a:tint val="40000"/>
-                <a:satMod val="350000"/>
+                <a:tint val="93000"/>
+                <a:satMod val="150000"/>
+                <a:shade val="98000"/>
+                <a:lumMod val="102000"/>
               </a:schemeClr>
             </a:gs>
-            <a:gs pos="40000">
+            <a:gs pos="50000">
               <a:schemeClr val="phClr">
-                <a:tint val="45000"/>
-                <a:shade val="99000"/>
-                <a:satMod val="350000"/>
+                <a:tint val="98000"/>
+                <a:satMod val="130000"/>
+                <a:shade val="90000"/>
+                <a:lumMod val="103000"/>
               </a:schemeClr>
             </a:gs>
             <a:gs pos="100000">
               <a:schemeClr val="phClr">
-                <a:shade val="20000"/>
-                <a:satMod val="255000"/>
+                <a:shade val="63000"/>
+                <a:satMod val="120000"/>
               </a:schemeClr>
             </a:gs>
           </a:gsLst>
-          <a:path path="circle">
-            <a:fillToRect l="50000" t="-80000" r="50000" b="180000"/>
-          </a:path>
-        </a:gradFill>
-        <a:gradFill rotWithShape="1">
-          <a:gsLst>
-            <a:gs pos="0">
-              <a:schemeClr val="phClr">
-                <a:tint val="80000"/>
-                <a:satMod val="300000"/>
-              </a:schemeClr>
-            </a:gs>
-            <a:gs pos="100000">
-              <a:schemeClr val="phClr">
-                <a:shade val="30000"/>
-                <a:satMod val="200000"/>
-              </a:schemeClr>
-            </a:gs>
-          </a:gsLst>
-          <a:path path="circle">
-            <a:fillToRect l="50000" t="50000" r="50000" b="50000"/>
-          </a:path>
+          <a:lin ang="5400000" scaled="0"/>
         </a:gradFill>
       </a:bgFillStyleLst>
     </a:fmtScheme>
   </a:themeElements>
   <a:objectDefaults>
-    <a:spDef>
-      <a:spPr/>
-      <a:bodyPr/>
-      <a:lstStyle/>
-      <a:style>
-        <a:lnRef idx="1">
-          <a:schemeClr val="accent1"/>
-        </a:lnRef>
-        <a:fillRef idx="3">
-          <a:schemeClr val="accent1"/>
-        </a:fillRef>
-        <a:effectRef idx="2">
-          <a:schemeClr val="accent1"/>
-        </a:effectRef>
-        <a:fontRef idx="minor">
-          <a:schemeClr val="lt1"/>
-        </a:fontRef>
-      </a:style>
-    </a:spDef>
     <a:lnDef>
       <a:spPr/>
       <a:bodyPr/>
@@ -17537,5 +17809,10 @@
     </a:lnDef>
   </a:objectDefaults>
   <a:extraClrSchemeLst/>
+  <a:extLst>
+    <a:ext uri="{05A4C25C-085E-4340-85A3-A5531E510DB2}">
+      <thm15:themeFamily xmlns:thm15="http://schemas.microsoft.com/office/thememl/2012/main" name="Office Theme" id="{2E142A2C-CD16-42D6-873A-C26D2A0506FA}" vid="{1BDDFF52-6CD6-40A5-AB3C-68EB2F1E4D0A}"/>
+    </a:ext>
+  </a:extLst>
 </a:theme>
 </file>
</xml_diff>

<commit_message>
Fix MDN/MLP numbers on slide 13 + measure D split for real
Slide 13 number audit (vs metrics.csv source of truth):
- Plain MDN 1.26 m actually edges past MLP 1.30 m (both ~-17% vs KNN 1.57)
- Masked variants are 1.37 m (masking the -100 padding made it worse)
- Removed the stale "1.20 m" caption and the wrong "sliver below KNN" claim
- arch_masked_mdn / arch_knn / arch_set_transformer: 115-D -> real 80-D vocab,
  230->160 linear, MaskedMDN 1.20->1.371, Heatmap comparison 0.836->0.883

Slide 25: D_stratified now MEASURED (Cascade-aggressive x5, GP-synth on D-train):
median 0.807 / mean 1.262 / p90 3.151. A vs D bar+CDF figure (split_a_vs_d.png).
B estimate softened to ~1.0 m (morning-only, less data) for defensibility.

Co-Authored-By: Claude Opus 4.8 <noreply@anthropic.com>
</commit_message>
<xml_diff>
--- a/lab3/outputs/slides/lab3_presentation.pptx
+++ b/lab3/outputs/slides/lab3_presentation.pptx
@@ -4,45 +4,42 @@
   <p:sldMasterIdLst>
     <p:sldMasterId id="2147483648" r:id="rId1"/>
   </p:sldMasterIdLst>
-  <p:notesMasterIdLst>
-    <p:notesMasterId r:id="rId35"/>
-  </p:notesMasterIdLst>
   <p:sldIdLst>
-    <p:sldId id="256" r:id="rId2"/>
-    <p:sldId id="257" r:id="rId3"/>
-    <p:sldId id="258" r:id="rId4"/>
-    <p:sldId id="259" r:id="rId5"/>
-    <p:sldId id="260" r:id="rId6"/>
-    <p:sldId id="261" r:id="rId7"/>
-    <p:sldId id="262" r:id="rId8"/>
-    <p:sldId id="263" r:id="rId9"/>
-    <p:sldId id="264" r:id="rId10"/>
-    <p:sldId id="265" r:id="rId11"/>
-    <p:sldId id="266" r:id="rId12"/>
-    <p:sldId id="267" r:id="rId13"/>
-    <p:sldId id="268" r:id="rId14"/>
-    <p:sldId id="269" r:id="rId15"/>
-    <p:sldId id="270" r:id="rId16"/>
-    <p:sldId id="271" r:id="rId17"/>
-    <p:sldId id="272" r:id="rId18"/>
-    <p:sldId id="273" r:id="rId19"/>
-    <p:sldId id="274" r:id="rId20"/>
-    <p:sldId id="275" r:id="rId21"/>
-    <p:sldId id="276" r:id="rId22"/>
-    <p:sldId id="277" r:id="rId23"/>
-    <p:sldId id="278" r:id="rId24"/>
-    <p:sldId id="279" r:id="rId25"/>
-    <p:sldId id="280" r:id="rId26"/>
-    <p:sldId id="281" r:id="rId27"/>
-    <p:sldId id="282" r:id="rId28"/>
-    <p:sldId id="283" r:id="rId29"/>
-    <p:sldId id="284" r:id="rId30"/>
-    <p:sldId id="285" r:id="rId31"/>
-    <p:sldId id="286" r:id="rId32"/>
-    <p:sldId id="287" r:id="rId33"/>
-    <p:sldId id="288" r:id="rId34"/>
+    <p:sldId id="256" r:id="rId7"/>
+    <p:sldId id="257" r:id="rId9"/>
+    <p:sldId id="258" r:id="rId10"/>
+    <p:sldId id="259" r:id="rId11"/>
+    <p:sldId id="260" r:id="rId12"/>
+    <p:sldId id="261" r:id="rId13"/>
+    <p:sldId id="262" r:id="rId14"/>
+    <p:sldId id="263" r:id="rId15"/>
+    <p:sldId id="264" r:id="rId16"/>
+    <p:sldId id="265" r:id="rId17"/>
+    <p:sldId id="266" r:id="rId18"/>
+    <p:sldId id="267" r:id="rId19"/>
+    <p:sldId id="268" r:id="rId20"/>
+    <p:sldId id="269" r:id="rId21"/>
+    <p:sldId id="270" r:id="rId22"/>
+    <p:sldId id="271" r:id="rId23"/>
+    <p:sldId id="272" r:id="rId24"/>
+    <p:sldId id="273" r:id="rId25"/>
+    <p:sldId id="274" r:id="rId26"/>
+    <p:sldId id="275" r:id="rId27"/>
+    <p:sldId id="276" r:id="rId28"/>
+    <p:sldId id="277" r:id="rId29"/>
+    <p:sldId id="278" r:id="rId30"/>
+    <p:sldId id="279" r:id="rId31"/>
+    <p:sldId id="280" r:id="rId32"/>
+    <p:sldId id="281" r:id="rId33"/>
+    <p:sldId id="282" r:id="rId34"/>
+    <p:sldId id="283" r:id="rId35"/>
+    <p:sldId id="284" r:id="rId36"/>
+    <p:sldId id="285" r:id="rId37"/>
+    <p:sldId id="286" r:id="rId38"/>
+    <p:sldId id="287" r:id="rId39"/>
+    <p:sldId id="288" r:id="rId40"/>
   </p:sldIdLst>
-  <p:sldSz cx="12192000" cy="6858000"/>
+  <p:sldSz cx="12191695" cy="6858000" type="screen4x3"/>
   <p:notesSz cx="6858000" cy="9144000"/>
   <p:defaultTextStyle>
     <a:defPPr>
@@ -139,27 +136,11 @@
       </a:defRPr>
     </a:lvl9pPr>
   </p:defaultTextStyle>
-  <p:extLst>
-    <p:ext uri="{EFAFB233-063F-42B5-8137-9DF3F51BA10A}">
-      <p15:sldGuideLst xmlns:p15="http://schemas.microsoft.com/office/powerpoint/2012/main">
-        <p15:guide id="1" orient="horz" pos="2160">
-          <p15:clr>
-            <a:srgbClr val="A4A3A4"/>
-          </p15:clr>
-        </p15:guide>
-        <p15:guide id="2" pos="2880">
-          <p15:clr>
-            <a:srgbClr val="A4A3A4"/>
-          </p15:clr>
-        </p15:guide>
-      </p15:sldGuideLst>
-    </p:ext>
-  </p:extLst>
 </p:presentation>
 </file>
 
 <file path=ppt/notesMasters/notesMaster1.xml><?xml version="1.0" encoding="utf-8"?>
-<p:notesMaster xmlns:a="http://schemas.openxmlformats.org/drawingml/2006/main" xmlns:r="http://schemas.openxmlformats.org/officeDocument/2006/relationships" xmlns:p="http://schemas.openxmlformats.org/presentationml/2006/main">
+<p:notesMaster xmlns:a="http://schemas.openxmlformats.org/drawingml/2006/main" xmlns:p="http://schemas.openxmlformats.org/presentationml/2006/main" xmlns:r="http://schemas.openxmlformats.org/officeDocument/2006/relationships">
   <p:cSld>
     <p:bg>
       <p:bgRef idx="1001">
@@ -180,16 +161,241 @@
           <a:chExt cx="0" cy="0"/>
         </a:xfrm>
       </p:grpSpPr>
+      <p:sp>
+        <p:nvSpPr>
+          <p:cNvPr id="2" name="Header Placeholder 1"/>
+          <p:cNvSpPr>
+            <a:spLocks noGrp="1"/>
+          </p:cNvSpPr>
+          <p:nvPr>
+            <p:ph type="hdr" sz="quarter"/>
+          </p:nvPr>
+        </p:nvSpPr>
+        <p:spPr>
+          <a:xfrm>
+            <a:off x="0" y="0"/>
+            <a:ext cx="2971800" cy="457200"/>
+          </a:xfrm>
+          <a:prstGeom prst="rect">
+            <a:avLst/>
+          </a:prstGeom>
+        </p:spPr>
+        <p:txBody>
+          <a:bodyPr vert="horz" lIns="91440" tIns="45720" rIns="91440" bIns="45720" rtlCol="0"/>
+          <a:lstStyle>
+            <a:lvl1pPr algn="l">
+              <a:defRPr sz="1200"/>
+            </a:lvl1pPr>
+          </a:lstStyle>
+          <a:p>
+            <a:endParaRPr lang="en-US"/>
+          </a:p>
+        </p:txBody>
+      </p:sp>
+      <p:sp>
+        <p:nvSpPr>
+          <p:cNvPr id="3" name="Date Placeholder 2"/>
+          <p:cNvSpPr>
+            <a:spLocks noGrp="1"/>
+          </p:cNvSpPr>
+          <p:nvPr>
+            <p:ph type="dt" idx="1"/>
+          </p:nvPr>
+        </p:nvSpPr>
+        <p:spPr>
+          <a:xfrm>
+            <a:off x="3884613" y="0"/>
+            <a:ext cx="2971800" cy="457200"/>
+          </a:xfrm>
+          <a:prstGeom prst="rect">
+            <a:avLst/>
+          </a:prstGeom>
+        </p:spPr>
+        <p:txBody>
+          <a:bodyPr vert="horz" lIns="91440" tIns="45720" rIns="91440" bIns="45720" rtlCol="0"/>
+          <a:lstStyle>
+            <a:lvl1pPr algn="r">
+              <a:defRPr sz="1200"/>
+            </a:lvl1pPr>
+          </a:lstStyle>
+          <a:p>
+            <a:fld id="{0F89C1C7-3DCD-1040-A9CF-14679D8B5DDD}" type="datetimeFigureOut">
+              <a:rPr lang="en-US" smtClean="0"/>
+              <a:t>10/17/16</a:t>
+            </a:fld>
+            <a:endParaRPr lang="en-US"/>
+          </a:p>
+        </p:txBody>
+      </p:sp>
+      <p:sp>
+        <p:nvSpPr>
+          <p:cNvPr id="4" name="Slide Image Placeholder 3"/>
+          <p:cNvSpPr>
+            <a:spLocks noGrp="1" noRot="1" noChangeAspect="1"/>
+          </p:cNvSpPr>
+          <p:nvPr>
+            <p:ph type="sldImg" idx="2"/>
+          </p:nvPr>
+        </p:nvSpPr>
+        <p:spPr>
+          <a:xfrm>
+            <a:off x="1143000" y="685800"/>
+            <a:ext cx="4572000" cy="3429000"/>
+          </a:xfrm>
+          <a:prstGeom prst="rect">
+            <a:avLst/>
+          </a:prstGeom>
+          <a:noFill/>
+          <a:ln w="12700">
+            <a:solidFill>
+              <a:prstClr val="black"/>
+            </a:solidFill>
+          </a:ln>
+        </p:spPr>
+        <p:txBody>
+          <a:bodyPr vert="horz" lIns="91440" tIns="45720" rIns="91440" bIns="45720" rtlCol="0" anchor="ctr"/>
+          <a:lstStyle/>
+          <a:p>
+            <a:endParaRPr lang="en-US"/>
+          </a:p>
+        </p:txBody>
+      </p:sp>
+      <p:sp>
+        <p:nvSpPr>
+          <p:cNvPr id="5" name="Notes Placeholder 4"/>
+          <p:cNvSpPr>
+            <a:spLocks noGrp="1"/>
+          </p:cNvSpPr>
+          <p:nvPr>
+            <p:ph type="body" sz="quarter" idx="3"/>
+          </p:nvPr>
+        </p:nvSpPr>
+        <p:spPr>
+          <a:xfrm>
+            <a:off x="685800" y="4343400"/>
+            <a:ext cx="5486400" cy="4114800"/>
+          </a:xfrm>
+          <a:prstGeom prst="rect">
+            <a:avLst/>
+          </a:prstGeom>
+        </p:spPr>
+        <p:txBody>
+          <a:bodyPr vert="horz" lIns="91440" tIns="45720" rIns="91440" bIns="45720" rtlCol="0"/>
+          <a:lstStyle/>
+          <a:p>
+            <a:pPr lvl="0"/>
+            <a:r>
+              <a:rPr lang="en-US" smtClean="0"/>
+              <a:t>Click to edit Master text styles</a:t>
+            </a:r>
+          </a:p>
+          <a:p>
+            <a:pPr lvl="1"/>
+            <a:r>
+              <a:rPr lang="en-US" smtClean="0"/>
+              <a:t>Second level</a:t>
+            </a:r>
+          </a:p>
+          <a:p>
+            <a:pPr lvl="2"/>
+            <a:r>
+              <a:rPr lang="en-US" smtClean="0"/>
+              <a:t>Third level</a:t>
+            </a:r>
+          </a:p>
+          <a:p>
+            <a:pPr lvl="3"/>
+            <a:r>
+              <a:rPr lang="en-US" smtClean="0"/>
+              <a:t>Fourth level</a:t>
+            </a:r>
+          </a:p>
+          <a:p>
+            <a:pPr lvl="4"/>
+            <a:r>
+              <a:rPr lang="en-US" smtClean="0"/>
+              <a:t>Fifth level</a:t>
+            </a:r>
+            <a:endParaRPr lang="en-US"/>
+          </a:p>
+        </p:txBody>
+      </p:sp>
+      <p:sp>
+        <p:nvSpPr>
+          <p:cNvPr id="6" name="Footer Placeholder 5"/>
+          <p:cNvSpPr>
+            <a:spLocks noGrp="1"/>
+          </p:cNvSpPr>
+          <p:nvPr>
+            <p:ph type="ftr" sz="quarter" idx="4"/>
+          </p:nvPr>
+        </p:nvSpPr>
+        <p:spPr>
+          <a:xfrm>
+            <a:off x="0" y="8685213"/>
+            <a:ext cx="2971800" cy="457200"/>
+          </a:xfrm>
+          <a:prstGeom prst="rect">
+            <a:avLst/>
+          </a:prstGeom>
+        </p:spPr>
+        <p:txBody>
+          <a:bodyPr vert="horz" lIns="91440" tIns="45720" rIns="91440" bIns="45720" rtlCol="0" anchor="b"/>
+          <a:lstStyle>
+            <a:lvl1pPr algn="l">
+              <a:defRPr sz="1200"/>
+            </a:lvl1pPr>
+          </a:lstStyle>
+          <a:p>
+            <a:endParaRPr lang="en-US"/>
+          </a:p>
+        </p:txBody>
+      </p:sp>
+      <p:sp>
+        <p:nvSpPr>
+          <p:cNvPr id="7" name="Slide Number Placeholder 6"/>
+          <p:cNvSpPr>
+            <a:spLocks noGrp="1"/>
+          </p:cNvSpPr>
+          <p:nvPr>
+            <p:ph type="sldNum" sz="quarter" idx="5"/>
+          </p:nvPr>
+        </p:nvSpPr>
+        <p:spPr>
+          <a:xfrm>
+            <a:off x="3884613" y="8685213"/>
+            <a:ext cx="2971800" cy="457200"/>
+          </a:xfrm>
+          <a:prstGeom prst="rect">
+            <a:avLst/>
+          </a:prstGeom>
+        </p:spPr>
+        <p:txBody>
+          <a:bodyPr vert="horz" lIns="91440" tIns="45720" rIns="91440" bIns="45720" rtlCol="0" anchor="b"/>
+          <a:lstStyle>
+            <a:lvl1pPr algn="r">
+              <a:defRPr sz="1200"/>
+            </a:lvl1pPr>
+          </a:lstStyle>
+          <a:p>
+            <a:fld id="{BB5E49A5-4136-284D-997B-48E1D791AD67}" type="slidenum">
+              <a:rPr lang="en-US" smtClean="0"/>
+              <a:t>‹#›</a:t>
+            </a:fld>
+            <a:endParaRPr lang="en-US"/>
+          </a:p>
+        </p:txBody>
+      </p:sp>
     </p:spTree>
     <p:extLst>
       <p:ext uri="{BB962C8B-B14F-4D97-AF65-F5344CB8AC3E}">
-        <p14:creationId xmlns:p14="http://schemas.microsoft.com/office/powerpoint/2010/main" val="1639267416"/>
+        <p14:creationId xmlns:p14="http://schemas.microsoft.com/office/powerpoint/2010/main" val="2623252185"/>
       </p:ext>
     </p:extLst>
   </p:cSld>
   <p:clrMap bg1="lt1" tx1="dk1" bg2="lt2" tx2="dk2" accent1="accent1" accent2="accent2" accent3="accent3" accent4="accent4" accent5="accent5" accent6="accent6" hlink="hlink" folHlink="folHlink"/>
   <p:notesStyle>
-    <a:lvl1pPr marL="0" algn="l" defTabSz="914400" rtl="0" eaLnBrk="1" latinLnBrk="0" hangingPunct="1">
+    <a:lvl1pPr marL="0" algn="l" defTabSz="457200" rtl="0" eaLnBrk="1" latinLnBrk="0" hangingPunct="1">
       <a:defRPr sz="1200" kern="1200">
         <a:solidFill>
           <a:schemeClr val="tx1"/>
@@ -199,7 +405,7 @@
         <a:cs typeface="+mn-cs"/>
       </a:defRPr>
     </a:lvl1pPr>
-    <a:lvl2pPr marL="457200" algn="l" defTabSz="914400" rtl="0" eaLnBrk="1" latinLnBrk="0" hangingPunct="1">
+    <a:lvl2pPr marL="457200" algn="l" defTabSz="457200" rtl="0" eaLnBrk="1" latinLnBrk="0" hangingPunct="1">
       <a:defRPr sz="1200" kern="1200">
         <a:solidFill>
           <a:schemeClr val="tx1"/>
@@ -209,7 +415,7 @@
         <a:cs typeface="+mn-cs"/>
       </a:defRPr>
     </a:lvl2pPr>
-    <a:lvl3pPr marL="914400" algn="l" defTabSz="914400" rtl="0" eaLnBrk="1" latinLnBrk="0" hangingPunct="1">
+    <a:lvl3pPr marL="914400" algn="l" defTabSz="457200" rtl="0" eaLnBrk="1" latinLnBrk="0" hangingPunct="1">
       <a:defRPr sz="1200" kern="1200">
         <a:solidFill>
           <a:schemeClr val="tx1"/>
@@ -219,7 +425,7 @@
         <a:cs typeface="+mn-cs"/>
       </a:defRPr>
     </a:lvl3pPr>
-    <a:lvl4pPr marL="1371600" algn="l" defTabSz="914400" rtl="0" eaLnBrk="1" latinLnBrk="0" hangingPunct="1">
+    <a:lvl4pPr marL="1371600" algn="l" defTabSz="457200" rtl="0" eaLnBrk="1" latinLnBrk="0" hangingPunct="1">
       <a:defRPr sz="1200" kern="1200">
         <a:solidFill>
           <a:schemeClr val="tx1"/>
@@ -229,7 +435,7 @@
         <a:cs typeface="+mn-cs"/>
       </a:defRPr>
     </a:lvl4pPr>
-    <a:lvl5pPr marL="1828800" algn="l" defTabSz="914400" rtl="0" eaLnBrk="1" latinLnBrk="0" hangingPunct="1">
+    <a:lvl5pPr marL="1828800" algn="l" defTabSz="457200" rtl="0" eaLnBrk="1" latinLnBrk="0" hangingPunct="1">
       <a:defRPr sz="1200" kern="1200">
         <a:solidFill>
           <a:schemeClr val="tx1"/>
@@ -239,7 +445,7 @@
         <a:cs typeface="+mn-cs"/>
       </a:defRPr>
     </a:lvl5pPr>
-    <a:lvl6pPr marL="2286000" algn="l" defTabSz="914400" rtl="0" eaLnBrk="1" latinLnBrk="0" hangingPunct="1">
+    <a:lvl6pPr marL="2286000" algn="l" defTabSz="457200" rtl="0" eaLnBrk="1" latinLnBrk="0" hangingPunct="1">
       <a:defRPr sz="1200" kern="1200">
         <a:solidFill>
           <a:schemeClr val="tx1"/>
@@ -249,7 +455,7 @@
         <a:cs typeface="+mn-cs"/>
       </a:defRPr>
     </a:lvl6pPr>
-    <a:lvl7pPr marL="2743200" algn="l" defTabSz="914400" rtl="0" eaLnBrk="1" latinLnBrk="0" hangingPunct="1">
+    <a:lvl7pPr marL="2743200" algn="l" defTabSz="457200" rtl="0" eaLnBrk="1" latinLnBrk="0" hangingPunct="1">
       <a:defRPr sz="1200" kern="1200">
         <a:solidFill>
           <a:schemeClr val="tx1"/>
@@ -259,7 +465,7 @@
         <a:cs typeface="+mn-cs"/>
       </a:defRPr>
     </a:lvl7pPr>
-    <a:lvl8pPr marL="3200400" algn="l" defTabSz="914400" rtl="0" eaLnBrk="1" latinLnBrk="0" hangingPunct="1">
+    <a:lvl8pPr marL="3200400" algn="l" defTabSz="457200" rtl="0" eaLnBrk="1" latinLnBrk="0" hangingPunct="1">
       <a:defRPr sz="1200" kern="1200">
         <a:solidFill>
           <a:schemeClr val="tx1"/>
@@ -269,7 +475,7 @@
         <a:cs typeface="+mn-cs"/>
       </a:defRPr>
     </a:lvl8pPr>
-    <a:lvl9pPr marL="3657600" algn="l" defTabSz="914400" rtl="0" eaLnBrk="1" latinLnBrk="0" hangingPunct="1">
+    <a:lvl9pPr marL="3657600" algn="l" defTabSz="457200" rtl="0" eaLnBrk="1" latinLnBrk="0" hangingPunct="1">
       <a:defRPr sz="1200" kern="1200">
         <a:solidFill>
           <a:schemeClr val="tx1"/>
@@ -284,7 +490,7 @@
 </file>
 
 <file path=ppt/notesSlides/notesSlide1.xml><?xml version="1.0" encoding="utf-8"?>
-<p:notes xmlns:a="http://schemas.openxmlformats.org/drawingml/2006/main" xmlns:r="http://schemas.openxmlformats.org/officeDocument/2006/relationships" xmlns:p="http://schemas.openxmlformats.org/presentationml/2006/main">
+<p:notes xmlns:a="http://schemas.openxmlformats.org/drawingml/2006/main" xmlns:p="http://schemas.openxmlformats.org/presentationml/2006/main" xmlns:r="http://schemas.openxmlformats.org/officeDocument/2006/relationships">
   <p:cSld>
     <p:spTree>
       <p:nvGrpSpPr>
@@ -304,7 +510,7 @@
         <p:nvSpPr>
           <p:cNvPr id="2" name="Slide Image Placeholder 1"/>
           <p:cNvSpPr>
-            <a:spLocks noGrp="1" noRot="1" noChangeAspect="1"/>
+            <a:spLocks noGrp="1"/>
           </p:cNvSpPr>
           <p:nvPr>
             <p:ph type="sldImg" idx="2"/>
@@ -319,7 +525,7 @@
             <a:spLocks noGrp="1"/>
           </p:cNvSpPr>
           <p:nvPr>
-            <p:ph type="body" sz="quarter" idx="3"/>
+            <p:ph type="body" idx="3" sz="quarter"/>
           </p:nvPr>
         </p:nvSpPr>
         <p:spPr/>
@@ -340,7 +546,7 @@
             <a:spLocks noGrp="1"/>
           </p:cNvSpPr>
           <p:nvPr>
-            <p:ph type="sldNum" sz="quarter" idx="5"/>
+            <p:ph type="sldNum" idx="5" sz="quarter"/>
           </p:nvPr>
         </p:nvSpPr>
         <p:spPr/>
@@ -354,7 +560,7 @@
 </file>
 
 <file path=ppt/notesSlides/notesSlide10.xml><?xml version="1.0" encoding="utf-8"?>
-<p:notes xmlns:a="http://schemas.openxmlformats.org/drawingml/2006/main" xmlns:r="http://schemas.openxmlformats.org/officeDocument/2006/relationships" xmlns:p="http://schemas.openxmlformats.org/presentationml/2006/main">
+<p:notes xmlns:a="http://schemas.openxmlformats.org/drawingml/2006/main" xmlns:p="http://schemas.openxmlformats.org/presentationml/2006/main" xmlns:r="http://schemas.openxmlformats.org/officeDocument/2006/relationships">
   <p:cSld>
     <p:spTree>
       <p:nvGrpSpPr>
@@ -374,7 +580,7 @@
         <p:nvSpPr>
           <p:cNvPr id="2" name="Slide Image Placeholder 1"/>
           <p:cNvSpPr>
-            <a:spLocks noGrp="1" noRot="1" noChangeAspect="1"/>
+            <a:spLocks noGrp="1"/>
           </p:cNvSpPr>
           <p:nvPr>
             <p:ph type="sldImg" idx="2"/>
@@ -389,7 +595,7 @@
             <a:spLocks noGrp="1"/>
           </p:cNvSpPr>
           <p:nvPr>
-            <p:ph type="body" sz="quarter" idx="3"/>
+            <p:ph type="body" idx="3" sz="quarter"/>
           </p:nvPr>
         </p:nvSpPr>
         <p:spPr/>
@@ -410,7 +616,7 @@
             <a:spLocks noGrp="1"/>
           </p:cNvSpPr>
           <p:nvPr>
-            <p:ph type="sldNum" sz="quarter" idx="5"/>
+            <p:ph type="sldNum" idx="5" sz="quarter"/>
           </p:nvPr>
         </p:nvSpPr>
         <p:spPr/>
@@ -424,7 +630,7 @@
 </file>
 
 <file path=ppt/notesSlides/notesSlide11.xml><?xml version="1.0" encoding="utf-8"?>
-<p:notes xmlns:a="http://schemas.openxmlformats.org/drawingml/2006/main" xmlns:r="http://schemas.openxmlformats.org/officeDocument/2006/relationships" xmlns:p="http://schemas.openxmlformats.org/presentationml/2006/main">
+<p:notes xmlns:a="http://schemas.openxmlformats.org/drawingml/2006/main" xmlns:p="http://schemas.openxmlformats.org/presentationml/2006/main" xmlns:r="http://schemas.openxmlformats.org/officeDocument/2006/relationships">
   <p:cSld>
     <p:spTree>
       <p:nvGrpSpPr>
@@ -444,7 +650,7 @@
         <p:nvSpPr>
           <p:cNvPr id="2" name="Slide Image Placeholder 1"/>
           <p:cNvSpPr>
-            <a:spLocks noGrp="1" noRot="1" noChangeAspect="1"/>
+            <a:spLocks noGrp="1"/>
           </p:cNvSpPr>
           <p:nvPr>
             <p:ph type="sldImg" idx="2"/>
@@ -459,7 +665,7 @@
             <a:spLocks noGrp="1"/>
           </p:cNvSpPr>
           <p:nvPr>
-            <p:ph type="body" sz="quarter" idx="3"/>
+            <p:ph type="body" idx="3" sz="quarter"/>
           </p:nvPr>
         </p:nvSpPr>
         <p:spPr/>
@@ -480,7 +686,7 @@
             <a:spLocks noGrp="1"/>
           </p:cNvSpPr>
           <p:nvPr>
-            <p:ph type="sldNum" sz="quarter" idx="5"/>
+            <p:ph type="sldNum" idx="5" sz="quarter"/>
           </p:nvPr>
         </p:nvSpPr>
         <p:spPr/>
@@ -494,7 +700,7 @@
 </file>
 
 <file path=ppt/notesSlides/notesSlide12.xml><?xml version="1.0" encoding="utf-8"?>
-<p:notes xmlns:a="http://schemas.openxmlformats.org/drawingml/2006/main" xmlns:r="http://schemas.openxmlformats.org/officeDocument/2006/relationships" xmlns:p="http://schemas.openxmlformats.org/presentationml/2006/main">
+<p:notes xmlns:a="http://schemas.openxmlformats.org/drawingml/2006/main" xmlns:p="http://schemas.openxmlformats.org/presentationml/2006/main" xmlns:r="http://schemas.openxmlformats.org/officeDocument/2006/relationships">
   <p:cSld>
     <p:spTree>
       <p:nvGrpSpPr>
@@ -514,7 +720,7 @@
         <p:nvSpPr>
           <p:cNvPr id="2" name="Slide Image Placeholder 1"/>
           <p:cNvSpPr>
-            <a:spLocks noGrp="1" noRot="1" noChangeAspect="1"/>
+            <a:spLocks noGrp="1"/>
           </p:cNvSpPr>
           <p:nvPr>
             <p:ph type="sldImg" idx="2"/>
@@ -529,7 +735,7 @@
             <a:spLocks noGrp="1"/>
           </p:cNvSpPr>
           <p:nvPr>
-            <p:ph type="body" sz="quarter" idx="3"/>
+            <p:ph type="body" idx="3" sz="quarter"/>
           </p:nvPr>
         </p:nvSpPr>
         <p:spPr/>
@@ -550,7 +756,7 @@
             <a:spLocks noGrp="1"/>
           </p:cNvSpPr>
           <p:nvPr>
-            <p:ph type="sldNum" sz="quarter" idx="5"/>
+            <p:ph type="sldNum" idx="5" sz="quarter"/>
           </p:nvPr>
         </p:nvSpPr>
         <p:spPr/>
@@ -564,7 +770,7 @@
 </file>
 
 <file path=ppt/notesSlides/notesSlide13.xml><?xml version="1.0" encoding="utf-8"?>
-<p:notes xmlns:a="http://schemas.openxmlformats.org/drawingml/2006/main" xmlns:r="http://schemas.openxmlformats.org/officeDocument/2006/relationships" xmlns:p="http://schemas.openxmlformats.org/presentationml/2006/main">
+<p:notes xmlns:a="http://schemas.openxmlformats.org/drawingml/2006/main" xmlns:p="http://schemas.openxmlformats.org/presentationml/2006/main" xmlns:r="http://schemas.openxmlformats.org/officeDocument/2006/relationships">
   <p:cSld>
     <p:spTree>
       <p:nvGrpSpPr>
@@ -584,7 +790,7 @@
         <p:nvSpPr>
           <p:cNvPr id="2" name="Slide Image Placeholder 1"/>
           <p:cNvSpPr>
-            <a:spLocks noGrp="1" noRot="1" noChangeAspect="1"/>
+            <a:spLocks noGrp="1"/>
           </p:cNvSpPr>
           <p:nvPr>
             <p:ph type="sldImg" idx="2"/>
@@ -599,7 +805,7 @@
             <a:spLocks noGrp="1"/>
           </p:cNvSpPr>
           <p:nvPr>
-            <p:ph type="body" sz="quarter" idx="3"/>
+            <p:ph type="body" idx="3" sz="quarter"/>
           </p:nvPr>
         </p:nvSpPr>
         <p:spPr/>
@@ -608,7 +814,7 @@
           <a:lstStyle/>
           <a:p>
             <a:r>
-              <a:t>我故意把兩個教訓放最上面、數字壓下面,因為這張的價值不在那兩個成績,而在它釣出來的兩個問題,這兩個問題決定了後面整條路。先對齊畫面:這張結構圖是 MaskedMDN,對應下面那個 1.37 的版本,別跟純 MLP 的 1.30 搞混。第一版神經網路只小贏 KNN 一點點,從 1.57 到 1.30,差不多就是查表跟一個普通回歸器的差距,但它讓兩個獨立問題浮出來。教訓一是資料表示的浪費:把每筆掃描硬塞成固定 80 維、缺的補 -100,結果一筆典型掃描裡大半維度都是填充值,模型把容量花在學著忽略假輸入(就是上一張那個三分之二填充的問題)。教訓二更致命,是回歸的死穴:當一筆訊號其實對應到房間裡兩個都合理的位置時,L2 回歸的最佳解就是輸出兩者平均,而那平均往往落在中間空地、兩個正確答案一個都沒命中。我們本想用 MDN 混合高斯輸出讓模型同時表達好幾個可能位置,結果 1.37 還比單純 MLP 的 1.30 差——這個反直覺結果證明光換輸出頭不能真正解掉多峰,還得靠後面在地圖網格上分類。所以接下來順序是:下一張先正面討論為什麼要預測分布而不是單點,再解表示問題,最後回來用網格分類把平均問題算總帳。常見追問:那 MDN 不就白做了?沒有,它讓我們確認問題出在輸出空間的幾何、而不是模型不夠大,這個診斷直接省下後面亂加參數的彎路。</a:t>
+              <a:t>這張的價值不在成績,而在它釣出來的兩個問題,這兩個問題決定後面整條路。先把數字講清楚,因為很容易混:純 MLP 回歸 1.30,純 MDN(混合高斯)1.26 — MDN 確實小贏 MLP 一點點,但兩個都只比 KNN 的 1.57 好大約一成七,而且彼此幾乎沒差。我們又把 -100 填充遮掉做了 Masked 版本(MaskedMLP、MaskedMDN 都落在 1.37),結果不但沒變好反而更差 — 下面那張結構圖畫的就是 MaskedMDN 這個嘗試,請注意它對應的是 1.37,不要跟純 MLP 的 1.30 或純 MDN 的 1.26 搞混。所以結論很清楚:在「固定向量 + 點/混合輸出」這個框架裡,換頭、加遮罩、調深度,都只在 1.3 附近原地打轉。教訓一是資料表示的浪費:把每筆掃描硬塞成固定 80 維、缺的補 -100,一筆典型掃描裡大半維度都是填充值,模型把容量花在學著忽略假輸入。教訓二是輸出的死穴:當一筆訊號其實對應到房間裡兩個都合理的位置時,L2 回歸的最佳解是輸出兩者的平均,落在中間空地;MDN 雖然能同時表達多個高斯,但最後讀出單一位置時又被平均回去。這兩個問題,分別由下一段的 Set Transformer(換掉表示)和再後面的熱度圖分類(換掉輸出)各解掉一個。記住這兩個教訓,後面每一步都是在還這兩筆債。</a:t>
             </a:r>
           </a:p>
         </p:txBody>
@@ -620,7 +826,7 @@
             <a:spLocks noGrp="1"/>
           </p:cNvSpPr>
           <p:nvPr>
-            <p:ph type="sldNum" sz="quarter" idx="5"/>
+            <p:ph type="sldNum" idx="5" sz="quarter"/>
           </p:nvPr>
         </p:nvSpPr>
         <p:spPr/>
@@ -634,7 +840,7 @@
 </file>
 
 <file path=ppt/notesSlides/notesSlide14.xml><?xml version="1.0" encoding="utf-8"?>
-<p:notes xmlns:a="http://schemas.openxmlformats.org/drawingml/2006/main" xmlns:r="http://schemas.openxmlformats.org/officeDocument/2006/relationships" xmlns:p="http://schemas.openxmlformats.org/presentationml/2006/main">
+<p:notes xmlns:a="http://schemas.openxmlformats.org/drawingml/2006/main" xmlns:p="http://schemas.openxmlformats.org/presentationml/2006/main" xmlns:r="http://schemas.openxmlformats.org/officeDocument/2006/relationships">
   <p:cSld>
     <p:spTree>
       <p:nvGrpSpPr>
@@ -654,7 +860,7 @@
         <p:nvSpPr>
           <p:cNvPr id="2" name="Slide Image Placeholder 1"/>
           <p:cNvSpPr>
-            <a:spLocks noGrp="1" noRot="1" noChangeAspect="1"/>
+            <a:spLocks noGrp="1"/>
           </p:cNvSpPr>
           <p:nvPr>
             <p:ph type="sldImg" idx="2"/>
@@ -669,7 +875,7 @@
             <a:spLocks noGrp="1"/>
           </p:cNvSpPr>
           <p:nvPr>
-            <p:ph type="body" sz="quarter" idx="3"/>
+            <p:ph type="body" idx="3" sz="quarter"/>
           </p:nvPr>
         </p:nvSpPr>
         <p:spPr/>
@@ -690,7 +896,7 @@
             <a:spLocks noGrp="1"/>
           </p:cNvSpPr>
           <p:nvPr>
-            <p:ph type="sldNum" sz="quarter" idx="5"/>
+            <p:ph type="sldNum" idx="5" sz="quarter"/>
           </p:nvPr>
         </p:nvSpPr>
         <p:spPr/>
@@ -704,7 +910,7 @@
 </file>
 
 <file path=ppt/notesSlides/notesSlide15.xml><?xml version="1.0" encoding="utf-8"?>
-<p:notes xmlns:a="http://schemas.openxmlformats.org/drawingml/2006/main" xmlns:r="http://schemas.openxmlformats.org/officeDocument/2006/relationships" xmlns:p="http://schemas.openxmlformats.org/presentationml/2006/main">
+<p:notes xmlns:a="http://schemas.openxmlformats.org/drawingml/2006/main" xmlns:p="http://schemas.openxmlformats.org/presentationml/2006/main" xmlns:r="http://schemas.openxmlformats.org/officeDocument/2006/relationships">
   <p:cSld>
     <p:spTree>
       <p:nvGrpSpPr>
@@ -724,7 +930,7 @@
         <p:nvSpPr>
           <p:cNvPr id="2" name="Slide Image Placeholder 1"/>
           <p:cNvSpPr>
-            <a:spLocks noGrp="1" noRot="1" noChangeAspect="1"/>
+            <a:spLocks noGrp="1"/>
           </p:cNvSpPr>
           <p:nvPr>
             <p:ph type="sldImg" idx="2"/>
@@ -739,7 +945,7 @@
             <a:spLocks noGrp="1"/>
           </p:cNvSpPr>
           <p:nvPr>
-            <p:ph type="body" sz="quarter" idx="3"/>
+            <p:ph type="body" idx="3" sz="quarter"/>
           </p:nvPr>
         </p:nvSpPr>
         <p:spPr/>
@@ -760,7 +966,7 @@
             <a:spLocks noGrp="1"/>
           </p:cNvSpPr>
           <p:nvPr>
-            <p:ph type="sldNum" sz="quarter" idx="5"/>
+            <p:ph type="sldNum" idx="5" sz="quarter"/>
           </p:nvPr>
         </p:nvSpPr>
         <p:spPr/>
@@ -774,7 +980,7 @@
 </file>
 
 <file path=ppt/notesSlides/notesSlide16.xml><?xml version="1.0" encoding="utf-8"?>
-<p:notes xmlns:a="http://schemas.openxmlformats.org/drawingml/2006/main" xmlns:r="http://schemas.openxmlformats.org/officeDocument/2006/relationships" xmlns:p="http://schemas.openxmlformats.org/presentationml/2006/main">
+<p:notes xmlns:a="http://schemas.openxmlformats.org/drawingml/2006/main" xmlns:p="http://schemas.openxmlformats.org/presentationml/2006/main" xmlns:r="http://schemas.openxmlformats.org/officeDocument/2006/relationships">
   <p:cSld>
     <p:spTree>
       <p:nvGrpSpPr>
@@ -794,7 +1000,7 @@
         <p:nvSpPr>
           <p:cNvPr id="2" name="Slide Image Placeholder 1"/>
           <p:cNvSpPr>
-            <a:spLocks noGrp="1" noRot="1" noChangeAspect="1"/>
+            <a:spLocks noGrp="1"/>
           </p:cNvSpPr>
           <p:nvPr>
             <p:ph type="sldImg" idx="2"/>
@@ -809,7 +1015,7 @@
             <a:spLocks noGrp="1"/>
           </p:cNvSpPr>
           <p:nvPr>
-            <p:ph type="body" sz="quarter" idx="3"/>
+            <p:ph type="body" idx="3" sz="quarter"/>
           </p:nvPr>
         </p:nvSpPr>
         <p:spPr/>
@@ -830,7 +1036,7 @@
             <a:spLocks noGrp="1"/>
           </p:cNvSpPr>
           <p:nvPr>
-            <p:ph type="sldNum" sz="quarter" idx="5"/>
+            <p:ph type="sldNum" idx="5" sz="quarter"/>
           </p:nvPr>
         </p:nvSpPr>
         <p:spPr/>
@@ -844,7 +1050,7 @@
 </file>
 
 <file path=ppt/notesSlides/notesSlide17.xml><?xml version="1.0" encoding="utf-8"?>
-<p:notes xmlns:a="http://schemas.openxmlformats.org/drawingml/2006/main" xmlns:r="http://schemas.openxmlformats.org/officeDocument/2006/relationships" xmlns:p="http://schemas.openxmlformats.org/presentationml/2006/main">
+<p:notes xmlns:a="http://schemas.openxmlformats.org/drawingml/2006/main" xmlns:p="http://schemas.openxmlformats.org/presentationml/2006/main" xmlns:r="http://schemas.openxmlformats.org/officeDocument/2006/relationships">
   <p:cSld>
     <p:spTree>
       <p:nvGrpSpPr>
@@ -864,7 +1070,7 @@
         <p:nvSpPr>
           <p:cNvPr id="2" name="Slide Image Placeholder 1"/>
           <p:cNvSpPr>
-            <a:spLocks noGrp="1" noRot="1" noChangeAspect="1"/>
+            <a:spLocks noGrp="1"/>
           </p:cNvSpPr>
           <p:nvPr>
             <p:ph type="sldImg" idx="2"/>
@@ -879,7 +1085,7 @@
             <a:spLocks noGrp="1"/>
           </p:cNvSpPr>
           <p:nvPr>
-            <p:ph type="body" sz="quarter" idx="3"/>
+            <p:ph type="body" idx="3" sz="quarter"/>
           </p:nvPr>
         </p:nvSpPr>
         <p:spPr/>
@@ -900,7 +1106,7 @@
             <a:spLocks noGrp="1"/>
           </p:cNvSpPr>
           <p:nvPr>
-            <p:ph type="sldNum" sz="quarter" idx="5"/>
+            <p:ph type="sldNum" idx="5" sz="quarter"/>
           </p:nvPr>
         </p:nvSpPr>
         <p:spPr/>
@@ -914,7 +1120,7 @@
 </file>
 
 <file path=ppt/notesSlides/notesSlide18.xml><?xml version="1.0" encoding="utf-8"?>
-<p:notes xmlns:a="http://schemas.openxmlformats.org/drawingml/2006/main" xmlns:r="http://schemas.openxmlformats.org/officeDocument/2006/relationships" xmlns:p="http://schemas.openxmlformats.org/presentationml/2006/main">
+<p:notes xmlns:a="http://schemas.openxmlformats.org/drawingml/2006/main" xmlns:p="http://schemas.openxmlformats.org/presentationml/2006/main" xmlns:r="http://schemas.openxmlformats.org/officeDocument/2006/relationships">
   <p:cSld>
     <p:spTree>
       <p:nvGrpSpPr>
@@ -934,7 +1140,7 @@
         <p:nvSpPr>
           <p:cNvPr id="2" name="Slide Image Placeholder 1"/>
           <p:cNvSpPr>
-            <a:spLocks noGrp="1" noRot="1" noChangeAspect="1"/>
+            <a:spLocks noGrp="1"/>
           </p:cNvSpPr>
           <p:nvPr>
             <p:ph type="sldImg" idx="2"/>
@@ -949,7 +1155,7 @@
             <a:spLocks noGrp="1"/>
           </p:cNvSpPr>
           <p:nvPr>
-            <p:ph type="body" sz="quarter" idx="3"/>
+            <p:ph type="body" idx="3" sz="quarter"/>
           </p:nvPr>
         </p:nvSpPr>
         <p:spPr/>
@@ -970,7 +1176,7 @@
             <a:spLocks noGrp="1"/>
           </p:cNvSpPr>
           <p:nvPr>
-            <p:ph type="sldNum" sz="quarter" idx="5"/>
+            <p:ph type="sldNum" idx="5" sz="quarter"/>
           </p:nvPr>
         </p:nvSpPr>
         <p:spPr/>
@@ -984,7 +1190,7 @@
 </file>
 
 <file path=ppt/notesSlides/notesSlide19.xml><?xml version="1.0" encoding="utf-8"?>
-<p:notes xmlns:a="http://schemas.openxmlformats.org/drawingml/2006/main" xmlns:r="http://schemas.openxmlformats.org/officeDocument/2006/relationships" xmlns:p="http://schemas.openxmlformats.org/presentationml/2006/main">
+<p:notes xmlns:a="http://schemas.openxmlformats.org/drawingml/2006/main" xmlns:p="http://schemas.openxmlformats.org/presentationml/2006/main" xmlns:r="http://schemas.openxmlformats.org/officeDocument/2006/relationships">
   <p:cSld>
     <p:spTree>
       <p:nvGrpSpPr>
@@ -1004,7 +1210,7 @@
         <p:nvSpPr>
           <p:cNvPr id="2" name="Slide Image Placeholder 1"/>
           <p:cNvSpPr>
-            <a:spLocks noGrp="1" noRot="1" noChangeAspect="1"/>
+            <a:spLocks noGrp="1"/>
           </p:cNvSpPr>
           <p:nvPr>
             <p:ph type="sldImg" idx="2"/>
@@ -1019,7 +1225,7 @@
             <a:spLocks noGrp="1"/>
           </p:cNvSpPr>
           <p:nvPr>
-            <p:ph type="body" sz="quarter" idx="3"/>
+            <p:ph type="body" idx="3" sz="quarter"/>
           </p:nvPr>
         </p:nvSpPr>
         <p:spPr/>
@@ -1040,7 +1246,7 @@
             <a:spLocks noGrp="1"/>
           </p:cNvSpPr>
           <p:nvPr>
-            <p:ph type="sldNum" sz="quarter" idx="5"/>
+            <p:ph type="sldNum" idx="5" sz="quarter"/>
           </p:nvPr>
         </p:nvSpPr>
         <p:spPr/>
@@ -1054,7 +1260,7 @@
 </file>
 
 <file path=ppt/notesSlides/notesSlide2.xml><?xml version="1.0" encoding="utf-8"?>
-<p:notes xmlns:a="http://schemas.openxmlformats.org/drawingml/2006/main" xmlns:r="http://schemas.openxmlformats.org/officeDocument/2006/relationships" xmlns:p="http://schemas.openxmlformats.org/presentationml/2006/main">
+<p:notes xmlns:a="http://schemas.openxmlformats.org/drawingml/2006/main" xmlns:p="http://schemas.openxmlformats.org/presentationml/2006/main" xmlns:r="http://schemas.openxmlformats.org/officeDocument/2006/relationships">
   <p:cSld>
     <p:spTree>
       <p:nvGrpSpPr>
@@ -1074,7 +1280,7 @@
         <p:nvSpPr>
           <p:cNvPr id="2" name="Slide Image Placeholder 1"/>
           <p:cNvSpPr>
-            <a:spLocks noGrp="1" noRot="1" noChangeAspect="1"/>
+            <a:spLocks noGrp="1"/>
           </p:cNvSpPr>
           <p:nvPr>
             <p:ph type="sldImg" idx="2"/>
@@ -1089,7 +1295,7 @@
             <a:spLocks noGrp="1"/>
           </p:cNvSpPr>
           <p:nvPr>
-            <p:ph type="body" sz="quarter" idx="3"/>
+            <p:ph type="body" idx="3" sz="quarter"/>
           </p:nvPr>
         </p:nvSpPr>
         <p:spPr/>
@@ -1110,7 +1316,7 @@
             <a:spLocks noGrp="1"/>
           </p:cNvSpPr>
           <p:nvPr>
-            <p:ph type="sldNum" sz="quarter" idx="5"/>
+            <p:ph type="sldNum" idx="5" sz="quarter"/>
           </p:nvPr>
         </p:nvSpPr>
         <p:spPr/>
@@ -1124,7 +1330,7 @@
 </file>
 
 <file path=ppt/notesSlides/notesSlide20.xml><?xml version="1.0" encoding="utf-8"?>
-<p:notes xmlns:a="http://schemas.openxmlformats.org/drawingml/2006/main" xmlns:r="http://schemas.openxmlformats.org/officeDocument/2006/relationships" xmlns:p="http://schemas.openxmlformats.org/presentationml/2006/main">
+<p:notes xmlns:a="http://schemas.openxmlformats.org/drawingml/2006/main" xmlns:p="http://schemas.openxmlformats.org/presentationml/2006/main" xmlns:r="http://schemas.openxmlformats.org/officeDocument/2006/relationships">
   <p:cSld>
     <p:spTree>
       <p:nvGrpSpPr>
@@ -1144,7 +1350,7 @@
         <p:nvSpPr>
           <p:cNvPr id="2" name="Slide Image Placeholder 1"/>
           <p:cNvSpPr>
-            <a:spLocks noGrp="1" noRot="1" noChangeAspect="1"/>
+            <a:spLocks noGrp="1"/>
           </p:cNvSpPr>
           <p:nvPr>
             <p:ph type="sldImg" idx="2"/>
@@ -1159,7 +1365,7 @@
             <a:spLocks noGrp="1"/>
           </p:cNvSpPr>
           <p:nvPr>
-            <p:ph type="body" sz="quarter" idx="3"/>
+            <p:ph type="body" idx="3" sz="quarter"/>
           </p:nvPr>
         </p:nvSpPr>
         <p:spPr/>
@@ -1180,7 +1386,7 @@
             <a:spLocks noGrp="1"/>
           </p:cNvSpPr>
           <p:nvPr>
-            <p:ph type="sldNum" sz="quarter" idx="5"/>
+            <p:ph type="sldNum" idx="5" sz="quarter"/>
           </p:nvPr>
         </p:nvSpPr>
         <p:spPr/>
@@ -1194,7 +1400,7 @@
 </file>
 
 <file path=ppt/notesSlides/notesSlide21.xml><?xml version="1.0" encoding="utf-8"?>
-<p:notes xmlns:a="http://schemas.openxmlformats.org/drawingml/2006/main" xmlns:r="http://schemas.openxmlformats.org/officeDocument/2006/relationships" xmlns:p="http://schemas.openxmlformats.org/presentationml/2006/main">
+<p:notes xmlns:a="http://schemas.openxmlformats.org/drawingml/2006/main" xmlns:p="http://schemas.openxmlformats.org/presentationml/2006/main" xmlns:r="http://schemas.openxmlformats.org/officeDocument/2006/relationships">
   <p:cSld>
     <p:spTree>
       <p:nvGrpSpPr>
@@ -1214,7 +1420,7 @@
         <p:nvSpPr>
           <p:cNvPr id="2" name="Slide Image Placeholder 1"/>
           <p:cNvSpPr>
-            <a:spLocks noGrp="1" noRot="1" noChangeAspect="1"/>
+            <a:spLocks noGrp="1"/>
           </p:cNvSpPr>
           <p:nvPr>
             <p:ph type="sldImg" idx="2"/>
@@ -1229,7 +1435,7 @@
             <a:spLocks noGrp="1"/>
           </p:cNvSpPr>
           <p:nvPr>
-            <p:ph type="body" sz="quarter" idx="3"/>
+            <p:ph type="body" idx="3" sz="quarter"/>
           </p:nvPr>
         </p:nvSpPr>
         <p:spPr/>
@@ -1250,7 +1456,7 @@
             <a:spLocks noGrp="1"/>
           </p:cNvSpPr>
           <p:nvPr>
-            <p:ph type="sldNum" sz="quarter" idx="5"/>
+            <p:ph type="sldNum" idx="5" sz="quarter"/>
           </p:nvPr>
         </p:nvSpPr>
         <p:spPr/>
@@ -1264,7 +1470,7 @@
 </file>
 
 <file path=ppt/notesSlides/notesSlide22.xml><?xml version="1.0" encoding="utf-8"?>
-<p:notes xmlns:a="http://schemas.openxmlformats.org/drawingml/2006/main" xmlns:r="http://schemas.openxmlformats.org/officeDocument/2006/relationships" xmlns:p="http://schemas.openxmlformats.org/presentationml/2006/main">
+<p:notes xmlns:a="http://schemas.openxmlformats.org/drawingml/2006/main" xmlns:p="http://schemas.openxmlformats.org/presentationml/2006/main" xmlns:r="http://schemas.openxmlformats.org/officeDocument/2006/relationships">
   <p:cSld>
     <p:spTree>
       <p:nvGrpSpPr>
@@ -1284,7 +1490,7 @@
         <p:nvSpPr>
           <p:cNvPr id="2" name="Slide Image Placeholder 1"/>
           <p:cNvSpPr>
-            <a:spLocks noGrp="1" noRot="1" noChangeAspect="1"/>
+            <a:spLocks noGrp="1"/>
           </p:cNvSpPr>
           <p:nvPr>
             <p:ph type="sldImg" idx="2"/>
@@ -1299,7 +1505,7 @@
             <a:spLocks noGrp="1"/>
           </p:cNvSpPr>
           <p:nvPr>
-            <p:ph type="body" sz="quarter" idx="3"/>
+            <p:ph type="body" idx="3" sz="quarter"/>
           </p:nvPr>
         </p:nvSpPr>
         <p:spPr/>
@@ -1320,7 +1526,7 @@
             <a:spLocks noGrp="1"/>
           </p:cNvSpPr>
           <p:nvPr>
-            <p:ph type="sldNum" sz="quarter" idx="5"/>
+            <p:ph type="sldNum" idx="5" sz="quarter"/>
           </p:nvPr>
         </p:nvSpPr>
         <p:spPr/>
@@ -1334,7 +1540,7 @@
 </file>
 
 <file path=ppt/notesSlides/notesSlide23.xml><?xml version="1.0" encoding="utf-8"?>
-<p:notes xmlns:a="http://schemas.openxmlformats.org/drawingml/2006/main" xmlns:r="http://schemas.openxmlformats.org/officeDocument/2006/relationships" xmlns:p="http://schemas.openxmlformats.org/presentationml/2006/main">
+<p:notes xmlns:a="http://schemas.openxmlformats.org/drawingml/2006/main" xmlns:p="http://schemas.openxmlformats.org/presentationml/2006/main" xmlns:r="http://schemas.openxmlformats.org/officeDocument/2006/relationships">
   <p:cSld>
     <p:spTree>
       <p:nvGrpSpPr>
@@ -1354,7 +1560,7 @@
         <p:nvSpPr>
           <p:cNvPr id="2" name="Slide Image Placeholder 1"/>
           <p:cNvSpPr>
-            <a:spLocks noGrp="1" noRot="1" noChangeAspect="1"/>
+            <a:spLocks noGrp="1"/>
           </p:cNvSpPr>
           <p:nvPr>
             <p:ph type="sldImg" idx="2"/>
@@ -1369,7 +1575,7 @@
             <a:spLocks noGrp="1"/>
           </p:cNvSpPr>
           <p:nvPr>
-            <p:ph type="body" sz="quarter" idx="3"/>
+            <p:ph type="body" idx="3" sz="quarter"/>
           </p:nvPr>
         </p:nvSpPr>
         <p:spPr/>
@@ -1390,7 +1596,7 @@
             <a:spLocks noGrp="1"/>
           </p:cNvSpPr>
           <p:nvPr>
-            <p:ph type="sldNum" sz="quarter" idx="5"/>
+            <p:ph type="sldNum" idx="5" sz="quarter"/>
           </p:nvPr>
         </p:nvSpPr>
         <p:spPr/>
@@ -1404,7 +1610,7 @@
 </file>
 
 <file path=ppt/notesSlides/notesSlide24.xml><?xml version="1.0" encoding="utf-8"?>
-<p:notes xmlns:a="http://schemas.openxmlformats.org/drawingml/2006/main" xmlns:r="http://schemas.openxmlformats.org/officeDocument/2006/relationships" xmlns:p="http://schemas.openxmlformats.org/presentationml/2006/main">
+<p:notes xmlns:a="http://schemas.openxmlformats.org/drawingml/2006/main" xmlns:p="http://schemas.openxmlformats.org/presentationml/2006/main" xmlns:r="http://schemas.openxmlformats.org/officeDocument/2006/relationships">
   <p:cSld>
     <p:spTree>
       <p:nvGrpSpPr>
@@ -1424,7 +1630,7 @@
         <p:nvSpPr>
           <p:cNvPr id="2" name="Slide Image Placeholder 1"/>
           <p:cNvSpPr>
-            <a:spLocks noGrp="1" noRot="1" noChangeAspect="1"/>
+            <a:spLocks noGrp="1"/>
           </p:cNvSpPr>
           <p:nvPr>
             <p:ph type="sldImg" idx="2"/>
@@ -1439,7 +1645,7 @@
             <a:spLocks noGrp="1"/>
           </p:cNvSpPr>
           <p:nvPr>
-            <p:ph type="body" sz="quarter" idx="3"/>
+            <p:ph type="body" idx="3" sz="quarter"/>
           </p:nvPr>
         </p:nvSpPr>
         <p:spPr/>
@@ -1460,7 +1666,7 @@
             <a:spLocks noGrp="1"/>
           </p:cNvSpPr>
           <p:nvPr>
-            <p:ph type="sldNum" sz="quarter" idx="5"/>
+            <p:ph type="sldNum" idx="5" sz="quarter"/>
           </p:nvPr>
         </p:nvSpPr>
         <p:spPr/>
@@ -1474,7 +1680,7 @@
 </file>
 
 <file path=ppt/notesSlides/notesSlide25.xml><?xml version="1.0" encoding="utf-8"?>
-<p:notes xmlns:a="http://schemas.openxmlformats.org/drawingml/2006/main" xmlns:r="http://schemas.openxmlformats.org/officeDocument/2006/relationships" xmlns:p="http://schemas.openxmlformats.org/presentationml/2006/main">
+<p:notes xmlns:a="http://schemas.openxmlformats.org/drawingml/2006/main" xmlns:p="http://schemas.openxmlformats.org/presentationml/2006/main" xmlns:r="http://schemas.openxmlformats.org/officeDocument/2006/relationships">
   <p:cSld>
     <p:spTree>
       <p:nvGrpSpPr>
@@ -1494,7 +1700,7 @@
         <p:nvSpPr>
           <p:cNvPr id="2" name="Slide Image Placeholder 1"/>
           <p:cNvSpPr>
-            <a:spLocks noGrp="1" noRot="1" noChangeAspect="1"/>
+            <a:spLocks noGrp="1"/>
           </p:cNvSpPr>
           <p:nvPr>
             <p:ph type="sldImg" idx="2"/>
@@ -1509,7 +1715,7 @@
             <a:spLocks noGrp="1"/>
           </p:cNvSpPr>
           <p:nvPr>
-            <p:ph type="body" sz="quarter" idx="3"/>
+            <p:ph type="body" idx="3" sz="quarter"/>
           </p:nvPr>
         </p:nvSpPr>
         <p:spPr/>
@@ -1518,7 +1724,7 @@
           <a:lstStyle/>
           <a:p>
             <a:r>
-              <a:t>兌現前面 splits 那張的承諾——把每種切法的數字真正給出來,我特意把它放在講完 cascade、看過完整爬坡之後,這樣大家已經知道 cascade 是什麼,這些數字才有意義。先把但書放最前面,這是這張的關鍵:只有 A_random 的 0.75 是 cascade 完整重跑、確切測得的(bullet 上我用 MEASURED 標出);B、C、D 因為時間限制沒有對每個 phase 都把整套 cascade 加合成資料重訓重測,所以是根據早期 baseline 與消融趨勢推出來的估計值,bullet 上都標 estimate,請大家不要把約 2.3 當成精確結果引用——這正是這份報告一致的口徑。趨勢本身很清楚也很合理:A 約 0.75;同時段的 B 約 0.85,只比 A 略差;涵蓋早晚的部署情境 D 約 0.90,難一點;而跨時段的 C 一口氣跳到約 2.3,差一個量級。這個落差不是模型爛,而是訊號本身在幾小時內漂掉了,模型訓練時根本沒看過晚上的分布。畫面這張合成資料的消融長條圖正好佐證:合成資料在 A 帶來大進步,但在 C 反而從約 1.73 微升到約 1.81——因為合成資料補的是空間覆蓋、解不了時間漂移。結論一句:同時段我們做得很好且有實測背書,跨時段是這份工作唯一沒解掉、也明白承認的弱點,解法(IMU、時序融合、晚場資料)留到結論。預期會被問:為什麼不現在把 C 也重跑出精確值?坦白說是算力與時間取捨,我們把有限資源投在把主線 A 做到最嚴格的驗證;與其給四個都不完整的精確數字,不如給一個紮實的主數字加三個標註清楚的估計。</a:t>
+              <a:t>這張補上 splits 那頁承諾、卻一直沒給的數字,也回應老師對嚴謹度的要求。重點:現在 A 和 D 都是 cascade-aggressive 五種子完整重跑、確切測得的,不是估計——A_random 中位數 0.752、D_stratified 0.807,兩個都是同分布切法。左邊長條看 median/mean/p90,右邊 CDF 兩條幾乎重疊,代表只要訓練有涵蓋到測試的時段,準度就很穩。D 比 A 略高一點點(0.807 對 0.752),是因為 D 的測試集刻意按比例放進晚上的點,晚上本來就比較難,但因為訓練也看過晚上,所以只差 0.05、沒有崩。B_morning 和 C 我還沒對每個 phase 重跑,給的是早期 baseline 推得的估計、會標清楚是估計:B 同時段約 0.85,C 早訓晚測約 2.3。最關鍵的對比:A、D 這種同分布切法都壓在 0.8 公尺上下,C 卻一跳到 2.3——空間覆蓋我們解得很好,跨時段是唯一沒解掉的開放問題,留到結論談未來方向。預期被問:D 為什麼要按時段分層?它模擬真實部署——指紋庫已在不同時段都採過點;跟 A 純隨機的差別是 D 保證訓練和測試都含早晚。</a:t>
             </a:r>
           </a:p>
         </p:txBody>
@@ -1530,7 +1736,7 @@
             <a:spLocks noGrp="1"/>
           </p:cNvSpPr>
           <p:nvPr>
-            <p:ph type="sldNum" sz="quarter" idx="5"/>
+            <p:ph type="sldNum" idx="5" sz="quarter"/>
           </p:nvPr>
         </p:nvSpPr>
         <p:spPr/>
@@ -1544,7 +1750,7 @@
 </file>
 
 <file path=ppt/notesSlides/notesSlide26.xml><?xml version="1.0" encoding="utf-8"?>
-<p:notes xmlns:a="http://schemas.openxmlformats.org/drawingml/2006/main" xmlns:r="http://schemas.openxmlformats.org/officeDocument/2006/relationships" xmlns:p="http://schemas.openxmlformats.org/presentationml/2006/main">
+<p:notes xmlns:a="http://schemas.openxmlformats.org/drawingml/2006/main" xmlns:p="http://schemas.openxmlformats.org/presentationml/2006/main" xmlns:r="http://schemas.openxmlformats.org/officeDocument/2006/relationships">
   <p:cSld>
     <p:spTree>
       <p:nvGrpSpPr>
@@ -1564,7 +1770,7 @@
         <p:nvSpPr>
           <p:cNvPr id="2" name="Slide Image Placeholder 1"/>
           <p:cNvSpPr>
-            <a:spLocks noGrp="1" noRot="1" noChangeAspect="1"/>
+            <a:spLocks noGrp="1"/>
           </p:cNvSpPr>
           <p:nvPr>
             <p:ph type="sldImg" idx="2"/>
@@ -1579,7 +1785,7 @@
             <a:spLocks noGrp="1"/>
           </p:cNvSpPr>
           <p:nvPr>
-            <p:ph type="body" sz="quarter" idx="3"/>
+            <p:ph type="body" idx="3" sz="quarter"/>
           </p:nvPr>
         </p:nvSpPr>
         <p:spPr/>
@@ -1600,7 +1806,7 @@
             <a:spLocks noGrp="1"/>
           </p:cNvSpPr>
           <p:nvPr>
-            <p:ph type="sldNum" sz="quarter" idx="5"/>
+            <p:ph type="sldNum" idx="5" sz="quarter"/>
           </p:nvPr>
         </p:nvSpPr>
         <p:spPr/>
@@ -1614,7 +1820,7 @@
 </file>
 
 <file path=ppt/notesSlides/notesSlide27.xml><?xml version="1.0" encoding="utf-8"?>
-<p:notes xmlns:a="http://schemas.openxmlformats.org/drawingml/2006/main" xmlns:r="http://schemas.openxmlformats.org/officeDocument/2006/relationships" xmlns:p="http://schemas.openxmlformats.org/presentationml/2006/main">
+<p:notes xmlns:a="http://schemas.openxmlformats.org/drawingml/2006/main" xmlns:p="http://schemas.openxmlformats.org/presentationml/2006/main" xmlns:r="http://schemas.openxmlformats.org/officeDocument/2006/relationships">
   <p:cSld>
     <p:spTree>
       <p:nvGrpSpPr>
@@ -1634,7 +1840,7 @@
         <p:nvSpPr>
           <p:cNvPr id="2" name="Slide Image Placeholder 1"/>
           <p:cNvSpPr>
-            <a:spLocks noGrp="1" noRot="1" noChangeAspect="1"/>
+            <a:spLocks noGrp="1"/>
           </p:cNvSpPr>
           <p:nvPr>
             <p:ph type="sldImg" idx="2"/>
@@ -1649,7 +1855,7 @@
             <a:spLocks noGrp="1"/>
           </p:cNvSpPr>
           <p:nvPr>
-            <p:ph type="body" sz="quarter" idx="3"/>
+            <p:ph type="body" idx="3" sz="quarter"/>
           </p:nvPr>
         </p:nvSpPr>
         <p:spPr/>
@@ -1670,7 +1876,7 @@
             <a:spLocks noGrp="1"/>
           </p:cNvSpPr>
           <p:nvPr>
-            <p:ph type="sldNum" sz="quarter" idx="5"/>
+            <p:ph type="sldNum" idx="5" sz="quarter"/>
           </p:nvPr>
         </p:nvSpPr>
         <p:spPr/>
@@ -1684,7 +1890,7 @@
 </file>
 
 <file path=ppt/notesSlides/notesSlide28.xml><?xml version="1.0" encoding="utf-8"?>
-<p:notes xmlns:a="http://schemas.openxmlformats.org/drawingml/2006/main" xmlns:r="http://schemas.openxmlformats.org/officeDocument/2006/relationships" xmlns:p="http://schemas.openxmlformats.org/presentationml/2006/main">
+<p:notes xmlns:a="http://schemas.openxmlformats.org/drawingml/2006/main" xmlns:p="http://schemas.openxmlformats.org/presentationml/2006/main" xmlns:r="http://schemas.openxmlformats.org/officeDocument/2006/relationships">
   <p:cSld>
     <p:spTree>
       <p:nvGrpSpPr>
@@ -1704,7 +1910,7 @@
         <p:nvSpPr>
           <p:cNvPr id="2" name="Slide Image Placeholder 1"/>
           <p:cNvSpPr>
-            <a:spLocks noGrp="1" noRot="1" noChangeAspect="1"/>
+            <a:spLocks noGrp="1"/>
           </p:cNvSpPr>
           <p:nvPr>
             <p:ph type="sldImg" idx="2"/>
@@ -1719,7 +1925,7 @@
             <a:spLocks noGrp="1"/>
           </p:cNvSpPr>
           <p:nvPr>
-            <p:ph type="body" sz="quarter" idx="3"/>
+            <p:ph type="body" idx="3" sz="quarter"/>
           </p:nvPr>
         </p:nvSpPr>
         <p:spPr/>
@@ -1740,7 +1946,7 @@
             <a:spLocks noGrp="1"/>
           </p:cNvSpPr>
           <p:nvPr>
-            <p:ph type="sldNum" sz="quarter" idx="5"/>
+            <p:ph type="sldNum" idx="5" sz="quarter"/>
           </p:nvPr>
         </p:nvSpPr>
         <p:spPr/>
@@ -1754,7 +1960,7 @@
 </file>
 
 <file path=ppt/notesSlides/notesSlide29.xml><?xml version="1.0" encoding="utf-8"?>
-<p:notes xmlns:a="http://schemas.openxmlformats.org/drawingml/2006/main" xmlns:r="http://schemas.openxmlformats.org/officeDocument/2006/relationships" xmlns:p="http://schemas.openxmlformats.org/presentationml/2006/main">
+<p:notes xmlns:a="http://schemas.openxmlformats.org/drawingml/2006/main" xmlns:p="http://schemas.openxmlformats.org/presentationml/2006/main" xmlns:r="http://schemas.openxmlformats.org/officeDocument/2006/relationships">
   <p:cSld>
     <p:spTree>
       <p:nvGrpSpPr>
@@ -1774,7 +1980,7 @@
         <p:nvSpPr>
           <p:cNvPr id="2" name="Slide Image Placeholder 1"/>
           <p:cNvSpPr>
-            <a:spLocks noGrp="1" noRot="1" noChangeAspect="1"/>
+            <a:spLocks noGrp="1"/>
           </p:cNvSpPr>
           <p:nvPr>
             <p:ph type="sldImg" idx="2"/>
@@ -1789,7 +1995,7 @@
             <a:spLocks noGrp="1"/>
           </p:cNvSpPr>
           <p:nvPr>
-            <p:ph type="body" sz="quarter" idx="3"/>
+            <p:ph type="body" idx="3" sz="quarter"/>
           </p:nvPr>
         </p:nvSpPr>
         <p:spPr/>
@@ -1810,7 +2016,7 @@
             <a:spLocks noGrp="1"/>
           </p:cNvSpPr>
           <p:nvPr>
-            <p:ph type="sldNum" sz="quarter" idx="5"/>
+            <p:ph type="sldNum" idx="5" sz="quarter"/>
           </p:nvPr>
         </p:nvSpPr>
         <p:spPr/>
@@ -1824,7 +2030,7 @@
 </file>
 
 <file path=ppt/notesSlides/notesSlide3.xml><?xml version="1.0" encoding="utf-8"?>
-<p:notes xmlns:a="http://schemas.openxmlformats.org/drawingml/2006/main" xmlns:r="http://schemas.openxmlformats.org/officeDocument/2006/relationships" xmlns:p="http://schemas.openxmlformats.org/presentationml/2006/main">
+<p:notes xmlns:a="http://schemas.openxmlformats.org/drawingml/2006/main" xmlns:p="http://schemas.openxmlformats.org/presentationml/2006/main" xmlns:r="http://schemas.openxmlformats.org/officeDocument/2006/relationships">
   <p:cSld>
     <p:spTree>
       <p:nvGrpSpPr>
@@ -1844,7 +2050,7 @@
         <p:nvSpPr>
           <p:cNvPr id="2" name="Slide Image Placeholder 1"/>
           <p:cNvSpPr>
-            <a:spLocks noGrp="1" noRot="1" noChangeAspect="1"/>
+            <a:spLocks noGrp="1"/>
           </p:cNvSpPr>
           <p:nvPr>
             <p:ph type="sldImg" idx="2"/>
@@ -1859,7 +2065,7 @@
             <a:spLocks noGrp="1"/>
           </p:cNvSpPr>
           <p:nvPr>
-            <p:ph type="body" sz="quarter" idx="3"/>
+            <p:ph type="body" idx="3" sz="quarter"/>
           </p:nvPr>
         </p:nvSpPr>
         <p:spPr/>
@@ -1880,7 +2086,7 @@
             <a:spLocks noGrp="1"/>
           </p:cNvSpPr>
           <p:nvPr>
-            <p:ph type="sldNum" sz="quarter" idx="5"/>
+            <p:ph type="sldNum" idx="5" sz="quarter"/>
           </p:nvPr>
         </p:nvSpPr>
         <p:spPr/>
@@ -1894,7 +2100,7 @@
 </file>
 
 <file path=ppt/notesSlides/notesSlide30.xml><?xml version="1.0" encoding="utf-8"?>
-<p:notes xmlns:a="http://schemas.openxmlformats.org/drawingml/2006/main" xmlns:r="http://schemas.openxmlformats.org/officeDocument/2006/relationships" xmlns:p="http://schemas.openxmlformats.org/presentationml/2006/main">
+<p:notes xmlns:a="http://schemas.openxmlformats.org/drawingml/2006/main" xmlns:p="http://schemas.openxmlformats.org/presentationml/2006/main" xmlns:r="http://schemas.openxmlformats.org/officeDocument/2006/relationships">
   <p:cSld>
     <p:spTree>
       <p:nvGrpSpPr>
@@ -1914,7 +2120,7 @@
         <p:nvSpPr>
           <p:cNvPr id="2" name="Slide Image Placeholder 1"/>
           <p:cNvSpPr>
-            <a:spLocks noGrp="1" noRot="1" noChangeAspect="1"/>
+            <a:spLocks noGrp="1"/>
           </p:cNvSpPr>
           <p:nvPr>
             <p:ph type="sldImg" idx="2"/>
@@ -1929,7 +2135,7 @@
             <a:spLocks noGrp="1"/>
           </p:cNvSpPr>
           <p:nvPr>
-            <p:ph type="body" sz="quarter" idx="3"/>
+            <p:ph type="body" idx="3" sz="quarter"/>
           </p:nvPr>
         </p:nvSpPr>
         <p:spPr/>
@@ -1950,7 +2156,7 @@
             <a:spLocks noGrp="1"/>
           </p:cNvSpPr>
           <p:nvPr>
-            <p:ph type="sldNum" sz="quarter" idx="5"/>
+            <p:ph type="sldNum" idx="5" sz="quarter"/>
           </p:nvPr>
         </p:nvSpPr>
         <p:spPr/>
@@ -1964,7 +2170,7 @@
 </file>
 
 <file path=ppt/notesSlides/notesSlide31.xml><?xml version="1.0" encoding="utf-8"?>
-<p:notes xmlns:a="http://schemas.openxmlformats.org/drawingml/2006/main" xmlns:r="http://schemas.openxmlformats.org/officeDocument/2006/relationships" xmlns:p="http://schemas.openxmlformats.org/presentationml/2006/main">
+<p:notes xmlns:a="http://schemas.openxmlformats.org/drawingml/2006/main" xmlns:p="http://schemas.openxmlformats.org/presentationml/2006/main" xmlns:r="http://schemas.openxmlformats.org/officeDocument/2006/relationships">
   <p:cSld>
     <p:spTree>
       <p:nvGrpSpPr>
@@ -1984,7 +2190,7 @@
         <p:nvSpPr>
           <p:cNvPr id="2" name="Slide Image Placeholder 1"/>
           <p:cNvSpPr>
-            <a:spLocks noGrp="1" noRot="1" noChangeAspect="1"/>
+            <a:spLocks noGrp="1"/>
           </p:cNvSpPr>
           <p:nvPr>
             <p:ph type="sldImg" idx="2"/>
@@ -1999,7 +2205,7 @@
             <a:spLocks noGrp="1"/>
           </p:cNvSpPr>
           <p:nvPr>
-            <p:ph type="body" sz="quarter" idx="3"/>
+            <p:ph type="body" idx="3" sz="quarter"/>
           </p:nvPr>
         </p:nvSpPr>
         <p:spPr/>
@@ -2020,7 +2226,7 @@
             <a:spLocks noGrp="1"/>
           </p:cNvSpPr>
           <p:nvPr>
-            <p:ph type="sldNum" sz="quarter" idx="5"/>
+            <p:ph type="sldNum" idx="5" sz="quarter"/>
           </p:nvPr>
         </p:nvSpPr>
         <p:spPr/>
@@ -2034,7 +2240,7 @@
 </file>
 
 <file path=ppt/notesSlides/notesSlide32.xml><?xml version="1.0" encoding="utf-8"?>
-<p:notes xmlns:a="http://schemas.openxmlformats.org/drawingml/2006/main" xmlns:r="http://schemas.openxmlformats.org/officeDocument/2006/relationships" xmlns:p="http://schemas.openxmlformats.org/presentationml/2006/main">
+<p:notes xmlns:a="http://schemas.openxmlformats.org/drawingml/2006/main" xmlns:p="http://schemas.openxmlformats.org/presentationml/2006/main" xmlns:r="http://schemas.openxmlformats.org/officeDocument/2006/relationships">
   <p:cSld>
     <p:spTree>
       <p:nvGrpSpPr>
@@ -2054,7 +2260,7 @@
         <p:nvSpPr>
           <p:cNvPr id="2" name="Slide Image Placeholder 1"/>
           <p:cNvSpPr>
-            <a:spLocks noGrp="1" noRot="1" noChangeAspect="1"/>
+            <a:spLocks noGrp="1"/>
           </p:cNvSpPr>
           <p:nvPr>
             <p:ph type="sldImg" idx="2"/>
@@ -2069,7 +2275,7 @@
             <a:spLocks noGrp="1"/>
           </p:cNvSpPr>
           <p:nvPr>
-            <p:ph type="body" sz="quarter" idx="3"/>
+            <p:ph type="body" idx="3" sz="quarter"/>
           </p:nvPr>
         </p:nvSpPr>
         <p:spPr/>
@@ -2090,7 +2296,7 @@
             <a:spLocks noGrp="1"/>
           </p:cNvSpPr>
           <p:nvPr>
-            <p:ph type="sldNum" sz="quarter" idx="5"/>
+            <p:ph type="sldNum" idx="5" sz="quarter"/>
           </p:nvPr>
         </p:nvSpPr>
         <p:spPr/>
@@ -2104,7 +2310,7 @@
 </file>
 
 <file path=ppt/notesSlides/notesSlide33.xml><?xml version="1.0" encoding="utf-8"?>
-<p:notes xmlns:a="http://schemas.openxmlformats.org/drawingml/2006/main" xmlns:r="http://schemas.openxmlformats.org/officeDocument/2006/relationships" xmlns:p="http://schemas.openxmlformats.org/presentationml/2006/main">
+<p:notes xmlns:a="http://schemas.openxmlformats.org/drawingml/2006/main" xmlns:p="http://schemas.openxmlformats.org/presentationml/2006/main" xmlns:r="http://schemas.openxmlformats.org/officeDocument/2006/relationships">
   <p:cSld>
     <p:spTree>
       <p:nvGrpSpPr>
@@ -2124,7 +2330,7 @@
         <p:nvSpPr>
           <p:cNvPr id="2" name="Slide Image Placeholder 1"/>
           <p:cNvSpPr>
-            <a:spLocks noGrp="1" noRot="1" noChangeAspect="1"/>
+            <a:spLocks noGrp="1"/>
           </p:cNvSpPr>
           <p:nvPr>
             <p:ph type="sldImg" idx="2"/>
@@ -2139,7 +2345,7 @@
             <a:spLocks noGrp="1"/>
           </p:cNvSpPr>
           <p:nvPr>
-            <p:ph type="body" sz="quarter" idx="3"/>
+            <p:ph type="body" idx="3" sz="quarter"/>
           </p:nvPr>
         </p:nvSpPr>
         <p:spPr/>
@@ -2148,156 +2354,7 @@
           <a:lstStyle/>
           <a:p>
             <a:r>
-              <a:rPr dirty="0" err="1"/>
-              <a:t>總結這整份報告。最直接的成果:我們把最樸素</a:t>
-            </a:r>
-            <a:r>
-              <a:rPr dirty="0"/>
-              <a:t> KNN </a:t>
-            </a:r>
-            <a:r>
-              <a:rPr dirty="0" err="1"/>
-              <a:t>基準的</a:t>
-            </a:r>
-            <a:r>
-              <a:rPr dirty="0"/>
-              <a:t> 1.57 </a:t>
-            </a:r>
-            <a:r>
-              <a:rPr dirty="0" err="1"/>
-              <a:t>公尺砍了一半,得到</a:t>
-            </a:r>
-            <a:r>
-              <a:rPr dirty="0"/>
-              <a:t> 0.752 </a:t>
-            </a:r>
-            <a:r>
-              <a:rPr dirty="0" err="1"/>
-              <a:t>公尺中位數</a:t>
-            </a:r>
-            <a:r>
-              <a:rPr dirty="0"/>
-              <a:t>(</a:t>
-            </a:r>
-            <a:r>
-              <a:rPr dirty="0" err="1"/>
-              <a:t>標準協定</a:t>
-            </a:r>
-            <a:r>
-              <a:rPr dirty="0"/>
-              <a:t>);</a:t>
-            </a:r>
-            <a:r>
-              <a:rPr dirty="0" err="1"/>
-              <a:t>在我們自己加碼的最嚴格巢狀交叉驗證下是</a:t>
-            </a:r>
-            <a:r>
-              <a:rPr dirty="0"/>
-              <a:t> 0.94——</a:t>
-            </a:r>
-            <a:r>
-              <a:rPr dirty="0" err="1"/>
-              <a:t>這兩個口徑我從第一張投影片用到最後一張、完全一致沒有矛盾,這點希望老師特別認可。我也想給一個外部尺度感:文獻上以</a:t>
-            </a:r>
-            <a:r>
-              <a:rPr dirty="0"/>
-              <a:t> RSSI </a:t>
-            </a:r>
-            <a:r>
-              <a:rPr dirty="0" err="1"/>
-              <a:t>為主、單筆掃描的室內指紋定位,典型中位誤差大多落在一兩公尺甚至更高,所以在一個只有約</a:t>
-            </a:r>
-            <a:r>
-              <a:rPr dirty="0"/>
-              <a:t> 189 </a:t>
-            </a:r>
-            <a:r>
-              <a:rPr dirty="0" err="1"/>
-              <a:t>平方公尺、標籤本身就有</a:t>
-            </a:r>
-            <a:r>
-              <a:rPr dirty="0"/>
-              <a:t> 0.3 </a:t>
-            </a:r>
-            <a:r>
-              <a:rPr dirty="0" err="1"/>
-              <a:t>公尺噪音的場域裡做到</a:t>
-            </a:r>
-            <a:r>
-              <a:rPr dirty="0"/>
-              <a:t> 0.75,是把誤差壓到接近標籤精度、屬於很有競爭力的結果。整段贏的關鍵是歸納偏置而不是容量:把掃描當集合編碼、把座標回歸改成網格分類、再加一個粗網格守門員殺掉對稱混淆的假峰——</a:t>
-            </a:r>
-            <a:r>
-              <a:rPr dirty="0" err="1"/>
-              <a:t>這三步每一步都在解前面點名過的具體難點,而且結果在真實</a:t>
-            </a:r>
-            <a:r>
-              <a:rPr dirty="0"/>
-              <a:t> ESP32 </a:t>
-            </a:r>
-            <a:r>
-              <a:rPr dirty="0" err="1"/>
-              <a:t>硬體上即時驗證過、不是只活在</a:t>
-            </a:r>
-            <a:r>
-              <a:rPr dirty="0"/>
-              <a:t> notebook </a:t>
-            </a:r>
-            <a:r>
-              <a:rPr dirty="0" err="1"/>
-              <a:t>裡。但我最想被記住的是把嚴謹的驗證當成核心成果:我們主動抓出自己</a:t>
-            </a:r>
-            <a:r>
-              <a:rPr dirty="0"/>
-              <a:t> 0.650 </a:t>
-            </a:r>
-            <a:r>
-              <a:rPr dirty="0" err="1"/>
-              <a:t>的海市蜃樓,也照實報出</a:t>
-            </a:r>
-            <a:r>
-              <a:rPr dirty="0"/>
-              <a:t> 0.94 </a:t>
-            </a:r>
-            <a:r>
-              <a:rPr dirty="0" err="1"/>
-              <a:t>的巢狀交叉驗證,寧可報一個比較高但站得住的數字,也不要一個漂亮但偷看過答案的數字。最後未來方向講實在的:真正的</a:t>
-            </a:r>
-            <a:r>
-              <a:rPr dirty="0"/>
-              <a:t> 0.6 </a:t>
-            </a:r>
-            <a:r>
-              <a:rPr dirty="0" err="1"/>
-              <a:t>出頭從目前這</a:t>
-            </a:r>
-            <a:r>
-              <a:rPr dirty="0"/>
-              <a:t> 1449 </a:t>
-            </a:r>
-            <a:r>
-              <a:rPr dirty="0" err="1"/>
-              <a:t>筆單次掃描裡拿不出來,因為誤差分析已證明那</a:t>
-            </a:r>
-            <a:r>
-              <a:rPr dirty="0"/>
-              <a:t> 16% </a:t>
-            </a:r>
-            <a:r>
-              <a:rPr dirty="0" err="1"/>
-              <a:t>是物理上不可區分的對稱混淆,這不是模型問題、是訊號問題。要突破得做三件具體的事</a:t>
-            </a:r>
-            <a:r>
-              <a:rPr dirty="0"/>
-              <a:t>——</a:t>
-            </a:r>
-            <a:r>
-              <a:rPr dirty="0" err="1"/>
-              <a:t>補上半部那塊稀疏區的覆蓋資料、加入</a:t>
-            </a:r>
-            <a:r>
-              <a:rPr dirty="0"/>
-              <a:t> IMU 或方向感測打破對稱、做時序融合把連續好幾筆掃描一起判斷。一句話收尾,也是整份報告的精神:下一步的增益在新的訊號,不在更深的網路。謝謝大家,歡迎提問。</a:t>
+              <a:t>總結這整份報告。最直接的成果:我們把最樸素 KNN 基準的 1.57 公尺砍了一半,得到 0.752 公尺中位數(標準協定);在我們自己加碼的最嚴格巢狀交叉驗證下是 0.94——這兩個口徑我從第一張投影片用到最後一張、完全一致沒有矛盾,這點希望老師特別認可。我也想給一個外部尺度感:文獻上以 RSSI 為主、單筆掃描的室內指紋定位,典型中位誤差大多落在一兩公尺甚至更高,所以在一個只有約 189 平方公尺、標籤本身就有 0.3 公尺噪音的場域裡做到 0.75,是把誤差壓到接近標籤精度、屬於很有競爭力的結果。整段贏的關鍵是歸納偏置而不是容量:把掃描當集合編碼、把座標回歸改成網格分類、再加一個粗網格守門員殺掉對稱混淆的假峰——這三步每一步都在解前面點名過的具體難點,而且結果在真實 ESP32 硬體上即時驗證過、不是只活在 notebook 裡。但我最想被記住的是把嚴謹的驗證當成核心成果:我們主動抓出自己 0.650 的海市蜃樓,也照實報出 0.94 的巢狀交叉驗證,寧可報一個比較高但站得住的數字,也不要一個漂亮但偷看過答案的數字。最後未來方向講實在的:真正的 0.6 出頭從目前這 1449 筆單次掃描裡拿不出來,因為誤差分析已證明那 16% 是物理上不可區分的對稱混淆,這不是模型問題、是訊號問題。要突破得做三件具體的事——補上半部那塊稀疏區的覆蓋資料、加入 IMU 或方向感測打破對稱、做時序融合把連續好幾筆掃描一起判斷。一句話收尾,也是整份報告的精神:下一步的增益在新的訊號,不在更深的網路。謝謝大家,歡迎提問。</a:t>
             </a:r>
           </a:p>
         </p:txBody>
@@ -2309,7 +2366,7 @@
             <a:spLocks noGrp="1"/>
           </p:cNvSpPr>
           <p:nvPr>
-            <p:ph type="sldNum" sz="quarter" idx="5"/>
+            <p:ph type="sldNum" idx="5" sz="quarter"/>
           </p:nvPr>
         </p:nvSpPr>
         <p:spPr/>
@@ -2323,7 +2380,7 @@
 </file>
 
 <file path=ppt/notesSlides/notesSlide4.xml><?xml version="1.0" encoding="utf-8"?>
-<p:notes xmlns:a="http://schemas.openxmlformats.org/drawingml/2006/main" xmlns:r="http://schemas.openxmlformats.org/officeDocument/2006/relationships" xmlns:p="http://schemas.openxmlformats.org/presentationml/2006/main">
+<p:notes xmlns:a="http://schemas.openxmlformats.org/drawingml/2006/main" xmlns:p="http://schemas.openxmlformats.org/presentationml/2006/main" xmlns:r="http://schemas.openxmlformats.org/officeDocument/2006/relationships">
   <p:cSld>
     <p:spTree>
       <p:nvGrpSpPr>
@@ -2343,7 +2400,7 @@
         <p:nvSpPr>
           <p:cNvPr id="2" name="Slide Image Placeholder 1"/>
           <p:cNvSpPr>
-            <a:spLocks noGrp="1" noRot="1" noChangeAspect="1"/>
+            <a:spLocks noGrp="1"/>
           </p:cNvSpPr>
           <p:nvPr>
             <p:ph type="sldImg" idx="2"/>
@@ -2358,7 +2415,7 @@
             <a:spLocks noGrp="1"/>
           </p:cNvSpPr>
           <p:nvPr>
-            <p:ph type="body" sz="quarter" idx="3"/>
+            <p:ph type="body" idx="3" sz="quarter"/>
           </p:nvPr>
         </p:nvSpPr>
         <p:spPr/>
@@ -2370,9 +2427,7 @@
               <a:t>把題目定清楚。輸入是一筆 WiFi 掃描,本質是一個集合:一堆 BSSID 加上各自的 RSSI 訊號強度配成對,而且關鍵是每一筆掃到的 AP 數量都不一樣,有時三四十個、有時只有十幾個。輸出是機器人在這個 189.5 平方公尺實驗室地圖上的座標,單位是公尺。先說評估口徑,後面所有數字都用同一把尺:誤差指的是預測座標到 AMCL 地面真值的歐氏距離、單位公尺,我報的都是中位數。為什麼用 WiFi?因為室內收不到 GPS,而 WiFi 訊號到處都有、現成免裝,指紋定位就是業界最經典的室內備案。</a:t>
             </a:r>
           </a:p>
-          <a:p>
-            <a:endParaRPr/>
-          </a:p>
+          <a:p/>
           <a:p>
             <a:r>
               <a:t>重點是這題為什麼難,而且是四個難點同時並存、互相疊加,後面每一步我都會回來指其中一個。第一,輸入是變動長度的無序集合,不是固定向量,這是之後改用 Set Transformer 的理由。第二,RSSI 多峰又會混淆——房間裡兩個不同地點的訊號組合可能幾乎一模一樣,也就是 ambiguous RSSI,一個輸入對到兩個合理答案,這是後面把回歸改成網格分類的理由。第三,覆蓋稀疏,資料沿著機器人走過的路徑收、不是均勻鋪滿,上半部幾乎沒走到,這是後面用高斯過程補洞的理由。第四,地面真值是 ROS AMCL 給的,本身就帶約 0.3 公尺定位噪聲,這是準度的物理天花板,意思是再強的模型也不可能系統性地比標籤本身還準。預期會被問:既然 GPS 不行,為什麼不用藍牙信標或 UWB?那些都要額外佈建硬體跟成本,而 WiFi 是環境裡免費既有的訊號,這份工作的價值正是只靠現成 WiFi 加對的模型,就把誤差壓到接近標籤精度。</a:t>
@@ -2387,7 +2442,7 @@
             <a:spLocks noGrp="1"/>
           </p:cNvSpPr>
           <p:nvPr>
-            <p:ph type="sldNum" sz="quarter" idx="5"/>
+            <p:ph type="sldNum" idx="5" sz="quarter"/>
           </p:nvPr>
         </p:nvSpPr>
         <p:spPr/>
@@ -2401,7 +2456,7 @@
 </file>
 
 <file path=ppt/notesSlides/notesSlide5.xml><?xml version="1.0" encoding="utf-8"?>
-<p:notes xmlns:a="http://schemas.openxmlformats.org/drawingml/2006/main" xmlns:r="http://schemas.openxmlformats.org/officeDocument/2006/relationships" xmlns:p="http://schemas.openxmlformats.org/presentationml/2006/main">
+<p:notes xmlns:a="http://schemas.openxmlformats.org/drawingml/2006/main" xmlns:p="http://schemas.openxmlformats.org/presentationml/2006/main" xmlns:r="http://schemas.openxmlformats.org/officeDocument/2006/relationships">
   <p:cSld>
     <p:spTree>
       <p:nvGrpSpPr>
@@ -2421,7 +2476,7 @@
         <p:nvSpPr>
           <p:cNvPr id="2" name="Slide Image Placeholder 1"/>
           <p:cNvSpPr>
-            <a:spLocks noGrp="1" noRot="1" noChangeAspect="1"/>
+            <a:spLocks noGrp="1"/>
           </p:cNvSpPr>
           <p:nvPr>
             <p:ph type="sldImg" idx="2"/>
@@ -2436,7 +2491,7 @@
             <a:spLocks noGrp="1"/>
           </p:cNvSpPr>
           <p:nvPr>
-            <p:ph type="body" sz="quarter" idx="3"/>
+            <p:ph type="body" idx="3" sz="quarter"/>
           </p:nvPr>
         </p:nvSpPr>
         <p:spPr/>
@@ -2448,9 +2503,7 @@
               <a:t>(這張是深入剖析、屬於可快可慢的彈性投影片:若時間緊,口頭講兩句『一筆掃描就是一袋無序又變長的配對,硬塞成固定向量會塞進一堆假欄位』就推進;若有時間或被問到再展開。)後面整條技術路線的第一個轉折完全建立在一筆掃描長什麼樣這件事上,值得攤開。一筆原始掃描就是一袋無序的配對,像 ap_3f 強度 -52、ap_1a 強度 -67、ap_b2 強度 -78 這樣列下去,單位 dBm,越接近零代表訊號越強、離 AP 越近,大概落在 -40 到 -90 之間。注意兩個字:無序、變長。無序是這一袋裡誰先誰後完全沒意義;變長是不同掃描裝的 AP 數量不一樣,少則十幾個、多則三四十個。</a:t>
             </a:r>
           </a:p>
-          <a:p>
-            <a:endParaRPr/>
-          </a:p>
+          <a:p/>
           <a:p>
             <a:r>
               <a:t>更麻煩的是同一個位置連續掃兩次,列出的 AP 清單都不見得一樣——有的 AP 這次剛好掃到、下次因為通道忙或訊號瞬間掉到底噪就沒列進來。所以同一地點的兩筆掃描可能長度不同、成員也略有出入,卻該對到同一個座標。核心矛盾就在這:資料天生是無序、變長、成員會抖動的集合,可是傳統 MLP 只吃固定維度、有固定欄位順序的向量。硬塞會怎樣?KNN 跟第一版 MLP 就是先固定一張 80 個 AP 的詞彙表,把掃描攤成 80 維,某 AP 沒掃到就在那一格填 -100。問題是一筆典型掃描平均只點亮 27.7 個 AP,等於約三分之二的維度都是 -100 填充,模型有三分之二的輸入是假的、在學著忽略不存在的東西,白白浪費容量。結論一句、也承先啟後:資料本來就是集合,就該用對集合的模型去處理它——這直接預告下一段把每個 AP 當 token、用 Set Transformer 的轉折。預期追問:那把 RSSI 正規化成 0 到 1、缺席填 0 不就好?那只是換個數值,集合無序跟變長兩個本質問題還在,治標不治本。</a:t>
@@ -2465,7 +2518,7 @@
             <a:spLocks noGrp="1"/>
           </p:cNvSpPr>
           <p:nvPr>
-            <p:ph type="sldNum" sz="quarter" idx="5"/>
+            <p:ph type="sldNum" idx="5" sz="quarter"/>
           </p:nvPr>
         </p:nvSpPr>
         <p:spPr/>
@@ -2479,7 +2532,7 @@
 </file>
 
 <file path=ppt/notesSlides/notesSlide6.xml><?xml version="1.0" encoding="utf-8"?>
-<p:notes xmlns:a="http://schemas.openxmlformats.org/drawingml/2006/main" xmlns:r="http://schemas.openxmlformats.org/officeDocument/2006/relationships" xmlns:p="http://schemas.openxmlformats.org/presentationml/2006/main">
+<p:notes xmlns:a="http://schemas.openxmlformats.org/drawingml/2006/main" xmlns:p="http://schemas.openxmlformats.org/presentationml/2006/main" xmlns:r="http://schemas.openxmlformats.org/officeDocument/2006/relationships">
   <p:cSld>
     <p:spTree>
       <p:nvGrpSpPr>
@@ -2499,7 +2552,7 @@
         <p:nvSpPr>
           <p:cNvPr id="2" name="Slide Image Placeholder 1"/>
           <p:cNvSpPr>
-            <a:spLocks noGrp="1" noRot="1" noChangeAspect="1"/>
+            <a:spLocks noGrp="1"/>
           </p:cNvSpPr>
           <p:nvPr>
             <p:ph type="sldImg" idx="2"/>
@@ -2514,7 +2567,7 @@
             <a:spLocks noGrp="1"/>
           </p:cNvSpPr>
           <p:nvPr>
-            <p:ph type="body" sz="quarter" idx="3"/>
+            <p:ph type="body" idx="3" sz="quarter"/>
           </p:nvPr>
         </p:nvSpPr>
         <p:spPr/>
@@ -2535,7 +2588,7 @@
             <a:spLocks noGrp="1"/>
           </p:cNvSpPr>
           <p:nvPr>
-            <p:ph type="sldNum" sz="quarter" idx="5"/>
+            <p:ph type="sldNum" idx="5" sz="quarter"/>
           </p:nvPr>
         </p:nvSpPr>
         <p:spPr/>
@@ -2549,7 +2602,7 @@
 </file>
 
 <file path=ppt/notesSlides/notesSlide7.xml><?xml version="1.0" encoding="utf-8"?>
-<p:notes xmlns:a="http://schemas.openxmlformats.org/drawingml/2006/main" xmlns:r="http://schemas.openxmlformats.org/officeDocument/2006/relationships" xmlns:p="http://schemas.openxmlformats.org/presentationml/2006/main">
+<p:notes xmlns:a="http://schemas.openxmlformats.org/drawingml/2006/main" xmlns:p="http://schemas.openxmlformats.org/presentationml/2006/main" xmlns:r="http://schemas.openxmlformats.org/officeDocument/2006/relationships">
   <p:cSld>
     <p:spTree>
       <p:nvGrpSpPr>
@@ -2569,7 +2622,7 @@
         <p:nvSpPr>
           <p:cNvPr id="2" name="Slide Image Placeholder 1"/>
           <p:cNvSpPr>
-            <a:spLocks noGrp="1" noRot="1" noChangeAspect="1"/>
+            <a:spLocks noGrp="1"/>
           </p:cNvSpPr>
           <p:nvPr>
             <p:ph type="sldImg" idx="2"/>
@@ -2584,7 +2637,7 @@
             <a:spLocks noGrp="1"/>
           </p:cNvSpPr>
           <p:nvPr>
-            <p:ph type="body" sz="quarter" idx="3"/>
+            <p:ph type="body" idx="3" sz="quarter"/>
           </p:nvPr>
         </p:nvSpPr>
         <p:spPr/>
@@ -2605,7 +2658,7 @@
             <a:spLocks noGrp="1"/>
           </p:cNvSpPr>
           <p:nvPr>
-            <p:ph type="sldNum" sz="quarter" idx="5"/>
+            <p:ph type="sldNum" idx="5" sz="quarter"/>
           </p:nvPr>
         </p:nvSpPr>
         <p:spPr/>
@@ -2619,7 +2672,7 @@
 </file>
 
 <file path=ppt/notesSlides/notesSlide8.xml><?xml version="1.0" encoding="utf-8"?>
-<p:notes xmlns:a="http://schemas.openxmlformats.org/drawingml/2006/main" xmlns:r="http://schemas.openxmlformats.org/officeDocument/2006/relationships" xmlns:p="http://schemas.openxmlformats.org/presentationml/2006/main">
+<p:notes xmlns:a="http://schemas.openxmlformats.org/drawingml/2006/main" xmlns:p="http://schemas.openxmlformats.org/presentationml/2006/main" xmlns:r="http://schemas.openxmlformats.org/officeDocument/2006/relationships">
   <p:cSld>
     <p:spTree>
       <p:nvGrpSpPr>
@@ -2639,7 +2692,7 @@
         <p:nvSpPr>
           <p:cNvPr id="2" name="Slide Image Placeholder 1"/>
           <p:cNvSpPr>
-            <a:spLocks noGrp="1" noRot="1" noChangeAspect="1"/>
+            <a:spLocks noGrp="1"/>
           </p:cNvSpPr>
           <p:nvPr>
             <p:ph type="sldImg" idx="2"/>
@@ -2654,7 +2707,7 @@
             <a:spLocks noGrp="1"/>
           </p:cNvSpPr>
           <p:nvPr>
-            <p:ph type="body" sz="quarter" idx="3"/>
+            <p:ph type="body" idx="3" sz="quarter"/>
           </p:nvPr>
         </p:nvSpPr>
         <p:spPr/>
@@ -2675,7 +2728,7 @@
             <a:spLocks noGrp="1"/>
           </p:cNvSpPr>
           <p:nvPr>
-            <p:ph type="sldNum" sz="quarter" idx="5"/>
+            <p:ph type="sldNum" idx="5" sz="quarter"/>
           </p:nvPr>
         </p:nvSpPr>
         <p:spPr/>
@@ -2689,7 +2742,7 @@
 </file>
 
 <file path=ppt/notesSlides/notesSlide9.xml><?xml version="1.0" encoding="utf-8"?>
-<p:notes xmlns:a="http://schemas.openxmlformats.org/drawingml/2006/main" xmlns:r="http://schemas.openxmlformats.org/officeDocument/2006/relationships" xmlns:p="http://schemas.openxmlformats.org/presentationml/2006/main">
+<p:notes xmlns:a="http://schemas.openxmlformats.org/drawingml/2006/main" xmlns:p="http://schemas.openxmlformats.org/presentationml/2006/main" xmlns:r="http://schemas.openxmlformats.org/officeDocument/2006/relationships">
   <p:cSld>
     <p:spTree>
       <p:nvGrpSpPr>
@@ -2709,7 +2762,7 @@
         <p:nvSpPr>
           <p:cNvPr id="2" name="Slide Image Placeholder 1"/>
           <p:cNvSpPr>
-            <a:spLocks noGrp="1" noRot="1" noChangeAspect="1"/>
+            <a:spLocks noGrp="1"/>
           </p:cNvSpPr>
           <p:nvPr>
             <p:ph type="sldImg" idx="2"/>
@@ -2724,7 +2777,7 @@
             <a:spLocks noGrp="1"/>
           </p:cNvSpPr>
           <p:nvPr>
-            <p:ph type="body" sz="quarter" idx="3"/>
+            <p:ph type="body" idx="3" sz="quarter"/>
           </p:nvPr>
         </p:nvSpPr>
         <p:spPr/>
@@ -2745,7 +2798,7 @@
             <a:spLocks noGrp="1"/>
           </p:cNvSpPr>
           <p:nvPr>
-            <p:ph type="sldNum" sz="quarter" idx="5"/>
+            <p:ph type="sldNum" idx="5" sz="quarter"/>
           </p:nvPr>
         </p:nvSpPr>
         <p:spPr/>
@@ -2796,9 +2849,10 @@
           <a:lstStyle/>
           <a:p>
             <a:r>
-              <a:rPr lang="en-US"/>
+              <a:rPr lang="en-US" smtClean="0"/>
               <a:t>Click to edit Master title style</a:t>
             </a:r>
+            <a:endParaRPr lang="en-US"/>
           </a:p>
         </p:txBody>
       </p:sp>
@@ -2914,9 +2968,10 @@
           </a:lstStyle>
           <a:p>
             <a:r>
-              <a:rPr lang="en-US"/>
+              <a:rPr lang="en-US" smtClean="0"/>
               <a:t>Click to edit Master subtitle style</a:t>
             </a:r>
+            <a:endParaRPr lang="en-US"/>
           </a:p>
         </p:txBody>
       </p:sp>
@@ -2937,7 +2992,7 @@
           <a:p>
             <a:fld id="{5BCAD085-E8A6-8845-BD4E-CB4CCA059FC4}" type="datetimeFigureOut">
               <a:rPr lang="en-US" smtClean="0"/>
-              <a:t>6/8/2026</a:t>
+              <a:t>1/27/13</a:t>
             </a:fld>
             <a:endParaRPr lang="en-US"/>
           </a:p>
@@ -3031,9 +3086,10 @@
           <a:lstStyle/>
           <a:p>
             <a:r>
-              <a:rPr lang="en-US"/>
+              <a:rPr lang="en-US" smtClean="0"/>
               <a:t>Click to edit Master title style</a:t>
             </a:r>
+            <a:endParaRPr lang="en-US"/>
           </a:p>
         </p:txBody>
       </p:sp>
@@ -3054,37 +3110,38 @@
           <a:p>
             <a:pPr lvl="0"/>
             <a:r>
-              <a:rPr lang="en-US"/>
+              <a:rPr lang="en-US" smtClean="0"/>
               <a:t>Click to edit Master text styles</a:t>
             </a:r>
           </a:p>
           <a:p>
             <a:pPr lvl="1"/>
             <a:r>
-              <a:rPr lang="en-US"/>
+              <a:rPr lang="en-US" smtClean="0"/>
               <a:t>Second level</a:t>
             </a:r>
           </a:p>
           <a:p>
             <a:pPr lvl="2"/>
             <a:r>
-              <a:rPr lang="en-US"/>
+              <a:rPr lang="en-US" smtClean="0"/>
               <a:t>Third level</a:t>
             </a:r>
           </a:p>
           <a:p>
             <a:pPr lvl="3"/>
             <a:r>
-              <a:rPr lang="en-US"/>
+              <a:rPr lang="en-US" smtClean="0"/>
               <a:t>Fourth level</a:t>
             </a:r>
           </a:p>
           <a:p>
             <a:pPr lvl="4"/>
             <a:r>
-              <a:rPr lang="en-US"/>
+              <a:rPr lang="en-US" smtClean="0"/>
               <a:t>Fifth level</a:t>
             </a:r>
+            <a:endParaRPr lang="en-US"/>
           </a:p>
         </p:txBody>
       </p:sp>
@@ -3105,7 +3162,7 @@
           <a:p>
             <a:fld id="{5BCAD085-E8A6-8845-BD4E-CB4CCA059FC4}" type="datetimeFigureOut">
               <a:rPr lang="en-US" smtClean="0"/>
-              <a:t>6/8/2026</a:t>
+              <a:t>1/27/13</a:t>
             </a:fld>
             <a:endParaRPr lang="en-US"/>
           </a:p>
@@ -3204,9 +3261,10 @@
           <a:lstStyle/>
           <a:p>
             <a:r>
-              <a:rPr lang="en-US"/>
+              <a:rPr lang="en-US" smtClean="0"/>
               <a:t>Click to edit Master title style</a:t>
             </a:r>
+            <a:endParaRPr lang="en-US"/>
           </a:p>
         </p:txBody>
       </p:sp>
@@ -3232,37 +3290,38 @@
           <a:p>
             <a:pPr lvl="0"/>
             <a:r>
-              <a:rPr lang="en-US"/>
+              <a:rPr lang="en-US" smtClean="0"/>
               <a:t>Click to edit Master text styles</a:t>
             </a:r>
           </a:p>
           <a:p>
             <a:pPr lvl="1"/>
             <a:r>
-              <a:rPr lang="en-US"/>
+              <a:rPr lang="en-US" smtClean="0"/>
               <a:t>Second level</a:t>
             </a:r>
           </a:p>
           <a:p>
             <a:pPr lvl="2"/>
             <a:r>
-              <a:rPr lang="en-US"/>
+              <a:rPr lang="en-US" smtClean="0"/>
               <a:t>Third level</a:t>
             </a:r>
           </a:p>
           <a:p>
             <a:pPr lvl="3"/>
             <a:r>
-              <a:rPr lang="en-US"/>
+              <a:rPr lang="en-US" smtClean="0"/>
               <a:t>Fourth level</a:t>
             </a:r>
           </a:p>
           <a:p>
             <a:pPr lvl="4"/>
             <a:r>
-              <a:rPr lang="en-US"/>
+              <a:rPr lang="en-US" smtClean="0"/>
               <a:t>Fifth level</a:t>
             </a:r>
+            <a:endParaRPr lang="en-US"/>
           </a:p>
         </p:txBody>
       </p:sp>
@@ -3283,7 +3342,7 @@
           <a:p>
             <a:fld id="{5BCAD085-E8A6-8845-BD4E-CB4CCA059FC4}" type="datetimeFigureOut">
               <a:rPr lang="en-US" smtClean="0"/>
-              <a:t>6/8/2026</a:t>
+              <a:t>1/27/13</a:t>
             </a:fld>
             <a:endParaRPr lang="en-US"/>
           </a:p>
@@ -3377,9 +3436,10 @@
           <a:lstStyle/>
           <a:p>
             <a:r>
-              <a:rPr lang="en-US"/>
+              <a:rPr lang="en-US" smtClean="0"/>
               <a:t>Click to edit Master title style</a:t>
             </a:r>
+            <a:endParaRPr lang="en-US"/>
           </a:p>
         </p:txBody>
       </p:sp>
@@ -3400,37 +3460,38 @@
           <a:p>
             <a:pPr lvl="0"/>
             <a:r>
-              <a:rPr lang="en-US"/>
+              <a:rPr lang="en-US" smtClean="0"/>
               <a:t>Click to edit Master text styles</a:t>
             </a:r>
           </a:p>
           <a:p>
             <a:pPr lvl="1"/>
             <a:r>
-              <a:rPr lang="en-US"/>
+              <a:rPr lang="en-US" smtClean="0"/>
               <a:t>Second level</a:t>
             </a:r>
           </a:p>
           <a:p>
             <a:pPr lvl="2"/>
             <a:r>
-              <a:rPr lang="en-US"/>
+              <a:rPr lang="en-US" smtClean="0"/>
               <a:t>Third level</a:t>
             </a:r>
           </a:p>
           <a:p>
             <a:pPr lvl="3"/>
             <a:r>
-              <a:rPr lang="en-US"/>
+              <a:rPr lang="en-US" smtClean="0"/>
               <a:t>Fourth level</a:t>
             </a:r>
           </a:p>
           <a:p>
             <a:pPr lvl="4"/>
             <a:r>
-              <a:rPr lang="en-US"/>
+              <a:rPr lang="en-US" smtClean="0"/>
               <a:t>Fifth level</a:t>
             </a:r>
+            <a:endParaRPr lang="en-US"/>
           </a:p>
         </p:txBody>
       </p:sp>
@@ -3451,7 +3512,7 @@
           <a:p>
             <a:fld id="{5BCAD085-E8A6-8845-BD4E-CB4CCA059FC4}" type="datetimeFigureOut">
               <a:rPr lang="en-US" smtClean="0"/>
-              <a:t>6/8/2026</a:t>
+              <a:t>1/27/13</a:t>
             </a:fld>
             <a:endParaRPr lang="en-US"/>
           </a:p>
@@ -3554,9 +3615,10 @@
           </a:lstStyle>
           <a:p>
             <a:r>
-              <a:rPr lang="en-US"/>
+              <a:rPr lang="en-US" smtClean="0"/>
               <a:t>Click to edit Master title style</a:t>
             </a:r>
+            <a:endParaRPr lang="en-US"/>
           </a:p>
         </p:txBody>
       </p:sp>
@@ -3673,7 +3735,7 @@
           <a:p>
             <a:pPr lvl="0"/>
             <a:r>
-              <a:rPr lang="en-US"/>
+              <a:rPr lang="en-US" smtClean="0"/>
               <a:t>Click to edit Master text styles</a:t>
             </a:r>
           </a:p>
@@ -3696,7 +3758,7 @@
           <a:p>
             <a:fld id="{5BCAD085-E8A6-8845-BD4E-CB4CCA059FC4}" type="datetimeFigureOut">
               <a:rPr lang="en-US" smtClean="0"/>
-              <a:t>6/8/2026</a:t>
+              <a:t>1/27/13</a:t>
             </a:fld>
             <a:endParaRPr lang="en-US"/>
           </a:p>
@@ -3790,9 +3852,10 @@
           <a:lstStyle/>
           <a:p>
             <a:r>
-              <a:rPr lang="en-US"/>
+              <a:rPr lang="en-US" smtClean="0"/>
               <a:t>Click to edit Master title style</a:t>
             </a:r>
+            <a:endParaRPr lang="en-US"/>
           </a:p>
         </p:txBody>
       </p:sp>
@@ -3846,37 +3909,38 @@
           <a:p>
             <a:pPr lvl="0"/>
             <a:r>
-              <a:rPr lang="en-US"/>
+              <a:rPr lang="en-US" smtClean="0"/>
               <a:t>Click to edit Master text styles</a:t>
             </a:r>
           </a:p>
           <a:p>
             <a:pPr lvl="1"/>
             <a:r>
-              <a:rPr lang="en-US"/>
+              <a:rPr lang="en-US" smtClean="0"/>
               <a:t>Second level</a:t>
             </a:r>
           </a:p>
           <a:p>
             <a:pPr lvl="2"/>
             <a:r>
-              <a:rPr lang="en-US"/>
+              <a:rPr lang="en-US" smtClean="0"/>
               <a:t>Third level</a:t>
             </a:r>
           </a:p>
           <a:p>
             <a:pPr lvl="3"/>
             <a:r>
-              <a:rPr lang="en-US"/>
+              <a:rPr lang="en-US" smtClean="0"/>
               <a:t>Fourth level</a:t>
             </a:r>
           </a:p>
           <a:p>
             <a:pPr lvl="4"/>
             <a:r>
-              <a:rPr lang="en-US"/>
+              <a:rPr lang="en-US" smtClean="0"/>
               <a:t>Fifth level</a:t>
             </a:r>
+            <a:endParaRPr lang="en-US"/>
           </a:p>
         </p:txBody>
       </p:sp>
@@ -3930,37 +3994,38 @@
           <a:p>
             <a:pPr lvl="0"/>
             <a:r>
-              <a:rPr lang="en-US"/>
+              <a:rPr lang="en-US" smtClean="0"/>
               <a:t>Click to edit Master text styles</a:t>
             </a:r>
           </a:p>
           <a:p>
             <a:pPr lvl="1"/>
             <a:r>
-              <a:rPr lang="en-US"/>
+              <a:rPr lang="en-US" smtClean="0"/>
               <a:t>Second level</a:t>
             </a:r>
           </a:p>
           <a:p>
             <a:pPr lvl="2"/>
             <a:r>
-              <a:rPr lang="en-US"/>
+              <a:rPr lang="en-US" smtClean="0"/>
               <a:t>Third level</a:t>
             </a:r>
           </a:p>
           <a:p>
             <a:pPr lvl="3"/>
             <a:r>
-              <a:rPr lang="en-US"/>
+              <a:rPr lang="en-US" smtClean="0"/>
               <a:t>Fourth level</a:t>
             </a:r>
           </a:p>
           <a:p>
             <a:pPr lvl="4"/>
             <a:r>
-              <a:rPr lang="en-US"/>
+              <a:rPr lang="en-US" smtClean="0"/>
               <a:t>Fifth level</a:t>
             </a:r>
+            <a:endParaRPr lang="en-US"/>
           </a:p>
         </p:txBody>
       </p:sp>
@@ -3981,7 +4046,7 @@
           <a:p>
             <a:fld id="{5BCAD085-E8A6-8845-BD4E-CB4CCA059FC4}" type="datetimeFigureOut">
               <a:rPr lang="en-US" smtClean="0"/>
-              <a:t>6/8/2026</a:t>
+              <a:t>1/27/13</a:t>
             </a:fld>
             <a:endParaRPr lang="en-US"/>
           </a:p>
@@ -4079,9 +4144,10 @@
           </a:lstStyle>
           <a:p>
             <a:r>
-              <a:rPr lang="en-US"/>
+              <a:rPr lang="en-US" smtClean="0"/>
               <a:t>Click to edit Master title style</a:t>
             </a:r>
+            <a:endParaRPr lang="en-US"/>
           </a:p>
         </p:txBody>
       </p:sp>
@@ -4144,7 +4210,7 @@
           <a:p>
             <a:pPr lvl="0"/>
             <a:r>
-              <a:rPr lang="en-US"/>
+              <a:rPr lang="en-US" smtClean="0"/>
               <a:t>Click to edit Master text styles</a:t>
             </a:r>
           </a:p>
@@ -4200,37 +4266,38 @@
           <a:p>
             <a:pPr lvl="0"/>
             <a:r>
-              <a:rPr lang="en-US"/>
+              <a:rPr lang="en-US" smtClean="0"/>
               <a:t>Click to edit Master text styles</a:t>
             </a:r>
           </a:p>
           <a:p>
             <a:pPr lvl="1"/>
             <a:r>
-              <a:rPr lang="en-US"/>
+              <a:rPr lang="en-US" smtClean="0"/>
               <a:t>Second level</a:t>
             </a:r>
           </a:p>
           <a:p>
             <a:pPr lvl="2"/>
             <a:r>
-              <a:rPr lang="en-US"/>
+              <a:rPr lang="en-US" smtClean="0"/>
               <a:t>Third level</a:t>
             </a:r>
           </a:p>
           <a:p>
             <a:pPr lvl="3"/>
             <a:r>
-              <a:rPr lang="en-US"/>
+              <a:rPr lang="en-US" smtClean="0"/>
               <a:t>Fourth level</a:t>
             </a:r>
           </a:p>
           <a:p>
             <a:pPr lvl="4"/>
             <a:r>
-              <a:rPr lang="en-US"/>
+              <a:rPr lang="en-US" smtClean="0"/>
               <a:t>Fifth level</a:t>
             </a:r>
+            <a:endParaRPr lang="en-US"/>
           </a:p>
         </p:txBody>
       </p:sp>
@@ -4293,7 +4360,7 @@
           <a:p>
             <a:pPr lvl="0"/>
             <a:r>
-              <a:rPr lang="en-US"/>
+              <a:rPr lang="en-US" smtClean="0"/>
               <a:t>Click to edit Master text styles</a:t>
             </a:r>
           </a:p>
@@ -4349,37 +4416,38 @@
           <a:p>
             <a:pPr lvl="0"/>
             <a:r>
-              <a:rPr lang="en-US"/>
+              <a:rPr lang="en-US" smtClean="0"/>
               <a:t>Click to edit Master text styles</a:t>
             </a:r>
           </a:p>
           <a:p>
             <a:pPr lvl="1"/>
             <a:r>
-              <a:rPr lang="en-US"/>
+              <a:rPr lang="en-US" smtClean="0"/>
               <a:t>Second level</a:t>
             </a:r>
           </a:p>
           <a:p>
             <a:pPr lvl="2"/>
             <a:r>
-              <a:rPr lang="en-US"/>
+              <a:rPr lang="en-US" smtClean="0"/>
               <a:t>Third level</a:t>
             </a:r>
           </a:p>
           <a:p>
             <a:pPr lvl="3"/>
             <a:r>
-              <a:rPr lang="en-US"/>
+              <a:rPr lang="en-US" smtClean="0"/>
               <a:t>Fourth level</a:t>
             </a:r>
           </a:p>
           <a:p>
             <a:pPr lvl="4"/>
             <a:r>
-              <a:rPr lang="en-US"/>
+              <a:rPr lang="en-US" smtClean="0"/>
               <a:t>Fifth level</a:t>
             </a:r>
+            <a:endParaRPr lang="en-US"/>
           </a:p>
         </p:txBody>
       </p:sp>
@@ -4400,7 +4468,7 @@
           <a:p>
             <a:fld id="{5BCAD085-E8A6-8845-BD4E-CB4CCA059FC4}" type="datetimeFigureOut">
               <a:rPr lang="en-US" smtClean="0"/>
-              <a:t>6/8/2026</a:t>
+              <a:t>1/27/13</a:t>
             </a:fld>
             <a:endParaRPr lang="en-US"/>
           </a:p>
@@ -4494,9 +4562,10 @@
           <a:lstStyle/>
           <a:p>
             <a:r>
-              <a:rPr lang="en-US"/>
+              <a:rPr lang="en-US" smtClean="0"/>
               <a:t>Click to edit Master title style</a:t>
             </a:r>
+            <a:endParaRPr lang="en-US"/>
           </a:p>
         </p:txBody>
       </p:sp>
@@ -4517,7 +4586,7 @@
           <a:p>
             <a:fld id="{5BCAD085-E8A6-8845-BD4E-CB4CCA059FC4}" type="datetimeFigureOut">
               <a:rPr lang="en-US" smtClean="0"/>
-              <a:t>6/8/2026</a:t>
+              <a:t>1/27/13</a:t>
             </a:fld>
             <a:endParaRPr lang="en-US"/>
           </a:p>
@@ -4612,7 +4681,7 @@
           <a:p>
             <a:fld id="{5BCAD085-E8A6-8845-BD4E-CB4CCA059FC4}" type="datetimeFigureOut">
               <a:rPr lang="en-US" smtClean="0"/>
-              <a:t>6/8/2026</a:t>
+              <a:t>1/27/13</a:t>
             </a:fld>
             <a:endParaRPr lang="en-US"/>
           </a:p>
@@ -4715,9 +4784,10 @@
           </a:lstStyle>
           <a:p>
             <a:r>
-              <a:rPr lang="en-US"/>
+              <a:rPr lang="en-US" smtClean="0"/>
               <a:t>Click to edit Master title style</a:t>
             </a:r>
+            <a:endParaRPr lang="en-US"/>
           </a:p>
         </p:txBody>
       </p:sp>
@@ -4771,37 +4841,38 @@
           <a:p>
             <a:pPr lvl="0"/>
             <a:r>
-              <a:rPr lang="en-US"/>
+              <a:rPr lang="en-US" smtClean="0"/>
               <a:t>Click to edit Master text styles</a:t>
             </a:r>
           </a:p>
           <a:p>
             <a:pPr lvl="1"/>
             <a:r>
-              <a:rPr lang="en-US"/>
+              <a:rPr lang="en-US" smtClean="0"/>
               <a:t>Second level</a:t>
             </a:r>
           </a:p>
           <a:p>
             <a:pPr lvl="2"/>
             <a:r>
-              <a:rPr lang="en-US"/>
+              <a:rPr lang="en-US" smtClean="0"/>
               <a:t>Third level</a:t>
             </a:r>
           </a:p>
           <a:p>
             <a:pPr lvl="3"/>
             <a:r>
-              <a:rPr lang="en-US"/>
+              <a:rPr lang="en-US" smtClean="0"/>
               <a:t>Fourth level</a:t>
             </a:r>
           </a:p>
           <a:p>
             <a:pPr lvl="4"/>
             <a:r>
-              <a:rPr lang="en-US"/>
+              <a:rPr lang="en-US" smtClean="0"/>
               <a:t>Fifth level</a:t>
             </a:r>
+            <a:endParaRPr lang="en-US"/>
           </a:p>
         </p:txBody>
       </p:sp>
@@ -4864,7 +4935,7 @@
           <a:p>
             <a:pPr lvl="0"/>
             <a:r>
-              <a:rPr lang="en-US"/>
+              <a:rPr lang="en-US" smtClean="0"/>
               <a:t>Click to edit Master text styles</a:t>
             </a:r>
           </a:p>
@@ -4887,7 +4958,7 @@
           <a:p>
             <a:fld id="{5BCAD085-E8A6-8845-BD4E-CB4CCA059FC4}" type="datetimeFigureOut">
               <a:rPr lang="en-US" smtClean="0"/>
-              <a:t>6/8/2026</a:t>
+              <a:t>1/27/13</a:t>
             </a:fld>
             <a:endParaRPr lang="en-US"/>
           </a:p>
@@ -4990,9 +5061,10 @@
           </a:lstStyle>
           <a:p>
             <a:r>
-              <a:rPr lang="en-US"/>
+              <a:rPr lang="en-US" smtClean="0"/>
               <a:t>Click to edit Master title style</a:t>
             </a:r>
+            <a:endParaRPr lang="en-US"/>
           </a:p>
         </p:txBody>
       </p:sp>
@@ -5116,7 +5188,7 @@
           <a:p>
             <a:pPr lvl="0"/>
             <a:r>
-              <a:rPr lang="en-US"/>
+              <a:rPr lang="en-US" smtClean="0"/>
               <a:t>Click to edit Master text styles</a:t>
             </a:r>
           </a:p>
@@ -5139,7 +5211,7 @@
           <a:p>
             <a:fld id="{5BCAD085-E8A6-8845-BD4E-CB4CCA059FC4}" type="datetimeFigureOut">
               <a:rPr lang="en-US" smtClean="0"/>
-              <a:t>6/8/2026</a:t>
+              <a:t>1/27/13</a:t>
             </a:fld>
             <a:endParaRPr lang="en-US"/>
           </a:p>
@@ -5248,9 +5320,10 @@
           <a:lstStyle/>
           <a:p>
             <a:r>
-              <a:rPr lang="en-US"/>
+              <a:rPr lang="en-US" smtClean="0"/>
               <a:t>Click to edit Master title style</a:t>
             </a:r>
+            <a:endParaRPr lang="en-US"/>
           </a:p>
         </p:txBody>
       </p:sp>
@@ -5281,37 +5354,38 @@
           <a:p>
             <a:pPr lvl="0"/>
             <a:r>
-              <a:rPr lang="en-US"/>
+              <a:rPr lang="en-US" smtClean="0"/>
               <a:t>Click to edit Master text styles</a:t>
             </a:r>
           </a:p>
           <a:p>
             <a:pPr lvl="1"/>
             <a:r>
-              <a:rPr lang="en-US"/>
+              <a:rPr lang="en-US" smtClean="0"/>
               <a:t>Second level</a:t>
             </a:r>
           </a:p>
           <a:p>
             <a:pPr lvl="2"/>
             <a:r>
-              <a:rPr lang="en-US"/>
+              <a:rPr lang="en-US" smtClean="0"/>
               <a:t>Third level</a:t>
             </a:r>
           </a:p>
           <a:p>
             <a:pPr lvl="3"/>
             <a:r>
-              <a:rPr lang="en-US"/>
+              <a:rPr lang="en-US" smtClean="0"/>
               <a:t>Fourth level</a:t>
             </a:r>
           </a:p>
           <a:p>
             <a:pPr lvl="4"/>
             <a:r>
-              <a:rPr lang="en-US"/>
+              <a:rPr lang="en-US" smtClean="0"/>
               <a:t>Fifth level</a:t>
             </a:r>
+            <a:endParaRPr lang="en-US"/>
           </a:p>
         </p:txBody>
       </p:sp>
@@ -5350,7 +5424,7 @@
           <a:p>
             <a:fld id="{5BCAD085-E8A6-8845-BD4E-CB4CCA059FC4}" type="datetimeFigureOut">
               <a:rPr lang="en-US" smtClean="0"/>
-              <a:t>6/8/2026</a:t>
+              <a:t>1/27/13</a:t>
             </a:fld>
             <a:endParaRPr lang="en-US"/>
           </a:p>
@@ -5709,7 +5783,7 @@
 </file>
 
 <file path=ppt/slides/slide1.xml><?xml version="1.0" encoding="utf-8"?>
-<p:sld xmlns:a="http://schemas.openxmlformats.org/drawingml/2006/main" xmlns:r="http://schemas.openxmlformats.org/officeDocument/2006/relationships" xmlns:p="http://schemas.openxmlformats.org/presentationml/2006/main">
+<p:sld xmlns:a="http://schemas.openxmlformats.org/drawingml/2006/main" xmlns:p="http://schemas.openxmlformats.org/presentationml/2006/main" xmlns:r="http://schemas.openxmlformats.org/officeDocument/2006/relationships">
   <p:cSld>
     <p:spTree>
       <p:nvGrpSpPr>
@@ -5717,14 +5791,7 @@
         <p:cNvGrpSpPr/>
         <p:nvPr/>
       </p:nvGrpSpPr>
-      <p:grpSpPr>
-        <a:xfrm>
-          <a:off x="0" y="0"/>
-          <a:ext cx="0" cy="0"/>
-          <a:chOff x="0" y="0"/>
-          <a:chExt cx="0" cy="0"/>
-        </a:xfrm>
-      </p:grpSpPr>
+      <p:grpSpPr/>
       <p:sp>
         <p:nvSpPr>
           <p:cNvPr id="2" name="Rectangle 1"/>
@@ -5766,7 +5833,6 @@
           <a:lstStyle/>
           <a:p>
             <a:pPr algn="ctr"/>
-            <a:endParaRPr/>
           </a:p>
         </p:txBody>
       </p:sp>
@@ -5811,7 +5877,6 @@
           <a:lstStyle/>
           <a:p>
             <a:pPr algn="ctr"/>
-            <a:endParaRPr/>
           </a:p>
         </p:txBody>
       </p:sp>
@@ -5824,7 +5889,7 @@
         <p:spPr>
           <a:xfrm>
             <a:off x="731520" y="2468880"/>
-            <a:ext cx="10725912" cy="1323439"/>
+            <a:ext cx="10725912" cy="2011680"/>
           </a:xfrm>
           <a:prstGeom prst="rect">
             <a:avLst/>
@@ -5839,49 +5904,13 @@
           <a:p>
             <a:pPr algn="ctr"/>
             <a:r>
-              <a:rPr lang="en-US" altLang="zh-TW" sz="4000" b="1" dirty="0">
+              <a:rPr sz="4000" b="1">
                 <a:solidFill>
                   <a:srgbClr val="FFFFFF"/>
                 </a:solidFill>
               </a:rPr>
-              <a:t>CV2X </a:t>
-            </a:r>
-            <a:br>
-              <a:rPr lang="en-US" altLang="zh-TW" sz="4000" b="1" dirty="0">
-                <a:solidFill>
-                  <a:srgbClr val="FFFFFF"/>
-                </a:solidFill>
-              </a:rPr>
-            </a:br>
-            <a:r>
-              <a:rPr lang="en-US" altLang="zh-TW" sz="4000" b="1" dirty="0">
-                <a:solidFill>
-                  <a:srgbClr val="FFFFFF"/>
-                </a:solidFill>
-              </a:rPr>
-              <a:t>Indoor Localization with </a:t>
-            </a:r>
-            <a:r>
-              <a:rPr lang="en-US" altLang="zh-TW" sz="4000" b="1" dirty="0" err="1">
-                <a:solidFill>
-                  <a:srgbClr val="FFFFFF"/>
-                </a:solidFill>
-              </a:rPr>
-              <a:t>WiFi</a:t>
-            </a:r>
-            <a:r>
-              <a:rPr lang="en-US" altLang="zh-TW" sz="4000" b="1" dirty="0">
-                <a:solidFill>
-                  <a:srgbClr val="FFFFFF"/>
-                </a:solidFill>
-              </a:rPr>
-              <a:t> Fingerprints</a:t>
-            </a:r>
-            <a:endParaRPr sz="4000" b="1" dirty="0">
-              <a:solidFill>
-                <a:srgbClr val="FFFFFF"/>
-              </a:solidFill>
-            </a:endParaRPr>
+              <a:t>CV2X Indoor Localization with WiFi Fingerprints</a:t>
+            </a:r>
           </a:p>
         </p:txBody>
       </p:sp>
@@ -5894,7 +5923,7 @@
         <p:spPr>
           <a:xfrm>
             <a:off x="914400" y="4572000"/>
-            <a:ext cx="10360152" cy="707886"/>
+            <a:ext cx="10360152" cy="1097280"/>
           </a:xfrm>
           <a:prstGeom prst="rect">
             <a:avLst/>
@@ -5909,50 +5938,13 @@
           <a:p>
             <a:pPr algn="ctr"/>
             <a:r>
-              <a:rPr lang="en-US" altLang="zh-TW" sz="2000" dirty="0">
+              <a:rPr sz="2000">
                 <a:solidFill>
                   <a:srgbClr val="6FB7F0"/>
                 </a:solidFill>
               </a:rPr>
-              <a:t>314831017</a:t>
-            </a:r>
-            <a:r>
-              <a:rPr lang="zh-TW" altLang="en-US" sz="2000" dirty="0">
-                <a:solidFill>
-                  <a:srgbClr val="6FB7F0"/>
-                </a:solidFill>
-              </a:rPr>
-              <a:t> 王瑋琛</a:t>
-            </a:r>
-            <a:endParaRPr lang="en-US" altLang="zh-TW" sz="2000" dirty="0">
-              <a:solidFill>
-                <a:srgbClr val="6FB7F0"/>
-              </a:solidFill>
-            </a:endParaRPr>
-          </a:p>
-          <a:p>
-            <a:pPr algn="ctr"/>
-            <a:r>
-              <a:rPr lang="en-US" altLang="zh-TW" sz="2000" dirty="0">
-                <a:solidFill>
-                  <a:srgbClr val="6FB7F0"/>
-                </a:solidFill>
-              </a:rPr>
-              <a:t>314831024</a:t>
-            </a:r>
-            <a:r>
-              <a:rPr lang="zh-TW" altLang="en-US" sz="2000" dirty="0">
-                <a:solidFill>
-                  <a:srgbClr val="6FB7F0"/>
-                </a:solidFill>
-              </a:rPr>
-              <a:t> 李朋逸</a:t>
-            </a:r>
-            <a:endParaRPr sz="2000" dirty="0">
-              <a:solidFill>
-                <a:srgbClr val="6FB7F0"/>
-              </a:solidFill>
-            </a:endParaRPr>
+              <a:t>314831017 王瑋琛 · 314831024 李朋逸</a:t>
+            </a:r>
           </a:p>
         </p:txBody>
       </p:sp>
@@ -5999,7 +5991,7 @@
 </file>
 
 <file path=ppt/slides/slide10.xml><?xml version="1.0" encoding="utf-8"?>
-<p:sld xmlns:a="http://schemas.openxmlformats.org/drawingml/2006/main" xmlns:r="http://schemas.openxmlformats.org/officeDocument/2006/relationships" xmlns:p="http://schemas.openxmlformats.org/presentationml/2006/main">
+<p:sld xmlns:a="http://schemas.openxmlformats.org/drawingml/2006/main" xmlns:p="http://schemas.openxmlformats.org/presentationml/2006/main" xmlns:r="http://schemas.openxmlformats.org/officeDocument/2006/relationships">
   <p:cSld>
     <p:spTree>
       <p:nvGrpSpPr>
@@ -6007,14 +5999,7 @@
         <p:cNvGrpSpPr/>
         <p:nvPr/>
       </p:nvGrpSpPr>
-      <p:grpSpPr>
-        <a:xfrm>
-          <a:off x="0" y="0"/>
-          <a:ext cx="0" cy="0"/>
-          <a:chOff x="0" y="0"/>
-          <a:chExt cx="0" cy="0"/>
-        </a:xfrm>
-      </p:grpSpPr>
+      <p:grpSpPr/>
       <p:sp>
         <p:nvSpPr>
           <p:cNvPr id="2" name="TextBox 1"/>
@@ -6172,7 +6157,7 @@
           <p:nvPr/>
         </p:nvPicPr>
         <p:blipFill>
-          <a:blip r:embed="rId3"/>
+          <a:blip r:embed="rId2"/>
           <a:stretch>
             <a:fillRect/>
           </a:stretch>
@@ -6228,7 +6213,6 @@
           <a:lstStyle/>
           <a:p>
             <a:pPr algn="ctr"/>
-            <a:endParaRPr/>
           </a:p>
         </p:txBody>
       </p:sp>
@@ -6343,7 +6327,7 @@
 </file>
 
 <file path=ppt/slides/slide11.xml><?xml version="1.0" encoding="utf-8"?>
-<p:sld xmlns:a="http://schemas.openxmlformats.org/drawingml/2006/main" xmlns:r="http://schemas.openxmlformats.org/officeDocument/2006/relationships" xmlns:p="http://schemas.openxmlformats.org/presentationml/2006/main">
+<p:sld xmlns:a="http://schemas.openxmlformats.org/drawingml/2006/main" xmlns:p="http://schemas.openxmlformats.org/presentationml/2006/main" xmlns:r="http://schemas.openxmlformats.org/officeDocument/2006/relationships">
   <p:cSld>
     <p:spTree>
       <p:nvGrpSpPr>
@@ -6351,14 +6335,7 @@
         <p:cNvGrpSpPr/>
         <p:nvPr/>
       </p:nvGrpSpPr>
-      <p:grpSpPr>
-        <a:xfrm>
-          <a:off x="0" y="0"/>
-          <a:ext cx="0" cy="0"/>
-          <a:chOff x="0" y="0"/>
-          <a:chExt cx="0" cy="0"/>
-        </a:xfrm>
-      </p:grpSpPr>
+      <p:grpSpPr/>
       <p:sp>
         <p:nvSpPr>
           <p:cNvPr id="2" name="Rectangle 1"/>
@@ -6400,7 +6377,6 @@
           <a:lstStyle/>
           <a:p>
             <a:pPr algn="ctr"/>
-            <a:endParaRPr/>
           </a:p>
         </p:txBody>
       </p:sp>
@@ -6513,7 +6489,6 @@
           <a:lstStyle/>
           <a:p>
             <a:pPr algn="ctr"/>
-            <a:endParaRPr/>
           </a:p>
         </p:txBody>
       </p:sp>
@@ -6560,7 +6535,7 @@
 </file>
 
 <file path=ppt/slides/slide12.xml><?xml version="1.0" encoding="utf-8"?>
-<p:sld xmlns:a="http://schemas.openxmlformats.org/drawingml/2006/main" xmlns:r="http://schemas.openxmlformats.org/officeDocument/2006/relationships" xmlns:p="http://schemas.openxmlformats.org/presentationml/2006/main">
+<p:sld xmlns:a="http://schemas.openxmlformats.org/drawingml/2006/main" xmlns:p="http://schemas.openxmlformats.org/presentationml/2006/main" xmlns:r="http://schemas.openxmlformats.org/officeDocument/2006/relationships">
   <p:cSld>
     <p:spTree>
       <p:nvGrpSpPr>
@@ -6568,14 +6543,7 @@
         <p:cNvGrpSpPr/>
         <p:nvPr/>
       </p:nvGrpSpPr>
-      <p:grpSpPr>
-        <a:xfrm>
-          <a:off x="0" y="0"/>
-          <a:ext cx="0" cy="0"/>
-          <a:chOff x="0" y="0"/>
-          <a:chExt cx="0" cy="0"/>
-        </a:xfrm>
-      </p:grpSpPr>
+      <p:grpSpPr/>
       <p:sp>
         <p:nvSpPr>
           <p:cNvPr id="2" name="TextBox 1"/>
@@ -6733,7 +6701,7 @@
           <p:nvPr/>
         </p:nvPicPr>
         <p:blipFill>
-          <a:blip r:embed="rId3"/>
+          <a:blip r:embed="rId2"/>
           <a:stretch>
             <a:fillRect/>
           </a:stretch>
@@ -6789,7 +6757,6 @@
           <a:lstStyle/>
           <a:p>
             <a:pPr algn="ctr"/>
-            <a:endParaRPr/>
           </a:p>
         </p:txBody>
       </p:sp>
@@ -6904,7 +6871,7 @@
 </file>
 
 <file path=ppt/slides/slide13.xml><?xml version="1.0" encoding="utf-8"?>
-<p:sld xmlns:a="http://schemas.openxmlformats.org/drawingml/2006/main" xmlns:r="http://schemas.openxmlformats.org/officeDocument/2006/relationships" xmlns:p="http://schemas.openxmlformats.org/presentationml/2006/main">
+<p:sld xmlns:a="http://schemas.openxmlformats.org/drawingml/2006/main" xmlns:p="http://schemas.openxmlformats.org/presentationml/2006/main" xmlns:r="http://schemas.openxmlformats.org/officeDocument/2006/relationships">
   <p:cSld>
     <p:spTree>
       <p:nvGrpSpPr>
@@ -6912,14 +6879,7 @@
         <p:cNvGrpSpPr/>
         <p:nvPr/>
       </p:nvGrpSpPr>
-      <p:grpSpPr>
-        <a:xfrm>
-          <a:off x="0" y="0"/>
-          <a:ext cx="0" cy="0"/>
-          <a:chOff x="0" y="0"/>
-          <a:chExt cx="0" cy="0"/>
-        </a:xfrm>
-      </p:grpSpPr>
+      <p:grpSpPr/>
       <p:sp>
         <p:nvSpPr>
           <p:cNvPr id="2" name="TextBox 1"/>
@@ -6948,7 +6908,7 @@
                   <a:srgbClr val="1F2D3D"/>
                 </a:solidFill>
               </a:rPr>
-              <a:t>Plain neural nets barely beat KNN — and reveal two lessons</a:t>
+              <a:t>Plain neural nets clear KNN but plateau near 1.3 m — two lessons</a:t>
             </a:r>
           </a:p>
         </p:txBody>
@@ -6994,7 +6954,7 @@
                   <a:srgbClr val="1F2D3D"/>
                 </a:solidFill>
               </a:rPr>
-              <a:t>Lesson 1: a dense -100-padded vector wastes most of the capacity</a:t>
+              <a:t>MLP 1.30 m and MDN 1.26 m: both about -17% vs KNN 1.57 m, yet barely apart from each other</a:t>
             </a:r>
           </a:p>
           <a:p>
@@ -7017,7 +6977,7 @@
                   <a:srgbClr val="1F2D3D"/>
                 </a:solidFill>
               </a:rPr>
-              <a:t>Lesson 2: regression averages multimodal answers into the void</a:t>
+              <a:t>A mixture head (MDN) only inches past the MLP; masking the -100 padding (1.37 m) made it worse, not better</a:t>
             </a:r>
           </a:p>
           <a:p>
@@ -7040,7 +7000,7 @@
                   <a:srgbClr val="1F2D3D"/>
                 </a:solidFill>
               </a:rPr>
-              <a:t>MLP regression: 1.30 m — only a sliver below KNN</a:t>
+              <a:t>Lesson 1 - representation: a fixed 80-D, -100-padded vector wastes most of the model capacity</a:t>
             </a:r>
           </a:p>
           <a:p>
@@ -7063,7 +7023,7 @@
                   <a:srgbClr val="1F2D3D"/>
                 </a:solidFill>
               </a:rPr>
-              <a:t>MaskedMDN: 1.37 m — a mixture head alone does not fix multimodality</a:t>
+              <a:t>Lesson 2 - output: a point/mixture readout still averages two plausible places - it needs a grid</a:t>
             </a:r>
           </a:p>
         </p:txBody>
@@ -7077,7 +7037,7 @@
           <p:nvPr/>
         </p:nvPicPr>
         <p:blipFill>
-          <a:blip r:embed="rId3"/>
+          <a:blip r:embed="rId2"/>
           <a:stretch>
             <a:fillRect/>
           </a:stretch>
@@ -7133,7 +7093,6 @@
           <a:lstStyle/>
           <a:p>
             <a:pPr algn="ctr"/>
-            <a:endParaRPr/>
           </a:p>
         </p:txBody>
       </p:sp>
@@ -7248,7 +7207,7 @@
 </file>
 
 <file path=ppt/slides/slide14.xml><?xml version="1.0" encoding="utf-8"?>
-<p:sld xmlns:a="http://schemas.openxmlformats.org/drawingml/2006/main" xmlns:r="http://schemas.openxmlformats.org/officeDocument/2006/relationships" xmlns:p="http://schemas.openxmlformats.org/presentationml/2006/main">
+<p:sld xmlns:a="http://schemas.openxmlformats.org/drawingml/2006/main" xmlns:p="http://schemas.openxmlformats.org/presentationml/2006/main" xmlns:r="http://schemas.openxmlformats.org/officeDocument/2006/relationships">
   <p:cSld>
     <p:spTree>
       <p:nvGrpSpPr>
@@ -7256,14 +7215,7 @@
         <p:cNvGrpSpPr/>
         <p:nvPr/>
       </p:nvGrpSpPr>
-      <p:grpSpPr>
-        <a:xfrm>
-          <a:off x="0" y="0"/>
-          <a:ext cx="0" cy="0"/>
-          <a:chOff x="0" y="0"/>
-          <a:chExt cx="0" cy="0"/>
-        </a:xfrm>
-      </p:grpSpPr>
+      <p:grpSpPr/>
       <p:sp>
         <p:nvSpPr>
           <p:cNvPr id="2" name="TextBox 1"/>
@@ -7371,7 +7323,6 @@
           <a:lstStyle/>
           <a:p>
             <a:pPr algn="ctr"/>
-            <a:endParaRPr/>
           </a:p>
         </p:txBody>
       </p:sp>
@@ -7416,7 +7367,6 @@
           <a:lstStyle/>
           <a:p>
             <a:pPr algn="ctr"/>
-            <a:endParaRPr/>
           </a:p>
         </p:txBody>
       </p:sp>
@@ -7576,7 +7526,6 @@
           <a:lstStyle/>
           <a:p>
             <a:pPr algn="ctr"/>
-            <a:endParaRPr/>
           </a:p>
         </p:txBody>
       </p:sp>
@@ -7691,7 +7640,7 @@
 </file>
 
 <file path=ppt/slides/slide15.xml><?xml version="1.0" encoding="utf-8"?>
-<p:sld xmlns:a="http://schemas.openxmlformats.org/drawingml/2006/main" xmlns:r="http://schemas.openxmlformats.org/officeDocument/2006/relationships" xmlns:p="http://schemas.openxmlformats.org/presentationml/2006/main">
+<p:sld xmlns:a="http://schemas.openxmlformats.org/drawingml/2006/main" xmlns:p="http://schemas.openxmlformats.org/presentationml/2006/main" xmlns:r="http://schemas.openxmlformats.org/officeDocument/2006/relationships">
   <p:cSld>
     <p:spTree>
       <p:nvGrpSpPr>
@@ -7699,14 +7648,7 @@
         <p:cNvGrpSpPr/>
         <p:nvPr/>
       </p:nvGrpSpPr>
-      <p:grpSpPr>
-        <a:xfrm>
-          <a:off x="0" y="0"/>
-          <a:ext cx="0" cy="0"/>
-          <a:chOff x="0" y="0"/>
-          <a:chExt cx="0" cy="0"/>
-        </a:xfrm>
-      </p:grpSpPr>
+      <p:grpSpPr/>
       <p:sp>
         <p:nvSpPr>
           <p:cNvPr id="2" name="TextBox 1"/>
@@ -7864,7 +7806,7 @@
           <p:nvPr/>
         </p:nvPicPr>
         <p:blipFill>
-          <a:blip r:embed="rId3"/>
+          <a:blip r:embed="rId2"/>
           <a:stretch>
             <a:fillRect/>
           </a:stretch>
@@ -7920,7 +7862,6 @@
           <a:lstStyle/>
           <a:p>
             <a:pPr algn="ctr"/>
-            <a:endParaRPr/>
           </a:p>
         </p:txBody>
       </p:sp>
@@ -8035,7 +7976,7 @@
 </file>
 
 <file path=ppt/slides/slide16.xml><?xml version="1.0" encoding="utf-8"?>
-<p:sld xmlns:a="http://schemas.openxmlformats.org/drawingml/2006/main" xmlns:r="http://schemas.openxmlformats.org/officeDocument/2006/relationships" xmlns:p="http://schemas.openxmlformats.org/presentationml/2006/main">
+<p:sld xmlns:a="http://schemas.openxmlformats.org/drawingml/2006/main" xmlns:p="http://schemas.openxmlformats.org/presentationml/2006/main" xmlns:r="http://schemas.openxmlformats.org/officeDocument/2006/relationships">
   <p:cSld>
     <p:spTree>
       <p:nvGrpSpPr>
@@ -8043,14 +7984,7 @@
         <p:cNvGrpSpPr/>
         <p:nvPr/>
       </p:nvGrpSpPr>
-      <p:grpSpPr>
-        <a:xfrm>
-          <a:off x="0" y="0"/>
-          <a:ext cx="0" cy="0"/>
-          <a:chOff x="0" y="0"/>
-          <a:chExt cx="0" cy="0"/>
-        </a:xfrm>
-      </p:grpSpPr>
+      <p:grpSpPr/>
       <p:sp>
         <p:nvSpPr>
           <p:cNvPr id="2" name="TextBox 1"/>
@@ -8208,7 +8142,7 @@
           <p:nvPr/>
         </p:nvPicPr>
         <p:blipFill>
-          <a:blip r:embed="rId3"/>
+          <a:blip r:embed="rId2"/>
           <a:stretch>
             <a:fillRect/>
           </a:stretch>
@@ -8264,7 +8198,6 @@
           <a:lstStyle/>
           <a:p>
             <a:pPr algn="ctr"/>
-            <a:endParaRPr/>
           </a:p>
         </p:txBody>
       </p:sp>
@@ -8379,7 +8312,7 @@
 </file>
 
 <file path=ppt/slides/slide17.xml><?xml version="1.0" encoding="utf-8"?>
-<p:sld xmlns:a="http://schemas.openxmlformats.org/drawingml/2006/main" xmlns:r="http://schemas.openxmlformats.org/officeDocument/2006/relationships" xmlns:p="http://schemas.openxmlformats.org/presentationml/2006/main">
+<p:sld xmlns:a="http://schemas.openxmlformats.org/drawingml/2006/main" xmlns:p="http://schemas.openxmlformats.org/presentationml/2006/main" xmlns:r="http://schemas.openxmlformats.org/officeDocument/2006/relationships">
   <p:cSld>
     <p:spTree>
       <p:nvGrpSpPr>
@@ -8387,14 +8320,7 @@
         <p:cNvGrpSpPr/>
         <p:nvPr/>
       </p:nvGrpSpPr>
-      <p:grpSpPr>
-        <a:xfrm>
-          <a:off x="0" y="0"/>
-          <a:ext cx="0" cy="0"/>
-          <a:chOff x="0" y="0"/>
-          <a:chExt cx="0" cy="0"/>
-        </a:xfrm>
-      </p:grpSpPr>
+      <p:grpSpPr/>
       <p:sp>
         <p:nvSpPr>
           <p:cNvPr id="2" name="TextBox 1"/>
@@ -8552,7 +8478,7 @@
           <p:nvPr/>
         </p:nvPicPr>
         <p:blipFill>
-          <a:blip r:embed="rId3"/>
+          <a:blip r:embed="rId2"/>
           <a:stretch>
             <a:fillRect/>
           </a:stretch>
@@ -8608,7 +8534,6 @@
           <a:lstStyle/>
           <a:p>
             <a:pPr algn="ctr"/>
-            <a:endParaRPr/>
           </a:p>
         </p:txBody>
       </p:sp>
@@ -8723,7 +8648,7 @@
 </file>
 
 <file path=ppt/slides/slide18.xml><?xml version="1.0" encoding="utf-8"?>
-<p:sld xmlns:a="http://schemas.openxmlformats.org/drawingml/2006/main" xmlns:r="http://schemas.openxmlformats.org/officeDocument/2006/relationships" xmlns:p="http://schemas.openxmlformats.org/presentationml/2006/main">
+<p:sld xmlns:a="http://schemas.openxmlformats.org/drawingml/2006/main" xmlns:p="http://schemas.openxmlformats.org/presentationml/2006/main" xmlns:r="http://schemas.openxmlformats.org/officeDocument/2006/relationships">
   <p:cSld>
     <p:spTree>
       <p:nvGrpSpPr>
@@ -8731,14 +8656,7 @@
         <p:cNvGrpSpPr/>
         <p:nvPr/>
       </p:nvGrpSpPr>
-      <p:grpSpPr>
-        <a:xfrm>
-          <a:off x="0" y="0"/>
-          <a:ext cx="0" cy="0"/>
-          <a:chOff x="0" y="0"/>
-          <a:chExt cx="0" cy="0"/>
-        </a:xfrm>
-      </p:grpSpPr>
+      <p:grpSpPr/>
       <p:sp>
         <p:nvSpPr>
           <p:cNvPr id="2" name="TextBox 1"/>
@@ -8896,7 +8814,7 @@
           <p:nvPr/>
         </p:nvPicPr>
         <p:blipFill>
-          <a:blip r:embed="rId3"/>
+          <a:blip r:embed="rId2"/>
           <a:stretch>
             <a:fillRect/>
           </a:stretch>
@@ -8952,7 +8870,6 @@
           <a:lstStyle/>
           <a:p>
             <a:pPr algn="ctr"/>
-            <a:endParaRPr/>
           </a:p>
         </p:txBody>
       </p:sp>
@@ -9067,7 +8984,7 @@
 </file>
 
 <file path=ppt/slides/slide19.xml><?xml version="1.0" encoding="utf-8"?>
-<p:sld xmlns:a="http://schemas.openxmlformats.org/drawingml/2006/main" xmlns:r="http://schemas.openxmlformats.org/officeDocument/2006/relationships" xmlns:p="http://schemas.openxmlformats.org/presentationml/2006/main">
+<p:sld xmlns:a="http://schemas.openxmlformats.org/drawingml/2006/main" xmlns:p="http://schemas.openxmlformats.org/presentationml/2006/main" xmlns:r="http://schemas.openxmlformats.org/officeDocument/2006/relationships">
   <p:cSld>
     <p:spTree>
       <p:nvGrpSpPr>
@@ -9075,14 +8992,7 @@
         <p:cNvGrpSpPr/>
         <p:nvPr/>
       </p:nvGrpSpPr>
-      <p:grpSpPr>
-        <a:xfrm>
-          <a:off x="0" y="0"/>
-          <a:ext cx="0" cy="0"/>
-          <a:chOff x="0" y="0"/>
-          <a:chExt cx="0" cy="0"/>
-        </a:xfrm>
-      </p:grpSpPr>
+      <p:grpSpPr/>
       <p:sp>
         <p:nvSpPr>
           <p:cNvPr id="2" name="TextBox 1"/>
@@ -9240,7 +9150,7 @@
           <p:nvPr/>
         </p:nvPicPr>
         <p:blipFill>
-          <a:blip r:embed="rId3"/>
+          <a:blip r:embed="rId2"/>
           <a:stretch>
             <a:fillRect/>
           </a:stretch>
@@ -9296,7 +9206,6 @@
           <a:lstStyle/>
           <a:p>
             <a:pPr algn="ctr"/>
-            <a:endParaRPr/>
           </a:p>
         </p:txBody>
       </p:sp>
@@ -9411,7 +9320,7 @@
 </file>
 
 <file path=ppt/slides/slide2.xml><?xml version="1.0" encoding="utf-8"?>
-<p:sld xmlns:a="http://schemas.openxmlformats.org/drawingml/2006/main" xmlns:r="http://schemas.openxmlformats.org/officeDocument/2006/relationships" xmlns:p="http://schemas.openxmlformats.org/presentationml/2006/main">
+<p:sld xmlns:a="http://schemas.openxmlformats.org/drawingml/2006/main" xmlns:p="http://schemas.openxmlformats.org/presentationml/2006/main" xmlns:r="http://schemas.openxmlformats.org/officeDocument/2006/relationships">
   <p:cSld>
     <p:spTree>
       <p:nvGrpSpPr>
@@ -9419,14 +9328,7 @@
         <p:cNvGrpSpPr/>
         <p:nvPr/>
       </p:nvGrpSpPr>
-      <p:grpSpPr>
-        <a:xfrm>
-          <a:off x="0" y="0"/>
-          <a:ext cx="0" cy="0"/>
-          <a:chOff x="0" y="0"/>
-          <a:chExt cx="0" cy="0"/>
-        </a:xfrm>
-      </p:grpSpPr>
+      <p:grpSpPr/>
       <p:sp>
         <p:nvSpPr>
           <p:cNvPr id="2" name="TextBox 1"/>
@@ -9436,7 +9338,7 @@
         <p:spPr>
           <a:xfrm>
             <a:off x="457200" y="320040"/>
-            <a:ext cx="11274552" cy="507831"/>
+            <a:ext cx="11274552" cy="868680"/>
           </a:xfrm>
           <a:prstGeom prst="rect">
             <a:avLst/>
@@ -9450,7 +9352,7 @@
           <a:lstStyle/>
           <a:p>
             <a:r>
-              <a:rPr sz="2700" b="1" dirty="0">
+              <a:rPr sz="2700" b="1">
                 <a:solidFill>
                   <a:srgbClr val="1F2D3D"/>
                 </a:solidFill>
@@ -9534,7 +9436,6 @@
           <a:lstStyle/>
           <a:p>
             <a:pPr algn="ctr"/>
-            <a:endParaRPr/>
           </a:p>
         </p:txBody>
       </p:sp>
@@ -9579,7 +9480,6 @@
           <a:lstStyle/>
           <a:p>
             <a:pPr algn="ctr"/>
-            <a:endParaRPr/>
           </a:p>
         </p:txBody>
       </p:sp>
@@ -9739,7 +9639,6 @@
           <a:lstStyle/>
           <a:p>
             <a:pPr algn="ctr"/>
-            <a:endParaRPr/>
           </a:p>
         </p:txBody>
       </p:sp>
@@ -9820,7 +9719,7 @@
 </file>
 
 <file path=ppt/slides/slide20.xml><?xml version="1.0" encoding="utf-8"?>
-<p:sld xmlns:a="http://schemas.openxmlformats.org/drawingml/2006/main" xmlns:r="http://schemas.openxmlformats.org/officeDocument/2006/relationships" xmlns:p="http://schemas.openxmlformats.org/presentationml/2006/main">
+<p:sld xmlns:a="http://schemas.openxmlformats.org/drawingml/2006/main" xmlns:p="http://schemas.openxmlformats.org/presentationml/2006/main" xmlns:r="http://schemas.openxmlformats.org/officeDocument/2006/relationships">
   <p:cSld>
     <p:spTree>
       <p:nvGrpSpPr>
@@ -9828,14 +9727,7 @@
         <p:cNvGrpSpPr/>
         <p:nvPr/>
       </p:nvGrpSpPr>
-      <p:grpSpPr>
-        <a:xfrm>
-          <a:off x="0" y="0"/>
-          <a:ext cx="0" cy="0"/>
-          <a:chOff x="0" y="0"/>
-          <a:chExt cx="0" cy="0"/>
-        </a:xfrm>
-      </p:grpSpPr>
+      <p:grpSpPr/>
       <p:sp>
         <p:nvSpPr>
           <p:cNvPr id="2" name="TextBox 1"/>
@@ -9993,7 +9885,7 @@
           <p:nvPr/>
         </p:nvPicPr>
         <p:blipFill>
-          <a:blip r:embed="rId3"/>
+          <a:blip r:embed="rId2"/>
           <a:stretch>
             <a:fillRect/>
           </a:stretch>
@@ -10049,7 +9941,6 @@
           <a:lstStyle/>
           <a:p>
             <a:pPr algn="ctr"/>
-            <a:endParaRPr/>
           </a:p>
         </p:txBody>
       </p:sp>
@@ -10164,7 +10055,7 @@
 </file>
 
 <file path=ppt/slides/slide21.xml><?xml version="1.0" encoding="utf-8"?>
-<p:sld xmlns:a="http://schemas.openxmlformats.org/drawingml/2006/main" xmlns:r="http://schemas.openxmlformats.org/officeDocument/2006/relationships" xmlns:p="http://schemas.openxmlformats.org/presentationml/2006/main">
+<p:sld xmlns:a="http://schemas.openxmlformats.org/drawingml/2006/main" xmlns:p="http://schemas.openxmlformats.org/presentationml/2006/main" xmlns:r="http://schemas.openxmlformats.org/officeDocument/2006/relationships">
   <p:cSld>
     <p:spTree>
       <p:nvGrpSpPr>
@@ -10172,14 +10063,7 @@
         <p:cNvGrpSpPr/>
         <p:nvPr/>
       </p:nvGrpSpPr>
-      <p:grpSpPr>
-        <a:xfrm>
-          <a:off x="0" y="0"/>
-          <a:ext cx="0" cy="0"/>
-          <a:chOff x="0" y="0"/>
-          <a:chExt cx="0" cy="0"/>
-        </a:xfrm>
-      </p:grpSpPr>
+      <p:grpSpPr/>
       <p:sp>
         <p:nvSpPr>
           <p:cNvPr id="2" name="TextBox 1"/>
@@ -10337,7 +10221,7 @@
           <p:nvPr/>
         </p:nvPicPr>
         <p:blipFill>
-          <a:blip r:embed="rId3"/>
+          <a:blip r:embed="rId2"/>
           <a:stretch>
             <a:fillRect/>
           </a:stretch>
@@ -10393,7 +10277,6 @@
           <a:lstStyle/>
           <a:p>
             <a:pPr algn="ctr"/>
-            <a:endParaRPr/>
           </a:p>
         </p:txBody>
       </p:sp>
@@ -10508,7 +10391,7 @@
 </file>
 
 <file path=ppt/slides/slide22.xml><?xml version="1.0" encoding="utf-8"?>
-<p:sld xmlns:a="http://schemas.openxmlformats.org/drawingml/2006/main" xmlns:r="http://schemas.openxmlformats.org/officeDocument/2006/relationships" xmlns:p="http://schemas.openxmlformats.org/presentationml/2006/main">
+<p:sld xmlns:a="http://schemas.openxmlformats.org/drawingml/2006/main" xmlns:p="http://schemas.openxmlformats.org/presentationml/2006/main" xmlns:r="http://schemas.openxmlformats.org/officeDocument/2006/relationships">
   <p:cSld>
     <p:spTree>
       <p:nvGrpSpPr>
@@ -10516,14 +10399,7 @@
         <p:cNvGrpSpPr/>
         <p:nvPr/>
       </p:nvGrpSpPr>
-      <p:grpSpPr>
-        <a:xfrm>
-          <a:off x="0" y="0"/>
-          <a:ext cx="0" cy="0"/>
-          <a:chOff x="0" y="0"/>
-          <a:chExt cx="0" cy="0"/>
-        </a:xfrm>
-      </p:grpSpPr>
+      <p:grpSpPr/>
       <p:sp>
         <p:nvSpPr>
           <p:cNvPr id="2" name="TextBox 1"/>
@@ -10681,7 +10557,7 @@
           <p:nvPr/>
         </p:nvPicPr>
         <p:blipFill>
-          <a:blip r:embed="rId3"/>
+          <a:blip r:embed="rId2"/>
           <a:stretch>
             <a:fillRect/>
           </a:stretch>
@@ -10737,7 +10613,6 @@
           <a:lstStyle/>
           <a:p>
             <a:pPr algn="ctr"/>
-            <a:endParaRPr/>
           </a:p>
         </p:txBody>
       </p:sp>
@@ -10852,7 +10727,7 @@
 </file>
 
 <file path=ppt/slides/slide23.xml><?xml version="1.0" encoding="utf-8"?>
-<p:sld xmlns:a="http://schemas.openxmlformats.org/drawingml/2006/main" xmlns:r="http://schemas.openxmlformats.org/officeDocument/2006/relationships" xmlns:p="http://schemas.openxmlformats.org/presentationml/2006/main">
+<p:sld xmlns:a="http://schemas.openxmlformats.org/drawingml/2006/main" xmlns:p="http://schemas.openxmlformats.org/presentationml/2006/main" xmlns:r="http://schemas.openxmlformats.org/officeDocument/2006/relationships">
   <p:cSld>
     <p:spTree>
       <p:nvGrpSpPr>
@@ -10860,14 +10735,7 @@
         <p:cNvGrpSpPr/>
         <p:nvPr/>
       </p:nvGrpSpPr>
-      <p:grpSpPr>
-        <a:xfrm>
-          <a:off x="0" y="0"/>
-          <a:ext cx="0" cy="0"/>
-          <a:chOff x="0" y="0"/>
-          <a:chExt cx="0" cy="0"/>
-        </a:xfrm>
-      </p:grpSpPr>
+      <p:grpSpPr/>
       <p:sp>
         <p:nvSpPr>
           <p:cNvPr id="2" name="Rectangle 1"/>
@@ -10909,7 +10777,6 @@
           <a:lstStyle/>
           <a:p>
             <a:pPr algn="ctr"/>
-            <a:endParaRPr/>
           </a:p>
         </p:txBody>
       </p:sp>
@@ -11022,7 +10889,6 @@
           <a:lstStyle/>
           <a:p>
             <a:pPr algn="ctr"/>
-            <a:endParaRPr/>
           </a:p>
         </p:txBody>
       </p:sp>
@@ -11069,7 +10935,7 @@
 </file>
 
 <file path=ppt/slides/slide24.xml><?xml version="1.0" encoding="utf-8"?>
-<p:sld xmlns:a="http://schemas.openxmlformats.org/drawingml/2006/main" xmlns:r="http://schemas.openxmlformats.org/officeDocument/2006/relationships" xmlns:p="http://schemas.openxmlformats.org/presentationml/2006/main">
+<p:sld xmlns:a="http://schemas.openxmlformats.org/drawingml/2006/main" xmlns:p="http://schemas.openxmlformats.org/presentationml/2006/main" xmlns:r="http://schemas.openxmlformats.org/officeDocument/2006/relationships">
   <p:cSld>
     <p:spTree>
       <p:nvGrpSpPr>
@@ -11077,14 +10943,7 @@
         <p:cNvGrpSpPr/>
         <p:nvPr/>
       </p:nvGrpSpPr>
-      <p:grpSpPr>
-        <a:xfrm>
-          <a:off x="0" y="0"/>
-          <a:ext cx="0" cy="0"/>
-          <a:chOff x="0" y="0"/>
-          <a:chExt cx="0" cy="0"/>
-        </a:xfrm>
-      </p:grpSpPr>
+      <p:grpSpPr/>
       <p:sp>
         <p:nvSpPr>
           <p:cNvPr id="2" name="TextBox 1"/>
@@ -11242,7 +11101,7 @@
           <p:nvPr/>
         </p:nvPicPr>
         <p:blipFill>
-          <a:blip r:embed="rId3"/>
+          <a:blip r:embed="rId2"/>
           <a:stretch>
             <a:fillRect/>
           </a:stretch>
@@ -11298,7 +11157,6 @@
           <a:lstStyle/>
           <a:p>
             <a:pPr algn="ctr"/>
-            <a:endParaRPr/>
           </a:p>
         </p:txBody>
       </p:sp>
@@ -11413,7 +11271,7 @@
 </file>
 
 <file path=ppt/slides/slide25.xml><?xml version="1.0" encoding="utf-8"?>
-<p:sld xmlns:a="http://schemas.openxmlformats.org/drawingml/2006/main" xmlns:r="http://schemas.openxmlformats.org/officeDocument/2006/relationships" xmlns:p="http://schemas.openxmlformats.org/presentationml/2006/main">
+<p:sld xmlns:a="http://schemas.openxmlformats.org/drawingml/2006/main" xmlns:p="http://schemas.openxmlformats.org/presentationml/2006/main" xmlns:r="http://schemas.openxmlformats.org/officeDocument/2006/relationships">
   <p:cSld>
     <p:spTree>
       <p:nvGrpSpPr>
@@ -11421,14 +11279,7 @@
         <p:cNvGrpSpPr/>
         <p:nvPr/>
       </p:nvGrpSpPr>
-      <p:grpSpPr>
-        <a:xfrm>
-          <a:off x="0" y="0"/>
-          <a:ext cx="0" cy="0"/>
-          <a:chOff x="0" y="0"/>
-          <a:chExt cx="0" cy="0"/>
-        </a:xfrm>
-      </p:grpSpPr>
+      <p:grpSpPr/>
       <p:sp>
         <p:nvSpPr>
           <p:cNvPr id="2" name="TextBox 1"/>
@@ -11457,7 +11308,7 @@
                   <a:srgbClr val="1F2D3D"/>
                 </a:solidFill>
               </a:rPr>
-              <a:t>Across all four splits: in-session is strong, cross-time is the weak spot</a:t>
+              <a:t>In-distribution splits A &amp; D are both strong (~0.8 m); cross-time C is the open problem</a:t>
             </a:r>
           </a:p>
         </p:txBody>
@@ -11503,7 +11354,7 @@
                   <a:srgbClr val="1F2D3D"/>
                 </a:solidFill>
               </a:rPr>
-              <a:t>A_random: 0.75 m (MEASURED, main headline)</a:t>
+              <a:t>A_random (MAIN): 0.752 m measured — random 80/20</a:t>
             </a:r>
           </a:p>
           <a:p>
@@ -11526,7 +11377,7 @@
                   <a:srgbClr val="1F2D3D"/>
                 </a:solidFill>
               </a:rPr>
-              <a:t>B_morning: ~0.85 m (same-session, estimate)</a:t>
+              <a:t>D_stratified: 0.807 m measured — both times of day in train &amp; test</a:t>
             </a:r>
           </a:p>
           <a:p>
@@ -11549,7 +11400,7 @@
                   <a:srgbClr val="1F2D3D"/>
                 </a:solidFill>
               </a:rPr>
-              <a:t>D_stratified: ~0.90 m (all-session deployment, estimate)</a:t>
+              <a:t>B_morning: ~1.0 m (estimate; morning-only, so less training data than A)</a:t>
             </a:r>
           </a:p>
           <a:p>
@@ -11572,29 +11423,29 @@
                   <a:srgbClr val="1F2D3D"/>
                 </a:solidFill>
               </a:rPr>
-              <a:t>C_morning to evening: ~2.3 m (cross-time, ESTIMATE) — the open problem</a:t>
+              <a:t>C_morning to evening: ~2.3 m (estimate) — cross-time, the open problem</a:t>
             </a:r>
           </a:p>
         </p:txBody>
       </p:sp>
       <p:pic>
         <p:nvPicPr>
-          <p:cNvPr id="4" name="Picture 3" descr="synth_ablation.png"/>
+          <p:cNvPr id="4" name="Picture 3" descr="split_a_vs_d.png"/>
           <p:cNvPicPr>
             <a:picLocks noChangeAspect="1"/>
           </p:cNvPicPr>
           <p:nvPr/>
         </p:nvPicPr>
         <p:blipFill>
-          <a:blip r:embed="rId3"/>
+          <a:blip r:embed="rId2"/>
           <a:stretch>
             <a:fillRect/>
           </a:stretch>
         </p:blipFill>
         <p:spPr>
           <a:xfrm>
-            <a:off x="1490518" y="2651760"/>
-            <a:ext cx="9207915" cy="3657600"/>
+            <a:off x="1744046" y="2651760"/>
+            <a:ext cx="8700859" cy="3657600"/>
           </a:xfrm>
           <a:prstGeom prst="rect">
             <a:avLst/>
@@ -11642,7 +11493,6 @@
           <a:lstStyle/>
           <a:p>
             <a:pPr algn="ctr"/>
-            <a:endParaRPr/>
           </a:p>
         </p:txBody>
       </p:sp>
@@ -11757,7 +11607,7 @@
 </file>
 
 <file path=ppt/slides/slide26.xml><?xml version="1.0" encoding="utf-8"?>
-<p:sld xmlns:a="http://schemas.openxmlformats.org/drawingml/2006/main" xmlns:r="http://schemas.openxmlformats.org/officeDocument/2006/relationships" xmlns:p="http://schemas.openxmlformats.org/presentationml/2006/main">
+<p:sld xmlns:a="http://schemas.openxmlformats.org/drawingml/2006/main" xmlns:p="http://schemas.openxmlformats.org/presentationml/2006/main" xmlns:r="http://schemas.openxmlformats.org/officeDocument/2006/relationships">
   <p:cSld>
     <p:spTree>
       <p:nvGrpSpPr>
@@ -11765,14 +11615,7 @@
         <p:cNvGrpSpPr/>
         <p:nvPr/>
       </p:nvGrpSpPr>
-      <p:grpSpPr>
-        <a:xfrm>
-          <a:off x="0" y="0"/>
-          <a:ext cx="0" cy="0"/>
-          <a:chOff x="0" y="0"/>
-          <a:chExt cx="0" cy="0"/>
-        </a:xfrm>
-      </p:grpSpPr>
+      <p:grpSpPr/>
       <p:sp>
         <p:nvSpPr>
           <p:cNvPr id="2" name="TextBox 1"/>
@@ -11930,7 +11773,7 @@
           <p:nvPr/>
         </p:nvPicPr>
         <p:blipFill>
-          <a:blip r:embed="rId3"/>
+          <a:blip r:embed="rId2"/>
           <a:stretch>
             <a:fillRect/>
           </a:stretch>
@@ -11986,7 +11829,6 @@
           <a:lstStyle/>
           <a:p>
             <a:pPr algn="ctr"/>
-            <a:endParaRPr/>
           </a:p>
         </p:txBody>
       </p:sp>
@@ -12101,7 +11943,7 @@
 </file>
 
 <file path=ppt/slides/slide27.xml><?xml version="1.0" encoding="utf-8"?>
-<p:sld xmlns:a="http://schemas.openxmlformats.org/drawingml/2006/main" xmlns:r="http://schemas.openxmlformats.org/officeDocument/2006/relationships" xmlns:p="http://schemas.openxmlformats.org/presentationml/2006/main">
+<p:sld xmlns:a="http://schemas.openxmlformats.org/drawingml/2006/main" xmlns:p="http://schemas.openxmlformats.org/presentationml/2006/main" xmlns:r="http://schemas.openxmlformats.org/officeDocument/2006/relationships">
   <p:cSld>
     <p:spTree>
       <p:nvGrpSpPr>
@@ -12109,14 +11951,7 @@
         <p:cNvGrpSpPr/>
         <p:nvPr/>
       </p:nvGrpSpPr>
-      <p:grpSpPr>
-        <a:xfrm>
-          <a:off x="0" y="0"/>
-          <a:ext cx="0" cy="0"/>
-          <a:chOff x="0" y="0"/>
-          <a:chExt cx="0" cy="0"/>
-        </a:xfrm>
-      </p:grpSpPr>
+      <p:grpSpPr/>
       <p:sp>
         <p:nvSpPr>
           <p:cNvPr id="2" name="TextBox 1"/>
@@ -12274,7 +12109,7 @@
           <p:nvPr/>
         </p:nvPicPr>
         <p:blipFill>
-          <a:blip r:embed="rId3"/>
+          <a:blip r:embed="rId2"/>
           <a:stretch>
             <a:fillRect/>
           </a:stretch>
@@ -12330,7 +12165,6 @@
           <a:lstStyle/>
           <a:p>
             <a:pPr algn="ctr"/>
-            <a:endParaRPr/>
           </a:p>
         </p:txBody>
       </p:sp>
@@ -12445,7 +12279,7 @@
 </file>
 
 <file path=ppt/slides/slide28.xml><?xml version="1.0" encoding="utf-8"?>
-<p:sld xmlns:a="http://schemas.openxmlformats.org/drawingml/2006/main" xmlns:r="http://schemas.openxmlformats.org/officeDocument/2006/relationships" xmlns:p="http://schemas.openxmlformats.org/presentationml/2006/main">
+<p:sld xmlns:a="http://schemas.openxmlformats.org/drawingml/2006/main" xmlns:p="http://schemas.openxmlformats.org/presentationml/2006/main" xmlns:r="http://schemas.openxmlformats.org/officeDocument/2006/relationships">
   <p:cSld>
     <p:spTree>
       <p:nvGrpSpPr>
@@ -12453,14 +12287,7 @@
         <p:cNvGrpSpPr/>
         <p:nvPr/>
       </p:nvGrpSpPr>
-      <p:grpSpPr>
-        <a:xfrm>
-          <a:off x="0" y="0"/>
-          <a:ext cx="0" cy="0"/>
-          <a:chOff x="0" y="0"/>
-          <a:chExt cx="0" cy="0"/>
-        </a:xfrm>
-      </p:grpSpPr>
+      <p:grpSpPr/>
       <p:sp>
         <p:nvSpPr>
           <p:cNvPr id="2" name="TextBox 1"/>
@@ -12618,7 +12445,7 @@
           <p:nvPr/>
         </p:nvPicPr>
         <p:blipFill>
-          <a:blip r:embed="rId3"/>
+          <a:blip r:embed="rId2"/>
           <a:stretch>
             <a:fillRect/>
           </a:stretch>
@@ -12674,7 +12501,6 @@
           <a:lstStyle/>
           <a:p>
             <a:pPr algn="ctr"/>
-            <a:endParaRPr/>
           </a:p>
         </p:txBody>
       </p:sp>
@@ -12789,7 +12615,7 @@
 </file>
 
 <file path=ppt/slides/slide29.xml><?xml version="1.0" encoding="utf-8"?>
-<p:sld xmlns:a="http://schemas.openxmlformats.org/drawingml/2006/main" xmlns:r="http://schemas.openxmlformats.org/officeDocument/2006/relationships" xmlns:p="http://schemas.openxmlformats.org/presentationml/2006/main">
+<p:sld xmlns:a="http://schemas.openxmlformats.org/drawingml/2006/main" xmlns:p="http://schemas.openxmlformats.org/presentationml/2006/main" xmlns:r="http://schemas.openxmlformats.org/officeDocument/2006/relationships">
   <p:cSld>
     <p:spTree>
       <p:nvGrpSpPr>
@@ -12797,14 +12623,7 @@
         <p:cNvGrpSpPr/>
         <p:nvPr/>
       </p:nvGrpSpPr>
-      <p:grpSpPr>
-        <a:xfrm>
-          <a:off x="0" y="0"/>
-          <a:ext cx="0" cy="0"/>
-          <a:chOff x="0" y="0"/>
-          <a:chExt cx="0" cy="0"/>
-        </a:xfrm>
-      </p:grpSpPr>
+      <p:grpSpPr/>
       <p:sp>
         <p:nvSpPr>
           <p:cNvPr id="2" name="TextBox 1"/>
@@ -12962,7 +12781,7 @@
           <p:nvPr/>
         </p:nvPicPr>
         <p:blipFill>
-          <a:blip r:embed="rId3"/>
+          <a:blip r:embed="rId2"/>
           <a:stretch>
             <a:fillRect/>
           </a:stretch>
@@ -13018,7 +12837,6 @@
           <a:lstStyle/>
           <a:p>
             <a:pPr algn="ctr"/>
-            <a:endParaRPr/>
           </a:p>
         </p:txBody>
       </p:sp>
@@ -13133,7 +12951,7 @@
 </file>
 
 <file path=ppt/slides/slide3.xml><?xml version="1.0" encoding="utf-8"?>
-<p:sld xmlns:a="http://schemas.openxmlformats.org/drawingml/2006/main" xmlns:r="http://schemas.openxmlformats.org/officeDocument/2006/relationships" xmlns:p="http://schemas.openxmlformats.org/presentationml/2006/main">
+<p:sld xmlns:a="http://schemas.openxmlformats.org/drawingml/2006/main" xmlns:p="http://schemas.openxmlformats.org/presentationml/2006/main" xmlns:r="http://schemas.openxmlformats.org/officeDocument/2006/relationships">
   <p:cSld>
     <p:spTree>
       <p:nvGrpSpPr>
@@ -13141,14 +12959,7 @@
         <p:cNvGrpSpPr/>
         <p:nvPr/>
       </p:nvGrpSpPr>
-      <p:grpSpPr>
-        <a:xfrm>
-          <a:off x="0" y="0"/>
-          <a:ext cx="0" cy="0"/>
-          <a:chOff x="0" y="0"/>
-          <a:chExt cx="0" cy="0"/>
-        </a:xfrm>
-      </p:grpSpPr>
+      <p:grpSpPr/>
       <p:sp>
         <p:nvSpPr>
           <p:cNvPr id="2" name="Rectangle 1"/>
@@ -13190,7 +13001,6 @@
           <a:lstStyle/>
           <a:p>
             <a:pPr algn="ctr"/>
-            <a:endParaRPr/>
           </a:p>
         </p:txBody>
       </p:sp>
@@ -13303,7 +13113,6 @@
           <a:lstStyle/>
           <a:p>
             <a:pPr algn="ctr"/>
-            <a:endParaRPr/>
           </a:p>
         </p:txBody>
       </p:sp>
@@ -13350,7 +13159,7 @@
 </file>
 
 <file path=ppt/slides/slide30.xml><?xml version="1.0" encoding="utf-8"?>
-<p:sld xmlns:a="http://schemas.openxmlformats.org/drawingml/2006/main" xmlns:r="http://schemas.openxmlformats.org/officeDocument/2006/relationships" xmlns:p="http://schemas.openxmlformats.org/presentationml/2006/main">
+<p:sld xmlns:a="http://schemas.openxmlformats.org/drawingml/2006/main" xmlns:p="http://schemas.openxmlformats.org/presentationml/2006/main" xmlns:r="http://schemas.openxmlformats.org/officeDocument/2006/relationships">
   <p:cSld>
     <p:spTree>
       <p:nvGrpSpPr>
@@ -13358,14 +13167,7 @@
         <p:cNvGrpSpPr/>
         <p:nvPr/>
       </p:nvGrpSpPr>
-      <p:grpSpPr>
-        <a:xfrm>
-          <a:off x="0" y="0"/>
-          <a:ext cx="0" cy="0"/>
-          <a:chOff x="0" y="0"/>
-          <a:chExt cx="0" cy="0"/>
-        </a:xfrm>
-      </p:grpSpPr>
+      <p:grpSpPr/>
       <p:sp>
         <p:nvSpPr>
           <p:cNvPr id="2" name="TextBox 1"/>
@@ -13523,7 +13325,7 @@
           <p:nvPr/>
         </p:nvPicPr>
         <p:blipFill>
-          <a:blip r:embed="rId3"/>
+          <a:blip r:embed="rId2"/>
           <a:stretch>
             <a:fillRect/>
           </a:stretch>
@@ -13579,7 +13381,6 @@
           <a:lstStyle/>
           <a:p>
             <a:pPr algn="ctr"/>
-            <a:endParaRPr/>
           </a:p>
         </p:txBody>
       </p:sp>
@@ -13694,7 +13495,7 @@
 </file>
 
 <file path=ppt/slides/slide31.xml><?xml version="1.0" encoding="utf-8"?>
-<p:sld xmlns:a="http://schemas.openxmlformats.org/drawingml/2006/main" xmlns:r="http://schemas.openxmlformats.org/officeDocument/2006/relationships" xmlns:p="http://schemas.openxmlformats.org/presentationml/2006/main">
+<p:sld xmlns:a="http://schemas.openxmlformats.org/drawingml/2006/main" xmlns:p="http://schemas.openxmlformats.org/presentationml/2006/main" xmlns:r="http://schemas.openxmlformats.org/officeDocument/2006/relationships">
   <p:cSld>
     <p:spTree>
       <p:nvGrpSpPr>
@@ -13702,14 +13503,7 @@
         <p:cNvGrpSpPr/>
         <p:nvPr/>
       </p:nvGrpSpPr>
-      <p:grpSpPr>
-        <a:xfrm>
-          <a:off x="0" y="0"/>
-          <a:ext cx="0" cy="0"/>
-          <a:chOff x="0" y="0"/>
-          <a:chExt cx="0" cy="0"/>
-        </a:xfrm>
-      </p:grpSpPr>
+      <p:grpSpPr/>
       <p:sp>
         <p:nvSpPr>
           <p:cNvPr id="2" name="TextBox 1"/>
@@ -13867,7 +13661,7 @@
           <p:nvPr/>
         </p:nvPicPr>
         <p:blipFill>
-          <a:blip r:embed="rId3"/>
+          <a:blip r:embed="rId2"/>
           <a:stretch>
             <a:fillRect/>
           </a:stretch>
@@ -13923,7 +13717,6 @@
           <a:lstStyle/>
           <a:p>
             <a:pPr algn="ctr"/>
-            <a:endParaRPr/>
           </a:p>
         </p:txBody>
       </p:sp>
@@ -14038,7 +13831,7 @@
 </file>
 
 <file path=ppt/slides/slide32.xml><?xml version="1.0" encoding="utf-8"?>
-<p:sld xmlns:a="http://schemas.openxmlformats.org/drawingml/2006/main" xmlns:r="http://schemas.openxmlformats.org/officeDocument/2006/relationships" xmlns:p="http://schemas.openxmlformats.org/presentationml/2006/main">
+<p:sld xmlns:a="http://schemas.openxmlformats.org/drawingml/2006/main" xmlns:p="http://schemas.openxmlformats.org/presentationml/2006/main" xmlns:r="http://schemas.openxmlformats.org/officeDocument/2006/relationships">
   <p:cSld>
     <p:spTree>
       <p:nvGrpSpPr>
@@ -14046,14 +13839,7 @@
         <p:cNvGrpSpPr/>
         <p:nvPr/>
       </p:nvGrpSpPr>
-      <p:grpSpPr>
-        <a:xfrm>
-          <a:off x="0" y="0"/>
-          <a:ext cx="0" cy="0"/>
-          <a:chOff x="0" y="0"/>
-          <a:chExt cx="0" cy="0"/>
-        </a:xfrm>
-      </p:grpSpPr>
+      <p:grpSpPr/>
       <p:sp>
         <p:nvSpPr>
           <p:cNvPr id="2" name="TextBox 1"/>
@@ -14211,7 +13997,7 @@
           <p:nvPr/>
         </p:nvPicPr>
         <p:blipFill>
-          <a:blip r:embed="rId3"/>
+          <a:blip r:embed="rId2"/>
           <a:stretch>
             <a:fillRect/>
           </a:stretch>
@@ -14268,7 +14054,6 @@
           <a:lstStyle/>
           <a:p>
             <a:pPr algn="ctr"/>
-            <a:endParaRPr/>
           </a:p>
         </p:txBody>
       </p:sp>
@@ -14312,7 +14097,6 @@
           <a:lstStyle/>
           <a:p>
             <a:pPr algn="ctr"/>
-            <a:endParaRPr/>
           </a:p>
         </p:txBody>
       </p:sp>
@@ -14391,7 +14175,6 @@
           <a:lstStyle/>
           <a:p>
             <a:pPr algn="ctr"/>
-            <a:endParaRPr/>
           </a:p>
         </p:txBody>
       </p:sp>
@@ -14506,7 +14289,7 @@
 </file>
 
 <file path=ppt/slides/slide33.xml><?xml version="1.0" encoding="utf-8"?>
-<p:sld xmlns:a="http://schemas.openxmlformats.org/drawingml/2006/main" xmlns:r="http://schemas.openxmlformats.org/officeDocument/2006/relationships" xmlns:p="http://schemas.openxmlformats.org/presentationml/2006/main">
+<p:sld xmlns:a="http://schemas.openxmlformats.org/drawingml/2006/main" xmlns:p="http://schemas.openxmlformats.org/presentationml/2006/main" xmlns:r="http://schemas.openxmlformats.org/officeDocument/2006/relationships">
   <p:cSld>
     <p:spTree>
       <p:nvGrpSpPr>
@@ -14514,14 +14297,7 @@
         <p:cNvGrpSpPr/>
         <p:nvPr/>
       </p:nvGrpSpPr>
-      <p:grpSpPr>
-        <a:xfrm>
-          <a:off x="0" y="0"/>
-          <a:ext cx="0" cy="0"/>
-          <a:chOff x="0" y="0"/>
-          <a:chExt cx="0" cy="0"/>
-        </a:xfrm>
-      </p:grpSpPr>
+      <p:grpSpPr/>
       <p:sp>
         <p:nvSpPr>
           <p:cNvPr id="2" name="TextBox 1"/>
@@ -14679,7 +14455,7 @@
           <p:nvPr/>
         </p:nvPicPr>
         <p:blipFill>
-          <a:blip r:embed="rId3"/>
+          <a:blip r:embed="rId2"/>
           <a:stretch>
             <a:fillRect/>
           </a:stretch>
@@ -14735,7 +14511,6 @@
           <a:lstStyle/>
           <a:p>
             <a:pPr algn="ctr"/>
-            <a:endParaRPr/>
           </a:p>
         </p:txBody>
       </p:sp>
@@ -14850,7 +14625,7 @@
 </file>
 
 <file path=ppt/slides/slide4.xml><?xml version="1.0" encoding="utf-8"?>
-<p:sld xmlns:a="http://schemas.openxmlformats.org/drawingml/2006/main" xmlns:r="http://schemas.openxmlformats.org/officeDocument/2006/relationships" xmlns:p="http://schemas.openxmlformats.org/presentationml/2006/main">
+<p:sld xmlns:a="http://schemas.openxmlformats.org/drawingml/2006/main" xmlns:p="http://schemas.openxmlformats.org/presentationml/2006/main" xmlns:r="http://schemas.openxmlformats.org/officeDocument/2006/relationships">
   <p:cSld>
     <p:spTree>
       <p:nvGrpSpPr>
@@ -14858,14 +14633,7 @@
         <p:cNvGrpSpPr/>
         <p:nvPr/>
       </p:nvGrpSpPr>
-      <p:grpSpPr>
-        <a:xfrm>
-          <a:off x="0" y="0"/>
-          <a:ext cx="0" cy="0"/>
-          <a:chOff x="0" y="0"/>
-          <a:chExt cx="0" cy="0"/>
-        </a:xfrm>
-      </p:grpSpPr>
+      <p:grpSpPr/>
       <p:sp>
         <p:nvSpPr>
           <p:cNvPr id="2" name="TextBox 1"/>
@@ -14973,7 +14741,6 @@
           <a:lstStyle/>
           <a:p>
             <a:pPr algn="ctr"/>
-            <a:endParaRPr/>
           </a:p>
         </p:txBody>
       </p:sp>
@@ -15018,7 +14785,6 @@
           <a:lstStyle/>
           <a:p>
             <a:pPr algn="ctr"/>
-            <a:endParaRPr/>
           </a:p>
         </p:txBody>
       </p:sp>
@@ -15087,29 +14853,6 @@
                 </a:solidFill>
               </a:rPr>
               <a:t>Output: robot position (x, y) on the 189.5 m² floor plan</a:t>
-            </a:r>
-          </a:p>
-          <a:p>
-            <a:pPr>
-              <a:spcAft>
-                <a:spcPts val="1600"/>
-              </a:spcAft>
-            </a:pPr>
-            <a:r>
-              <a:rPr sz="2600" b="1">
-                <a:solidFill>
-                  <a:srgbClr val="1B6EC2"/>
-                </a:solidFill>
-              </a:rPr>
-              <a:t>▪  </a:t>
-            </a:r>
-            <a:r>
-              <a:rPr sz="2600">
-                <a:solidFill>
-                  <a:srgbClr val="1F2D3D"/>
-                </a:solidFill>
-              </a:rPr>
-              <a:t>No GPS indoors — WiFi fingerprinting is the classic fallback</a:t>
             </a:r>
           </a:p>
           <a:p>
@@ -15178,7 +14921,6 @@
           <a:lstStyle/>
           <a:p>
             <a:pPr algn="ctr"/>
-            <a:endParaRPr/>
           </a:p>
         </p:txBody>
       </p:sp>
@@ -15293,7 +15035,7 @@
 </file>
 
 <file path=ppt/slides/slide5.xml><?xml version="1.0" encoding="utf-8"?>
-<p:sld xmlns:a="http://schemas.openxmlformats.org/drawingml/2006/main" xmlns:r="http://schemas.openxmlformats.org/officeDocument/2006/relationships" xmlns:p="http://schemas.openxmlformats.org/presentationml/2006/main">
+<p:sld xmlns:a="http://schemas.openxmlformats.org/drawingml/2006/main" xmlns:p="http://schemas.openxmlformats.org/presentationml/2006/main" xmlns:r="http://schemas.openxmlformats.org/officeDocument/2006/relationships">
   <p:cSld>
     <p:spTree>
       <p:nvGrpSpPr>
@@ -15301,14 +15043,7 @@
         <p:cNvGrpSpPr/>
         <p:nvPr/>
       </p:nvGrpSpPr>
-      <p:grpSpPr>
-        <a:xfrm>
-          <a:off x="0" y="0"/>
-          <a:ext cx="0" cy="0"/>
-          <a:chOff x="0" y="0"/>
-          <a:chExt cx="0" cy="0"/>
-        </a:xfrm>
-      </p:grpSpPr>
+      <p:grpSpPr/>
       <p:sp>
         <p:nvSpPr>
           <p:cNvPr id="2" name="TextBox 1"/>
@@ -15416,7 +15151,6 @@
           <a:lstStyle/>
           <a:p>
             <a:pPr algn="ctr"/>
-            <a:endParaRPr/>
           </a:p>
         </p:txBody>
       </p:sp>
@@ -15461,7 +15195,6 @@
           <a:lstStyle/>
           <a:p>
             <a:pPr algn="ctr"/>
-            <a:endParaRPr/>
           </a:p>
         </p:txBody>
       </p:sp>
@@ -15621,7 +15354,6 @@
           <a:lstStyle/>
           <a:p>
             <a:pPr algn="ctr"/>
-            <a:endParaRPr/>
           </a:p>
         </p:txBody>
       </p:sp>
@@ -15736,7 +15468,7 @@
 </file>
 
 <file path=ppt/slides/slide6.xml><?xml version="1.0" encoding="utf-8"?>
-<p:sld xmlns:a="http://schemas.openxmlformats.org/drawingml/2006/main" xmlns:r="http://schemas.openxmlformats.org/officeDocument/2006/relationships" xmlns:p="http://schemas.openxmlformats.org/presentationml/2006/main">
+<p:sld xmlns:a="http://schemas.openxmlformats.org/drawingml/2006/main" xmlns:p="http://schemas.openxmlformats.org/presentationml/2006/main" xmlns:r="http://schemas.openxmlformats.org/officeDocument/2006/relationships">
   <p:cSld>
     <p:spTree>
       <p:nvGrpSpPr>
@@ -15744,14 +15476,7 @@
         <p:cNvGrpSpPr/>
         <p:nvPr/>
       </p:nvGrpSpPr>
-      <p:grpSpPr>
-        <a:xfrm>
-          <a:off x="0" y="0"/>
-          <a:ext cx="0" cy="0"/>
-          <a:chOff x="0" y="0"/>
-          <a:chExt cx="0" cy="0"/>
-        </a:xfrm>
-      </p:grpSpPr>
+      <p:grpSpPr/>
       <p:sp>
         <p:nvSpPr>
           <p:cNvPr id="2" name="Rectangle 1"/>
@@ -15793,7 +15518,6 @@
           <a:lstStyle/>
           <a:p>
             <a:pPr algn="ctr"/>
-            <a:endParaRPr/>
           </a:p>
         </p:txBody>
       </p:sp>
@@ -15906,7 +15630,6 @@
           <a:lstStyle/>
           <a:p>
             <a:pPr algn="ctr"/>
-            <a:endParaRPr/>
           </a:p>
         </p:txBody>
       </p:sp>
@@ -15953,7 +15676,7 @@
 </file>
 
 <file path=ppt/slides/slide7.xml><?xml version="1.0" encoding="utf-8"?>
-<p:sld xmlns:a="http://schemas.openxmlformats.org/drawingml/2006/main" xmlns:r="http://schemas.openxmlformats.org/officeDocument/2006/relationships" xmlns:p="http://schemas.openxmlformats.org/presentationml/2006/main">
+<p:sld xmlns:a="http://schemas.openxmlformats.org/drawingml/2006/main" xmlns:p="http://schemas.openxmlformats.org/presentationml/2006/main" xmlns:r="http://schemas.openxmlformats.org/officeDocument/2006/relationships">
   <p:cSld>
     <p:spTree>
       <p:nvGrpSpPr>
@@ -15961,14 +15684,7 @@
         <p:cNvGrpSpPr/>
         <p:nvPr/>
       </p:nvGrpSpPr>
-      <p:grpSpPr>
-        <a:xfrm>
-          <a:off x="0" y="0"/>
-          <a:ext cx="0" cy="0"/>
-          <a:chOff x="0" y="0"/>
-          <a:chExt cx="0" cy="0"/>
-        </a:xfrm>
-      </p:grpSpPr>
+      <p:grpSpPr/>
       <p:sp>
         <p:nvSpPr>
           <p:cNvPr id="2" name="TextBox 1"/>
@@ -16076,7 +15792,6 @@
           <a:lstStyle/>
           <a:p>
             <a:pPr algn="ctr"/>
-            <a:endParaRPr/>
           </a:p>
         </p:txBody>
       </p:sp>
@@ -16121,7 +15836,6 @@
           <a:lstStyle/>
           <a:p>
             <a:pPr algn="ctr"/>
-            <a:endParaRPr/>
           </a:p>
         </p:txBody>
       </p:sp>
@@ -16281,7 +15995,6 @@
           <a:lstStyle/>
           <a:p>
             <a:pPr algn="ctr"/>
-            <a:endParaRPr/>
           </a:p>
         </p:txBody>
       </p:sp>
@@ -16396,7 +16109,7 @@
 </file>
 
 <file path=ppt/slides/slide8.xml><?xml version="1.0" encoding="utf-8"?>
-<p:sld xmlns:a="http://schemas.openxmlformats.org/drawingml/2006/main" xmlns:r="http://schemas.openxmlformats.org/officeDocument/2006/relationships" xmlns:p="http://schemas.openxmlformats.org/presentationml/2006/main">
+<p:sld xmlns:a="http://schemas.openxmlformats.org/drawingml/2006/main" xmlns:p="http://schemas.openxmlformats.org/presentationml/2006/main" xmlns:r="http://schemas.openxmlformats.org/officeDocument/2006/relationships">
   <p:cSld>
     <p:spTree>
       <p:nvGrpSpPr>
@@ -16404,14 +16117,7 @@
         <p:cNvGrpSpPr/>
         <p:nvPr/>
       </p:nvGrpSpPr>
-      <p:grpSpPr>
-        <a:xfrm>
-          <a:off x="0" y="0"/>
-          <a:ext cx="0" cy="0"/>
-          <a:chOff x="0" y="0"/>
-          <a:chExt cx="0" cy="0"/>
-        </a:xfrm>
-      </p:grpSpPr>
+      <p:grpSpPr/>
       <p:sp>
         <p:nvSpPr>
           <p:cNvPr id="2" name="TextBox 1"/>
@@ -16569,7 +16275,7 @@
           <p:nvPr/>
         </p:nvPicPr>
         <p:blipFill>
-          <a:blip r:embed="rId3"/>
+          <a:blip r:embed="rId2"/>
           <a:stretch>
             <a:fillRect/>
           </a:stretch>
@@ -16625,7 +16331,6 @@
           <a:lstStyle/>
           <a:p>
             <a:pPr algn="ctr"/>
-            <a:endParaRPr/>
           </a:p>
         </p:txBody>
       </p:sp>
@@ -16740,7 +16445,7 @@
 </file>
 
 <file path=ppt/slides/slide9.xml><?xml version="1.0" encoding="utf-8"?>
-<p:sld xmlns:a="http://schemas.openxmlformats.org/drawingml/2006/main" xmlns:r="http://schemas.openxmlformats.org/officeDocument/2006/relationships" xmlns:p="http://schemas.openxmlformats.org/presentationml/2006/main">
+<p:sld xmlns:a="http://schemas.openxmlformats.org/drawingml/2006/main" xmlns:p="http://schemas.openxmlformats.org/presentationml/2006/main" xmlns:r="http://schemas.openxmlformats.org/officeDocument/2006/relationships">
   <p:cSld>
     <p:spTree>
       <p:nvGrpSpPr>
@@ -16748,14 +16453,7 @@
         <p:cNvGrpSpPr/>
         <p:nvPr/>
       </p:nvGrpSpPr>
-      <p:grpSpPr>
-        <a:xfrm>
-          <a:off x="0" y="0"/>
-          <a:ext cx="0" cy="0"/>
-          <a:chOff x="0" y="0"/>
-          <a:chExt cx="0" cy="0"/>
-        </a:xfrm>
-      </p:grpSpPr>
+      <p:grpSpPr/>
       <p:sp>
         <p:nvSpPr>
           <p:cNvPr id="2" name="TextBox 1"/>
@@ -16863,7 +16561,6 @@
           <a:lstStyle/>
           <a:p>
             <a:pPr algn="ctr"/>
-            <a:endParaRPr/>
           </a:p>
         </p:txBody>
       </p:sp>
@@ -16908,7 +16605,6 @@
           <a:lstStyle/>
           <a:p>
             <a:pPr algn="ctr"/>
-            <a:endParaRPr/>
           </a:p>
         </p:txBody>
       </p:sp>
@@ -17068,7 +16764,6 @@
           <a:lstStyle/>
           <a:p>
             <a:pPr algn="ctr"/>
-            <a:endParaRPr/>
           </a:p>
         </p:txBody>
       </p:sp>
@@ -17503,7 +17198,7 @@
 </file>
 
 <file path=ppt/theme/theme2.xml><?xml version="1.0" encoding="utf-8"?>
-<a:theme xmlns:a="http://schemas.openxmlformats.org/drawingml/2006/main" name="Office 佈景主題">
+<a:theme xmlns:a="http://schemas.openxmlformats.org/drawingml/2006/main" name="Office Theme">
   <a:themeElements>
     <a:clrScheme name="Office">
       <a:dk1>
@@ -17513,44 +17208,44 @@
         <a:sysClr val="window" lastClr="FFFFFF"/>
       </a:lt1>
       <a:dk2>
-        <a:srgbClr val="0E2841"/>
+        <a:srgbClr val="1F497D"/>
       </a:dk2>
       <a:lt2>
-        <a:srgbClr val="E8E8E8"/>
+        <a:srgbClr val="EEECE1"/>
       </a:lt2>
       <a:accent1>
-        <a:srgbClr val="156082"/>
+        <a:srgbClr val="4F81BD"/>
       </a:accent1>
       <a:accent2>
-        <a:srgbClr val="E97132"/>
+        <a:srgbClr val="C0504D"/>
       </a:accent2>
       <a:accent3>
-        <a:srgbClr val="196B24"/>
+        <a:srgbClr val="9BBB59"/>
       </a:accent3>
       <a:accent4>
-        <a:srgbClr val="0F9ED5"/>
+        <a:srgbClr val="8064A2"/>
       </a:accent4>
       <a:accent5>
-        <a:srgbClr val="A02B93"/>
+        <a:srgbClr val="4BACC6"/>
       </a:accent5>
       <a:accent6>
-        <a:srgbClr val="4EA72E"/>
+        <a:srgbClr val="F79646"/>
       </a:accent6>
       <a:hlink>
-        <a:srgbClr val="467886"/>
+        <a:srgbClr val="0000FF"/>
       </a:hlink>
       <a:folHlink>
-        <a:srgbClr val="96607D"/>
+        <a:srgbClr val="800080"/>
       </a:folHlink>
     </a:clrScheme>
     <a:fontScheme name="Office">
       <a:majorFont>
-        <a:latin typeface="Aptos Display" panose="02110004020202020204"/>
+        <a:latin typeface="Calibri"/>
         <a:ea typeface=""/>
         <a:cs typeface=""/>
-        <a:font script="Jpan" typeface="游ゴシック Light"/>
+        <a:font script="Jpan" typeface="ＭＳ Ｐゴシック"/>
         <a:font script="Hang" typeface="맑은 고딕"/>
-        <a:font script="Hans" typeface="等线 Light"/>
+        <a:font script="Hans" typeface="宋体"/>
         <a:font script="Hant" typeface="新細明體"/>
         <a:font script="Arab" typeface="Times New Roman"/>
         <a:font script="Hebr" typeface="Times New Roman"/>
@@ -17578,31 +17273,14 @@
         <a:font script="Viet" typeface="Times New Roman"/>
         <a:font script="Uigh" typeface="Microsoft Uighur"/>
         <a:font script="Geor" typeface="Sylfaen"/>
-        <a:font script="Armn" typeface="Arial"/>
-        <a:font script="Bugi" typeface="Leelawadee UI"/>
-        <a:font script="Bopo" typeface="Microsoft JhengHei"/>
-        <a:font script="Java" typeface="Javanese Text"/>
-        <a:font script="Lisu" typeface="Segoe UI"/>
-        <a:font script="Mymr" typeface="Myanmar Text"/>
-        <a:font script="Nkoo" typeface="Ebrima"/>
-        <a:font script="Olck" typeface="Nirmala UI"/>
-        <a:font script="Osma" typeface="Ebrima"/>
-        <a:font script="Phag" typeface="Phagspa"/>
-        <a:font script="Syrn" typeface="Estrangelo Edessa"/>
-        <a:font script="Syrj" typeface="Estrangelo Edessa"/>
-        <a:font script="Syre" typeface="Estrangelo Edessa"/>
-        <a:font script="Sora" typeface="Nirmala UI"/>
-        <a:font script="Tale" typeface="Microsoft Tai Le"/>
-        <a:font script="Talu" typeface="Microsoft New Tai Lue"/>
-        <a:font script="Tfng" typeface="Ebrima"/>
       </a:majorFont>
       <a:minorFont>
-        <a:latin typeface="Aptos" panose="02110004020202020204"/>
+        <a:latin typeface="Calibri"/>
         <a:ea typeface=""/>
         <a:cs typeface=""/>
-        <a:font script="Jpan" typeface="游ゴシック"/>
+        <a:font script="Jpan" typeface="ＭＳ Ｐゴシック"/>
         <a:font script="Hang" typeface="맑은 고딕"/>
-        <a:font script="Hans" typeface="等线"/>
+        <a:font script="Hans" typeface="宋体"/>
         <a:font script="Hant" typeface="新細明體"/>
         <a:font script="Arab" typeface="Arial"/>
         <a:font script="Hebr" typeface="Arial"/>
@@ -17630,23 +17308,6 @@
         <a:font script="Viet" typeface="Arial"/>
         <a:font script="Uigh" typeface="Microsoft Uighur"/>
         <a:font script="Geor" typeface="Sylfaen"/>
-        <a:font script="Armn" typeface="Arial"/>
-        <a:font script="Bugi" typeface="Leelawadee UI"/>
-        <a:font script="Bopo" typeface="Microsoft JhengHei"/>
-        <a:font script="Java" typeface="Javanese Text"/>
-        <a:font script="Lisu" typeface="Segoe UI"/>
-        <a:font script="Mymr" typeface="Myanmar Text"/>
-        <a:font script="Nkoo" typeface="Ebrima"/>
-        <a:font script="Olck" typeface="Nirmala UI"/>
-        <a:font script="Osma" typeface="Ebrima"/>
-        <a:font script="Phag" typeface="Phagspa"/>
-        <a:font script="Syrn" typeface="Estrangelo Edessa"/>
-        <a:font script="Syrj" typeface="Estrangelo Edessa"/>
-        <a:font script="Syre" typeface="Estrangelo Edessa"/>
-        <a:font script="Sora" typeface="Nirmala UI"/>
-        <a:font script="Tale" typeface="Microsoft Tai Le"/>
-        <a:font script="Talu" typeface="Microsoft New Tai Lue"/>
-        <a:font script="Tfng" typeface="Ebrima"/>
       </a:minorFont>
     </a:fontScheme>
     <a:fmtScheme name="Office">
@@ -17658,136 +17319,180 @@
           <a:gsLst>
             <a:gs pos="0">
               <a:schemeClr val="phClr">
-                <a:lumMod val="110000"/>
-                <a:satMod val="105000"/>
-                <a:tint val="67000"/>
+                <a:tint val="50000"/>
+                <a:satMod val="300000"/>
               </a:schemeClr>
             </a:gs>
-            <a:gs pos="50000">
+            <a:gs pos="35000">
               <a:schemeClr val="phClr">
-                <a:lumMod val="105000"/>
-                <a:satMod val="103000"/>
-                <a:tint val="73000"/>
+                <a:tint val="37000"/>
+                <a:satMod val="300000"/>
               </a:schemeClr>
             </a:gs>
             <a:gs pos="100000">
               <a:schemeClr val="phClr">
-                <a:lumMod val="105000"/>
-                <a:satMod val="109000"/>
-                <a:tint val="81000"/>
+                <a:tint val="15000"/>
+                <a:satMod val="350000"/>
               </a:schemeClr>
             </a:gs>
           </a:gsLst>
-          <a:lin ang="5400000" scaled="0"/>
+          <a:lin ang="16200000" scaled="1"/>
         </a:gradFill>
         <a:gradFill rotWithShape="1">
           <a:gsLst>
             <a:gs pos="0">
               <a:schemeClr val="phClr">
-                <a:satMod val="103000"/>
-                <a:lumMod val="102000"/>
-                <a:tint val="94000"/>
-              </a:schemeClr>
-            </a:gs>
-            <a:gs pos="50000">
-              <a:schemeClr val="phClr">
-                <a:satMod val="110000"/>
-                <a:lumMod val="100000"/>
+                <a:tint val="100000"/>
                 <a:shade val="100000"/>
+                <a:satMod val="130000"/>
               </a:schemeClr>
             </a:gs>
             <a:gs pos="100000">
               <a:schemeClr val="phClr">
-                <a:lumMod val="99000"/>
-                <a:satMod val="120000"/>
-                <a:shade val="78000"/>
+                <a:tint val="50000"/>
+                <a:shade val="100000"/>
+                <a:satMod val="350000"/>
               </a:schemeClr>
             </a:gs>
           </a:gsLst>
-          <a:lin ang="5400000" scaled="0"/>
+          <a:lin ang="16200000" scaled="0"/>
         </a:gradFill>
       </a:fillStyleLst>
       <a:lnStyleLst>
-        <a:ln w="12700" cap="flat" cmpd="sng" algn="ctr">
+        <a:ln w="9525" cap="flat" cmpd="sng" algn="ctr">
           <a:solidFill>
-            <a:schemeClr val="phClr"/>
+            <a:schemeClr val="phClr">
+              <a:shade val="95000"/>
+              <a:satMod val="105000"/>
+            </a:schemeClr>
           </a:solidFill>
           <a:prstDash val="solid"/>
-          <a:miter lim="800000"/>
-        </a:ln>
-        <a:ln w="19050" cap="flat" cmpd="sng" algn="ctr">
-          <a:solidFill>
-            <a:schemeClr val="phClr"/>
-          </a:solidFill>
-          <a:prstDash val="solid"/>
-          <a:miter lim="800000"/>
         </a:ln>
         <a:ln w="25400" cap="flat" cmpd="sng" algn="ctr">
           <a:solidFill>
             <a:schemeClr val="phClr"/>
           </a:solidFill>
           <a:prstDash val="solid"/>
-          <a:miter lim="800000"/>
+        </a:ln>
+        <a:ln w="38100" cap="flat" cmpd="sng" algn="ctr">
+          <a:solidFill>
+            <a:schemeClr val="phClr"/>
+          </a:solidFill>
+          <a:prstDash val="solid"/>
         </a:ln>
       </a:lnStyleLst>
       <a:effectStyleLst>
         <a:effectStyle>
-          <a:effectLst/>
-        </a:effectStyle>
-        <a:effectStyle>
-          <a:effectLst/>
+          <a:effectLst>
+            <a:outerShdw blurRad="40000" dist="20000" dir="5400000" rotWithShape="0">
+              <a:srgbClr val="000000">
+                <a:alpha val="38000"/>
+              </a:srgbClr>
+            </a:outerShdw>
+          </a:effectLst>
         </a:effectStyle>
         <a:effectStyle>
           <a:effectLst>
-            <a:outerShdw blurRad="57150" dist="19050" dir="5400000" algn="ctr" rotWithShape="0">
+            <a:outerShdw blurRad="40000" dist="23000" dir="5400000" rotWithShape="0">
               <a:srgbClr val="000000">
-                <a:alpha val="63000"/>
+                <a:alpha val="35000"/>
               </a:srgbClr>
             </a:outerShdw>
           </a:effectLst>
+        </a:effectStyle>
+        <a:effectStyle>
+          <a:effectLst>
+            <a:outerShdw blurRad="40000" dist="23000" dir="5400000" rotWithShape="0">
+              <a:srgbClr val="000000">
+                <a:alpha val="35000"/>
+              </a:srgbClr>
+            </a:outerShdw>
+          </a:effectLst>
+          <a:scene3d>
+            <a:camera prst="orthographicFront">
+              <a:rot lat="0" lon="0" rev="0"/>
+            </a:camera>
+            <a:lightRig rig="threePt" dir="t">
+              <a:rot lat="0" lon="0" rev="1200000"/>
+            </a:lightRig>
+          </a:scene3d>
+          <a:sp3d>
+            <a:bevelT w="63500" h="25400"/>
+          </a:sp3d>
         </a:effectStyle>
       </a:effectStyleLst>
       <a:bgFillStyleLst>
         <a:solidFill>
           <a:schemeClr val="phClr"/>
         </a:solidFill>
-        <a:solidFill>
-          <a:schemeClr val="phClr">
-            <a:tint val="95000"/>
-            <a:satMod val="170000"/>
-          </a:schemeClr>
-        </a:solidFill>
         <a:gradFill rotWithShape="1">
           <a:gsLst>
             <a:gs pos="0">
               <a:schemeClr val="phClr">
-                <a:tint val="93000"/>
-                <a:satMod val="150000"/>
-                <a:shade val="98000"/>
-                <a:lumMod val="102000"/>
+                <a:tint val="40000"/>
+                <a:satMod val="350000"/>
               </a:schemeClr>
             </a:gs>
-            <a:gs pos="50000">
+            <a:gs pos="40000">
               <a:schemeClr val="phClr">
-                <a:tint val="98000"/>
-                <a:satMod val="130000"/>
-                <a:shade val="90000"/>
-                <a:lumMod val="103000"/>
+                <a:tint val="45000"/>
+                <a:shade val="99000"/>
+                <a:satMod val="350000"/>
               </a:schemeClr>
             </a:gs>
             <a:gs pos="100000">
               <a:schemeClr val="phClr">
-                <a:shade val="63000"/>
-                <a:satMod val="120000"/>
+                <a:shade val="20000"/>
+                <a:satMod val="255000"/>
               </a:schemeClr>
             </a:gs>
           </a:gsLst>
-          <a:lin ang="5400000" scaled="0"/>
+          <a:path path="circle">
+            <a:fillToRect l="50000" t="-80000" r="50000" b="180000"/>
+          </a:path>
+        </a:gradFill>
+        <a:gradFill rotWithShape="1">
+          <a:gsLst>
+            <a:gs pos="0">
+              <a:schemeClr val="phClr">
+                <a:tint val="80000"/>
+                <a:satMod val="300000"/>
+              </a:schemeClr>
+            </a:gs>
+            <a:gs pos="100000">
+              <a:schemeClr val="phClr">
+                <a:shade val="30000"/>
+                <a:satMod val="200000"/>
+              </a:schemeClr>
+            </a:gs>
+          </a:gsLst>
+          <a:path path="circle">
+            <a:fillToRect l="50000" t="50000" r="50000" b="50000"/>
+          </a:path>
         </a:gradFill>
       </a:bgFillStyleLst>
     </a:fmtScheme>
   </a:themeElements>
   <a:objectDefaults>
+    <a:spDef>
+      <a:spPr/>
+      <a:bodyPr/>
+      <a:lstStyle/>
+      <a:style>
+        <a:lnRef idx="1">
+          <a:schemeClr val="accent1"/>
+        </a:lnRef>
+        <a:fillRef idx="3">
+          <a:schemeClr val="accent1"/>
+        </a:fillRef>
+        <a:effectRef idx="2">
+          <a:schemeClr val="accent1"/>
+        </a:effectRef>
+        <a:fontRef idx="minor">
+          <a:schemeClr val="lt1"/>
+        </a:fontRef>
+      </a:style>
+    </a:spDef>
     <a:lnDef>
       <a:spPr/>
       <a:bodyPr/>
@@ -17809,10 +17514,5 @@
     </a:lnDef>
   </a:objectDefaults>
   <a:extraClrSchemeLst/>
-  <a:extLst>
-    <a:ext uri="{05A4C25C-085E-4340-85A3-A5531E510DB2}">
-      <thm15:themeFamily xmlns:thm15="http://schemas.microsoft.com/office/thememl/2012/main" name="Office Theme" id="{2E142A2C-CD16-42D6-873A-C26D2A0506FA}" vid="{1BDDFF52-6CD6-40A5-AB3C-68EB2F1E4D0A}"/>
-    </a:ext>
-  </a:extLst>
 </a:theme>
 </file>
</xml_diff>

<commit_message>
Drop the 0.94 nested-CV number from the presentation
Per request: don't present the pessimistic nested-CV figure. Removed it
from all visible slides + speaker notes (the deep technical record in
TECHNICAL_REPORT.md keeps it):

- Deleted the dedicated nested-CV slide (its whole payload was 0.94) -> 32 slides
- Reframed honesty-audit slide around the still-valuable lesson without 0.94:
  0.650 test-tuned mirage -> 0.710 exposed on held-out val -> 0.752 honest
- Regenerated honest_validation.png right panel to match (no 0.94 bar)
- Scrubbed 0.94/nested from roadmap, results divider, conclusion, title &
  gp-synth notes; kept the unrelated C-Mixup 0.94 dead-end on slide 29
- READMEs (root, lab3, slides) headline/footnotes no longer state 0.94

Co-Authored-By: Claude Opus 4.8 <noreply@anthropic.com>
</commit_message>
<xml_diff>
--- a/lab3/outputs/slides/lab3_presentation.pptx
+++ b/lab3/outputs/slides/lab3_presentation.pptx
@@ -37,7 +37,6 @@
     <p:sldId id="285" r:id="rId37"/>
     <p:sldId id="286" r:id="rId38"/>
     <p:sldId id="287" r:id="rId39"/>
-    <p:sldId id="288" r:id="rId40"/>
   </p:sldIdLst>
   <p:sldSz cx="12191695" cy="6858000" type="screen4x3"/>
   <p:notesSz cx="6858000" cy="9144000"/>
@@ -534,7 +533,7 @@
           <a:lstStyle/>
           <a:p>
             <a:r>
-              <a:t>先把這份報告的定位講清楚:它講的是一個工程過程,不是單一模型的炫技。題目來自 Lab 2,我們用 ESP32-S3 裝在 TurtleBot3 上,在約 189.5 平方公尺的實驗室收 WiFi 訊號強度,目標是讓機器人不靠 GPS 在室內定出座標。我會從不用訓練的 KNN 基準線 1.57 公尺講起,一步步說明每次卡關、為什麼換方法,最後把中位數誤差砍到約 0.75。請先記住三個數字:標準 train→test 是 0.75;最嚴格的無洩漏巢狀五折交叉驗證是 0.94(最保守的上限);另外早期曾在測試集上做模型選擇挑出 0.65,那個不算數、後面會說明原因。畫面這張爬坡圖貫穿全場,從 1.57 一路往下,每一格後面都會回來細講。(開場點一下三個數字就推進,別在這裡耗時間。)</a:t>
+              <a:t>先把這份報告的定位講清楚:它講的是一個工程過程,不是單一模型的炫技。題目來自 Lab 2,我們用 ESP32-S3 裝在 TurtleBot3 上,在約 189.5 平方公尺的實驗室收 WiFi 訊號強度,目標是讓機器人不靠 GPS 在室內定出座標。我會從不用訓練的 KNN 基準線 1.57 公尺講起,一步步說明每次卡關、為什麼換方法,最後把中位數誤差砍到約 0.75。請先記住兩個數字:標準 train→test 中位誤差是 0.75,這是貫穿全場的主數字;另外早期曾在測試集上做模型選擇挑出 0.65,那個不算數、後面會專門說明原因。畫面這張爬坡圖貫穿全場,從 1.57 一路往下,每一格後面都會回來細講。(開場點一下這兩個數字就推進,別在這裡耗時間。)</a:t>
             </a:r>
           </a:p>
         </p:txBody>
@@ -1164,7 +1163,7 @@
           <a:lstStyle/>
           <a:p>
             <a:r>
-              <a:t>(BACKUP-eligible:這張的口頭版只要 lead 那個 27.1 對 27.7 的體檢數字就很有說服力,流程細節有時間或被問到再展開。)我要回答一個很合理也很尖銳的質疑:你生的是假資料,憑什麼相信它沒把模型帶歪、甚至沒洩漏測試集?所以這張把生成流程拆成兩個模型加一道體檢,並先把無洩漏這點講死。第一個模型是強度:對每個 AP 各擬一個二維高斯過程,從位置映到 RSSI,GP 不只給內插值還給每個位置的不確定度,本質是平滑場,在沒走過的上半部生出來的訊號會平滑延續鄰近真實量測、不會憑空冒尖峰,這就是 kriging 的精神。但光有強度不夠真實,因為不是每個 AP 在每個位置都收得到,離得遠或被牆擋就掃不到;所以第二個模型是偵測:用一個 KNN 偵測模型,根據鄰近真實掃描判斷在這個位置某個 AP 看不看得見,只有判定可見的 AP 才放進這筆合成掃描、再由 GP 填強度。最關鍵的無洩漏原則:這兩個模型——GP 跟 KNN 偵測——都只用訓練集的位置去擬合,從不碰任何測試位姿,合成掃描也只生在訓練分布裡,所以標準 A 切法的 0.91 是乾淨的;而且在後面巢狀交叉驗證裡,合成資料是每一折用該折的訓練資料重新生成的,不會把外層測試折的資訊漏進去,否則那個 0.94 就不成立。我們在可行空間抽樣五千個位置生成,偏重那塊空白上半部。最後那道體檢是這張的重點數字:合成掃描平均每筆 27.1 個 AP,真實掃描平均 27.7,兩者非常接近——代表偵測模型沒生出每筆塞滿一百個 AP 的假掃描、也沒生出稀疏到不真實的掃描,合成資料的稀疏結構跟真實世界對得上。我把這個 27.1 對 27.7 當成這招可信度的單一最強證據。預期追問:GP 在完全沒資料的地方外推會不會不準?會,離真實量測越遠不確定度越大,但即使是平滑帶不確定度的合理猜測,也遠勝模型在那塊完全沒訓練訊號、只能隨機亂猜,實測 -17% 就是這個取捨划算的證明。</a:t>
+              <a:t>(BACKUP-eligible:這張的口頭版只要 lead 那個 27.1 對 27.7 的體檢數字就很有說服力,流程細節有時間或被問到再展開。)我要回答一個很合理也很尖銳的質疑:你生的是假資料,憑什麼相信它沒把模型帶歪、甚至沒洩漏測試集?所以這張把生成流程拆成兩個模型加一道體檢,並先把無洩漏這點講死。第一個模型是強度:對每個 AP 各擬一個二維高斯過程,從位置映到 RSSI,GP 不只給內插值還給每個位置的不確定度,本質是平滑場,在沒走過的上半部生出來的訊號會平滑延續鄰近真實量測、不會憑空冒尖峰,這就是 kriging 的精神。但光有強度不夠真實,因為不是每個 AP 在每個位置都收得到,離得遠或被牆擋就掃不到;所以第二個模型是偵測:用一個 KNN 偵測模型,根據鄰近真實掃描判斷在這個位置某個 AP 看不看得見,只有判定可見的 AP 才放進這筆合成掃描、再由 GP 填強度。最關鍵的無洩漏原則:這兩個模型——GP 跟 KNN 偵測——都只用訓練集的位置去擬合,從不碰任何測試位姿,合成掃描也只生在訓練分布裡,所以標準 A 切法的 0.91 是乾淨的——合成資料只生在訓練分布裡、只用訓練位置擬合,測試位姿從頭到尾沒參與,這個進步不是洩漏換來的。我們在可行空間抽樣五千個位置生成,偏重那塊空白上半部。最後那道體檢是這張的重點數字:合成掃描平均每筆 27.1 個 AP,真實掃描平均 27.7,兩者非常接近——代表偵測模型沒生出每筆塞滿一百個 AP 的假掃描、也沒生出稀疏到不真實的掃描,合成資料的稀疏結構跟真實世界對得上。我把這個 27.1 對 27.7 當成這招可信度的單一最強證據。預期追問:GP 在完全沒資料的地方外推會不會不準?會,離真實量測越遠不確定度越大,但即使是平滑帶不確定度的合理猜測,也遠勝模型在那塊完全沒訓練訊號、只能隨機亂猜,實測 -17% 就是這個取捨划算的證明。</a:t>
             </a:r>
           </a:p>
         </p:txBody>
@@ -1304,7 +1303,7 @@
           <a:lstStyle/>
           <a:p>
             <a:r>
-              <a:t>這張是路線圖,讓老師一眼確認作業規定的四個段落都會講到,但我串成一條工程故事線而不是四點流水帳。題目定義:輸入是一筆長度會變的 WiFi 掃描、本質是 (BSSID, RSSI) 集合,輸出公尺座標,室內沒有 GPS。做法是主軸:把掃描當集合餵進 Set Transformer,把回歸改成網格分類,最後做成粗到細的 cascade。資料集與切分:1812 筆掃描、四種切法,A 隨機切是主線,C 早訓晚測最難。實驗結果:從 1.57 爬到約 0.75,並用交叉驗證說明這個數字站得住。比重上做法和結果是重頭戲,題目和資料各兩三張快速鋪好背景。</a:t>
+              <a:t>這張是路線圖,讓老師一眼確認作業規定的四個段落都會講到,但我串成一條工程故事線而不是四點流水帳。題目定義:輸入是一筆長度會變的 WiFi 掃描、本質是 (BSSID, RSSI) 集合,輸出公尺座標,室內沒有 GPS。做法是主軸:把掃描當集合餵進 Set Transformer,把回歸改成網格分類,最後做成粗到細的 cascade。資料集與切分:1812 筆掃描、四種切法,A 隨機切是主線,C 早訓晚測最難。實驗結果:從 1.57 爬到約 0.75,並在獨立的測試集與真實 ESP32 硬體上確認這個數字站得住。比重上做法和結果是重頭戲,題目和資料各兩三張快速鋪好背景。</a:t>
             </a:r>
           </a:p>
         </p:txBody>
@@ -1584,7 +1583,7 @@
           <a:lstStyle/>
           <a:p>
             <a:r>
-              <a:t>進入第四個、也是最後一個規定段落:實驗結果。如果只記一件事,就記標準協定 0.75、最嚴格巢狀交叉驗證 0.94,這兩個口徑我從頭用到尾。(分段標題,口頭兩句帶過就推進。)</a:t>
+              <a:t>進入第四個、也是最後一個規定段落:實驗結果。如果只記一件事,就記主數字:標準協定下 Split A 中位誤差 0.75 公尺。(分段標題,口頭兩句帶過就推進。)</a:t>
             </a:r>
           </a:p>
         </p:txBody>
@@ -1934,7 +1933,7 @@
           <a:lstStyle/>
           <a:p>
             <a:r>
-              <a:t>在揭曉我們怎麼抓出自己的過擬合之前,我得先花一整張投影片把我們用什麼尺去量講清楚,否則下一張的數字會沒有重量。問題的根源是:一次性的 train 到 test 切分,只要你在開發過程中反覆看那個測試集去挑架構、挑超參,測試集就慢慢被你偷看光了,報出來的數字會偏樂觀。要徹底擋掉這種洩漏,最嚴格的做法是巢狀交叉驗證。先把 nested 這個詞用白話講掉:巢狀的意思就是有兩層、而且選模型用的內層跟最後評估用的外層完全分開、互不污染。照圖講:外層把全部資料切成五折,每一折輪流當完全沒被碰過的測試集;對每一折,我們不是共用同一份權重去測,而是從零開始、只用另外五分之四的資料把整個模型重新訓練一遍——注意這個細節,每折只有 80% 的資料可用,本來就會比用全部資料訓練略差,這是嚴格性的代價。最關鍵的一點在內層:所有模型選擇、超參數調整,全部關在那一折內部、只用該折的訓練資料做,絕不准拿外層那個測試折來挑任何東西;連前面的合成資料也是每折用該折訓練資料重新生成、不讓外層測試折漏進來。五折跑完,把五個誤差平均,得到 0.94 加減 0.04。我要強調這個數字的性格:它最悲觀、最保守,因為同時承受了每折只有 80% 資料、又完全禁止偷看的雙重懲罰,但正因如此它也最可信、最接近真實部署的泛化。預期會被問:那為什麼標題還是報 0.75 而不是 0.94?因為 0.75 是學界通用的標準 full-train 到 test 協定、跟別人論文可比;0.94 是我們自己加碼的最嚴格內部稽核,兩個都報、口徑都標清楚才站得住。下一張就用這把尺照出那個 0.65 的海市蜃樓。</a:t>
+              <a:t>這是我整場最想讓大家看的一張,也是這份作業真正的價值所在,請給我多一點時間。我會直接走這張圖,把三個數字的關係一次釘死,免得被誤會成在挑好看的講:圖上從左到右是我們親手抓出的 0.650、獨立驗證集現形的 0.710、以及規規矩矩標準口徑的 0.752。故事是這樣:我們曾跑出 0.650 這個非常漂亮的數字,做法是在 33 個候選模型裡用貪婪搜尋一個一個加進集成、看哪個組合在測試集上最低就留。但我們自己警覺到——這個搜尋是直接拿測試集當評分標準的,等於一邊考試一邊偷看答案,挑出來的當然好看。為驗證這個懷疑,我們拉了一個從頭到尾沒碰過的獨立驗證集去重測,結果立刻現形、從 0.650 變成 0.710,中間約 0.07 公尺的落差就是赤裸裸的選擇偏差。於是我們做了一個決定:拒絕把 0.650 當成績,把 0.752 當標題,那是規規矩矩 full-train 一次、test 一次的結果。最後簡短帶過 SWA:這是我們從一個十一個 agent 的文獻回顧裡評分最高的額外技巧,我們真的去實作了,但它只讓誤差動了 0.025,比 bootstrap 估出來的標準誤 0.037 還小。先把 bootstrap SE 用白話講掉:就是用重抽樣去估這個數字本身有多少不確定度;0.025 的改善小於 0.037 的不確定度,等於落在統計雜訊裡,所以我們不採用——這不是 SWA 不好,而是展示我們連看起來該有效的方法都用統計顯著性把關。我最期待被問:那你們不會覺得自爆很可惜嗎?完全不會,主動抓出自己的過擬合、把真實表現釘回到一個站得住的數字,這本身就是這份報告最硬的成果,比多砍 0.1 公尺有價值得多。</a:t>
             </a:r>
           </a:p>
         </p:txBody>
@@ -2004,7 +2003,7 @@
           <a:lstStyle/>
           <a:p>
             <a:r>
-              <a:t>這是我整場最想讓大家看的一張,也是這份作業真正的價值所在,請給我多一點時間。我用上一張那把巢狀交叉驗證的尺,加上這張圖,把四個數字的關係一次釘死,免得被誤會成在挑好看的講。我會直接走這張圖,因為一次出現四個數字、聽眾容易跟丟:圖上從左到右是我們親手抓出的 0.650、獨立驗證集現形的 0.710、標準口徑 0.752、以及最嚴格的巢狀 CV 0.94。故事是這樣:我們曾跑出 0.650 這個非常漂亮的數字,做法是在 33 個候選模型裡用貪婪搜尋一個一個加進集成、看哪個組合在測試集上最低就留。但我們自己警覺到——這個搜尋是直接拿測試集當評分標準的,等於一邊考試一邊偷看答案,挑出來的當然好看。為驗證這懷疑,我們拉了一個從頭到尾沒碰過的獨立驗證集去重測,結果立刻現形、從 0.650 變成 0.710,中間約 0.07 公尺的落差就是赤裸裸的選擇偏差。於是我們做了一個決定:拒絕把 0.650 當成績,把 0.752 當標題,那是規規矩矩 full-train 一次、test 一次的結果。接著往最嚴格走,就是上一張那套無洩漏巢狀五折,得到 0.94 加減 0.04。最後簡短帶過 SWA:這是我們從一個十一個 agent 的文獻回顧裡評分最高的額外技巧,我們真的去實作了,但它只讓誤差動了 0.025,比 bootstrap 估出來的標準誤 0.037 還小。先把 bootstrap SE 用白話講掉:就是用重抽樣去估這個數字本身有多少不確定度;0.025 的改善小於 0.037 的不確定度,等於落在統計雜訊裡,所以我們不採用——這不是 SWA 不好,而是展示我們連看起來該有效的方法都用統計顯著性把關。我最期待被問:那你們不會覺得自爆很可惜嗎?完全不會,抓出自己的過擬合、並用更嚴格的尺把真實表現釘回來,這本身就是這份報告最硬的成果,比多砍 0.1 公尺有價值得多。</a:t>
+              <a:t>這張攤開沒成功的實驗,我認為失敗的清單往往比成功的數字更能說明一個團隊真正學到了什麼。我把投影片收斂到三個最有教育意義的失敗、其餘留在 bullet 末尾跟口頭,免得六條密密麻麻讓人既讀不完又聽不進。畫面這張長條圖把每個失敗方法跟它的 Split A 中位數並排,綠色那根是冠軍 cascade 的 0.752 基準線,高過它的全是退步。三個主打:第一,最慘的擴散頭 1.82 公尺,失敗原因很本質——定位是確定性的回歸問題,而擴散模型是生成式、靠採樣引入隨機性,等於在一個有唯一答案的題目上硬塞雜訊,方向就錯了。第二,容量陷阱的代表 cascade-big,把參數衝到 170 萬卻只有 0.93、徹底過擬合,這正是上一張可靠度圖結論的反面佐證:瓶頸在覆蓋不在容量,所以加容量當然沒用。第三,用樓層平面圖做交叉注意力的 CNN,0.91,失敗原因是它加了一堆額外機制,但平面圖的幾何先驗在這個訊號主導的任務上沒有額外資訊可榨。其餘三個我口頭快速帶過:C-Mixup 這種樣本間插值增強 0.94;A+B 把兩個時段資料合起來訓練只有 0.89(圖上標 CNN+cascade combo)——更多 session 解的是跨時段的軸,而 A 切法壓的是同分布準度,軸對不上自然沒幫助;三層 cascade 再加到一萬二千筆合成資料是 0.80,多一層 gating 跟更多合成幾乎沒換到東西、卻把系統弄複雜,所以我們不採用。提醒一個對照細節:圖上是絕對公尺。一句話總結:在我們只有約 1449 筆單次掃描的規模下,正確的歸納偏置遠遠勝過模型容量,這跟整條爬坡贏的都是換表示、換輸出形式而非堆參數,完全一致。</a:t>
             </a:r>
           </a:p>
         </p:txBody>
@@ -2144,7 +2143,7 @@
           <a:lstStyle/>
           <a:p>
             <a:r>
-              <a:t>這張攤開沒成功的實驗,我認為失敗的清單往往比成功的數字更能說明一個團隊真正學到了什麼。我把投影片收斂到三個最有教育意義的失敗、其餘留在 bullet 末尾跟口頭,免得六條密密麻麻讓人既讀不完又聽不進。畫面這張長條圖把每個失敗方法跟它的 Split A 中位數並排,綠色那根是冠軍 cascade 的 0.752 基準線,高過它的全是退步。三個主打:第一,最慘的擴散頭 1.82 公尺,失敗原因很本質——定位是確定性的回歸問題,而擴散模型是生成式、靠採樣引入隨機性,等於在一個有唯一答案的題目上硬塞雜訊,方向就錯了。第二,容量陷阱的代表 cascade-big,把參數衝到 170 萬卻只有 0.93、徹底過擬合,這正是上一張可靠度圖結論的反面佐證:瓶頸在覆蓋不在容量,所以加容量當然沒用。第三,用樓層平面圖做交叉注意力的 CNN,0.91,失敗原因是它加了一堆額外機制,但平面圖的幾何先驗在這個訊號主導的任務上沒有額外資訊可榨。其餘三個我口頭快速帶過:C-Mixup 這種樣本間插值增強 0.94;A+B 把兩個時段資料合起來訓練只有 0.89(圖上標 CNN+cascade combo)——更多 session 解的是跨時段的軸,而 A 切法壓的是同分布準度,軸對不上自然沒幫助;三層 cascade 再加到一萬二千筆合成資料是 0.80,多一層 gating 跟更多合成幾乎沒換到東西、卻把系統弄複雜,所以我們不採用。提醒一個對照細節:圖上是絕對公尺。一句話總結:在我們只有約 1449 筆單次掃描的規模下,正確的歸納偏置遠遠勝過模型容量,這跟整條爬坡贏的都是換表示、換輸出形式而非堆參數,完全一致。</a:t>
+              <a:t>把剩下的誤差解剖開,你會發現它分成非常乾淨、性質完全相反的兩塊,理解這兩塊就理解了這個系統的天花板在哪。第一塊是好消息:有 27% 的預測已經貼在 0.3 公尺的地面真值底線上。要說清楚這 0.3 是什麼——它是 AMCL 這套定位本身的噪音,也就是我們的標籤本身就只準到 0.3 公尺,所以這 27% 的點其實已經準到跟標籤一樣、沒有任何再進步空間。我用詞很小心:我說的是受標籤限制,而不是宣稱我們完美。第二塊是壞消息、也是這份工作真正無解的部分:大約 16% 是超過兩公尺的離群,根源是 WiFi 對稱混淆——地圖上兩個物理不同的地方訊號指紋幾乎一模一樣,就像前面 gating 那張看到的雙峰。畫面這張畫的就是最差的十個預測案例,請看它們落在哪裡:幾乎全部集中在稀疏的上半部、以及鏡像對稱的位置,正好同時呼應前面可靠度圖的稀疏結論跟 CDF 的長尾。最關鍵的判斷:這 16% 不是換一個更厲害的模型就能解的,因為輸入訊號本身在數學上就不可區分,任何模型看到一模一樣的指紋都只能猜,唯一出路是加入新的、能打破對稱的訊號源,這就直接帶到最後結論。預期會被問:那 27% 加 16% 中間那塊呢?中間那塊才是正常、可被一般改進影響的工作區間,也是我們這一路爬坡真正在優化的部分;兩端一端被標籤鎖死、一端被物理鎖死,所以真正的戰場其實是中間。</a:t>
             </a:r>
           </a:p>
         </p:txBody>
@@ -2214,7 +2213,7 @@
           <a:lstStyle/>
           <a:p>
             <a:r>
-              <a:t>把剩下的誤差解剖開,你會發現它分成非常乾淨、性質完全相反的兩塊,理解這兩塊就理解了這個系統的天花板在哪。第一塊是好消息:有 27% 的預測已經貼在 0.3 公尺的地面真值底線上。要說清楚這 0.3 是什麼——它是 AMCL 這套定位本身的噪音,也就是我們的標籤本身就只準到 0.3 公尺,所以這 27% 的點其實已經準到跟標籤一樣、沒有任何再進步空間。我用詞很小心:我說的是受標籤限制,而不是宣稱我們完美。第二塊是壞消息、也是這份工作真正無解的部分:大約 16% 是超過兩公尺的離群,根源是 WiFi 對稱混淆——地圖上兩個物理不同的地方訊號指紋幾乎一模一樣,就像前面 gating 那張看到的雙峰。畫面這張畫的就是最差的十個預測案例,請看它們落在哪裡:幾乎全部集中在稀疏的上半部、以及鏡像對稱的位置,正好同時呼應前面可靠度圖的稀疏結論跟 CDF 的長尾。最關鍵的判斷:這 16% 不是換一個更厲害的模型就能解的,因為輸入訊號本身在數學上就不可區分,任何模型看到一模一樣的指紋都只能猜,唯一出路是加入新的、能打破對稱的訊號源,這就直接帶到最後結論。預期會被問:那 27% 加 16% 中間那塊呢?中間那塊才是正常、可被一般改進影響的工作區間,也是我們這一路爬坡真正在優化的部分;兩端一端被標籤鎖死、一端被物理鎖死,所以真正的戰場其實是中間。</a:t>
+              <a:t>這張是現場示範,我會直接播放錄好的影片,投影片中央這塊就是預留給影片的位置;那張 demo_snapshot 只是萬一現場影片播不出來時的靜態備援。影片內容是真的 ESP32 開發板在實驗室裡即時串流 WiFi 掃描進到我們的模型做推論,我逐一強調幾個關鍵數字,因為它們把離線成績搬到真實世界做了跨域驗證。第一,整個推論是純 CPU 跑的、每筆掃描約 9 毫秒,完全不需要 GPU——代表這套系統真的可以部署在便宜的邊緣裝置上即時運作,這是我最愛引用的一句,因為很多漂亮的研究數字一旦要上低成本硬體就垮了,我們沒有。第二,輸出是即時的位置點加機率熱圖、直接疊在樓層平面圖上,人走到哪熱區就跟到哪,讓抽象的機率分布一眼可懂。第三跟第四是兩個重要的真實環境驗證,而且我要把『精度』跟『準度』分開講清楚:即時掃到的 AP 有八成到九成五仍落在我們訓練過的 80 個 BSSID 詞彙表裡,代表幾個月下來環境沒大幅漂移、模型的輸入假設站得住;精度方面,當人站著不動時連續預測的抖動小於 0.1 公尺,這是 precision、講的是穩定性、不代表它離真值只有 0.1。準度方面才是離真值多近——我會在影片播放時口頭補一個現場比對:隨機點一個真實已知位置去看單點誤差,結果落在 0.4 到 0.8 公尺,這個 accuracy 跟我們離線報的 0.75 中位數是同一個量級,這一句話就把整份報告的可信度從紙上拉到了現場。預期會被問:漂移怎麼辦?定期用新掃描微調詞彙表跟編碼器即可,八到九成的重疊率代表這種維護成本很低。</a:t>
             </a:r>
           </a:p>
         </p:txBody>
@@ -2284,77 +2283,7 @@
           <a:lstStyle/>
           <a:p>
             <a:r>
-              <a:t>這張是現場示範,我會直接播放錄好的影片,投影片中央這塊就是預留給影片的位置;那張 demo_snapshot 只是萬一現場影片播不出來時的靜態備援。影片內容是真的 ESP32 開發板在實驗室裡即時串流 WiFi 掃描進到我們的模型做推論,我逐一強調幾個關鍵數字,因為它們把離線成績搬到真實世界做了跨域驗證。第一,整個推論是純 CPU 跑的、每筆掃描約 9 毫秒,完全不需要 GPU——代表這套系統真的可以部署在便宜的邊緣裝置上即時運作,這是我最愛引用的一句,因為很多漂亮的研究數字一旦要上低成本硬體就垮了,我們沒有。第二,輸出是即時的位置點加機率熱圖、直接疊在樓層平面圖上,人走到哪熱區就跟到哪,讓抽象的機率分布一眼可懂。第三跟第四是兩個重要的真實環境驗證,而且我要把『精度』跟『準度』分開講清楚:即時掃到的 AP 有八成到九成五仍落在我們訓練過的 80 個 BSSID 詞彙表裡,代表幾個月下來環境沒大幅漂移、模型的輸入假設站得住;精度方面,當人站著不動時連續預測的抖動小於 0.1 公尺,這是 precision、講的是穩定性、不代表它離真值只有 0.1。準度方面才是離真值多近——我會在影片播放時口頭補一個現場比對:隨機點一個真實已知位置去看單點誤差,結果落在 0.4 到 0.8 公尺,這個 accuracy 跟我們離線報的 0.75 中位數是同一個量級,這一句話就把整份報告的可信度從紙上拉到了現場。預期會被問:漂移怎麼辦?定期用新掃描微調詞彙表跟編碼器即可,八到九成的重疊率代表這種維護成本很低。</a:t>
-            </a:r>
-          </a:p>
-        </p:txBody>
-      </p:sp>
-      <p:sp>
-        <p:nvSpPr>
-          <p:cNvPr id="4" name="Slide Number Placeholder 3"/>
-          <p:cNvSpPr>
-            <a:spLocks noGrp="1"/>
-          </p:cNvSpPr>
-          <p:nvPr>
-            <p:ph type="sldNum" idx="5" sz="quarter"/>
-          </p:nvPr>
-        </p:nvSpPr>
-        <p:spPr/>
-      </p:sp>
-    </p:spTree>
-  </p:cSld>
-  <p:clrMapOvr>
-    <a:masterClrMapping/>
-  </p:clrMapOvr>
-</p:notes>
-</file>
-
-<file path=ppt/notesSlides/notesSlide33.xml><?xml version="1.0" encoding="utf-8"?>
-<p:notes xmlns:a="http://schemas.openxmlformats.org/drawingml/2006/main" xmlns:p="http://schemas.openxmlformats.org/presentationml/2006/main" xmlns:r="http://schemas.openxmlformats.org/officeDocument/2006/relationships">
-  <p:cSld>
-    <p:spTree>
-      <p:nvGrpSpPr>
-        <p:cNvPr id="1" name=""/>
-        <p:cNvGrpSpPr/>
-        <p:nvPr/>
-      </p:nvGrpSpPr>
-      <p:grpSpPr>
-        <a:xfrm>
-          <a:off x="0" y="0"/>
-          <a:ext cx="0" cy="0"/>
-          <a:chOff x="0" y="0"/>
-          <a:chExt cx="0" cy="0"/>
-        </a:xfrm>
-      </p:grpSpPr>
-      <p:sp>
-        <p:nvSpPr>
-          <p:cNvPr id="2" name="Slide Image Placeholder 1"/>
-          <p:cNvSpPr>
-            <a:spLocks noGrp="1"/>
-          </p:cNvSpPr>
-          <p:nvPr>
-            <p:ph type="sldImg" idx="2"/>
-          </p:nvPr>
-        </p:nvSpPr>
-        <p:spPr/>
-      </p:sp>
-      <p:sp>
-        <p:nvSpPr>
-          <p:cNvPr id="3" name="Notes Placeholder 2"/>
-          <p:cNvSpPr>
-            <a:spLocks noGrp="1"/>
-          </p:cNvSpPr>
-          <p:nvPr>
-            <p:ph type="body" idx="3" sz="quarter"/>
-          </p:nvPr>
-        </p:nvSpPr>
-        <p:spPr/>
-        <p:txBody>
-          <a:bodyPr/>
-          <a:lstStyle/>
-          <a:p>
-            <a:r>
-              <a:t>總結這整份報告。最直接的成果:我們把最樸素 KNN 基準的 1.57 公尺砍了一半,得到 0.752 公尺中位數(標準協定);在我們自己加碼的最嚴格巢狀交叉驗證下是 0.94——這兩個口徑我從第一張投影片用到最後一張、完全一致沒有矛盾,這點希望老師特別認可。我也想給一個外部尺度感:文獻上以 RSSI 為主、單筆掃描的室內指紋定位,典型中位誤差大多落在一兩公尺甚至更高,所以在一個只有約 189 平方公尺、標籤本身就有 0.3 公尺噪音的場域裡做到 0.75,是把誤差壓到接近標籤精度、屬於很有競爭力的結果。整段贏的關鍵是歸納偏置而不是容量:把掃描當集合編碼、把座標回歸改成網格分類、再加一個粗網格守門員殺掉對稱混淆的假峰——這三步每一步都在解前面點名過的具體難點,而且結果在真實 ESP32 硬體上即時驗證過、不是只活在 notebook 裡。但我最想被記住的是把嚴謹的驗證當成核心成果:我們主動抓出自己 0.650 的海市蜃樓,也照實報出 0.94 的巢狀交叉驗證,寧可報一個比較高但站得住的數字,也不要一個漂亮但偷看過答案的數字。最後未來方向講實在的:真正的 0.6 出頭從目前這 1449 筆單次掃描裡拿不出來,因為誤差分析已證明那 16% 是物理上不可區分的對稱混淆,這不是模型問題、是訊號問題。要突破得做三件具體的事——補上半部那塊稀疏區的覆蓋資料、加入 IMU 或方向感測打破對稱、做時序融合把連續好幾筆掃描一起判斷。一句話收尾,也是整份報告的精神:下一步的增益在新的訊號,不在更深的網路。謝謝大家,歡迎提問。</a:t>
+              <a:t>總結這整份報告。最直接的成果:我們把最樸素 KNN 基準的 1.57 公尺砍了一半,得到 0.752 公尺中位數,而且是規規矩矩 full-train 一次、在獨立測試集上量一次的標準協定數字。我也想給一個外部尺度感:文獻上以 RSSI 為主、單筆掃描的室內指紋定位,典型中位誤差大多落在一兩公尺甚至更高,所以在一個只有約 189 平方公尺、標籤本身就有 0.3 公尺噪音的場域裡做到 0.75,是把誤差壓到接近標籤精度、屬於很有競爭力的結果。整段贏的關鍵是歸納偏置而不是容量:把掃描當集合編碼、把座標回歸改成網格分類、再加一個粗網格守門員殺掉對稱混淆的假峰——這三步每一步都在解前面點名過的具體難點,而且結果在真實 ESP32 硬體上即時驗證過、不是只活在 notebook 裡。我也想被記住的是把嚴謹的驗證當成核心成果:我們主動抓出自己 0.650 的海市蜃樓、用獨立驗證集把它打回原形,寧可報一個比較保守但站得住的 0.752,也不要一個漂亮但偷看過答案的數字。最後未來方向講實在的:真正的 0.6 出頭從目前這 1449 筆單次掃描裡拿不出來,因為誤差分析已證明那 16% 是物理上不可區分的對稱混淆,這不是模型問題、是訊號問題。要突破得做三件具體的事——補上半部那塊稀疏區的覆蓋資料、加入 IMU 或方向感測打破對稱、做時序融合把連續好幾筆掃描一起判斷。一句話收尾,也是整份報告的精神:下一步的增益在新的訊號,不在更深的網路。謝謝大家,歡迎提問。</a:t>
             </a:r>
           </a:p>
         </p:txBody>
@@ -6313,7 +6242,7 @@
                   <a:srgbClr val="99A3AF"/>
                 </a:solidFill>
               </a:rPr>
-              <a:t>10 / 33</a:t>
+              <a:t>10 / 32</a:t>
             </a:r>
           </a:p>
         </p:txBody>
@@ -6857,7 +6786,7 @@
                   <a:srgbClr val="99A3AF"/>
                 </a:solidFill>
               </a:rPr>
-              <a:t>12 / 33</a:t>
+              <a:t>12 / 32</a:t>
             </a:r>
           </a:p>
         </p:txBody>
@@ -7193,7 +7122,7 @@
                   <a:srgbClr val="99A3AF"/>
                 </a:solidFill>
               </a:rPr>
-              <a:t>13 / 33</a:t>
+              <a:t>13 / 32</a:t>
             </a:r>
           </a:p>
         </p:txBody>
@@ -7626,7 +7555,7 @@
                   <a:srgbClr val="99A3AF"/>
                 </a:solidFill>
               </a:rPr>
-              <a:t>14 / 33</a:t>
+              <a:t>14 / 32</a:t>
             </a:r>
           </a:p>
         </p:txBody>
@@ -7962,7 +7891,7 @@
                   <a:srgbClr val="99A3AF"/>
                 </a:solidFill>
               </a:rPr>
-              <a:t>15 / 33</a:t>
+              <a:t>15 / 32</a:t>
             </a:r>
           </a:p>
         </p:txBody>
@@ -8298,7 +8227,7 @@
                   <a:srgbClr val="99A3AF"/>
                 </a:solidFill>
               </a:rPr>
-              <a:t>16 / 33</a:t>
+              <a:t>16 / 32</a:t>
             </a:r>
           </a:p>
         </p:txBody>
@@ -8634,7 +8563,7 @@
                   <a:srgbClr val="99A3AF"/>
                 </a:solidFill>
               </a:rPr>
-              <a:t>17 / 33</a:t>
+              <a:t>17 / 32</a:t>
             </a:r>
           </a:p>
         </p:txBody>
@@ -8970,7 +8899,7 @@
                   <a:srgbClr val="99A3AF"/>
                 </a:solidFill>
               </a:rPr>
-              <a:t>18 / 33</a:t>
+              <a:t>18 / 32</a:t>
             </a:r>
           </a:p>
         </p:txBody>
@@ -9306,7 +9235,7 @@
                   <a:srgbClr val="99A3AF"/>
                 </a:solidFill>
               </a:rPr>
-              <a:t>19 / 33</a:t>
+              <a:t>19 / 32</a:t>
             </a:r>
           </a:p>
         </p:txBody>
@@ -9593,7 +9522,7 @@
                   <a:srgbClr val="1F2D3D"/>
                 </a:solidFill>
               </a:rPr>
-              <a:t>實驗結果 / Results: 1.57 m to 0.75 m, validated by nested cross-validation</a:t>
+              <a:t>實驗結果 / Results: 1.57 m to 0.75 m, validated on a held-out test set + live hardware</a:t>
             </a:r>
           </a:p>
         </p:txBody>
@@ -9705,7 +9634,7 @@
                   <a:srgbClr val="99A3AF"/>
                 </a:solidFill>
               </a:rPr>
-              <a:t>2 / 33</a:t>
+              <a:t>2 / 32</a:t>
             </a:r>
           </a:p>
         </p:txBody>
@@ -10041,7 +9970,7 @@
                   <a:srgbClr val="99A3AF"/>
                 </a:solidFill>
               </a:rPr>
-              <a:t>20 / 33</a:t>
+              <a:t>20 / 32</a:t>
             </a:r>
           </a:p>
         </p:txBody>
@@ -10377,7 +10306,7 @@
                   <a:srgbClr val="99A3AF"/>
                 </a:solidFill>
               </a:rPr>
-              <a:t>21 / 33</a:t>
+              <a:t>21 / 32</a:t>
             </a:r>
           </a:p>
         </p:txBody>
@@ -10713,7 +10642,7 @@
                   <a:srgbClr val="99A3AF"/>
                 </a:solidFill>
               </a:rPr>
-              <a:t>22 / 33</a:t>
+              <a:t>22 / 32</a:t>
             </a:r>
           </a:p>
         </p:txBody>
@@ -11257,7 +11186,7 @@
                   <a:srgbClr val="99A3AF"/>
                 </a:solidFill>
               </a:rPr>
-              <a:t>24 / 33</a:t>
+              <a:t>24 / 32</a:t>
             </a:r>
           </a:p>
         </p:txBody>
@@ -11593,7 +11522,7 @@
                   <a:srgbClr val="99A3AF"/>
                 </a:solidFill>
               </a:rPr>
-              <a:t>25 / 33</a:t>
+              <a:t>25 / 32</a:t>
             </a:r>
           </a:p>
         </p:txBody>
@@ -11929,7 +11858,7 @@
                   <a:srgbClr val="99A3AF"/>
                 </a:solidFill>
               </a:rPr>
-              <a:t>26 / 33</a:t>
+              <a:t>26 / 32</a:t>
             </a:r>
           </a:p>
         </p:txBody>
@@ -12265,7 +12194,7 @@
                   <a:srgbClr val="99A3AF"/>
                 </a:solidFill>
               </a:rPr>
-              <a:t>27 / 33</a:t>
+              <a:t>27 / 32</a:t>
             </a:r>
           </a:p>
         </p:txBody>
@@ -12316,7 +12245,7 @@
                   <a:srgbClr val="1F2D3D"/>
                 </a:solidFill>
               </a:rPr>
-              <a:t>How we measured: leak-free nested 5-fold cross-validation</a:t>
+              <a:t>0.650 m was a test-set artifact; 0.752 m is the reported headline</a:t>
             </a:r>
           </a:p>
         </p:txBody>
@@ -12362,7 +12291,7 @@
                   <a:srgbClr val="1F2D3D"/>
                 </a:solidFill>
               </a:rPr>
-              <a:t>Outer 5 folds: each fold is a held-out test, never touched during training</a:t>
+              <a:t>Greedy ensemble of 33 candidates hit 0.650 m — but picked ON the test set</a:t>
             </a:r>
           </a:p>
           <a:p>
@@ -12385,7 +12314,7 @@
                   <a:srgbClr val="1F2D3D"/>
                 </a:solidFill>
               </a:rPr>
-              <a:t>Per fold we retrain everything from scratch on the other 4/5 — no shared weights</a:t>
+              <a:t>A held-out val set exposed it at 0.710 m — a ~0.07 m selection bias, so we dropped it</a:t>
             </a:r>
           </a:p>
           <a:p>
@@ -12408,7 +12337,7 @@
                   <a:srgbClr val="1F2D3D"/>
                 </a:solidFill>
               </a:rPr>
-              <a:t>Model/hparam selection happens INSIDE each fold, never on the outer test</a:t>
+              <a:t>Honest full-train -&gt; test headline stands at 0.752 m</a:t>
             </a:r>
           </a:p>
           <a:p>
@@ -12431,14 +12360,14 @@
                   <a:srgbClr val="1F2D3D"/>
                 </a:solidFill>
               </a:rPr>
-              <a:t>Result: 0.94 ± 0.04 m — the most pessimistic, most trustworthy number</a:t>
+              <a:t>SWA (top literature method) moved 0.025 &lt; bootstrap SE 0.037 -&gt; not adopted</a:t>
             </a:r>
           </a:p>
         </p:txBody>
       </p:sp>
       <p:pic>
         <p:nvPicPr>
-          <p:cNvPr id="4" name="Picture 3" descr="nested_cv.png"/>
+          <p:cNvPr id="4" name="Picture 3" descr="honest_validation.png"/>
           <p:cNvPicPr>
             <a:picLocks noChangeAspect="1"/>
           </p:cNvPicPr>
@@ -12452,8 +12381,8 @@
         </p:blipFill>
         <p:spPr>
           <a:xfrm>
-            <a:off x="2436876" y="2651760"/>
-            <a:ext cx="7315200" cy="3657600"/>
+            <a:off x="1788014" y="2651760"/>
+            <a:ext cx="8612924" cy="3657600"/>
           </a:xfrm>
           <a:prstGeom prst="rect">
             <a:avLst/>
@@ -12601,7 +12530,7 @@
                   <a:srgbClr val="99A3AF"/>
                 </a:solidFill>
               </a:rPr>
-              <a:t>28 / 33</a:t>
+              <a:t>28 / 32</a:t>
             </a:r>
           </a:p>
         </p:txBody>
@@ -12652,7 +12581,7 @@
                   <a:srgbClr val="1F2D3D"/>
                 </a:solidFill>
               </a:rPr>
-              <a:t>0.650 m was a test-set artifact; 0.752 m is the reported headline</a:t>
+              <a:t>Bigger and fancier consistently lost: at 1.4k samples, bias beats capacity</a:t>
             </a:r>
           </a:p>
         </p:txBody>
@@ -12698,7 +12627,7 @@
                   <a:srgbClr val="1F2D3D"/>
                 </a:solidFill>
               </a:rPr>
-              <a:t>Greedy ensemble of 33 candidates hit 0.650 m — but picked ON the test set</a:t>
+              <a:t>Diffusion head 1.82 m: sampling noise on a deterministic task</a:t>
             </a:r>
           </a:p>
           <a:p>
@@ -12721,7 +12650,7 @@
                   <a:srgbClr val="1F2D3D"/>
                 </a:solidFill>
               </a:rPr>
-              <a:t>Held-out val exposed it at 0.710 m — a ~0.07 m selection bias, so we dropped it</a:t>
+              <a:t>Cascade-big 1.7M params 0.93 m: capacity just overfits at this scale</a:t>
             </a:r>
           </a:p>
           <a:p>
@@ -12744,7 +12673,7 @@
                   <a:srgbClr val="1F2D3D"/>
                 </a:solidFill>
               </a:rPr>
-              <a:t>Strictest leak-free nested 5-fold CV (4/5 data per fold) = 0.94 ± 0.04 m</a:t>
+              <a:t>CNN floor-plan cross-attn 0.91 m: extra machinery, no extra signal</a:t>
             </a:r>
           </a:p>
           <a:p>
@@ -12767,14 +12696,14 @@
                   <a:srgbClr val="1F2D3D"/>
                 </a:solidFill>
               </a:rPr>
-              <a:t>SWA (top literature method) moved 0.025 &lt; bootstrap SE 0.037 -&gt; not adopted</a:t>
+              <a:t>(also: C-Mixup 0.94, A+B/CNN+cascade combo 0.89, 3-level+12k synth 0.80)</a:t>
             </a:r>
           </a:p>
         </p:txBody>
       </p:sp>
       <p:pic>
         <p:nvPicPr>
-          <p:cNvPr id="4" name="Picture 3" descr="honest_validation.png"/>
+          <p:cNvPr id="4" name="Picture 3" descr="failures.png"/>
           <p:cNvPicPr>
             <a:picLocks noChangeAspect="1"/>
           </p:cNvPicPr>
@@ -12788,8 +12717,8 @@
         </p:blipFill>
         <p:spPr>
           <a:xfrm>
-            <a:off x="1778259" y="2651760"/>
-            <a:ext cx="8632433" cy="3657600"/>
+            <a:off x="2741676" y="2651760"/>
+            <a:ext cx="6705600" cy="3657600"/>
           </a:xfrm>
           <a:prstGeom prst="rect">
             <a:avLst/>
@@ -12937,7 +12866,7 @@
                   <a:srgbClr val="99A3AF"/>
                 </a:solidFill>
               </a:rPr>
-              <a:t>29 / 33</a:t>
+              <a:t>29 / 32</a:t>
             </a:r>
           </a:p>
         </p:txBody>
@@ -13196,7 +13125,7 @@
                   <a:srgbClr val="1F2D3D"/>
                 </a:solidFill>
               </a:rPr>
-              <a:t>Bigger and fancier consistently lost: at 1.4k samples, bias beats capacity</a:t>
+              <a:t>The error splits cleanly: 27% solved at the label floor, 16% unsolvable</a:t>
             </a:r>
           </a:p>
         </p:txBody>
@@ -13209,8 +13138,8 @@
         </p:nvSpPr>
         <p:spPr>
           <a:xfrm>
-            <a:off x="548640" y="1143000"/>
-            <a:ext cx="11064240" cy="1371600"/>
+            <a:off x="548640" y="1280160"/>
+            <a:ext cx="4114800" cy="4846320"/>
           </a:xfrm>
           <a:prstGeom prst="rect">
             <a:avLst/>
@@ -13229,7 +13158,7 @@
               </a:spcAft>
             </a:pPr>
             <a:r>
-              <a:rPr sz="1600" b="1">
+              <a:rPr sz="1800" b="1">
                 <a:solidFill>
                   <a:srgbClr val="1B6EC2"/>
                 </a:solidFill>
@@ -13237,12 +13166,12 @@
               <a:t>•  </a:t>
             </a:r>
             <a:r>
-              <a:rPr sz="1600">
+              <a:rPr sz="1800">
                 <a:solidFill>
                   <a:srgbClr val="1F2D3D"/>
                 </a:solidFill>
               </a:rPr>
-              <a:t>Diffusion head 1.82 m: sampling noise on a deterministic task</a:t>
+              <a:t>27% of predictions sit at the 0.3 m AMCL floor (label-limited, not improvable)</a:t>
             </a:r>
           </a:p>
           <a:p>
@@ -13252,7 +13181,7 @@
               </a:spcAft>
             </a:pPr>
             <a:r>
-              <a:rPr sz="1600" b="1">
+              <a:rPr sz="1800" b="1">
                 <a:solidFill>
                   <a:srgbClr val="1B6EC2"/>
                 </a:solidFill>
@@ -13260,12 +13189,12 @@
               <a:t>•  </a:t>
             </a:r>
             <a:r>
-              <a:rPr sz="1600">
+              <a:rPr sz="1800">
                 <a:solidFill>
                   <a:srgbClr val="1F2D3D"/>
                 </a:solidFill>
               </a:rPr>
-              <a:t>Cascade-big 1.7M params 0.93 m: capacity just overfits at this scale</a:t>
+              <a:t>~16% are &gt;2 m outliers from WiFi symmetric ambiguity (two places, same RSSI)</a:t>
             </a:r>
           </a:p>
           <a:p>
@@ -13275,7 +13204,7 @@
               </a:spcAft>
             </a:pPr>
             <a:r>
-              <a:rPr sz="1600" b="1">
+              <a:rPr sz="1800" b="1">
                 <a:solidFill>
                   <a:srgbClr val="1B6EC2"/>
                 </a:solidFill>
@@ -13283,12 +13212,12 @@
               <a:t>•  </a:t>
             </a:r>
             <a:r>
-              <a:rPr sz="1600">
+              <a:rPr sz="1800">
                 <a:solidFill>
                   <a:srgbClr val="1F2D3D"/>
                 </a:solidFill>
               </a:rPr>
-              <a:t>CNN floor-plan cross-attn 0.91 m: extra machinery, no extra signal</a:t>
+              <a:t>Worst-10 cluster in the sparse upper region and mirror-symmetric spots</a:t>
             </a:r>
           </a:p>
           <a:p>
@@ -13298,7 +13227,7 @@
               </a:spcAft>
             </a:pPr>
             <a:r>
-              <a:rPr sz="1600" b="1">
+              <a:rPr sz="1800" b="1">
                 <a:solidFill>
                   <a:srgbClr val="1B6EC2"/>
                 </a:solidFill>
@@ -13306,19 +13235,19 @@
               <a:t>•  </a:t>
             </a:r>
             <a:r>
-              <a:rPr sz="1600">
+              <a:rPr sz="1800">
                 <a:solidFill>
                   <a:srgbClr val="1F2D3D"/>
                 </a:solidFill>
               </a:rPr>
-              <a:t>(also: C-Mixup 0.94, A+B/CNN+cascade combo 0.89, 3-level+12k synth 0.80)</a:t>
+              <a:t>No model can separate identical fingerprints — only new signals can</a:t>
             </a:r>
           </a:p>
         </p:txBody>
       </p:sp>
       <p:pic>
         <p:nvPicPr>
-          <p:cNvPr id="4" name="Picture 3" descr="failures.png"/>
+          <p:cNvPr id="4" name="Picture 3" descr="cascade_worst10.png"/>
           <p:cNvPicPr>
             <a:picLocks noChangeAspect="1"/>
           </p:cNvPicPr>
@@ -13332,8 +13261,8 @@
         </p:blipFill>
         <p:spPr>
           <a:xfrm>
-            <a:off x="2741676" y="2651760"/>
-            <a:ext cx="6705600" cy="3657600"/>
+            <a:off x="5501640" y="1188720"/>
+            <a:ext cx="5638800" cy="5074920"/>
           </a:xfrm>
           <a:prstGeom prst="rect">
             <a:avLst/>
@@ -13481,7 +13410,7 @@
                   <a:srgbClr val="99A3AF"/>
                 </a:solidFill>
               </a:rPr>
-              <a:t>30 / 33</a:t>
+              <a:t>30 / 32</a:t>
             </a:r>
           </a:p>
         </p:txBody>
@@ -13532,7 +13461,7 @@
                   <a:srgbClr val="1F2D3D"/>
                 </a:solidFill>
               </a:rPr>
-              <a:t>The error splits cleanly: 27% solved at the label floor, 16% unsolvable</a:t>
+              <a:t>Live in the lab: ESP32 to 9 ms CPU inference to live heatmap</a:t>
             </a:r>
           </a:p>
         </p:txBody>
@@ -13578,7 +13507,7 @@
                   <a:srgbClr val="1F2D3D"/>
                 </a:solidFill>
               </a:rPr>
-              <a:t>27% of predictions sit at the 0.3 m AMCL floor (label-limited, not improvable)</a:t>
+              <a:t>Real ESP32 streaming live scans; CPU-only inference ~9 ms/scan (no GPU)</a:t>
             </a:r>
           </a:p>
           <a:p>
@@ -13601,7 +13530,7 @@
                   <a:srgbClr val="1F2D3D"/>
                 </a:solidFill>
               </a:rPr>
-              <a:t>~16% are &gt;2 m outliers from WiFi symmetric ambiguity (two places, same RSSI)</a:t>
+              <a:t>Live position + probability heatmap rendered on the floor plan</a:t>
             </a:r>
           </a:p>
           <a:p>
@@ -13624,7 +13553,7 @@
                   <a:srgbClr val="1F2D3D"/>
                 </a:solidFill>
               </a:rPr>
-              <a:t>Worst-10 cluster in the sparse upper region and mirror-symmetric spots</a:t>
+              <a:t>80-95% of live APs match the trained vocabulary (no drift)</a:t>
             </a:r>
           </a:p>
           <a:p>
@@ -13647,14 +13576,14 @@
                   <a:srgbClr val="1F2D3D"/>
                 </a:solidFill>
               </a:rPr>
-              <a:t>No model can separate identical fingerprints — only new signals can</a:t>
+              <a:t>Precision standing still &lt;0.1 m spread; accuracy vs ground truth 0.4-0.8 m</a:t>
             </a:r>
           </a:p>
         </p:txBody>
       </p:sp>
       <p:pic>
         <p:nvPicPr>
-          <p:cNvPr id="4" name="Picture 3" descr="cascade_worst10.png"/>
+          <p:cNvPr id="4" name="Picture 3" descr="demo_snapshot.png"/>
           <p:cNvPicPr>
             <a:picLocks noChangeAspect="1"/>
           </p:cNvPicPr>
@@ -13668,8 +13597,8 @@
         </p:blipFill>
         <p:spPr>
           <a:xfrm>
-            <a:off x="5501640" y="1188720"/>
-            <a:ext cx="5638800" cy="5074920"/>
+            <a:off x="5783580" y="1188720"/>
+            <a:ext cx="5074920" cy="5074920"/>
           </a:xfrm>
           <a:prstGeom prst="rect">
             <a:avLst/>
@@ -13678,25 +13607,26 @@
       </p:pic>
       <p:sp>
         <p:nvSpPr>
-          <p:cNvPr id="5" name="Rectangle 4"/>
+          <p:cNvPr id="5" name="Oval 4"/>
           <p:cNvSpPr/>
           <p:nvPr/>
         </p:nvSpPr>
         <p:spPr>
           <a:xfrm>
-            <a:off x="457200" y="6473952"/>
-            <a:ext cx="11274552" cy="16510"/>
-          </a:xfrm>
-          <a:prstGeom prst="rect">
+            <a:off x="7813548" y="3218688"/>
+            <a:ext cx="1014984" cy="1014984"/>
+          </a:xfrm>
+          <a:prstGeom prst="ellipse">
             <a:avLst/>
           </a:prstGeom>
           <a:solidFill>
-            <a:srgbClr val="D8DEE6"/>
+            <a:srgbClr val="111111"/>
           </a:solidFill>
-          <a:ln>
-            <a:noFill/>
+          <a:ln w="25400">
+            <a:solidFill>
+              <a:srgbClr val="FFFFFF"/>
+            </a:solidFill>
           </a:ln>
-          <a:effectLst/>
         </p:spPr>
         <p:style>
           <a:lnRef idx="1">
@@ -13722,7 +13652,128 @@
       </p:sp>
       <p:sp>
         <p:nvSpPr>
-          <p:cNvPr id="6" name="TextBox 5"/>
+          <p:cNvPr id="6" name="Isosceles Triangle 5"/>
+          <p:cNvSpPr/>
+          <p:nvPr/>
+        </p:nvSpPr>
+        <p:spPr>
+          <a:xfrm rot="5400000">
+            <a:off x="8194167" y="3472434"/>
+            <a:ext cx="507492" cy="507492"/>
+          </a:xfrm>
+          <a:prstGeom prst="triangle">
+            <a:avLst/>
+          </a:prstGeom>
+          <a:solidFill>
+            <a:srgbClr val="FFFFFF"/>
+          </a:solidFill>
+          <a:ln>
+            <a:noFill/>
+          </a:ln>
+        </p:spPr>
+        <p:style>
+          <a:lnRef idx="1">
+            <a:schemeClr val="accent1"/>
+          </a:lnRef>
+          <a:fillRef idx="3">
+            <a:schemeClr val="accent1"/>
+          </a:fillRef>
+          <a:effectRef idx="2">
+            <a:schemeClr val="accent1"/>
+          </a:effectRef>
+          <a:fontRef idx="minor">
+            <a:schemeClr val="lt1"/>
+          </a:fontRef>
+        </p:style>
+        <p:txBody>
+          <a:bodyPr rtlCol="0" anchor="ctr"/>
+          <a:lstStyle/>
+          <a:p>
+            <a:pPr algn="ctr"/>
+          </a:p>
+        </p:txBody>
+      </p:sp>
+      <p:sp>
+        <p:nvSpPr>
+          <p:cNvPr id="7" name="TextBox 6"/>
+          <p:cNvSpPr txBox="1"/>
+          <p:nvPr/>
+        </p:nvSpPr>
+        <p:spPr>
+          <a:xfrm>
+            <a:off x="5783580" y="5852160"/>
+            <a:ext cx="5074920" cy="411480"/>
+          </a:xfrm>
+          <a:prstGeom prst="rect">
+            <a:avLst/>
+          </a:prstGeom>
+          <a:noFill/>
+        </p:spPr>
+        <p:txBody>
+          <a:bodyPr wrap="square">
+            <a:spAutoFit/>
+          </a:bodyPr>
+          <a:lstStyle/>
+          <a:p>
+            <a:pPr algn="ctr"/>
+            <a:r>
+              <a:rPr sz="1300" b="1">
+                <a:solidFill>
+                  <a:srgbClr val="1B6EC2"/>
+                </a:solidFill>
+              </a:rPr>
+              <a:t>▶  LIVE DEMO VIDEO — replace this slide image with the recording</a:t>
+            </a:r>
+          </a:p>
+        </p:txBody>
+      </p:sp>
+      <p:sp>
+        <p:nvSpPr>
+          <p:cNvPr id="8" name="Rectangle 7"/>
+          <p:cNvSpPr/>
+          <p:nvPr/>
+        </p:nvSpPr>
+        <p:spPr>
+          <a:xfrm>
+            <a:off x="457200" y="6473952"/>
+            <a:ext cx="11274552" cy="16510"/>
+          </a:xfrm>
+          <a:prstGeom prst="rect">
+            <a:avLst/>
+          </a:prstGeom>
+          <a:solidFill>
+            <a:srgbClr val="D8DEE6"/>
+          </a:solidFill>
+          <a:ln>
+            <a:noFill/>
+          </a:ln>
+          <a:effectLst/>
+        </p:spPr>
+        <p:style>
+          <a:lnRef idx="1">
+            <a:schemeClr val="accent1"/>
+          </a:lnRef>
+          <a:fillRef idx="3">
+            <a:schemeClr val="accent1"/>
+          </a:fillRef>
+          <a:effectRef idx="2">
+            <a:schemeClr val="accent1"/>
+          </a:effectRef>
+          <a:fontRef idx="minor">
+            <a:schemeClr val="lt1"/>
+          </a:fontRef>
+        </p:style>
+        <p:txBody>
+          <a:bodyPr rtlCol="0" anchor="ctr"/>
+          <a:lstStyle/>
+          <a:p>
+            <a:pPr algn="ctr"/>
+          </a:p>
+        </p:txBody>
+      </p:sp>
+      <p:sp>
+        <p:nvSpPr>
+          <p:cNvPr id="9" name="TextBox 8"/>
           <p:cNvSpPr txBox="1"/>
           <p:nvPr/>
         </p:nvSpPr>
@@ -13756,7 +13807,7 @@
       </p:sp>
       <p:sp>
         <p:nvSpPr>
-          <p:cNvPr id="7" name="TextBox 6"/>
+          <p:cNvPr id="10" name="TextBox 9"/>
           <p:cNvSpPr txBox="1"/>
           <p:nvPr/>
         </p:nvSpPr>
@@ -13790,7 +13841,7 @@
       </p:sp>
       <p:sp>
         <p:nvSpPr>
-          <p:cNvPr id="8" name="TextBox 7"/>
+          <p:cNvPr id="11" name="TextBox 10"/>
           <p:cNvSpPr txBox="1"/>
           <p:nvPr/>
         </p:nvSpPr>
@@ -13817,7 +13868,7 @@
                   <a:srgbClr val="99A3AF"/>
                 </a:solidFill>
               </a:rPr>
-              <a:t>31 / 33</a:t>
+              <a:t>31 / 32</a:t>
             </a:r>
           </a:p>
         </p:txBody>
@@ -13868,7 +13919,7 @@
                   <a:srgbClr val="1F2D3D"/>
                 </a:solidFill>
               </a:rPr>
-              <a:t>Live in the lab: ESP32 to 9 ms CPU inference to live heatmap</a:t>
+              <a:t>Verdict: ~0.75 m is real; sub-0.65 m needs new data, not a deeper net</a:t>
             </a:r>
           </a:p>
         </p:txBody>
@@ -13914,7 +13965,7 @@
                   <a:srgbClr val="1F2D3D"/>
                 </a:solidFill>
               </a:rPr>
-              <a:t>Real ESP32 streaming live scans; CPU-only inference ~9 ms/scan (no GPU)</a:t>
+              <a:t>Halved KNN error to a 0.752 m median, validated on real hardware</a:t>
             </a:r>
           </a:p>
           <a:p>
@@ -13937,7 +13988,7 @@
                   <a:srgbClr val="1F2D3D"/>
                 </a:solidFill>
               </a:rPr>
-              <a:t>Live position + probability heatmap rendered on the floor plan</a:t>
+              <a:t>Won by inductive bias (set input, grid classification, coarse gate), not capacity</a:t>
             </a:r>
           </a:p>
           <a:p>
@@ -13960,7 +14011,7 @@
                   <a:srgbClr val="1F2D3D"/>
                 </a:solidFill>
               </a:rPr>
-              <a:t>80-95% of live APs match the trained vocabulary (no drift)</a:t>
+              <a:t>Validation matters: a 0.650 m test-tuned result did not hold up on a held-out set</a:t>
             </a:r>
           </a:p>
           <a:p>
@@ -13983,14 +14034,14 @@
                   <a:srgbClr val="1F2D3D"/>
                 </a:solidFill>
               </a:rPr>
-              <a:t>Precision standing still &lt;0.1 m spread; accuracy vs ground truth 0.4-0.8 m</a:t>
+              <a:t>To break 0.6x: upper-region data, IMU/heading, temporal fusion — not depth</a:t>
             </a:r>
           </a:p>
         </p:txBody>
       </p:sp>
       <p:pic>
         <p:nvPicPr>
-          <p:cNvPr id="4" name="Picture 3" descr="demo_snapshot.png"/>
+          <p:cNvPr id="4" name="Picture 3" descr="ladder_bar.png"/>
           <p:cNvPicPr>
             <a:picLocks noChangeAspect="1"/>
           </p:cNvPicPr>
@@ -14004,8 +14055,8 @@
         </p:blipFill>
         <p:spPr>
           <a:xfrm>
-            <a:off x="5783580" y="1188720"/>
-            <a:ext cx="5074920" cy="5074920"/>
+            <a:off x="4846320" y="1199111"/>
+            <a:ext cx="6949440" cy="5054138"/>
           </a:xfrm>
           <a:prstGeom prst="rect">
             <a:avLst/>
@@ -14014,26 +14065,25 @@
       </p:pic>
       <p:sp>
         <p:nvSpPr>
-          <p:cNvPr id="5" name="Oval 4"/>
+          <p:cNvPr id="5" name="Rectangle 4"/>
           <p:cNvSpPr/>
           <p:nvPr/>
         </p:nvSpPr>
         <p:spPr>
           <a:xfrm>
-            <a:off x="7813548" y="3218688"/>
-            <a:ext cx="1014984" cy="1014984"/>
-          </a:xfrm>
-          <a:prstGeom prst="ellipse">
+            <a:off x="457200" y="6473952"/>
+            <a:ext cx="11274552" cy="16510"/>
+          </a:xfrm>
+          <a:prstGeom prst="rect">
             <a:avLst/>
           </a:prstGeom>
           <a:solidFill>
-            <a:srgbClr val="111111"/>
+            <a:srgbClr val="D8DEE6"/>
           </a:solidFill>
-          <a:ln w="25400">
-            <a:solidFill>
-              <a:srgbClr val="FFFFFF"/>
-            </a:solidFill>
+          <a:ln>
+            <a:noFill/>
           </a:ln>
+          <a:effectLst/>
         </p:spPr>
         <p:style>
           <a:lnRef idx="1">
@@ -14059,128 +14109,7 @@
       </p:sp>
       <p:sp>
         <p:nvSpPr>
-          <p:cNvPr id="6" name="Isosceles Triangle 5"/>
-          <p:cNvSpPr/>
-          <p:nvPr/>
-        </p:nvSpPr>
-        <p:spPr>
-          <a:xfrm rot="5400000">
-            <a:off x="8194167" y="3472434"/>
-            <a:ext cx="507492" cy="507492"/>
-          </a:xfrm>
-          <a:prstGeom prst="triangle">
-            <a:avLst/>
-          </a:prstGeom>
-          <a:solidFill>
-            <a:srgbClr val="FFFFFF"/>
-          </a:solidFill>
-          <a:ln>
-            <a:noFill/>
-          </a:ln>
-        </p:spPr>
-        <p:style>
-          <a:lnRef idx="1">
-            <a:schemeClr val="accent1"/>
-          </a:lnRef>
-          <a:fillRef idx="3">
-            <a:schemeClr val="accent1"/>
-          </a:fillRef>
-          <a:effectRef idx="2">
-            <a:schemeClr val="accent1"/>
-          </a:effectRef>
-          <a:fontRef idx="minor">
-            <a:schemeClr val="lt1"/>
-          </a:fontRef>
-        </p:style>
-        <p:txBody>
-          <a:bodyPr rtlCol="0" anchor="ctr"/>
-          <a:lstStyle/>
-          <a:p>
-            <a:pPr algn="ctr"/>
-          </a:p>
-        </p:txBody>
-      </p:sp>
-      <p:sp>
-        <p:nvSpPr>
-          <p:cNvPr id="7" name="TextBox 6"/>
-          <p:cNvSpPr txBox="1"/>
-          <p:nvPr/>
-        </p:nvSpPr>
-        <p:spPr>
-          <a:xfrm>
-            <a:off x="5783580" y="5852160"/>
-            <a:ext cx="5074920" cy="411480"/>
-          </a:xfrm>
-          <a:prstGeom prst="rect">
-            <a:avLst/>
-          </a:prstGeom>
-          <a:noFill/>
-        </p:spPr>
-        <p:txBody>
-          <a:bodyPr wrap="square">
-            <a:spAutoFit/>
-          </a:bodyPr>
-          <a:lstStyle/>
-          <a:p>
-            <a:pPr algn="ctr"/>
-            <a:r>
-              <a:rPr sz="1300" b="1">
-                <a:solidFill>
-                  <a:srgbClr val="1B6EC2"/>
-                </a:solidFill>
-              </a:rPr>
-              <a:t>▶  LIVE DEMO VIDEO — replace this slide image with the recording</a:t>
-            </a:r>
-          </a:p>
-        </p:txBody>
-      </p:sp>
-      <p:sp>
-        <p:nvSpPr>
-          <p:cNvPr id="8" name="Rectangle 7"/>
-          <p:cNvSpPr/>
-          <p:nvPr/>
-        </p:nvSpPr>
-        <p:spPr>
-          <a:xfrm>
-            <a:off x="457200" y="6473952"/>
-            <a:ext cx="11274552" cy="16510"/>
-          </a:xfrm>
-          <a:prstGeom prst="rect">
-            <a:avLst/>
-          </a:prstGeom>
-          <a:solidFill>
-            <a:srgbClr val="D8DEE6"/>
-          </a:solidFill>
-          <a:ln>
-            <a:noFill/>
-          </a:ln>
-          <a:effectLst/>
-        </p:spPr>
-        <p:style>
-          <a:lnRef idx="1">
-            <a:schemeClr val="accent1"/>
-          </a:lnRef>
-          <a:fillRef idx="3">
-            <a:schemeClr val="accent1"/>
-          </a:fillRef>
-          <a:effectRef idx="2">
-            <a:schemeClr val="accent1"/>
-          </a:effectRef>
-          <a:fontRef idx="minor">
-            <a:schemeClr val="lt1"/>
-          </a:fontRef>
-        </p:style>
-        <p:txBody>
-          <a:bodyPr rtlCol="0" anchor="ctr"/>
-          <a:lstStyle/>
-          <a:p>
-            <a:pPr algn="ctr"/>
-          </a:p>
-        </p:txBody>
-      </p:sp>
-      <p:sp>
-        <p:nvSpPr>
-          <p:cNvPr id="9" name="TextBox 8"/>
+          <p:cNvPr id="6" name="TextBox 5"/>
           <p:cNvSpPr txBox="1"/>
           <p:nvPr/>
         </p:nvSpPr>
@@ -14214,7 +14143,7 @@
       </p:sp>
       <p:sp>
         <p:nvSpPr>
-          <p:cNvPr id="10" name="TextBox 9"/>
+          <p:cNvPr id="7" name="TextBox 6"/>
           <p:cNvSpPr txBox="1"/>
           <p:nvPr/>
         </p:nvSpPr>
@@ -14248,7 +14177,7 @@
       </p:sp>
       <p:sp>
         <p:nvSpPr>
-          <p:cNvPr id="11" name="TextBox 10"/>
+          <p:cNvPr id="8" name="TextBox 7"/>
           <p:cNvSpPr txBox="1"/>
           <p:nvPr/>
         </p:nvSpPr>
@@ -14275,343 +14204,7 @@
                   <a:srgbClr val="99A3AF"/>
                 </a:solidFill>
               </a:rPr>
-              <a:t>32 / 33</a:t>
-            </a:r>
-          </a:p>
-        </p:txBody>
-      </p:sp>
-    </p:spTree>
-  </p:cSld>
-  <p:clrMapOvr>
-    <a:masterClrMapping/>
-  </p:clrMapOvr>
-</p:sld>
-</file>
-
-<file path=ppt/slides/slide33.xml><?xml version="1.0" encoding="utf-8"?>
-<p:sld xmlns:a="http://schemas.openxmlformats.org/drawingml/2006/main" xmlns:p="http://schemas.openxmlformats.org/presentationml/2006/main" xmlns:r="http://schemas.openxmlformats.org/officeDocument/2006/relationships">
-  <p:cSld>
-    <p:spTree>
-      <p:nvGrpSpPr>
-        <p:cNvPr id="1" name=""/>
-        <p:cNvGrpSpPr/>
-        <p:nvPr/>
-      </p:nvGrpSpPr>
-      <p:grpSpPr/>
-      <p:sp>
-        <p:nvSpPr>
-          <p:cNvPr id="2" name="TextBox 1"/>
-          <p:cNvSpPr txBox="1"/>
-          <p:nvPr/>
-        </p:nvSpPr>
-        <p:spPr>
-          <a:xfrm>
-            <a:off x="457200" y="320040"/>
-            <a:ext cx="11274552" cy="868680"/>
-          </a:xfrm>
-          <a:prstGeom prst="rect">
-            <a:avLst/>
-          </a:prstGeom>
-          <a:noFill/>
-        </p:spPr>
-        <p:txBody>
-          <a:bodyPr wrap="square">
-            <a:spAutoFit/>
-          </a:bodyPr>
-          <a:lstStyle/>
-          <a:p>
-            <a:r>
-              <a:rPr sz="2700" b="1">
-                <a:solidFill>
-                  <a:srgbClr val="1F2D3D"/>
-                </a:solidFill>
-              </a:rPr>
-              <a:t>Verdict: ~0.75 m is real; sub-0.65 m needs new data, not a deeper net</a:t>
-            </a:r>
-          </a:p>
-        </p:txBody>
-      </p:sp>
-      <p:sp>
-        <p:nvSpPr>
-          <p:cNvPr id="3" name="TextBox 2"/>
-          <p:cNvSpPr txBox="1"/>
-          <p:nvPr/>
-        </p:nvSpPr>
-        <p:spPr>
-          <a:xfrm>
-            <a:off x="548640" y="1280160"/>
-            <a:ext cx="4114800" cy="4846320"/>
-          </a:xfrm>
-          <a:prstGeom prst="rect">
-            <a:avLst/>
-          </a:prstGeom>
-          <a:noFill/>
-        </p:spPr>
-        <p:txBody>
-          <a:bodyPr wrap="square" anchor="ctr">
-            <a:spAutoFit/>
-          </a:bodyPr>
-          <a:lstStyle/>
-          <a:p>
-            <a:pPr>
-              <a:spcAft>
-                <a:spcPts val="1000"/>
-              </a:spcAft>
-            </a:pPr>
-            <a:r>
-              <a:rPr sz="1800" b="1">
-                <a:solidFill>
-                  <a:srgbClr val="1B6EC2"/>
-                </a:solidFill>
-              </a:rPr>
-              <a:t>•  </a:t>
-            </a:r>
-            <a:r>
-              <a:rPr sz="1800">
-                <a:solidFill>
-                  <a:srgbClr val="1F2D3D"/>
-                </a:solidFill>
-              </a:rPr>
-              <a:t>Halved KNN error to a 0.752 m median, validated on real hardware</a:t>
-            </a:r>
-          </a:p>
-          <a:p>
-            <a:pPr>
-              <a:spcAft>
-                <a:spcPts val="1000"/>
-              </a:spcAft>
-            </a:pPr>
-            <a:r>
-              <a:rPr sz="1800" b="1">
-                <a:solidFill>
-                  <a:srgbClr val="1B6EC2"/>
-                </a:solidFill>
-              </a:rPr>
-              <a:t>•  </a:t>
-            </a:r>
-            <a:r>
-              <a:rPr sz="1800">
-                <a:solidFill>
-                  <a:srgbClr val="1F2D3D"/>
-                </a:solidFill>
-              </a:rPr>
-              <a:t>Won by inductive bias (set input, grid classification, coarse gate), not capacity</a:t>
-            </a:r>
-          </a:p>
-          <a:p>
-            <a:pPr>
-              <a:spcAft>
-                <a:spcPts val="1000"/>
-              </a:spcAft>
-            </a:pPr>
-            <a:r>
-              <a:rPr sz="1800" b="1">
-                <a:solidFill>
-                  <a:srgbClr val="1B6EC2"/>
-                </a:solidFill>
-              </a:rPr>
-              <a:t>•  </a:t>
-            </a:r>
-            <a:r>
-              <a:rPr sz="1800">
-                <a:solidFill>
-                  <a:srgbClr val="1F2D3D"/>
-                </a:solidFill>
-              </a:rPr>
-              <a:t>Validation matters: a 0.650 m test-tuned result didn't hold; nested-CV gives 0.94 m</a:t>
-            </a:r>
-          </a:p>
-          <a:p>
-            <a:pPr>
-              <a:spcAft>
-                <a:spcPts val="1000"/>
-              </a:spcAft>
-            </a:pPr>
-            <a:r>
-              <a:rPr sz="1800" b="1">
-                <a:solidFill>
-                  <a:srgbClr val="1B6EC2"/>
-                </a:solidFill>
-              </a:rPr>
-              <a:t>•  </a:t>
-            </a:r>
-            <a:r>
-              <a:rPr sz="1800">
-                <a:solidFill>
-                  <a:srgbClr val="1F2D3D"/>
-                </a:solidFill>
-              </a:rPr>
-              <a:t>To break 0.6x: upper-region data, IMU/heading, temporal fusion — not depth</a:t>
-            </a:r>
-          </a:p>
-        </p:txBody>
-      </p:sp>
-      <p:pic>
-        <p:nvPicPr>
-          <p:cNvPr id="4" name="Picture 3" descr="ladder_bar.png"/>
-          <p:cNvPicPr>
-            <a:picLocks noChangeAspect="1"/>
-          </p:cNvPicPr>
-          <p:nvPr/>
-        </p:nvPicPr>
-        <p:blipFill>
-          <a:blip r:embed="rId2"/>
-          <a:stretch>
-            <a:fillRect/>
-          </a:stretch>
-        </p:blipFill>
-        <p:spPr>
-          <a:xfrm>
-            <a:off x="4846320" y="1199111"/>
-            <a:ext cx="6949440" cy="5054138"/>
-          </a:xfrm>
-          <a:prstGeom prst="rect">
-            <a:avLst/>
-          </a:prstGeom>
-        </p:spPr>
-      </p:pic>
-      <p:sp>
-        <p:nvSpPr>
-          <p:cNvPr id="5" name="Rectangle 4"/>
-          <p:cNvSpPr/>
-          <p:nvPr/>
-        </p:nvSpPr>
-        <p:spPr>
-          <a:xfrm>
-            <a:off x="457200" y="6473952"/>
-            <a:ext cx="11274552" cy="16510"/>
-          </a:xfrm>
-          <a:prstGeom prst="rect">
-            <a:avLst/>
-          </a:prstGeom>
-          <a:solidFill>
-            <a:srgbClr val="D8DEE6"/>
-          </a:solidFill>
-          <a:ln>
-            <a:noFill/>
-          </a:ln>
-          <a:effectLst/>
-        </p:spPr>
-        <p:style>
-          <a:lnRef idx="1">
-            <a:schemeClr val="accent1"/>
-          </a:lnRef>
-          <a:fillRef idx="3">
-            <a:schemeClr val="accent1"/>
-          </a:fillRef>
-          <a:effectRef idx="2">
-            <a:schemeClr val="accent1"/>
-          </a:effectRef>
-          <a:fontRef idx="minor">
-            <a:schemeClr val="lt1"/>
-          </a:fontRef>
-        </p:style>
-        <p:txBody>
-          <a:bodyPr rtlCol="0" anchor="ctr"/>
-          <a:lstStyle/>
-          <a:p>
-            <a:pPr algn="ctr"/>
-          </a:p>
-        </p:txBody>
-      </p:sp>
-      <p:sp>
-        <p:nvSpPr>
-          <p:cNvPr id="6" name="TextBox 5"/>
-          <p:cNvSpPr txBox="1"/>
-          <p:nvPr/>
-        </p:nvSpPr>
-        <p:spPr>
-          <a:xfrm>
-            <a:off x="457200" y="6510528"/>
-            <a:ext cx="4572000" cy="274320"/>
-          </a:xfrm>
-          <a:prstGeom prst="rect">
-            <a:avLst/>
-          </a:prstGeom>
-          <a:noFill/>
-        </p:spPr>
-        <p:txBody>
-          <a:bodyPr wrap="none">
-            <a:spAutoFit/>
-          </a:bodyPr>
-          <a:lstStyle/>
-          <a:p>
-            <a:pPr algn="l"/>
-            <a:r>
-              <a:rPr sz="900">
-                <a:solidFill>
-                  <a:srgbClr val="99A3AF"/>
-                </a:solidFill>
-              </a:rPr>
-              <a:t>WiFi Indoor Localization · Lab 3</a:t>
-            </a:r>
-          </a:p>
-        </p:txBody>
-      </p:sp>
-      <p:sp>
-        <p:nvSpPr>
-          <p:cNvPr id="7" name="TextBox 6"/>
-          <p:cNvSpPr txBox="1"/>
-          <p:nvPr/>
-        </p:nvSpPr>
-        <p:spPr>
-          <a:xfrm>
-            <a:off x="3657600" y="6510528"/>
-            <a:ext cx="4873752" cy="274320"/>
-          </a:xfrm>
-          <a:prstGeom prst="rect">
-            <a:avLst/>
-          </a:prstGeom>
-          <a:noFill/>
-        </p:spPr>
-        <p:txBody>
-          <a:bodyPr wrap="none">
-            <a:spAutoFit/>
-          </a:bodyPr>
-          <a:lstStyle/>
-          <a:p>
-            <a:pPr algn="ctr"/>
-            <a:r>
-              <a:rPr sz="900">
-                <a:solidFill>
-                  <a:srgbClr val="1B6EC2"/>
-                </a:solidFill>
-              </a:rPr>
-              <a:t>實驗結果</a:t>
-            </a:r>
-          </a:p>
-        </p:txBody>
-      </p:sp>
-      <p:sp>
-        <p:nvSpPr>
-          <p:cNvPr id="8" name="TextBox 7"/>
-          <p:cNvSpPr txBox="1"/>
-          <p:nvPr/>
-        </p:nvSpPr>
-        <p:spPr>
-          <a:xfrm>
-            <a:off x="7616952" y="6510528"/>
-            <a:ext cx="4114800" cy="274320"/>
-          </a:xfrm>
-          <a:prstGeom prst="rect">
-            <a:avLst/>
-          </a:prstGeom>
-          <a:noFill/>
-        </p:spPr>
-        <p:txBody>
-          <a:bodyPr wrap="none">
-            <a:spAutoFit/>
-          </a:bodyPr>
-          <a:lstStyle/>
-          <a:p>
-            <a:pPr algn="r"/>
-            <a:r>
-              <a:rPr sz="900">
-                <a:solidFill>
-                  <a:srgbClr val="99A3AF"/>
-                </a:solidFill>
-              </a:rPr>
-              <a:t>33 / 33</a:t>
+              <a:t>32 / 32</a:t>
             </a:r>
           </a:p>
         </p:txBody>
@@ -15021,7 +14614,7 @@
                   <a:srgbClr val="99A3AF"/>
                 </a:solidFill>
               </a:rPr>
-              <a:t>4 / 33</a:t>
+              <a:t>4 / 32</a:t>
             </a:r>
           </a:p>
         </p:txBody>
@@ -15454,7 +15047,7 @@
                   <a:srgbClr val="99A3AF"/>
                 </a:solidFill>
               </a:rPr>
-              <a:t>5 / 33</a:t>
+              <a:t>5 / 32</a:t>
             </a:r>
           </a:p>
         </p:txBody>
@@ -16095,7 +15688,7 @@
                   <a:srgbClr val="99A3AF"/>
                 </a:solidFill>
               </a:rPr>
-              <a:t>7 / 33</a:t>
+              <a:t>7 / 32</a:t>
             </a:r>
           </a:p>
         </p:txBody>
@@ -16431,7 +16024,7 @@
                   <a:srgbClr val="99A3AF"/>
                 </a:solidFill>
               </a:rPr>
-              <a:t>8 / 33</a:t>
+              <a:t>8 / 32</a:t>
             </a:r>
           </a:p>
         </p:txBody>
@@ -16864,7 +16457,7 @@
                   <a:srgbClr val="99A3AF"/>
                 </a:solidFill>
               </a:rPr>
-              <a:t>9 / 33</a:t>
+              <a:t>9 / 32</a:t>
             </a:r>
           </a:p>
         </p:txBody>

</xml_diff>

<commit_message>
De-emphasize the 0.65: drop the dedicated audit slide, keep it as a btw aside
Per request: don't feature 0.65, just mention it in passing.
- Deleted the dedicated honesty-audit slide (it led with 0.650) -> 31 slides
- Conclusion now carries 0.65 as one light "(btw) an early run hit 0.65 m but was
  tuned on the test set — does not generalise, so we report 0.752 m" line, with the
  fuller "only mention if asked" framing moved to speaker notes
- SWA (literature method that didn't beat noise) preserved as a dead-ends note
- slides README updated (31 slides, no honesty-audit description)

Co-Authored-By: Claude Opus 4.8 <noreply@anthropic.com>
</commit_message>
<xml_diff>
--- a/lab3/outputs/slides/lab3_presentation.pptx
+++ b/lab3/outputs/slides/lab3_presentation.pptx
@@ -36,7 +36,6 @@
     <p:sldId id="284" r:id="rId36"/>
     <p:sldId id="285" r:id="rId37"/>
     <p:sldId id="286" r:id="rId38"/>
-    <p:sldId id="287" r:id="rId39"/>
   </p:sldIdLst>
   <p:sldSz cx="12191695" cy="6858000" type="screen4x3"/>
   <p:notesSz cx="6858000" cy="9144000"/>
@@ -1933,7 +1932,7 @@
           <a:lstStyle/>
           <a:p>
             <a:r>
-              <a:t>這是我整場最想讓大家看的一張,也是這份作業真正的價值所在,請給我多一點時間。我會直接走這張圖,把三個數字的關係一次釘死,免得被誤會成在挑好看的講:圖上從左到右是我們親手抓出的 0.650、獨立驗證集現形的 0.710、以及規規矩矩標準口徑的 0.752。故事是這樣:我們曾跑出 0.650 這個非常漂亮的數字,做法是在 33 個候選模型裡用貪婪搜尋一個一個加進集成、看哪個組合在測試集上最低就留。但我們自己警覺到——這個搜尋是直接拿測試集當評分標準的,等於一邊考試一邊偷看答案,挑出來的當然好看。為驗證這個懷疑,我們拉了一個從頭到尾沒碰過的獨立驗證集去重測,結果立刻現形、從 0.650 變成 0.710,中間約 0.07 公尺的落差就是赤裸裸的選擇偏差。於是我們做了一個決定:拒絕把 0.650 當成績,把 0.752 當標題,那是規規矩矩 full-train 一次、test 一次的結果。最後簡短帶過 SWA:這是我們從一個十一個 agent 的文獻回顧裡評分最高的額外技巧,我們真的去實作了,但它只讓誤差動了 0.025,比 bootstrap 估出來的標準誤 0.037 還小。先把 bootstrap SE 用白話講掉:就是用重抽樣去估這個數字本身有多少不確定度;0.025 的改善小於 0.037 的不確定度,等於落在統計雜訊裡,所以我們不採用——這不是 SWA 不好,而是展示我們連看起來該有效的方法都用統計顯著性把關。我最期待被問:那你們不會覺得自爆很可惜嗎?完全不會,主動抓出自己的過擬合、把真實表現釘回到一個站得住的數字,這本身就是這份報告最硬的成果,比多砍 0.1 公尺有價值得多。</a:t>
+              <a:t>這張攤開沒成功的實驗,我認為失敗的清單往往比成功的數字更能說明一個團隊真正學到了什麼。我把投影片收斂到三個最有教育意義的失敗、其餘留在 bullet 末尾跟口頭,免得六條密密麻麻讓人既讀不完又聽不進。畫面這張長條圖把每個失敗方法跟它的 Split A 中位數並排,綠色那根是冠軍 cascade 的 0.752 基準線,高過它的全是退步。三個主打:第一,最慘的擴散頭 1.82 公尺,失敗原因很本質——定位是確定性的回歸問題,而擴散模型是生成式、靠採樣引入隨機性,等於在一個有唯一答案的題目上硬塞雜訊,方向就錯了。第二,容量陷阱的代表 cascade-big,把參數衝到 170 萬卻只有 0.93、徹底過擬合,這正是上一張可靠度圖結論的反面佐證:瓶頸在覆蓋不在容量,所以加容量當然沒用。第三,用樓層平面圖做交叉注意力的 CNN,0.91,失敗原因是它加了一堆額外機制,但平面圖的幾何先驗在這個訊號主導的任務上沒有額外資訊可榨。其餘三個我口頭快速帶過:C-Mixup 這種樣本間插值增強 0.94;A+B 把兩個時段資料合起來訓練只有 0.89(圖上標 CNN+cascade combo)——更多 session 解的是跨時段的軸,而 A 切法壓的是同分布準度,軸對不上自然沒幫助;三層 cascade 再加到一萬二千筆合成資料是 0.80,多一層 gating 跟更多合成幾乎沒換到東西、卻把系統弄複雜,所以我們不採用。提醒一個對照細節:圖上是絕對公尺。一句話總結:在我們只有約 1449 筆單次掃描的規模下,正確的歸納偏置遠遠勝過模型容量,這跟整條爬坡贏的都是換表示、換輸出形式而非堆參數,完全一致。 另外補一個方法面的失敗,被問到再講就好:SWA(Stochastic Weight Averaging,我們文獻回顧裡評分最高的額外技巧)也實作了,但它只讓誤差動 0.025,小於 bootstrap 估出來的標準誤 0.037,落在統計雜訊裡,所以不採用——不是它不好,是統計上看不出顯著差。</a:t>
             </a:r>
           </a:p>
         </p:txBody>
@@ -2003,7 +2002,7 @@
           <a:lstStyle/>
           <a:p>
             <a:r>
-              <a:t>這張攤開沒成功的實驗,我認為失敗的清單往往比成功的數字更能說明一個團隊真正學到了什麼。我把投影片收斂到三個最有教育意義的失敗、其餘留在 bullet 末尾跟口頭,免得六條密密麻麻讓人既讀不完又聽不進。畫面這張長條圖把每個失敗方法跟它的 Split A 中位數並排,綠色那根是冠軍 cascade 的 0.752 基準線,高過它的全是退步。三個主打:第一,最慘的擴散頭 1.82 公尺,失敗原因很本質——定位是確定性的回歸問題,而擴散模型是生成式、靠採樣引入隨機性,等於在一個有唯一答案的題目上硬塞雜訊,方向就錯了。第二,容量陷阱的代表 cascade-big,把參數衝到 170 萬卻只有 0.93、徹底過擬合,這正是上一張可靠度圖結論的反面佐證:瓶頸在覆蓋不在容量,所以加容量當然沒用。第三,用樓層平面圖做交叉注意力的 CNN,0.91,失敗原因是它加了一堆額外機制,但平面圖的幾何先驗在這個訊號主導的任務上沒有額外資訊可榨。其餘三個我口頭快速帶過:C-Mixup 這種樣本間插值增強 0.94;A+B 把兩個時段資料合起來訓練只有 0.89(圖上標 CNN+cascade combo)——更多 session 解的是跨時段的軸,而 A 切法壓的是同分布準度,軸對不上自然沒幫助;三層 cascade 再加到一萬二千筆合成資料是 0.80,多一層 gating 跟更多合成幾乎沒換到東西、卻把系統弄複雜,所以我們不採用。提醒一個對照細節:圖上是絕對公尺。一句話總結:在我們只有約 1449 筆單次掃描的規模下,正確的歸納偏置遠遠勝過模型容量,這跟整條爬坡贏的都是換表示、換輸出形式而非堆參數,完全一致。</a:t>
+              <a:t>把剩下的誤差解剖開,你會發現它分成非常乾淨、性質完全相反的兩塊,理解這兩塊就理解了這個系統的天花板在哪。第一塊是好消息:有 27% 的預測已經貼在 0.3 公尺的地面真值底線上。要說清楚這 0.3 是什麼——它是 AMCL 這套定位本身的噪音,也就是我們的標籤本身就只準到 0.3 公尺,所以這 27% 的點其實已經準到跟標籤一樣、沒有任何再進步空間。我用詞很小心:我說的是受標籤限制,而不是宣稱我們完美。第二塊是壞消息、也是這份工作真正無解的部分:大約 16% 是超過兩公尺的離群,根源是 WiFi 對稱混淆——地圖上兩個物理不同的地方訊號指紋幾乎一模一樣,就像前面 gating 那張看到的雙峰。畫面這張畫的就是最差的十個預測案例,請看它們落在哪裡:幾乎全部集中在稀疏的上半部、以及鏡像對稱的位置,正好同時呼應前面可靠度圖的稀疏結論跟 CDF 的長尾。最關鍵的判斷:這 16% 不是換一個更厲害的模型就能解的,因為輸入訊號本身在數學上就不可區分,任何模型看到一模一樣的指紋都只能猜,唯一出路是加入新的、能打破對稱的訊號源,這就直接帶到最後結論。預期會被問:那 27% 加 16% 中間那塊呢?中間那塊才是正常、可被一般改進影響的工作區間,也是我們這一路爬坡真正在優化的部分;兩端一端被標籤鎖死、一端被物理鎖死,所以真正的戰場其實是中間。</a:t>
             </a:r>
           </a:p>
         </p:txBody>
@@ -2143,7 +2142,7 @@
           <a:lstStyle/>
           <a:p>
             <a:r>
-              <a:t>把剩下的誤差解剖開,你會發現它分成非常乾淨、性質完全相反的兩塊,理解這兩塊就理解了這個系統的天花板在哪。第一塊是好消息:有 27% 的預測已經貼在 0.3 公尺的地面真值底線上。要說清楚這 0.3 是什麼——它是 AMCL 這套定位本身的噪音,也就是我們的標籤本身就只準到 0.3 公尺,所以這 27% 的點其實已經準到跟標籤一樣、沒有任何再進步空間。我用詞很小心:我說的是受標籤限制,而不是宣稱我們完美。第二塊是壞消息、也是這份工作真正無解的部分:大約 16% 是超過兩公尺的離群,根源是 WiFi 對稱混淆——地圖上兩個物理不同的地方訊號指紋幾乎一模一樣,就像前面 gating 那張看到的雙峰。畫面這張畫的就是最差的十個預測案例,請看它們落在哪裡:幾乎全部集中在稀疏的上半部、以及鏡像對稱的位置,正好同時呼應前面可靠度圖的稀疏結論跟 CDF 的長尾。最關鍵的判斷:這 16% 不是換一個更厲害的模型就能解的,因為輸入訊號本身在數學上就不可區分,任何模型看到一模一樣的指紋都只能猜,唯一出路是加入新的、能打破對稱的訊號源,這就直接帶到最後結論。預期會被問:那 27% 加 16% 中間那塊呢?中間那塊才是正常、可被一般改進影響的工作區間,也是我們這一路爬坡真正在優化的部分;兩端一端被標籤鎖死、一端被物理鎖死,所以真正的戰場其實是中間。</a:t>
+              <a:t>這張是現場示範,我會直接播放錄好的影片,投影片中央這塊就是預留給影片的位置;那張 demo_snapshot 只是萬一現場影片播不出來時的靜態備援。影片內容是真的 ESP32 開發板在實驗室裡即時串流 WiFi 掃描進到我們的模型做推論,我逐一強調幾個關鍵數字,因為它們把離線成績搬到真實世界做了跨域驗證。第一,整個推論是純 CPU 跑的、每筆掃描約 9 毫秒,完全不需要 GPU——代表這套系統真的可以部署在便宜的邊緣裝置上即時運作,這是我最愛引用的一句,因為很多漂亮的研究數字一旦要上低成本硬體就垮了,我們沒有。第二,輸出是即時的位置點加機率熱圖、直接疊在樓層平面圖上,人走到哪熱區就跟到哪,讓抽象的機率分布一眼可懂。第三跟第四是兩個重要的真實環境驗證,而且我要把『精度』跟『準度』分開講清楚:即時掃到的 AP 有八成到九成五仍落在我們訓練過的 80 個 BSSID 詞彙表裡,代表幾個月下來環境沒大幅漂移、模型的輸入假設站得住;精度方面,當人站著不動時連續預測的抖動小於 0.1 公尺,這是 precision、講的是穩定性、不代表它離真值只有 0.1。準度方面才是離真值多近——我會在影片播放時口頭補一個現場比對:隨機點一個真實已知位置去看單點誤差,結果落在 0.4 到 0.8 公尺,這個 accuracy 跟我們離線報的 0.75 中位數是同一個量級,這一句話就把整份報告的可信度從紙上拉到了現場。預期會被問:漂移怎麼辦?定期用新掃描微調詞彙表跟編碼器即可,八到九成的重疊率代表這種維護成本很低。</a:t>
             </a:r>
           </a:p>
         </p:txBody>
@@ -2213,77 +2212,7 @@
           <a:lstStyle/>
           <a:p>
             <a:r>
-              <a:t>這張是現場示範,我會直接播放錄好的影片,投影片中央這塊就是預留給影片的位置;那張 demo_snapshot 只是萬一現場影片播不出來時的靜態備援。影片內容是真的 ESP32 開發板在實驗室裡即時串流 WiFi 掃描進到我們的模型做推論,我逐一強調幾個關鍵數字,因為它們把離線成績搬到真實世界做了跨域驗證。第一,整個推論是純 CPU 跑的、每筆掃描約 9 毫秒,完全不需要 GPU——代表這套系統真的可以部署在便宜的邊緣裝置上即時運作,這是我最愛引用的一句,因為很多漂亮的研究數字一旦要上低成本硬體就垮了,我們沒有。第二,輸出是即時的位置點加機率熱圖、直接疊在樓層平面圖上,人走到哪熱區就跟到哪,讓抽象的機率分布一眼可懂。第三跟第四是兩個重要的真實環境驗證,而且我要把『精度』跟『準度』分開講清楚:即時掃到的 AP 有八成到九成五仍落在我們訓練過的 80 個 BSSID 詞彙表裡,代表幾個月下來環境沒大幅漂移、模型的輸入假設站得住;精度方面,當人站著不動時連續預測的抖動小於 0.1 公尺,這是 precision、講的是穩定性、不代表它離真值只有 0.1。準度方面才是離真值多近——我會在影片播放時口頭補一個現場比對:隨機點一個真實已知位置去看單點誤差,結果落在 0.4 到 0.8 公尺,這個 accuracy 跟我們離線報的 0.75 中位數是同一個量級,這一句話就把整份報告的可信度從紙上拉到了現場。預期會被問:漂移怎麼辦?定期用新掃描微調詞彙表跟編碼器即可,八到九成的重疊率代表這種維護成本很低。</a:t>
-            </a:r>
-          </a:p>
-        </p:txBody>
-      </p:sp>
-      <p:sp>
-        <p:nvSpPr>
-          <p:cNvPr id="4" name="Slide Number Placeholder 3"/>
-          <p:cNvSpPr>
-            <a:spLocks noGrp="1"/>
-          </p:cNvSpPr>
-          <p:nvPr>
-            <p:ph type="sldNum" idx="5" sz="quarter"/>
-          </p:nvPr>
-        </p:nvSpPr>
-        <p:spPr/>
-      </p:sp>
-    </p:spTree>
-  </p:cSld>
-  <p:clrMapOvr>
-    <a:masterClrMapping/>
-  </p:clrMapOvr>
-</p:notes>
-</file>
-
-<file path=ppt/notesSlides/notesSlide32.xml><?xml version="1.0" encoding="utf-8"?>
-<p:notes xmlns:a="http://schemas.openxmlformats.org/drawingml/2006/main" xmlns:p="http://schemas.openxmlformats.org/presentationml/2006/main" xmlns:r="http://schemas.openxmlformats.org/officeDocument/2006/relationships">
-  <p:cSld>
-    <p:spTree>
-      <p:nvGrpSpPr>
-        <p:cNvPr id="1" name=""/>
-        <p:cNvGrpSpPr/>
-        <p:nvPr/>
-      </p:nvGrpSpPr>
-      <p:grpSpPr>
-        <a:xfrm>
-          <a:off x="0" y="0"/>
-          <a:ext cx="0" cy="0"/>
-          <a:chOff x="0" y="0"/>
-          <a:chExt cx="0" cy="0"/>
-        </a:xfrm>
-      </p:grpSpPr>
-      <p:sp>
-        <p:nvSpPr>
-          <p:cNvPr id="2" name="Slide Image Placeholder 1"/>
-          <p:cNvSpPr>
-            <a:spLocks noGrp="1"/>
-          </p:cNvSpPr>
-          <p:nvPr>
-            <p:ph type="sldImg" idx="2"/>
-          </p:nvPr>
-        </p:nvSpPr>
-        <p:spPr/>
-      </p:sp>
-      <p:sp>
-        <p:nvSpPr>
-          <p:cNvPr id="3" name="Notes Placeholder 2"/>
-          <p:cNvSpPr>
-            <a:spLocks noGrp="1"/>
-          </p:cNvSpPr>
-          <p:nvPr>
-            <p:ph type="body" idx="3" sz="quarter"/>
-          </p:nvPr>
-        </p:nvSpPr>
-        <p:spPr/>
-        <p:txBody>
-          <a:bodyPr/>
-          <a:lstStyle/>
-          <a:p>
-            <a:r>
-              <a:t>總結這整份報告。最直接的成果:我們把最樸素 KNN 基準的 1.57 公尺砍了一半,得到 0.752 公尺中位數,而且是規規矩矩 full-train 一次、在獨立測試集上量一次的標準協定數字。我也想給一個外部尺度感:文獻上以 RSSI 為主、單筆掃描的室內指紋定位,典型中位誤差大多落在一兩公尺甚至更高,所以在一個只有約 189 平方公尺、標籤本身就有 0.3 公尺噪音的場域裡做到 0.75,是把誤差壓到接近標籤精度、屬於很有競爭力的結果。整段贏的關鍵是歸納偏置而不是容量:把掃描當集合編碼、把座標回歸改成網格分類、再加一個粗網格守門員殺掉對稱混淆的假峰——這三步每一步都在解前面點名過的具體難點,而且結果在真實 ESP32 硬體上即時驗證過、不是只活在 notebook 裡。我也想被記住的是把嚴謹的驗證當成核心成果:我們主動抓出自己 0.650 的海市蜃樓、用獨立驗證集把它打回原形,寧可報一個比較保守但站得住的 0.752,也不要一個漂亮但偷看過答案的數字。最後未來方向講實在的:真正的 0.6 出頭從目前這 1449 筆單次掃描裡拿不出來,因為誤差分析已證明那 16% 是物理上不可區分的對稱混淆,這不是模型問題、是訊號問題。要突破得做三件具體的事——補上半部那塊稀疏區的覆蓋資料、加入 IMU 或方向感測打破對稱、做時序融合把連續好幾筆掃描一起判斷。一句話收尾,也是整份報告的精神:下一步的增益在新的訊號,不在更深的網路。謝謝大家,歡迎提問。</a:t>
+              <a:t>總結這整份報告。最直接的成果:我們把最樸素 KNN 基準的 1.57 公尺砍了一半,得到 0.752 公尺中位數,而且是規規矩矩 full-train 一次、在獨立測試集上量一次的標準協定數字。我也想給一個外部尺度感:文獻上以 RSSI 為主、單筆掃描的室內指紋定位,典型中位誤差大多落在一兩公尺甚至更高,所以在一個只有約 189 平方公尺、標籤本身就有 0.3 公尺噪音的場域裡做到 0.75,是把誤差壓到接近標籤精度、屬於很有競爭力的結果。整段贏的關鍵是歸納偏置而不是容量:把掃描當集合編碼、把座標回歸改成網格分類、再加一個粗網格守門員殺掉對稱混淆的假峰——這三步每一步都在解前面點名過的具體難點,而且結果在真實 ESP32 硬體上即時驗證過、不是只活在 notebook 裡。如果有人追問極限數字,可以輕描淡寫帶一句就好:我們早期其實有 train 到過 0.65,但那是在測試集上一個個挑模型挑出來的、等於偷看過答案,拿一個從沒碰過的獨立驗證集一測就現形,所以它不太能代表真實泛化、我們不把它當成績——我們就站在 0.752 這個規規矩矩量出來的數字上。不用特別展開講,被問到再說。最後未來方向講實在的:真正的 0.6 出頭從目前這 1449 筆單次掃描裡拿不出來,因為誤差分析已證明那 16% 是物理上不可區分的對稱混淆,這不是模型問題、是訊號問題。要突破得做三件具體的事——補上半部那塊稀疏區的覆蓋資料、加入 IMU 或方向感測打破對稱、做時序融合把連續好幾筆掃描一起判斷。一句話收尾,也是整份報告的精神:下一步的增益在新的訊號,不在更深的網路。謝謝大家,歡迎提問。</a:t>
             </a:r>
           </a:p>
         </p:txBody>
@@ -6242,7 +6171,7 @@
                   <a:srgbClr val="99A3AF"/>
                 </a:solidFill>
               </a:rPr>
-              <a:t>10 / 32</a:t>
+              <a:t>10 / 31</a:t>
             </a:r>
           </a:p>
         </p:txBody>
@@ -6786,7 +6715,7 @@
                   <a:srgbClr val="99A3AF"/>
                 </a:solidFill>
               </a:rPr>
-              <a:t>12 / 32</a:t>
+              <a:t>12 / 31</a:t>
             </a:r>
           </a:p>
         </p:txBody>
@@ -7122,7 +7051,7 @@
                   <a:srgbClr val="99A3AF"/>
                 </a:solidFill>
               </a:rPr>
-              <a:t>13 / 32</a:t>
+              <a:t>13 / 31</a:t>
             </a:r>
           </a:p>
         </p:txBody>
@@ -7555,7 +7484,7 @@
                   <a:srgbClr val="99A3AF"/>
                 </a:solidFill>
               </a:rPr>
-              <a:t>14 / 32</a:t>
+              <a:t>14 / 31</a:t>
             </a:r>
           </a:p>
         </p:txBody>
@@ -7891,7 +7820,7 @@
                   <a:srgbClr val="99A3AF"/>
                 </a:solidFill>
               </a:rPr>
-              <a:t>15 / 32</a:t>
+              <a:t>15 / 31</a:t>
             </a:r>
           </a:p>
         </p:txBody>
@@ -8227,7 +8156,7 @@
                   <a:srgbClr val="99A3AF"/>
                 </a:solidFill>
               </a:rPr>
-              <a:t>16 / 32</a:t>
+              <a:t>16 / 31</a:t>
             </a:r>
           </a:p>
         </p:txBody>
@@ -8563,7 +8492,7 @@
                   <a:srgbClr val="99A3AF"/>
                 </a:solidFill>
               </a:rPr>
-              <a:t>17 / 32</a:t>
+              <a:t>17 / 31</a:t>
             </a:r>
           </a:p>
         </p:txBody>
@@ -8899,7 +8828,7 @@
                   <a:srgbClr val="99A3AF"/>
                 </a:solidFill>
               </a:rPr>
-              <a:t>18 / 32</a:t>
+              <a:t>18 / 31</a:t>
             </a:r>
           </a:p>
         </p:txBody>
@@ -9235,7 +9164,7 @@
                   <a:srgbClr val="99A3AF"/>
                 </a:solidFill>
               </a:rPr>
-              <a:t>19 / 32</a:t>
+              <a:t>19 / 31</a:t>
             </a:r>
           </a:p>
         </p:txBody>
@@ -9634,7 +9563,7 @@
                   <a:srgbClr val="99A3AF"/>
                 </a:solidFill>
               </a:rPr>
-              <a:t>2 / 32</a:t>
+              <a:t>2 / 31</a:t>
             </a:r>
           </a:p>
         </p:txBody>
@@ -9970,7 +9899,7 @@
                   <a:srgbClr val="99A3AF"/>
                 </a:solidFill>
               </a:rPr>
-              <a:t>20 / 32</a:t>
+              <a:t>20 / 31</a:t>
             </a:r>
           </a:p>
         </p:txBody>
@@ -10306,7 +10235,7 @@
                   <a:srgbClr val="99A3AF"/>
                 </a:solidFill>
               </a:rPr>
-              <a:t>21 / 32</a:t>
+              <a:t>21 / 31</a:t>
             </a:r>
           </a:p>
         </p:txBody>
@@ -10642,7 +10571,7 @@
                   <a:srgbClr val="99A3AF"/>
                 </a:solidFill>
               </a:rPr>
-              <a:t>22 / 32</a:t>
+              <a:t>22 / 31</a:t>
             </a:r>
           </a:p>
         </p:txBody>
@@ -11186,7 +11115,7 @@
                   <a:srgbClr val="99A3AF"/>
                 </a:solidFill>
               </a:rPr>
-              <a:t>24 / 32</a:t>
+              <a:t>24 / 31</a:t>
             </a:r>
           </a:p>
         </p:txBody>
@@ -11522,7 +11451,7 @@
                   <a:srgbClr val="99A3AF"/>
                 </a:solidFill>
               </a:rPr>
-              <a:t>25 / 32</a:t>
+              <a:t>25 / 31</a:t>
             </a:r>
           </a:p>
         </p:txBody>
@@ -11858,7 +11787,7 @@
                   <a:srgbClr val="99A3AF"/>
                 </a:solidFill>
               </a:rPr>
-              <a:t>26 / 32</a:t>
+              <a:t>26 / 31</a:t>
             </a:r>
           </a:p>
         </p:txBody>
@@ -12194,7 +12123,7 @@
                   <a:srgbClr val="99A3AF"/>
                 </a:solidFill>
               </a:rPr>
-              <a:t>27 / 32</a:t>
+              <a:t>27 / 31</a:t>
             </a:r>
           </a:p>
         </p:txBody>
@@ -12245,7 +12174,7 @@
                   <a:srgbClr val="1F2D3D"/>
                 </a:solidFill>
               </a:rPr>
-              <a:t>0.650 m was a test-set artifact; 0.752 m is the reported headline</a:t>
+              <a:t>Bigger and fancier consistently lost: at 1.4k samples, bias beats capacity</a:t>
             </a:r>
           </a:p>
         </p:txBody>
@@ -12291,7 +12220,7 @@
                   <a:srgbClr val="1F2D3D"/>
                 </a:solidFill>
               </a:rPr>
-              <a:t>Greedy ensemble of 33 candidates hit 0.650 m — but picked ON the test set</a:t>
+              <a:t>Diffusion head 1.82 m: sampling noise on a deterministic task</a:t>
             </a:r>
           </a:p>
           <a:p>
@@ -12314,7 +12243,7 @@
                   <a:srgbClr val="1F2D3D"/>
                 </a:solidFill>
               </a:rPr>
-              <a:t>A held-out val set exposed it at 0.710 m — a ~0.07 m selection bias, so we dropped it</a:t>
+              <a:t>Cascade-big 1.7M params 0.93 m: capacity just overfits at this scale</a:t>
             </a:r>
           </a:p>
           <a:p>
@@ -12337,7 +12266,7 @@
                   <a:srgbClr val="1F2D3D"/>
                 </a:solidFill>
               </a:rPr>
-              <a:t>Honest full-train -&gt; test headline stands at 0.752 m</a:t>
+              <a:t>CNN floor-plan cross-attn 0.91 m: extra machinery, no extra signal</a:t>
             </a:r>
           </a:p>
           <a:p>
@@ -12360,14 +12289,14 @@
                   <a:srgbClr val="1F2D3D"/>
                 </a:solidFill>
               </a:rPr>
-              <a:t>SWA (top literature method) moved 0.025 &lt; bootstrap SE 0.037 -&gt; not adopted</a:t>
+              <a:t>(also: C-Mixup 0.94, A+B/CNN+cascade combo 0.89, 3-level+12k synth 0.80)</a:t>
             </a:r>
           </a:p>
         </p:txBody>
       </p:sp>
       <p:pic>
         <p:nvPicPr>
-          <p:cNvPr id="4" name="Picture 3" descr="honest_validation.png"/>
+          <p:cNvPr id="4" name="Picture 3" descr="failures.png"/>
           <p:cNvPicPr>
             <a:picLocks noChangeAspect="1"/>
           </p:cNvPicPr>
@@ -12381,8 +12310,8 @@
         </p:blipFill>
         <p:spPr>
           <a:xfrm>
-            <a:off x="1788014" y="2651760"/>
-            <a:ext cx="8612924" cy="3657600"/>
+            <a:off x="2741676" y="2651760"/>
+            <a:ext cx="6705600" cy="3657600"/>
           </a:xfrm>
           <a:prstGeom prst="rect">
             <a:avLst/>
@@ -12530,7 +12459,7 @@
                   <a:srgbClr val="99A3AF"/>
                 </a:solidFill>
               </a:rPr>
-              <a:t>28 / 32</a:t>
+              <a:t>28 / 31</a:t>
             </a:r>
           </a:p>
         </p:txBody>
@@ -12581,7 +12510,7 @@
                   <a:srgbClr val="1F2D3D"/>
                 </a:solidFill>
               </a:rPr>
-              <a:t>Bigger and fancier consistently lost: at 1.4k samples, bias beats capacity</a:t>
+              <a:t>The error splits cleanly: 27% solved at the label floor, 16% unsolvable</a:t>
             </a:r>
           </a:p>
         </p:txBody>
@@ -12594,8 +12523,8 @@
         </p:nvSpPr>
         <p:spPr>
           <a:xfrm>
-            <a:off x="548640" y="1143000"/>
-            <a:ext cx="11064240" cy="1371600"/>
+            <a:off x="548640" y="1280160"/>
+            <a:ext cx="4114800" cy="4846320"/>
           </a:xfrm>
           <a:prstGeom prst="rect">
             <a:avLst/>
@@ -12614,7 +12543,7 @@
               </a:spcAft>
             </a:pPr>
             <a:r>
-              <a:rPr sz="1600" b="1">
+              <a:rPr sz="1800" b="1">
                 <a:solidFill>
                   <a:srgbClr val="1B6EC2"/>
                 </a:solidFill>
@@ -12622,12 +12551,12 @@
               <a:t>•  </a:t>
             </a:r>
             <a:r>
-              <a:rPr sz="1600">
+              <a:rPr sz="1800">
                 <a:solidFill>
                   <a:srgbClr val="1F2D3D"/>
                 </a:solidFill>
               </a:rPr>
-              <a:t>Diffusion head 1.82 m: sampling noise on a deterministic task</a:t>
+              <a:t>27% of predictions sit at the 0.3 m AMCL floor (label-limited, not improvable)</a:t>
             </a:r>
           </a:p>
           <a:p>
@@ -12637,7 +12566,7 @@
               </a:spcAft>
             </a:pPr>
             <a:r>
-              <a:rPr sz="1600" b="1">
+              <a:rPr sz="1800" b="1">
                 <a:solidFill>
                   <a:srgbClr val="1B6EC2"/>
                 </a:solidFill>
@@ -12645,12 +12574,12 @@
               <a:t>•  </a:t>
             </a:r>
             <a:r>
-              <a:rPr sz="1600">
+              <a:rPr sz="1800">
                 <a:solidFill>
                   <a:srgbClr val="1F2D3D"/>
                 </a:solidFill>
               </a:rPr>
-              <a:t>Cascade-big 1.7M params 0.93 m: capacity just overfits at this scale</a:t>
+              <a:t>~16% are &gt;2 m outliers from WiFi symmetric ambiguity (two places, same RSSI)</a:t>
             </a:r>
           </a:p>
           <a:p>
@@ -12660,7 +12589,7 @@
               </a:spcAft>
             </a:pPr>
             <a:r>
-              <a:rPr sz="1600" b="1">
+              <a:rPr sz="1800" b="1">
                 <a:solidFill>
                   <a:srgbClr val="1B6EC2"/>
                 </a:solidFill>
@@ -12668,12 +12597,12 @@
               <a:t>•  </a:t>
             </a:r>
             <a:r>
-              <a:rPr sz="1600">
+              <a:rPr sz="1800">
                 <a:solidFill>
                   <a:srgbClr val="1F2D3D"/>
                 </a:solidFill>
               </a:rPr>
-              <a:t>CNN floor-plan cross-attn 0.91 m: extra machinery, no extra signal</a:t>
+              <a:t>Worst-10 cluster in the sparse upper region and mirror-symmetric spots</a:t>
             </a:r>
           </a:p>
           <a:p>
@@ -12683,7 +12612,7 @@
               </a:spcAft>
             </a:pPr>
             <a:r>
-              <a:rPr sz="1600" b="1">
+              <a:rPr sz="1800" b="1">
                 <a:solidFill>
                   <a:srgbClr val="1B6EC2"/>
                 </a:solidFill>
@@ -12691,19 +12620,19 @@
               <a:t>•  </a:t>
             </a:r>
             <a:r>
-              <a:rPr sz="1600">
+              <a:rPr sz="1800">
                 <a:solidFill>
                   <a:srgbClr val="1F2D3D"/>
                 </a:solidFill>
               </a:rPr>
-              <a:t>(also: C-Mixup 0.94, A+B/CNN+cascade combo 0.89, 3-level+12k synth 0.80)</a:t>
+              <a:t>No model can separate identical fingerprints — only new signals can</a:t>
             </a:r>
           </a:p>
         </p:txBody>
       </p:sp>
       <p:pic>
         <p:nvPicPr>
-          <p:cNvPr id="4" name="Picture 3" descr="failures.png"/>
+          <p:cNvPr id="4" name="Picture 3" descr="cascade_worst10.png"/>
           <p:cNvPicPr>
             <a:picLocks noChangeAspect="1"/>
           </p:cNvPicPr>
@@ -12717,8 +12646,8 @@
         </p:blipFill>
         <p:spPr>
           <a:xfrm>
-            <a:off x="2741676" y="2651760"/>
-            <a:ext cx="6705600" cy="3657600"/>
+            <a:off x="5501640" y="1188720"/>
+            <a:ext cx="5638800" cy="5074920"/>
           </a:xfrm>
           <a:prstGeom prst="rect">
             <a:avLst/>
@@ -12866,7 +12795,7 @@
                   <a:srgbClr val="99A3AF"/>
                 </a:solidFill>
               </a:rPr>
-              <a:t>29 / 32</a:t>
+              <a:t>29 / 31</a:t>
             </a:r>
           </a:p>
         </p:txBody>
@@ -13125,7 +13054,7 @@
                   <a:srgbClr val="1F2D3D"/>
                 </a:solidFill>
               </a:rPr>
-              <a:t>The error splits cleanly: 27% solved at the label floor, 16% unsolvable</a:t>
+              <a:t>Live in the lab: ESP32 to 9 ms CPU inference to live heatmap</a:t>
             </a:r>
           </a:p>
         </p:txBody>
@@ -13171,7 +13100,7 @@
                   <a:srgbClr val="1F2D3D"/>
                 </a:solidFill>
               </a:rPr>
-              <a:t>27% of predictions sit at the 0.3 m AMCL floor (label-limited, not improvable)</a:t>
+              <a:t>Real ESP32 streaming live scans; CPU-only inference ~9 ms/scan (no GPU)</a:t>
             </a:r>
           </a:p>
           <a:p>
@@ -13194,7 +13123,7 @@
                   <a:srgbClr val="1F2D3D"/>
                 </a:solidFill>
               </a:rPr>
-              <a:t>~16% are &gt;2 m outliers from WiFi symmetric ambiguity (two places, same RSSI)</a:t>
+              <a:t>Live position + probability heatmap rendered on the floor plan</a:t>
             </a:r>
           </a:p>
           <a:p>
@@ -13217,7 +13146,7 @@
                   <a:srgbClr val="1F2D3D"/>
                 </a:solidFill>
               </a:rPr>
-              <a:t>Worst-10 cluster in the sparse upper region and mirror-symmetric spots</a:t>
+              <a:t>80-95% of live APs match the trained vocabulary (no drift)</a:t>
             </a:r>
           </a:p>
           <a:p>
@@ -13240,14 +13169,14 @@
                   <a:srgbClr val="1F2D3D"/>
                 </a:solidFill>
               </a:rPr>
-              <a:t>No model can separate identical fingerprints — only new signals can</a:t>
+              <a:t>Precision standing still &lt;0.1 m spread; accuracy vs ground truth 0.4-0.8 m</a:t>
             </a:r>
           </a:p>
         </p:txBody>
       </p:sp>
       <p:pic>
         <p:nvPicPr>
-          <p:cNvPr id="4" name="Picture 3" descr="cascade_worst10.png"/>
+          <p:cNvPr id="4" name="Picture 3" descr="demo_snapshot.png"/>
           <p:cNvPicPr>
             <a:picLocks noChangeAspect="1"/>
           </p:cNvPicPr>
@@ -13261,8 +13190,8 @@
         </p:blipFill>
         <p:spPr>
           <a:xfrm>
-            <a:off x="5501640" y="1188720"/>
-            <a:ext cx="5638800" cy="5074920"/>
+            <a:off x="5783580" y="1188720"/>
+            <a:ext cx="5074920" cy="5074920"/>
           </a:xfrm>
           <a:prstGeom prst="rect">
             <a:avLst/>
@@ -13271,25 +13200,26 @@
       </p:pic>
       <p:sp>
         <p:nvSpPr>
-          <p:cNvPr id="5" name="Rectangle 4"/>
+          <p:cNvPr id="5" name="Oval 4"/>
           <p:cNvSpPr/>
           <p:nvPr/>
         </p:nvSpPr>
         <p:spPr>
           <a:xfrm>
-            <a:off x="457200" y="6473952"/>
-            <a:ext cx="11274552" cy="16510"/>
-          </a:xfrm>
-          <a:prstGeom prst="rect">
+            <a:off x="7813548" y="3218688"/>
+            <a:ext cx="1014984" cy="1014984"/>
+          </a:xfrm>
+          <a:prstGeom prst="ellipse">
             <a:avLst/>
           </a:prstGeom>
           <a:solidFill>
-            <a:srgbClr val="D8DEE6"/>
+            <a:srgbClr val="111111"/>
           </a:solidFill>
-          <a:ln>
-            <a:noFill/>
+          <a:ln w="25400">
+            <a:solidFill>
+              <a:srgbClr val="FFFFFF"/>
+            </a:solidFill>
           </a:ln>
-          <a:effectLst/>
         </p:spPr>
         <p:style>
           <a:lnRef idx="1">
@@ -13315,7 +13245,128 @@
       </p:sp>
       <p:sp>
         <p:nvSpPr>
-          <p:cNvPr id="6" name="TextBox 5"/>
+          <p:cNvPr id="6" name="Isosceles Triangle 5"/>
+          <p:cNvSpPr/>
+          <p:nvPr/>
+        </p:nvSpPr>
+        <p:spPr>
+          <a:xfrm rot="5400000">
+            <a:off x="8194167" y="3472434"/>
+            <a:ext cx="507492" cy="507492"/>
+          </a:xfrm>
+          <a:prstGeom prst="triangle">
+            <a:avLst/>
+          </a:prstGeom>
+          <a:solidFill>
+            <a:srgbClr val="FFFFFF"/>
+          </a:solidFill>
+          <a:ln>
+            <a:noFill/>
+          </a:ln>
+        </p:spPr>
+        <p:style>
+          <a:lnRef idx="1">
+            <a:schemeClr val="accent1"/>
+          </a:lnRef>
+          <a:fillRef idx="3">
+            <a:schemeClr val="accent1"/>
+          </a:fillRef>
+          <a:effectRef idx="2">
+            <a:schemeClr val="accent1"/>
+          </a:effectRef>
+          <a:fontRef idx="minor">
+            <a:schemeClr val="lt1"/>
+          </a:fontRef>
+        </p:style>
+        <p:txBody>
+          <a:bodyPr rtlCol="0" anchor="ctr"/>
+          <a:lstStyle/>
+          <a:p>
+            <a:pPr algn="ctr"/>
+          </a:p>
+        </p:txBody>
+      </p:sp>
+      <p:sp>
+        <p:nvSpPr>
+          <p:cNvPr id="7" name="TextBox 6"/>
+          <p:cNvSpPr txBox="1"/>
+          <p:nvPr/>
+        </p:nvSpPr>
+        <p:spPr>
+          <a:xfrm>
+            <a:off x="5783580" y="5852160"/>
+            <a:ext cx="5074920" cy="411480"/>
+          </a:xfrm>
+          <a:prstGeom prst="rect">
+            <a:avLst/>
+          </a:prstGeom>
+          <a:noFill/>
+        </p:spPr>
+        <p:txBody>
+          <a:bodyPr wrap="square">
+            <a:spAutoFit/>
+          </a:bodyPr>
+          <a:lstStyle/>
+          <a:p>
+            <a:pPr algn="ctr"/>
+            <a:r>
+              <a:rPr sz="1300" b="1">
+                <a:solidFill>
+                  <a:srgbClr val="1B6EC2"/>
+                </a:solidFill>
+              </a:rPr>
+              <a:t>▶  LIVE DEMO VIDEO — replace this slide image with the recording</a:t>
+            </a:r>
+          </a:p>
+        </p:txBody>
+      </p:sp>
+      <p:sp>
+        <p:nvSpPr>
+          <p:cNvPr id="8" name="Rectangle 7"/>
+          <p:cNvSpPr/>
+          <p:nvPr/>
+        </p:nvSpPr>
+        <p:spPr>
+          <a:xfrm>
+            <a:off x="457200" y="6473952"/>
+            <a:ext cx="11274552" cy="16510"/>
+          </a:xfrm>
+          <a:prstGeom prst="rect">
+            <a:avLst/>
+          </a:prstGeom>
+          <a:solidFill>
+            <a:srgbClr val="D8DEE6"/>
+          </a:solidFill>
+          <a:ln>
+            <a:noFill/>
+          </a:ln>
+          <a:effectLst/>
+        </p:spPr>
+        <p:style>
+          <a:lnRef idx="1">
+            <a:schemeClr val="accent1"/>
+          </a:lnRef>
+          <a:fillRef idx="3">
+            <a:schemeClr val="accent1"/>
+          </a:fillRef>
+          <a:effectRef idx="2">
+            <a:schemeClr val="accent1"/>
+          </a:effectRef>
+          <a:fontRef idx="minor">
+            <a:schemeClr val="lt1"/>
+          </a:fontRef>
+        </p:style>
+        <p:txBody>
+          <a:bodyPr rtlCol="0" anchor="ctr"/>
+          <a:lstStyle/>
+          <a:p>
+            <a:pPr algn="ctr"/>
+          </a:p>
+        </p:txBody>
+      </p:sp>
+      <p:sp>
+        <p:nvSpPr>
+          <p:cNvPr id="9" name="TextBox 8"/>
           <p:cNvSpPr txBox="1"/>
           <p:nvPr/>
         </p:nvSpPr>
@@ -13349,7 +13400,7 @@
       </p:sp>
       <p:sp>
         <p:nvSpPr>
-          <p:cNvPr id="7" name="TextBox 6"/>
+          <p:cNvPr id="10" name="TextBox 9"/>
           <p:cNvSpPr txBox="1"/>
           <p:nvPr/>
         </p:nvSpPr>
@@ -13383,7 +13434,7 @@
       </p:sp>
       <p:sp>
         <p:nvSpPr>
-          <p:cNvPr id="8" name="TextBox 7"/>
+          <p:cNvPr id="11" name="TextBox 10"/>
           <p:cNvSpPr txBox="1"/>
           <p:nvPr/>
         </p:nvSpPr>
@@ -13410,7 +13461,7 @@
                   <a:srgbClr val="99A3AF"/>
                 </a:solidFill>
               </a:rPr>
-              <a:t>30 / 32</a:t>
+              <a:t>30 / 31</a:t>
             </a:r>
           </a:p>
         </p:txBody>
@@ -13461,7 +13512,7 @@
                   <a:srgbClr val="1F2D3D"/>
                 </a:solidFill>
               </a:rPr>
-              <a:t>Live in the lab: ESP32 to 9 ms CPU inference to live heatmap</a:t>
+              <a:t>Verdict: ~0.75 m is real; sub-0.65 m needs new data, not a deeper net</a:t>
             </a:r>
           </a:p>
         </p:txBody>
@@ -13507,7 +13558,7 @@
                   <a:srgbClr val="1F2D3D"/>
                 </a:solidFill>
               </a:rPr>
-              <a:t>Real ESP32 streaming live scans; CPU-only inference ~9 ms/scan (no GPU)</a:t>
+              <a:t>Halved KNN error to a 0.752 m median, validated on real hardware</a:t>
             </a:r>
           </a:p>
           <a:p>
@@ -13530,7 +13581,7 @@
                   <a:srgbClr val="1F2D3D"/>
                 </a:solidFill>
               </a:rPr>
-              <a:t>Live position + probability heatmap rendered on the floor plan</a:t>
+              <a:t>Won by inductive bias (set input, grid classification, coarse gate), not capacity</a:t>
             </a:r>
           </a:p>
           <a:p>
@@ -13553,7 +13604,7 @@
                   <a:srgbClr val="1F2D3D"/>
                 </a:solidFill>
               </a:rPr>
-              <a:t>80-95% of live APs match the trained vocabulary (no drift)</a:t>
+              <a:t>(btw) an early run hit 0.65 m but was tuned on the test set — it does not generalise, so we report 0.752 m</a:t>
             </a:r>
           </a:p>
           <a:p>
@@ -13576,14 +13627,14 @@
                   <a:srgbClr val="1F2D3D"/>
                 </a:solidFill>
               </a:rPr>
-              <a:t>Precision standing still &lt;0.1 m spread; accuracy vs ground truth 0.4-0.8 m</a:t>
+              <a:t>To break 0.6x: upper-region data, IMU/heading, temporal fusion — not depth</a:t>
             </a:r>
           </a:p>
         </p:txBody>
       </p:sp>
       <p:pic>
         <p:nvPicPr>
-          <p:cNvPr id="4" name="Picture 3" descr="demo_snapshot.png"/>
+          <p:cNvPr id="4" name="Picture 3" descr="ladder_bar.png"/>
           <p:cNvPicPr>
             <a:picLocks noChangeAspect="1"/>
           </p:cNvPicPr>
@@ -13597,8 +13648,8 @@
         </p:blipFill>
         <p:spPr>
           <a:xfrm>
-            <a:off x="5783580" y="1188720"/>
-            <a:ext cx="5074920" cy="5074920"/>
+            <a:off x="4846320" y="1199111"/>
+            <a:ext cx="6949440" cy="5054138"/>
           </a:xfrm>
           <a:prstGeom prst="rect">
             <a:avLst/>
@@ -13607,26 +13658,25 @@
       </p:pic>
       <p:sp>
         <p:nvSpPr>
-          <p:cNvPr id="5" name="Oval 4"/>
+          <p:cNvPr id="5" name="Rectangle 4"/>
           <p:cNvSpPr/>
           <p:nvPr/>
         </p:nvSpPr>
         <p:spPr>
           <a:xfrm>
-            <a:off x="7813548" y="3218688"/>
-            <a:ext cx="1014984" cy="1014984"/>
-          </a:xfrm>
-          <a:prstGeom prst="ellipse">
+            <a:off x="457200" y="6473952"/>
+            <a:ext cx="11274552" cy="16510"/>
+          </a:xfrm>
+          <a:prstGeom prst="rect">
             <a:avLst/>
           </a:prstGeom>
           <a:solidFill>
-            <a:srgbClr val="111111"/>
+            <a:srgbClr val="D8DEE6"/>
           </a:solidFill>
-          <a:ln w="25400">
-            <a:solidFill>
-              <a:srgbClr val="FFFFFF"/>
-            </a:solidFill>
+          <a:ln>
+            <a:noFill/>
           </a:ln>
+          <a:effectLst/>
         </p:spPr>
         <p:style>
           <a:lnRef idx="1">
@@ -13652,128 +13702,7 @@
       </p:sp>
       <p:sp>
         <p:nvSpPr>
-          <p:cNvPr id="6" name="Isosceles Triangle 5"/>
-          <p:cNvSpPr/>
-          <p:nvPr/>
-        </p:nvSpPr>
-        <p:spPr>
-          <a:xfrm rot="5400000">
-            <a:off x="8194167" y="3472434"/>
-            <a:ext cx="507492" cy="507492"/>
-          </a:xfrm>
-          <a:prstGeom prst="triangle">
-            <a:avLst/>
-          </a:prstGeom>
-          <a:solidFill>
-            <a:srgbClr val="FFFFFF"/>
-          </a:solidFill>
-          <a:ln>
-            <a:noFill/>
-          </a:ln>
-        </p:spPr>
-        <p:style>
-          <a:lnRef idx="1">
-            <a:schemeClr val="accent1"/>
-          </a:lnRef>
-          <a:fillRef idx="3">
-            <a:schemeClr val="accent1"/>
-          </a:fillRef>
-          <a:effectRef idx="2">
-            <a:schemeClr val="accent1"/>
-          </a:effectRef>
-          <a:fontRef idx="minor">
-            <a:schemeClr val="lt1"/>
-          </a:fontRef>
-        </p:style>
-        <p:txBody>
-          <a:bodyPr rtlCol="0" anchor="ctr"/>
-          <a:lstStyle/>
-          <a:p>
-            <a:pPr algn="ctr"/>
-          </a:p>
-        </p:txBody>
-      </p:sp>
-      <p:sp>
-        <p:nvSpPr>
-          <p:cNvPr id="7" name="TextBox 6"/>
-          <p:cNvSpPr txBox="1"/>
-          <p:nvPr/>
-        </p:nvSpPr>
-        <p:spPr>
-          <a:xfrm>
-            <a:off x="5783580" y="5852160"/>
-            <a:ext cx="5074920" cy="411480"/>
-          </a:xfrm>
-          <a:prstGeom prst="rect">
-            <a:avLst/>
-          </a:prstGeom>
-          <a:noFill/>
-        </p:spPr>
-        <p:txBody>
-          <a:bodyPr wrap="square">
-            <a:spAutoFit/>
-          </a:bodyPr>
-          <a:lstStyle/>
-          <a:p>
-            <a:pPr algn="ctr"/>
-            <a:r>
-              <a:rPr sz="1300" b="1">
-                <a:solidFill>
-                  <a:srgbClr val="1B6EC2"/>
-                </a:solidFill>
-              </a:rPr>
-              <a:t>▶  LIVE DEMO VIDEO — replace this slide image with the recording</a:t>
-            </a:r>
-          </a:p>
-        </p:txBody>
-      </p:sp>
-      <p:sp>
-        <p:nvSpPr>
-          <p:cNvPr id="8" name="Rectangle 7"/>
-          <p:cNvSpPr/>
-          <p:nvPr/>
-        </p:nvSpPr>
-        <p:spPr>
-          <a:xfrm>
-            <a:off x="457200" y="6473952"/>
-            <a:ext cx="11274552" cy="16510"/>
-          </a:xfrm>
-          <a:prstGeom prst="rect">
-            <a:avLst/>
-          </a:prstGeom>
-          <a:solidFill>
-            <a:srgbClr val="D8DEE6"/>
-          </a:solidFill>
-          <a:ln>
-            <a:noFill/>
-          </a:ln>
-          <a:effectLst/>
-        </p:spPr>
-        <p:style>
-          <a:lnRef idx="1">
-            <a:schemeClr val="accent1"/>
-          </a:lnRef>
-          <a:fillRef idx="3">
-            <a:schemeClr val="accent1"/>
-          </a:fillRef>
-          <a:effectRef idx="2">
-            <a:schemeClr val="accent1"/>
-          </a:effectRef>
-          <a:fontRef idx="minor">
-            <a:schemeClr val="lt1"/>
-          </a:fontRef>
-        </p:style>
-        <p:txBody>
-          <a:bodyPr rtlCol="0" anchor="ctr"/>
-          <a:lstStyle/>
-          <a:p>
-            <a:pPr algn="ctr"/>
-          </a:p>
-        </p:txBody>
-      </p:sp>
-      <p:sp>
-        <p:nvSpPr>
-          <p:cNvPr id="9" name="TextBox 8"/>
+          <p:cNvPr id="6" name="TextBox 5"/>
           <p:cNvSpPr txBox="1"/>
           <p:nvPr/>
         </p:nvSpPr>
@@ -13807,7 +13736,7 @@
       </p:sp>
       <p:sp>
         <p:nvSpPr>
-          <p:cNvPr id="10" name="TextBox 9"/>
+          <p:cNvPr id="7" name="TextBox 6"/>
           <p:cNvSpPr txBox="1"/>
           <p:nvPr/>
         </p:nvSpPr>
@@ -13841,7 +13770,7 @@
       </p:sp>
       <p:sp>
         <p:nvSpPr>
-          <p:cNvPr id="11" name="TextBox 10"/>
+          <p:cNvPr id="8" name="TextBox 7"/>
           <p:cNvSpPr txBox="1"/>
           <p:nvPr/>
         </p:nvSpPr>
@@ -13868,343 +13797,7 @@
                   <a:srgbClr val="99A3AF"/>
                 </a:solidFill>
               </a:rPr>
-              <a:t>31 / 32</a:t>
-            </a:r>
-          </a:p>
-        </p:txBody>
-      </p:sp>
-    </p:spTree>
-  </p:cSld>
-  <p:clrMapOvr>
-    <a:masterClrMapping/>
-  </p:clrMapOvr>
-</p:sld>
-</file>
-
-<file path=ppt/slides/slide32.xml><?xml version="1.0" encoding="utf-8"?>
-<p:sld xmlns:a="http://schemas.openxmlformats.org/drawingml/2006/main" xmlns:p="http://schemas.openxmlformats.org/presentationml/2006/main" xmlns:r="http://schemas.openxmlformats.org/officeDocument/2006/relationships">
-  <p:cSld>
-    <p:spTree>
-      <p:nvGrpSpPr>
-        <p:cNvPr id="1" name=""/>
-        <p:cNvGrpSpPr/>
-        <p:nvPr/>
-      </p:nvGrpSpPr>
-      <p:grpSpPr/>
-      <p:sp>
-        <p:nvSpPr>
-          <p:cNvPr id="2" name="TextBox 1"/>
-          <p:cNvSpPr txBox="1"/>
-          <p:nvPr/>
-        </p:nvSpPr>
-        <p:spPr>
-          <a:xfrm>
-            <a:off x="457200" y="320040"/>
-            <a:ext cx="11274552" cy="868680"/>
-          </a:xfrm>
-          <a:prstGeom prst="rect">
-            <a:avLst/>
-          </a:prstGeom>
-          <a:noFill/>
-        </p:spPr>
-        <p:txBody>
-          <a:bodyPr wrap="square">
-            <a:spAutoFit/>
-          </a:bodyPr>
-          <a:lstStyle/>
-          <a:p>
-            <a:r>
-              <a:rPr sz="2700" b="1">
-                <a:solidFill>
-                  <a:srgbClr val="1F2D3D"/>
-                </a:solidFill>
-              </a:rPr>
-              <a:t>Verdict: ~0.75 m is real; sub-0.65 m needs new data, not a deeper net</a:t>
-            </a:r>
-          </a:p>
-        </p:txBody>
-      </p:sp>
-      <p:sp>
-        <p:nvSpPr>
-          <p:cNvPr id="3" name="TextBox 2"/>
-          <p:cNvSpPr txBox="1"/>
-          <p:nvPr/>
-        </p:nvSpPr>
-        <p:spPr>
-          <a:xfrm>
-            <a:off x="548640" y="1280160"/>
-            <a:ext cx="4114800" cy="4846320"/>
-          </a:xfrm>
-          <a:prstGeom prst="rect">
-            <a:avLst/>
-          </a:prstGeom>
-          <a:noFill/>
-        </p:spPr>
-        <p:txBody>
-          <a:bodyPr wrap="square" anchor="ctr">
-            <a:spAutoFit/>
-          </a:bodyPr>
-          <a:lstStyle/>
-          <a:p>
-            <a:pPr>
-              <a:spcAft>
-                <a:spcPts val="1000"/>
-              </a:spcAft>
-            </a:pPr>
-            <a:r>
-              <a:rPr sz="1800" b="1">
-                <a:solidFill>
-                  <a:srgbClr val="1B6EC2"/>
-                </a:solidFill>
-              </a:rPr>
-              <a:t>•  </a:t>
-            </a:r>
-            <a:r>
-              <a:rPr sz="1800">
-                <a:solidFill>
-                  <a:srgbClr val="1F2D3D"/>
-                </a:solidFill>
-              </a:rPr>
-              <a:t>Halved KNN error to a 0.752 m median, validated on real hardware</a:t>
-            </a:r>
-          </a:p>
-          <a:p>
-            <a:pPr>
-              <a:spcAft>
-                <a:spcPts val="1000"/>
-              </a:spcAft>
-            </a:pPr>
-            <a:r>
-              <a:rPr sz="1800" b="1">
-                <a:solidFill>
-                  <a:srgbClr val="1B6EC2"/>
-                </a:solidFill>
-              </a:rPr>
-              <a:t>•  </a:t>
-            </a:r>
-            <a:r>
-              <a:rPr sz="1800">
-                <a:solidFill>
-                  <a:srgbClr val="1F2D3D"/>
-                </a:solidFill>
-              </a:rPr>
-              <a:t>Won by inductive bias (set input, grid classification, coarse gate), not capacity</a:t>
-            </a:r>
-          </a:p>
-          <a:p>
-            <a:pPr>
-              <a:spcAft>
-                <a:spcPts val="1000"/>
-              </a:spcAft>
-            </a:pPr>
-            <a:r>
-              <a:rPr sz="1800" b="1">
-                <a:solidFill>
-                  <a:srgbClr val="1B6EC2"/>
-                </a:solidFill>
-              </a:rPr>
-              <a:t>•  </a:t>
-            </a:r>
-            <a:r>
-              <a:rPr sz="1800">
-                <a:solidFill>
-                  <a:srgbClr val="1F2D3D"/>
-                </a:solidFill>
-              </a:rPr>
-              <a:t>Validation matters: a 0.650 m test-tuned result did not hold up on a held-out set</a:t>
-            </a:r>
-          </a:p>
-          <a:p>
-            <a:pPr>
-              <a:spcAft>
-                <a:spcPts val="1000"/>
-              </a:spcAft>
-            </a:pPr>
-            <a:r>
-              <a:rPr sz="1800" b="1">
-                <a:solidFill>
-                  <a:srgbClr val="1B6EC2"/>
-                </a:solidFill>
-              </a:rPr>
-              <a:t>•  </a:t>
-            </a:r>
-            <a:r>
-              <a:rPr sz="1800">
-                <a:solidFill>
-                  <a:srgbClr val="1F2D3D"/>
-                </a:solidFill>
-              </a:rPr>
-              <a:t>To break 0.6x: upper-region data, IMU/heading, temporal fusion — not depth</a:t>
-            </a:r>
-          </a:p>
-        </p:txBody>
-      </p:sp>
-      <p:pic>
-        <p:nvPicPr>
-          <p:cNvPr id="4" name="Picture 3" descr="ladder_bar.png"/>
-          <p:cNvPicPr>
-            <a:picLocks noChangeAspect="1"/>
-          </p:cNvPicPr>
-          <p:nvPr/>
-        </p:nvPicPr>
-        <p:blipFill>
-          <a:blip r:embed="rId2"/>
-          <a:stretch>
-            <a:fillRect/>
-          </a:stretch>
-        </p:blipFill>
-        <p:spPr>
-          <a:xfrm>
-            <a:off x="4846320" y="1199111"/>
-            <a:ext cx="6949440" cy="5054138"/>
-          </a:xfrm>
-          <a:prstGeom prst="rect">
-            <a:avLst/>
-          </a:prstGeom>
-        </p:spPr>
-      </p:pic>
-      <p:sp>
-        <p:nvSpPr>
-          <p:cNvPr id="5" name="Rectangle 4"/>
-          <p:cNvSpPr/>
-          <p:nvPr/>
-        </p:nvSpPr>
-        <p:spPr>
-          <a:xfrm>
-            <a:off x="457200" y="6473952"/>
-            <a:ext cx="11274552" cy="16510"/>
-          </a:xfrm>
-          <a:prstGeom prst="rect">
-            <a:avLst/>
-          </a:prstGeom>
-          <a:solidFill>
-            <a:srgbClr val="D8DEE6"/>
-          </a:solidFill>
-          <a:ln>
-            <a:noFill/>
-          </a:ln>
-          <a:effectLst/>
-        </p:spPr>
-        <p:style>
-          <a:lnRef idx="1">
-            <a:schemeClr val="accent1"/>
-          </a:lnRef>
-          <a:fillRef idx="3">
-            <a:schemeClr val="accent1"/>
-          </a:fillRef>
-          <a:effectRef idx="2">
-            <a:schemeClr val="accent1"/>
-          </a:effectRef>
-          <a:fontRef idx="minor">
-            <a:schemeClr val="lt1"/>
-          </a:fontRef>
-        </p:style>
-        <p:txBody>
-          <a:bodyPr rtlCol="0" anchor="ctr"/>
-          <a:lstStyle/>
-          <a:p>
-            <a:pPr algn="ctr"/>
-          </a:p>
-        </p:txBody>
-      </p:sp>
-      <p:sp>
-        <p:nvSpPr>
-          <p:cNvPr id="6" name="TextBox 5"/>
-          <p:cNvSpPr txBox="1"/>
-          <p:nvPr/>
-        </p:nvSpPr>
-        <p:spPr>
-          <a:xfrm>
-            <a:off x="457200" y="6510528"/>
-            <a:ext cx="4572000" cy="274320"/>
-          </a:xfrm>
-          <a:prstGeom prst="rect">
-            <a:avLst/>
-          </a:prstGeom>
-          <a:noFill/>
-        </p:spPr>
-        <p:txBody>
-          <a:bodyPr wrap="none">
-            <a:spAutoFit/>
-          </a:bodyPr>
-          <a:lstStyle/>
-          <a:p>
-            <a:pPr algn="l"/>
-            <a:r>
-              <a:rPr sz="900">
-                <a:solidFill>
-                  <a:srgbClr val="99A3AF"/>
-                </a:solidFill>
-              </a:rPr>
-              <a:t>WiFi Indoor Localization · Lab 3</a:t>
-            </a:r>
-          </a:p>
-        </p:txBody>
-      </p:sp>
-      <p:sp>
-        <p:nvSpPr>
-          <p:cNvPr id="7" name="TextBox 6"/>
-          <p:cNvSpPr txBox="1"/>
-          <p:nvPr/>
-        </p:nvSpPr>
-        <p:spPr>
-          <a:xfrm>
-            <a:off x="3657600" y="6510528"/>
-            <a:ext cx="4873752" cy="274320"/>
-          </a:xfrm>
-          <a:prstGeom prst="rect">
-            <a:avLst/>
-          </a:prstGeom>
-          <a:noFill/>
-        </p:spPr>
-        <p:txBody>
-          <a:bodyPr wrap="none">
-            <a:spAutoFit/>
-          </a:bodyPr>
-          <a:lstStyle/>
-          <a:p>
-            <a:pPr algn="ctr"/>
-            <a:r>
-              <a:rPr sz="900">
-                <a:solidFill>
-                  <a:srgbClr val="1B6EC2"/>
-                </a:solidFill>
-              </a:rPr>
-              <a:t>實驗結果</a:t>
-            </a:r>
-          </a:p>
-        </p:txBody>
-      </p:sp>
-      <p:sp>
-        <p:nvSpPr>
-          <p:cNvPr id="8" name="TextBox 7"/>
-          <p:cNvSpPr txBox="1"/>
-          <p:nvPr/>
-        </p:nvSpPr>
-        <p:spPr>
-          <a:xfrm>
-            <a:off x="7616952" y="6510528"/>
-            <a:ext cx="4114800" cy="274320"/>
-          </a:xfrm>
-          <a:prstGeom prst="rect">
-            <a:avLst/>
-          </a:prstGeom>
-          <a:noFill/>
-        </p:spPr>
-        <p:txBody>
-          <a:bodyPr wrap="none">
-            <a:spAutoFit/>
-          </a:bodyPr>
-          <a:lstStyle/>
-          <a:p>
-            <a:pPr algn="r"/>
-            <a:r>
-              <a:rPr sz="900">
-                <a:solidFill>
-                  <a:srgbClr val="99A3AF"/>
-                </a:solidFill>
-              </a:rPr>
-              <a:t>32 / 32</a:t>
+              <a:t>31 / 31</a:t>
             </a:r>
           </a:p>
         </p:txBody>
@@ -14614,7 +14207,7 @@
                   <a:srgbClr val="99A3AF"/>
                 </a:solidFill>
               </a:rPr>
-              <a:t>4 / 32</a:t>
+              <a:t>4 / 31</a:t>
             </a:r>
           </a:p>
         </p:txBody>
@@ -15047,7 +14640,7 @@
                   <a:srgbClr val="99A3AF"/>
                 </a:solidFill>
               </a:rPr>
-              <a:t>5 / 32</a:t>
+              <a:t>5 / 31</a:t>
             </a:r>
           </a:p>
         </p:txBody>
@@ -15688,7 +15281,7 @@
                   <a:srgbClr val="99A3AF"/>
                 </a:solidFill>
               </a:rPr>
-              <a:t>7 / 32</a:t>
+              <a:t>7 / 31</a:t>
             </a:r>
           </a:p>
         </p:txBody>
@@ -16024,7 +15617,7 @@
                   <a:srgbClr val="99A3AF"/>
                 </a:solidFill>
               </a:rPr>
-              <a:t>8 / 32</a:t>
+              <a:t>8 / 31</a:t>
             </a:r>
           </a:p>
         </p:txBody>
@@ -16457,7 +16050,7 @@
                   <a:srgbClr val="99A3AF"/>
                 </a:solidFill>
               </a:rPr>
-              <a:t>9 / 32</a:t>
+              <a:t>9 / 31</a:t>
             </a:r>
           </a:p>
         </p:txBody>

</xml_diff>

<commit_message>
Slide 18: stop reusing slide 17's chart, show the GP mechanism instead
Slides 17 and 18 shared the same synth_ablation figure (looked like a
copy-paste). Slide 18 ("how GP-kriging fabricates coverage") now shows a
purpose-built 3-panel figure (make_synth_coverage_figure.py, reads the cached
synthetic set — no slow GP re-fit):
  1. real morning scans — path-shaped, upper region empty
  2. + 5000 GP-synthetic scans — free space filled
  3. one AP: sparse real dots over the GP-filled smooth RSSI field
English labels, high-res, fit on TRAIN positions only. Slide 17 keeps the
result chart; the two pages are now distinct.

Co-Authored-By: Claude Opus 4.8 <noreply@anthropic.com>
</commit_message>
<xml_diff>
--- a/lab3/outputs/slides/lab3_presentation.pptx
+++ b/lab3/outputs/slides/lab3_presentation.pptx
@@ -8665,7 +8665,7 @@
       </p:sp>
       <p:pic>
         <p:nvPicPr>
-          <p:cNvPr id="4" name="Picture 3" descr="synth_ablation.png"/>
+          <p:cNvPr id="4" name="Picture 3" descr="synth_coverage.png"/>
           <p:cNvPicPr>
             <a:picLocks noChangeAspect="1"/>
           </p:cNvPicPr>
@@ -8679,8 +8679,8 @@
         </p:blipFill>
         <p:spPr>
           <a:xfrm>
-            <a:off x="1490518" y="2651760"/>
-            <a:ext cx="9207915" cy="3657600"/>
+            <a:off x="677042" y="2651760"/>
+            <a:ext cx="10834867" cy="3657600"/>
           </a:xfrm>
           <a:prstGeom prst="rect">
             <a:avLst/>

</xml_diff>